<commit_message>
Adiciona segundo slide com compilado geral (big numbers)
Slide 2 traz números-chave da distrital (médicos classificados,
setores, cidades, % que prescreve EUF) e a distribuição por CAT
em cards grandes, no mesmo estilo visual do slide 1.

Co-Authored-By: Claude Sonnet 5 <noreply@anthropic.com>
Claude-Session: https://claude.ai/code/session_01KqmuB8xxfxpvceuypurV9G
</commit_message>
<xml_diff>
--- a/output/painel_medico_distrital_1880.pptx
+++ b/output/painel_medico_distrital_1880.pptx
@@ -6,9 +6,10 @@
   </p:sldMasterIdLst>
   <p:sldIdLst>
     <p:sldId id="256" r:id="rId2"/>
+    <p:sldId id="257" r:id="rId3"/>
   </p:sldIdLst>
   <p:notesMasterIdLst>
-    <p:notesMasterId r:id="rId3"/>
+    <p:notesMasterId r:id="rId4"/>
   </p:notesMasterIdLst>
   <p:sldSz cx="12192000" cy="6858000"/>
   <p:notesSz cx="6858000" cy="12192000"/>
@@ -544,6 +545,94 @@
 </p:notes>
 </file>
 
+<file path=ppt/notesSlides/notesSlide2.xml><?xml version="1.0" encoding="utf-8"?>
+<p:notes xmlns:a="http://schemas.openxmlformats.org/drawingml/2006/main" xmlns:r="http://schemas.openxmlformats.org/officeDocument/2006/relationships" xmlns:p="http://schemas.openxmlformats.org/presentationml/2006/main">
+  <p:cSld>
+    <p:spTree>
+      <p:nvGrpSpPr>
+        <p:cNvPr id="1" name=""/>
+        <p:cNvGrpSpPr/>
+        <p:nvPr/>
+      </p:nvGrpSpPr>
+      <p:grpSpPr>
+        <a:xfrm>
+          <a:off x="0" y="0"/>
+          <a:ext cx="0" cy="0"/>
+          <a:chOff x="0" y="0"/>
+          <a:chExt cx="0" cy="0"/>
+        </a:xfrm>
+      </p:grpSpPr>
+      <p:sp>
+        <p:nvSpPr>
+          <p:cNvPr id="2" name="Slide Image Placeholder 1"/>
+          <p:cNvSpPr>
+            <a:spLocks noGrp="1" noRot="1" noChangeAspect="1"/>
+          </p:cNvSpPr>
+          <p:nvPr>
+            <p:ph type="sldImg"/>
+          </p:nvPr>
+        </p:nvSpPr>
+        <p:spPr/>
+      </p:sp>
+      <p:sp>
+        <p:nvSpPr>
+          <p:cNvPr id="3" name="Notes Placeholder 2"/>
+          <p:cNvSpPr>
+            <a:spLocks noGrp="1"/>
+          </p:cNvSpPr>
+          <p:nvPr>
+            <p:ph type="body" idx="1"/>
+          </p:nvPr>
+        </p:nvSpPr>
+        <p:spPr/>
+        <p:txBody>
+          <a:bodyPr/>
+          <a:lstStyle/>
+          <a:p>
+            <a:r>
+              <a:rPr lang="en-US" dirty="0"/>
+              <a:t/>
+            </a:r>
+            <a:endParaRPr lang="en-US" dirty="0"/>
+          </a:p>
+        </p:txBody>
+      </p:sp>
+      <p:sp>
+        <p:nvSpPr>
+          <p:cNvPr id="4" name="Slide Number Placeholder 3"/>
+          <p:cNvSpPr>
+            <a:spLocks noGrp="1"/>
+          </p:cNvSpPr>
+          <p:nvPr>
+            <p:ph type="sldNum" sz="quarter" idx="10"/>
+          </p:nvPr>
+        </p:nvSpPr>
+        <p:spPr/>
+        <p:txBody>
+          <a:bodyPr/>
+          <a:lstStyle/>
+          <a:p>
+            <a:fld id="{F7021451-1387-4CA6-816F-3879F97B5CBC}" type="slidenum">
+              <a:rPr lang="en-US"/>
+              <a:t>2</a:t>
+            </a:fld>
+            <a:endParaRPr lang="en-US"/>
+          </a:p>
+        </p:txBody>
+      </p:sp>
+    </p:spTree>
+    <p:extLst>
+      <p:ext uri="{BB962C8B-B14F-4D97-AF65-F5344CB8AC3E}">
+        <p14:creationId xmlns:p14="http://schemas.microsoft.com/office/powerpoint/2010/main" val="1024086991"/>
+      </p:ext>
+    </p:extLst>
+  </p:cSld>
+  <p:clrMapOvr>
+    <a:masterClrMapping/>
+  </p:clrMapOvr>
+</p:notes>
+</file>
+
 <file path=ppt/slideLayouts/slideLayout1.xml><?xml version="1.0" encoding="utf-8"?>
 <p:sldLayout xmlns:a="http://schemas.openxmlformats.org/drawingml/2006/main" xmlns:r="http://schemas.openxmlformats.org/officeDocument/2006/relationships" xmlns:p="http://schemas.openxmlformats.org/presentationml/2006/main" preserve="1">
   <p:cSld name="DEFAULT">
@@ -11177,6 +11266,1366 @@
                 <a:cs typeface="Calibri" pitchFamily="34" charset="-120"/>
               </a:rPr>
               <a:t>"% do setor" = participação da CAT no total de médicos classificados (CAT 1 a 5) daquele setor.</a:t>
+            </a:r>
+            <a:endParaRPr lang="en-US" sz="850" dirty="0"/>
+          </a:p>
+        </p:txBody>
+      </p:sp>
+    </p:spTree>
+  </p:cSld>
+  <p:clrMapOvr>
+    <a:masterClrMapping/>
+  </p:clrMapOvr>
+</p:sld>
+</file>
+
+<file path=ppt/slides/slide2.xml><?xml version="1.0" encoding="utf-8"?>
+<p:sld xmlns:a="http://schemas.openxmlformats.org/drawingml/2006/main" xmlns:r="http://schemas.openxmlformats.org/officeDocument/2006/relationships" xmlns:p="http://schemas.openxmlformats.org/presentationml/2006/main">
+  <p:cSld name="Slide 2">
+    <p:bg>
+      <p:bgPr>
+        <a:solidFill>
+          <a:srgbClr val="FFFFFF"/>
+        </a:solidFill>
+      </p:bgPr>
+    </p:bg>
+    <p:spTree>
+      <p:nvGrpSpPr>
+        <p:cNvPr id="1" name=""/>
+        <p:cNvGrpSpPr/>
+        <p:nvPr/>
+      </p:nvGrpSpPr>
+      <p:grpSpPr>
+        <a:xfrm>
+          <a:off x="0" y="0"/>
+          <a:ext cx="0" cy="0"/>
+          <a:chOff x="0" y="0"/>
+          <a:chExt cx="0" cy="0"/>
+        </a:xfrm>
+      </p:grpSpPr>
+      <p:sp>
+        <p:nvSpPr>
+          <p:cNvPr id="2" name="Text 0"/>
+          <p:cNvSpPr txBox="1"/>
+          <p:nvPr/>
+        </p:nvSpPr>
+        <p:spPr>
+          <a:xfrm>
+            <a:off x="365760" y="228600"/>
+            <a:ext cx="11457432" cy="411480"/>
+          </a:xfrm>
+          <a:prstGeom prst="rect">
+            <a:avLst/>
+          </a:prstGeom>
+          <a:noFill/>
+          <a:ln/>
+        </p:spPr>
+        <p:txBody>
+          <a:bodyPr wrap="square" lIns="0" tIns="0" rIns="0" bIns="0" rtlCol="0" anchor="ctr"/>
+          <a:lstStyle/>
+          <a:p>
+            <a:pPr algn="l" indent="0" marL="0">
+              <a:buNone/>
+            </a:pPr>
+            <a:r>
+              <a:rPr lang="en-US" sz="3000" b="1" dirty="0">
+                <a:solidFill>
+                  <a:srgbClr val="1D3557"/>
+                </a:solidFill>
+                <a:latin typeface="Calibri" pitchFamily="34" charset="0"/>
+                <a:ea typeface="Calibri" pitchFamily="34" charset="-122"/>
+                <a:cs typeface="Calibri" pitchFamily="34" charset="-120"/>
+              </a:rPr>
+              <a:t>PAINEL MÉDICO</a:t>
+            </a:r>
+            <a:pPr algn="l" indent="0" marL="0">
+              <a:buNone/>
+            </a:pPr>
+            <a:r>
+              <a:rPr lang="en-US" sz="3000" b="1" dirty="0">
+                <a:solidFill>
+                  <a:srgbClr val="6A4C93"/>
+                </a:solidFill>
+                <a:latin typeface="Calibri" pitchFamily="34" charset="0"/>
+                <a:ea typeface="Calibri" pitchFamily="34" charset="-122"/>
+                <a:cs typeface="Calibri" pitchFamily="34" charset="-120"/>
+              </a:rPr>
+              <a:t>  —  DISTRITAL 1880</a:t>
+            </a:r>
+            <a:endParaRPr lang="en-US" sz="3000" dirty="0"/>
+          </a:p>
+        </p:txBody>
+      </p:sp>
+      <p:sp>
+        <p:nvSpPr>
+          <p:cNvPr id="3" name="Text 1"/>
+          <p:cNvSpPr txBox="1"/>
+          <p:nvPr/>
+        </p:nvSpPr>
+        <p:spPr>
+          <a:xfrm>
+            <a:off x="365760" y="658368"/>
+            <a:ext cx="11457432" cy="274320"/>
+          </a:xfrm>
+          <a:prstGeom prst="rect">
+            <a:avLst/>
+          </a:prstGeom>
+          <a:noFill/>
+          <a:ln/>
+        </p:spPr>
+        <p:txBody>
+          <a:bodyPr wrap="square" lIns="0" tIns="0" rIns="0" bIns="0" rtlCol="0" anchor="ctr"/>
+          <a:lstStyle/>
+          <a:p>
+            <a:pPr algn="l" indent="0" marL="0">
+              <a:buNone/>
+            </a:pPr>
+            <a:r>
+              <a:rPr lang="en-US" sz="1500" dirty="0">
+                <a:solidFill>
+                  <a:srgbClr val="6B7280"/>
+                </a:solidFill>
+                <a:latin typeface="Calibri" pitchFamily="34" charset="0"/>
+                <a:ea typeface="Calibri" pitchFamily="34" charset="-122"/>
+                <a:cs typeface="Calibri" pitchFamily="34" charset="-120"/>
+              </a:rPr>
+              <a:t>Compilado Geral</a:t>
+            </a:r>
+            <a:endParaRPr lang="en-US" sz="1500" dirty="0"/>
+          </a:p>
+        </p:txBody>
+      </p:sp>
+      <p:sp>
+        <p:nvSpPr>
+          <p:cNvPr id="4" name="Shape 2"/>
+          <p:cNvSpPr/>
+          <p:nvPr/>
+        </p:nvSpPr>
+        <p:spPr>
+          <a:xfrm>
+            <a:off x="365760" y="1143000"/>
+            <a:ext cx="2692908" cy="1600200"/>
+          </a:xfrm>
+          <a:prstGeom prst="roundRect">
+            <a:avLst>
+              <a:gd name="adj" fmla="val 4571"/>
+            </a:avLst>
+          </a:prstGeom>
+          <a:solidFill>
+            <a:srgbClr val="F5F6F8"/>
+          </a:solidFill>
+          <a:ln/>
+          <a:effectLst>
+            <a:outerShdw sx="100000" sy="100000" kx="0" ky="0" algn="bl" rotWithShape="0" blurRad="76200" dist="25400" dir="5400000">
+              <a:srgbClr val="000000">
+                <a:alpha val="12000"/>
+              </a:srgbClr>
+            </a:outerShdw>
+          </a:effectLst>
+        </p:spPr>
+      </p:sp>
+      <p:sp>
+        <p:nvSpPr>
+          <p:cNvPr id="5" name="Text 3"/>
+          <p:cNvSpPr txBox="1"/>
+          <p:nvPr/>
+        </p:nvSpPr>
+        <p:spPr>
+          <a:xfrm>
+            <a:off x="365760" y="1344168"/>
+            <a:ext cx="2692908" cy="868680"/>
+          </a:xfrm>
+          <a:prstGeom prst="rect">
+            <a:avLst/>
+          </a:prstGeom>
+          <a:noFill/>
+          <a:ln/>
+        </p:spPr>
+        <p:txBody>
+          <a:bodyPr wrap="square" lIns="0" tIns="0" rIns="0" bIns="0" rtlCol="0" anchor="ctr"/>
+          <a:lstStyle/>
+          <a:p>
+            <a:pPr algn="ctr" indent="0" marL="0">
+              <a:buNone/>
+            </a:pPr>
+            <a:r>
+              <a:rPr lang="en-US" sz="4600" b="1" dirty="0">
+                <a:solidFill>
+                  <a:srgbClr val="1D3557"/>
+                </a:solidFill>
+                <a:latin typeface="Calibri" pitchFamily="34" charset="0"/>
+                <a:ea typeface="Calibri" pitchFamily="34" charset="-122"/>
+                <a:cs typeface="Calibri" pitchFamily="34" charset="-120"/>
+              </a:rPr>
+              <a:t>2.343</a:t>
+            </a:r>
+            <a:endParaRPr lang="en-US" sz="4600" dirty="0"/>
+          </a:p>
+        </p:txBody>
+      </p:sp>
+      <p:sp>
+        <p:nvSpPr>
+          <p:cNvPr id="6" name="Text 4"/>
+          <p:cNvSpPr txBox="1"/>
+          <p:nvPr/>
+        </p:nvSpPr>
+        <p:spPr>
+          <a:xfrm>
+            <a:off x="502920" y="2286000"/>
+            <a:ext cx="2418588" cy="365760"/>
+          </a:xfrm>
+          <a:prstGeom prst="rect">
+            <a:avLst/>
+          </a:prstGeom>
+          <a:noFill/>
+          <a:ln/>
+        </p:spPr>
+        <p:txBody>
+          <a:bodyPr wrap="square" lIns="0" tIns="0" rIns="0" bIns="0" rtlCol="0" anchor="t"/>
+          <a:lstStyle/>
+          <a:p>
+            <a:pPr algn="ctr" indent="0" marL="0">
+              <a:buNone/>
+            </a:pPr>
+            <a:r>
+              <a:rPr lang="en-US" sz="1250" dirty="0">
+                <a:solidFill>
+                  <a:srgbClr val="6B7280"/>
+                </a:solidFill>
+                <a:latin typeface="Calibri" pitchFamily="34" charset="0"/>
+                <a:ea typeface="Calibri" pitchFamily="34" charset="-122"/>
+                <a:cs typeface="Calibri" pitchFamily="34" charset="-120"/>
+              </a:rPr>
+              <a:t>médicos classificados no painel</a:t>
+            </a:r>
+            <a:endParaRPr lang="en-US" sz="1250" dirty="0"/>
+          </a:p>
+        </p:txBody>
+      </p:sp>
+      <p:sp>
+        <p:nvSpPr>
+          <p:cNvPr id="7" name="Shape 5"/>
+          <p:cNvSpPr/>
+          <p:nvPr/>
+        </p:nvSpPr>
+        <p:spPr>
+          <a:xfrm>
+            <a:off x="3287268" y="1143000"/>
+            <a:ext cx="2692908" cy="1600200"/>
+          </a:xfrm>
+          <a:prstGeom prst="roundRect">
+            <a:avLst>
+              <a:gd name="adj" fmla="val 4571"/>
+            </a:avLst>
+          </a:prstGeom>
+          <a:solidFill>
+            <a:srgbClr val="F5F6F8"/>
+          </a:solidFill>
+          <a:ln/>
+          <a:effectLst>
+            <a:outerShdw sx="100000" sy="100000" kx="0" ky="0" algn="bl" rotWithShape="0" blurRad="76200" dist="25400" dir="5400000">
+              <a:srgbClr val="000000">
+                <a:alpha val="12000"/>
+              </a:srgbClr>
+            </a:outerShdw>
+          </a:effectLst>
+        </p:spPr>
+      </p:sp>
+      <p:sp>
+        <p:nvSpPr>
+          <p:cNvPr id="8" name="Text 6"/>
+          <p:cNvSpPr txBox="1"/>
+          <p:nvPr/>
+        </p:nvSpPr>
+        <p:spPr>
+          <a:xfrm>
+            <a:off x="3287268" y="1344168"/>
+            <a:ext cx="2692908" cy="868680"/>
+          </a:xfrm>
+          <a:prstGeom prst="rect">
+            <a:avLst/>
+          </a:prstGeom>
+          <a:noFill/>
+          <a:ln/>
+        </p:spPr>
+        <p:txBody>
+          <a:bodyPr wrap="square" lIns="0" tIns="0" rIns="0" bIns="0" rtlCol="0" anchor="ctr"/>
+          <a:lstStyle/>
+          <a:p>
+            <a:pPr algn="ctr" indent="0" marL="0">
+              <a:buNone/>
+            </a:pPr>
+            <a:r>
+              <a:rPr lang="en-US" sz="4600" b="1" dirty="0">
+                <a:solidFill>
+                  <a:srgbClr val="1D3557"/>
+                </a:solidFill>
+                <a:latin typeface="Calibri" pitchFamily="34" charset="0"/>
+                <a:ea typeface="Calibri" pitchFamily="34" charset="-122"/>
+                <a:cs typeface="Calibri" pitchFamily="34" charset="-120"/>
+              </a:rPr>
+              <a:t>8</a:t>
+            </a:r>
+            <a:endParaRPr lang="en-US" sz="4600" dirty="0"/>
+          </a:p>
+        </p:txBody>
+      </p:sp>
+      <p:sp>
+        <p:nvSpPr>
+          <p:cNvPr id="9" name="Text 7"/>
+          <p:cNvSpPr txBox="1"/>
+          <p:nvPr/>
+        </p:nvSpPr>
+        <p:spPr>
+          <a:xfrm>
+            <a:off x="3424428" y="2286000"/>
+            <a:ext cx="2418588" cy="365760"/>
+          </a:xfrm>
+          <a:prstGeom prst="rect">
+            <a:avLst/>
+          </a:prstGeom>
+          <a:noFill/>
+          <a:ln/>
+        </p:spPr>
+        <p:txBody>
+          <a:bodyPr wrap="square" lIns="0" tIns="0" rIns="0" bIns="0" rtlCol="0" anchor="t"/>
+          <a:lstStyle/>
+          <a:p>
+            <a:pPr algn="ctr" indent="0" marL="0">
+              <a:buNone/>
+            </a:pPr>
+            <a:r>
+              <a:rPr lang="en-US" sz="1250" dirty="0">
+                <a:solidFill>
+                  <a:srgbClr val="6B7280"/>
+                </a:solidFill>
+                <a:latin typeface="Calibri" pitchFamily="34" charset="0"/>
+                <a:ea typeface="Calibri" pitchFamily="34" charset="-122"/>
+                <a:cs typeface="Calibri" pitchFamily="34" charset="-120"/>
+              </a:rPr>
+              <a:t>setores mapeados</a:t>
+            </a:r>
+            <a:endParaRPr lang="en-US" sz="1250" dirty="0"/>
+          </a:p>
+        </p:txBody>
+      </p:sp>
+      <p:sp>
+        <p:nvSpPr>
+          <p:cNvPr id="10" name="Shape 8"/>
+          <p:cNvSpPr/>
+          <p:nvPr/>
+        </p:nvSpPr>
+        <p:spPr>
+          <a:xfrm>
+            <a:off x="6208776" y="1143000"/>
+            <a:ext cx="2692908" cy="1600200"/>
+          </a:xfrm>
+          <a:prstGeom prst="roundRect">
+            <a:avLst>
+              <a:gd name="adj" fmla="val 4571"/>
+            </a:avLst>
+          </a:prstGeom>
+          <a:solidFill>
+            <a:srgbClr val="F5F6F8"/>
+          </a:solidFill>
+          <a:ln/>
+          <a:effectLst>
+            <a:outerShdw sx="100000" sy="100000" kx="0" ky="0" algn="bl" rotWithShape="0" blurRad="76200" dist="25400" dir="5400000">
+              <a:srgbClr val="000000">
+                <a:alpha val="12000"/>
+              </a:srgbClr>
+            </a:outerShdw>
+          </a:effectLst>
+        </p:spPr>
+      </p:sp>
+      <p:sp>
+        <p:nvSpPr>
+          <p:cNvPr id="11" name="Text 9"/>
+          <p:cNvSpPr txBox="1"/>
+          <p:nvPr/>
+        </p:nvSpPr>
+        <p:spPr>
+          <a:xfrm>
+            <a:off x="6208776" y="1344168"/>
+            <a:ext cx="2692908" cy="868680"/>
+          </a:xfrm>
+          <a:prstGeom prst="rect">
+            <a:avLst/>
+          </a:prstGeom>
+          <a:noFill/>
+          <a:ln/>
+        </p:spPr>
+        <p:txBody>
+          <a:bodyPr wrap="square" lIns="0" tIns="0" rIns="0" bIns="0" rtlCol="0" anchor="ctr"/>
+          <a:lstStyle/>
+          <a:p>
+            <a:pPr algn="ctr" indent="0" marL="0">
+              <a:buNone/>
+            </a:pPr>
+            <a:r>
+              <a:rPr lang="en-US" sz="4600" b="1" dirty="0">
+                <a:solidFill>
+                  <a:srgbClr val="1D3557"/>
+                </a:solidFill>
+                <a:latin typeface="Calibri" pitchFamily="34" charset="0"/>
+                <a:ea typeface="Calibri" pitchFamily="34" charset="-122"/>
+                <a:cs typeface="Calibri" pitchFamily="34" charset="-120"/>
+              </a:rPr>
+              <a:t>64</a:t>
+            </a:r>
+            <a:endParaRPr lang="en-US" sz="4600" dirty="0"/>
+          </a:p>
+        </p:txBody>
+      </p:sp>
+      <p:sp>
+        <p:nvSpPr>
+          <p:cNvPr id="12" name="Text 10"/>
+          <p:cNvSpPr txBox="1"/>
+          <p:nvPr/>
+        </p:nvSpPr>
+        <p:spPr>
+          <a:xfrm>
+            <a:off x="6345936" y="2286000"/>
+            <a:ext cx="2418588" cy="365760"/>
+          </a:xfrm>
+          <a:prstGeom prst="rect">
+            <a:avLst/>
+          </a:prstGeom>
+          <a:noFill/>
+          <a:ln/>
+        </p:spPr>
+        <p:txBody>
+          <a:bodyPr wrap="square" lIns="0" tIns="0" rIns="0" bIns="0" rtlCol="0" anchor="t"/>
+          <a:lstStyle/>
+          <a:p>
+            <a:pPr algn="ctr" indent="0" marL="0">
+              <a:buNone/>
+            </a:pPr>
+            <a:r>
+              <a:rPr lang="en-US" sz="1250" dirty="0">
+                <a:solidFill>
+                  <a:srgbClr val="6B7280"/>
+                </a:solidFill>
+                <a:latin typeface="Calibri" pitchFamily="34" charset="0"/>
+                <a:ea typeface="Calibri" pitchFamily="34" charset="-122"/>
+                <a:cs typeface="Calibri" pitchFamily="34" charset="-120"/>
+              </a:rPr>
+              <a:t>cidades atendidas</a:t>
+            </a:r>
+            <a:endParaRPr lang="en-US" sz="1250" dirty="0"/>
+          </a:p>
+        </p:txBody>
+      </p:sp>
+      <p:sp>
+        <p:nvSpPr>
+          <p:cNvPr id="13" name="Shape 11"/>
+          <p:cNvSpPr/>
+          <p:nvPr/>
+        </p:nvSpPr>
+        <p:spPr>
+          <a:xfrm>
+            <a:off x="9130284" y="1143000"/>
+            <a:ext cx="2692908" cy="1600200"/>
+          </a:xfrm>
+          <a:prstGeom prst="roundRect">
+            <a:avLst>
+              <a:gd name="adj" fmla="val 4571"/>
+            </a:avLst>
+          </a:prstGeom>
+          <a:solidFill>
+            <a:srgbClr val="F5F6F8"/>
+          </a:solidFill>
+          <a:ln/>
+          <a:effectLst>
+            <a:outerShdw sx="100000" sy="100000" kx="0" ky="0" algn="bl" rotWithShape="0" blurRad="76200" dist="25400" dir="5400000">
+              <a:srgbClr val="000000">
+                <a:alpha val="12000"/>
+              </a:srgbClr>
+            </a:outerShdw>
+          </a:effectLst>
+        </p:spPr>
+      </p:sp>
+      <p:sp>
+        <p:nvSpPr>
+          <p:cNvPr id="14" name="Text 12"/>
+          <p:cNvSpPr txBox="1"/>
+          <p:nvPr/>
+        </p:nvSpPr>
+        <p:spPr>
+          <a:xfrm>
+            <a:off x="9130284" y="1344168"/>
+            <a:ext cx="2692908" cy="868680"/>
+          </a:xfrm>
+          <a:prstGeom prst="rect">
+            <a:avLst/>
+          </a:prstGeom>
+          <a:noFill/>
+          <a:ln/>
+        </p:spPr>
+        <p:txBody>
+          <a:bodyPr wrap="square" lIns="0" tIns="0" rIns="0" bIns="0" rtlCol="0" anchor="ctr"/>
+          <a:lstStyle/>
+          <a:p>
+            <a:pPr algn="ctr" indent="0" marL="0">
+              <a:buNone/>
+            </a:pPr>
+            <a:r>
+              <a:rPr lang="en-US" sz="4600" b="1" dirty="0">
+                <a:solidFill>
+                  <a:srgbClr val="1D3557"/>
+                </a:solidFill>
+                <a:latin typeface="Calibri" pitchFamily="34" charset="0"/>
+                <a:ea typeface="Calibri" pitchFamily="34" charset="-122"/>
+                <a:cs typeface="Calibri" pitchFamily="34" charset="-120"/>
+              </a:rPr>
+              <a:t>79,5%</a:t>
+            </a:r>
+            <a:endParaRPr lang="en-US" sz="4600" dirty="0"/>
+          </a:p>
+        </p:txBody>
+      </p:sp>
+      <p:sp>
+        <p:nvSpPr>
+          <p:cNvPr id="15" name="Text 13"/>
+          <p:cNvSpPr txBox="1"/>
+          <p:nvPr/>
+        </p:nvSpPr>
+        <p:spPr>
+          <a:xfrm>
+            <a:off x="9267444" y="2286000"/>
+            <a:ext cx="2418588" cy="365760"/>
+          </a:xfrm>
+          <a:prstGeom prst="rect">
+            <a:avLst/>
+          </a:prstGeom>
+          <a:noFill/>
+          <a:ln/>
+        </p:spPr>
+        <p:txBody>
+          <a:bodyPr wrap="square" lIns="0" tIns="0" rIns="0" bIns="0" rtlCol="0" anchor="t"/>
+          <a:lstStyle/>
+          <a:p>
+            <a:pPr algn="ctr" indent="0" marL="0">
+              <a:buNone/>
+            </a:pPr>
+            <a:r>
+              <a:rPr lang="en-US" sz="1250" dirty="0">
+                <a:solidFill>
+                  <a:srgbClr val="6B7280"/>
+                </a:solidFill>
+                <a:latin typeface="Calibri" pitchFamily="34" charset="0"/>
+                <a:ea typeface="Calibri" pitchFamily="34" charset="-122"/>
+                <a:cs typeface="Calibri" pitchFamily="34" charset="-120"/>
+              </a:rPr>
+              <a:t>prescrevem EUF (MAT)</a:t>
+            </a:r>
+            <a:endParaRPr lang="en-US" sz="1250" dirty="0"/>
+          </a:p>
+        </p:txBody>
+      </p:sp>
+      <p:sp>
+        <p:nvSpPr>
+          <p:cNvPr id="16" name="Text 14"/>
+          <p:cNvSpPr txBox="1"/>
+          <p:nvPr/>
+        </p:nvSpPr>
+        <p:spPr>
+          <a:xfrm>
+            <a:off x="365760" y="2880360"/>
+            <a:ext cx="11457432" cy="274320"/>
+          </a:xfrm>
+          <a:prstGeom prst="rect">
+            <a:avLst/>
+          </a:prstGeom>
+          <a:noFill/>
+          <a:ln/>
+        </p:spPr>
+        <p:txBody>
+          <a:bodyPr wrap="square" lIns="0" tIns="0" rIns="0" bIns="0" rtlCol="0" anchor="ctr"/>
+          <a:lstStyle/>
+          <a:p>
+            <a:pPr algn="l" indent="0" marL="0">
+              <a:buNone/>
+            </a:pPr>
+            <a:r>
+              <a:rPr lang="en-US" sz="1500" b="1" dirty="0">
+                <a:solidFill>
+                  <a:srgbClr val="1D3557"/>
+                </a:solidFill>
+                <a:latin typeface="Calibri" pitchFamily="34" charset="0"/>
+                <a:ea typeface="Calibri" pitchFamily="34" charset="-122"/>
+                <a:cs typeface="Calibri" pitchFamily="34" charset="-120"/>
+              </a:rPr>
+              <a:t>Distribuição por CAT</a:t>
+            </a:r>
+            <a:endParaRPr lang="en-US" sz="1500" dirty="0"/>
+          </a:p>
+        </p:txBody>
+      </p:sp>
+      <p:sp>
+        <p:nvSpPr>
+          <p:cNvPr id="17" name="Shape 15"/>
+          <p:cNvSpPr/>
+          <p:nvPr/>
+        </p:nvSpPr>
+        <p:spPr>
+          <a:xfrm>
+            <a:off x="365760" y="3246120"/>
+            <a:ext cx="2181758" cy="2880360"/>
+          </a:xfrm>
+          <a:prstGeom prst="roundRect">
+            <a:avLst>
+              <a:gd name="adj" fmla="val 3353"/>
+            </a:avLst>
+          </a:prstGeom>
+          <a:solidFill>
+            <a:srgbClr val="D62839"/>
+          </a:solidFill>
+          <a:ln/>
+          <a:effectLst>
+            <a:outerShdw sx="100000" sy="100000" kx="0" ky="0" algn="bl" rotWithShape="0" blurRad="76200" dist="25400" dir="5400000">
+              <a:srgbClr val="000000">
+                <a:alpha val="18000"/>
+              </a:srgbClr>
+            </a:outerShdw>
+          </a:effectLst>
+        </p:spPr>
+      </p:sp>
+      <p:sp>
+        <p:nvSpPr>
+          <p:cNvPr id="18" name="Text 16"/>
+          <p:cNvSpPr txBox="1"/>
+          <p:nvPr/>
+        </p:nvSpPr>
+        <p:spPr>
+          <a:xfrm>
+            <a:off x="475488" y="3429000"/>
+            <a:ext cx="1962302" cy="365760"/>
+          </a:xfrm>
+          <a:prstGeom prst="rect">
+            <a:avLst/>
+          </a:prstGeom>
+          <a:noFill/>
+          <a:ln/>
+        </p:spPr>
+        <p:txBody>
+          <a:bodyPr wrap="square" lIns="0" tIns="0" rIns="0" bIns="0" rtlCol="0" anchor="ctr"/>
+          <a:lstStyle/>
+          <a:p>
+            <a:pPr algn="l" indent="0" marL="0">
+              <a:buNone/>
+            </a:pPr>
+            <a:r>
+              <a:rPr lang="en-US" sz="1600" b="1" dirty="0">
+                <a:solidFill>
+                  <a:srgbClr val="FFFFFF"/>
+                </a:solidFill>
+                <a:latin typeface="Calibri" pitchFamily="34" charset="0"/>
+                <a:ea typeface="Calibri" pitchFamily="34" charset="-122"/>
+                <a:cs typeface="Calibri" pitchFamily="34" charset="-120"/>
+              </a:rPr>
+              <a:t>CAT 1</a:t>
+            </a:r>
+            <a:endParaRPr lang="en-US" sz="1600" dirty="0"/>
+          </a:p>
+        </p:txBody>
+      </p:sp>
+      <p:sp>
+        <p:nvSpPr>
+          <p:cNvPr id="19" name="Text 17"/>
+          <p:cNvSpPr txBox="1"/>
+          <p:nvPr/>
+        </p:nvSpPr>
+        <p:spPr>
+          <a:xfrm>
+            <a:off x="457200" y="4114800"/>
+            <a:ext cx="1998878" cy="1051560"/>
+          </a:xfrm>
+          <a:prstGeom prst="rect">
+            <a:avLst/>
+          </a:prstGeom>
+          <a:noFill/>
+          <a:ln/>
+        </p:spPr>
+        <p:txBody>
+          <a:bodyPr wrap="square" lIns="0" tIns="0" rIns="0" bIns="0" rtlCol="0" anchor="ctr"/>
+          <a:lstStyle/>
+          <a:p>
+            <a:pPr algn="ctr" indent="0" marL="0">
+              <a:buNone/>
+            </a:pPr>
+            <a:r>
+              <a:rPr lang="en-US" sz="4000" b="1" dirty="0">
+                <a:solidFill>
+                  <a:srgbClr val="FFFFFF"/>
+                </a:solidFill>
+                <a:latin typeface="Calibri" pitchFamily="34" charset="0"/>
+                <a:ea typeface="Calibri" pitchFamily="34" charset="-122"/>
+                <a:cs typeface="Calibri" pitchFamily="34" charset="-120"/>
+              </a:rPr>
+              <a:t>105</a:t>
+            </a:r>
+            <a:endParaRPr lang="en-US" sz="4000" dirty="0"/>
+          </a:p>
+        </p:txBody>
+      </p:sp>
+      <p:sp>
+        <p:nvSpPr>
+          <p:cNvPr id="20" name="Text 18"/>
+          <p:cNvSpPr txBox="1"/>
+          <p:nvPr/>
+        </p:nvSpPr>
+        <p:spPr>
+          <a:xfrm>
+            <a:off x="457200" y="5623560"/>
+            <a:ext cx="1998878" cy="320040"/>
+          </a:xfrm>
+          <a:prstGeom prst="rect">
+            <a:avLst/>
+          </a:prstGeom>
+          <a:noFill/>
+          <a:ln/>
+        </p:spPr>
+        <p:txBody>
+          <a:bodyPr wrap="square" lIns="0" tIns="0" rIns="0" bIns="0" rtlCol="0" anchor="ctr"/>
+          <a:lstStyle/>
+          <a:p>
+            <a:pPr algn="ctr" indent="0" marL="0">
+              <a:buNone/>
+            </a:pPr>
+            <a:r>
+              <a:rPr lang="en-US" sz="1250" dirty="0">
+                <a:solidFill>
+                  <a:srgbClr val="FFFFFF"/>
+                </a:solidFill>
+                <a:latin typeface="Calibri" pitchFamily="34" charset="0"/>
+                <a:ea typeface="Calibri" pitchFamily="34" charset="-122"/>
+                <a:cs typeface="Calibri" pitchFamily="34" charset="-120"/>
+              </a:rPr>
+              <a:t>4,5% do painel</a:t>
+            </a:r>
+            <a:endParaRPr lang="en-US" sz="1250" dirty="0"/>
+          </a:p>
+        </p:txBody>
+      </p:sp>
+      <p:sp>
+        <p:nvSpPr>
+          <p:cNvPr id="21" name="Shape 19"/>
+          <p:cNvSpPr/>
+          <p:nvPr/>
+        </p:nvSpPr>
+        <p:spPr>
+          <a:xfrm>
+            <a:off x="2684678" y="3246120"/>
+            <a:ext cx="2181758" cy="2880360"/>
+          </a:xfrm>
+          <a:prstGeom prst="roundRect">
+            <a:avLst>
+              <a:gd name="adj" fmla="val 3353"/>
+            </a:avLst>
+          </a:prstGeom>
+          <a:solidFill>
+            <a:srgbClr val="F3A712"/>
+          </a:solidFill>
+          <a:ln/>
+          <a:effectLst>
+            <a:outerShdw sx="100000" sy="100000" kx="0" ky="0" algn="bl" rotWithShape="0" blurRad="76200" dist="25400" dir="5400000">
+              <a:srgbClr val="000000">
+                <a:alpha val="18000"/>
+              </a:srgbClr>
+            </a:outerShdw>
+          </a:effectLst>
+        </p:spPr>
+      </p:sp>
+      <p:sp>
+        <p:nvSpPr>
+          <p:cNvPr id="22" name="Text 20"/>
+          <p:cNvSpPr txBox="1"/>
+          <p:nvPr/>
+        </p:nvSpPr>
+        <p:spPr>
+          <a:xfrm>
+            <a:off x="2794406" y="3429000"/>
+            <a:ext cx="1962302" cy="365760"/>
+          </a:xfrm>
+          <a:prstGeom prst="rect">
+            <a:avLst/>
+          </a:prstGeom>
+          <a:noFill/>
+          <a:ln/>
+        </p:spPr>
+        <p:txBody>
+          <a:bodyPr wrap="square" lIns="0" tIns="0" rIns="0" bIns="0" rtlCol="0" anchor="ctr"/>
+          <a:lstStyle/>
+          <a:p>
+            <a:pPr algn="l" indent="0" marL="0">
+              <a:buNone/>
+            </a:pPr>
+            <a:r>
+              <a:rPr lang="en-US" sz="1600" b="1" dirty="0">
+                <a:solidFill>
+                  <a:srgbClr val="FFFFFF"/>
+                </a:solidFill>
+                <a:latin typeface="Calibri" pitchFamily="34" charset="0"/>
+                <a:ea typeface="Calibri" pitchFamily="34" charset="-122"/>
+                <a:cs typeface="Calibri" pitchFamily="34" charset="-120"/>
+              </a:rPr>
+              <a:t>CAT 2</a:t>
+            </a:r>
+            <a:endParaRPr lang="en-US" sz="1600" dirty="0"/>
+          </a:p>
+        </p:txBody>
+      </p:sp>
+      <p:sp>
+        <p:nvSpPr>
+          <p:cNvPr id="23" name="Text 21"/>
+          <p:cNvSpPr txBox="1"/>
+          <p:nvPr/>
+        </p:nvSpPr>
+        <p:spPr>
+          <a:xfrm>
+            <a:off x="2776118" y="4114800"/>
+            <a:ext cx="1998878" cy="1051560"/>
+          </a:xfrm>
+          <a:prstGeom prst="rect">
+            <a:avLst/>
+          </a:prstGeom>
+          <a:noFill/>
+          <a:ln/>
+        </p:spPr>
+        <p:txBody>
+          <a:bodyPr wrap="square" lIns="0" tIns="0" rIns="0" bIns="0" rtlCol="0" anchor="ctr"/>
+          <a:lstStyle/>
+          <a:p>
+            <a:pPr algn="ctr" indent="0" marL="0">
+              <a:buNone/>
+            </a:pPr>
+            <a:r>
+              <a:rPr lang="en-US" sz="4000" b="1" dirty="0">
+                <a:solidFill>
+                  <a:srgbClr val="FFFFFF"/>
+                </a:solidFill>
+                <a:latin typeface="Calibri" pitchFamily="34" charset="0"/>
+                <a:ea typeface="Calibri" pitchFamily="34" charset="-122"/>
+                <a:cs typeface="Calibri" pitchFamily="34" charset="-120"/>
+              </a:rPr>
+              <a:t>224</a:t>
+            </a:r>
+            <a:endParaRPr lang="en-US" sz="4000" dirty="0"/>
+          </a:p>
+        </p:txBody>
+      </p:sp>
+      <p:sp>
+        <p:nvSpPr>
+          <p:cNvPr id="24" name="Text 22"/>
+          <p:cNvSpPr txBox="1"/>
+          <p:nvPr/>
+        </p:nvSpPr>
+        <p:spPr>
+          <a:xfrm>
+            <a:off x="2776118" y="5623560"/>
+            <a:ext cx="1998878" cy="320040"/>
+          </a:xfrm>
+          <a:prstGeom prst="rect">
+            <a:avLst/>
+          </a:prstGeom>
+          <a:noFill/>
+          <a:ln/>
+        </p:spPr>
+        <p:txBody>
+          <a:bodyPr wrap="square" lIns="0" tIns="0" rIns="0" bIns="0" rtlCol="0" anchor="ctr"/>
+          <a:lstStyle/>
+          <a:p>
+            <a:pPr algn="ctr" indent="0" marL="0">
+              <a:buNone/>
+            </a:pPr>
+            <a:r>
+              <a:rPr lang="en-US" sz="1250" dirty="0">
+                <a:solidFill>
+                  <a:srgbClr val="FFFFFF"/>
+                </a:solidFill>
+                <a:latin typeface="Calibri" pitchFamily="34" charset="0"/>
+                <a:ea typeface="Calibri" pitchFamily="34" charset="-122"/>
+                <a:cs typeface="Calibri" pitchFamily="34" charset="-120"/>
+              </a:rPr>
+              <a:t>9,6% do painel</a:t>
+            </a:r>
+            <a:endParaRPr lang="en-US" sz="1250" dirty="0"/>
+          </a:p>
+        </p:txBody>
+      </p:sp>
+      <p:sp>
+        <p:nvSpPr>
+          <p:cNvPr id="25" name="Shape 23"/>
+          <p:cNvSpPr/>
+          <p:nvPr/>
+        </p:nvSpPr>
+        <p:spPr>
+          <a:xfrm>
+            <a:off x="5003597" y="3246120"/>
+            <a:ext cx="2181758" cy="2880360"/>
+          </a:xfrm>
+          <a:prstGeom prst="roundRect">
+            <a:avLst>
+              <a:gd name="adj" fmla="val 3353"/>
+            </a:avLst>
+          </a:prstGeom>
+          <a:solidFill>
+            <a:srgbClr val="2A9D8F"/>
+          </a:solidFill>
+          <a:ln/>
+          <a:effectLst>
+            <a:outerShdw sx="100000" sy="100000" kx="0" ky="0" algn="bl" rotWithShape="0" blurRad="76200" dist="25400" dir="5400000">
+              <a:srgbClr val="000000">
+                <a:alpha val="18000"/>
+              </a:srgbClr>
+            </a:outerShdw>
+          </a:effectLst>
+        </p:spPr>
+      </p:sp>
+      <p:sp>
+        <p:nvSpPr>
+          <p:cNvPr id="26" name="Text 24"/>
+          <p:cNvSpPr txBox="1"/>
+          <p:nvPr/>
+        </p:nvSpPr>
+        <p:spPr>
+          <a:xfrm>
+            <a:off x="5113325" y="3429000"/>
+            <a:ext cx="1962302" cy="365760"/>
+          </a:xfrm>
+          <a:prstGeom prst="rect">
+            <a:avLst/>
+          </a:prstGeom>
+          <a:noFill/>
+          <a:ln/>
+        </p:spPr>
+        <p:txBody>
+          <a:bodyPr wrap="square" lIns="0" tIns="0" rIns="0" bIns="0" rtlCol="0" anchor="ctr"/>
+          <a:lstStyle/>
+          <a:p>
+            <a:pPr algn="l" indent="0" marL="0">
+              <a:buNone/>
+            </a:pPr>
+            <a:r>
+              <a:rPr lang="en-US" sz="1600" b="1" dirty="0">
+                <a:solidFill>
+                  <a:srgbClr val="FFFFFF"/>
+                </a:solidFill>
+                <a:latin typeface="Calibri" pitchFamily="34" charset="0"/>
+                <a:ea typeface="Calibri" pitchFamily="34" charset="-122"/>
+                <a:cs typeface="Calibri" pitchFamily="34" charset="-120"/>
+              </a:rPr>
+              <a:t>CAT 3</a:t>
+            </a:r>
+            <a:endParaRPr lang="en-US" sz="1600" dirty="0"/>
+          </a:p>
+        </p:txBody>
+      </p:sp>
+      <p:sp>
+        <p:nvSpPr>
+          <p:cNvPr id="27" name="Text 25"/>
+          <p:cNvSpPr txBox="1"/>
+          <p:nvPr/>
+        </p:nvSpPr>
+        <p:spPr>
+          <a:xfrm>
+            <a:off x="5095037" y="4114800"/>
+            <a:ext cx="1998878" cy="1051560"/>
+          </a:xfrm>
+          <a:prstGeom prst="rect">
+            <a:avLst/>
+          </a:prstGeom>
+          <a:noFill/>
+          <a:ln/>
+        </p:spPr>
+        <p:txBody>
+          <a:bodyPr wrap="square" lIns="0" tIns="0" rIns="0" bIns="0" rtlCol="0" anchor="ctr"/>
+          <a:lstStyle/>
+          <a:p>
+            <a:pPr algn="ctr" indent="0" marL="0">
+              <a:buNone/>
+            </a:pPr>
+            <a:r>
+              <a:rPr lang="en-US" sz="4000" b="1" dirty="0">
+                <a:solidFill>
+                  <a:srgbClr val="FFFFFF"/>
+                </a:solidFill>
+                <a:latin typeface="Calibri" pitchFamily="34" charset="0"/>
+                <a:ea typeface="Calibri" pitchFamily="34" charset="-122"/>
+                <a:cs typeface="Calibri" pitchFamily="34" charset="-120"/>
+              </a:rPr>
+              <a:t>351</a:t>
+            </a:r>
+            <a:endParaRPr lang="en-US" sz="4000" dirty="0"/>
+          </a:p>
+        </p:txBody>
+      </p:sp>
+      <p:sp>
+        <p:nvSpPr>
+          <p:cNvPr id="28" name="Text 26"/>
+          <p:cNvSpPr txBox="1"/>
+          <p:nvPr/>
+        </p:nvSpPr>
+        <p:spPr>
+          <a:xfrm>
+            <a:off x="5095037" y="5623560"/>
+            <a:ext cx="1998878" cy="320040"/>
+          </a:xfrm>
+          <a:prstGeom prst="rect">
+            <a:avLst/>
+          </a:prstGeom>
+          <a:noFill/>
+          <a:ln/>
+        </p:spPr>
+        <p:txBody>
+          <a:bodyPr wrap="square" lIns="0" tIns="0" rIns="0" bIns="0" rtlCol="0" anchor="ctr"/>
+          <a:lstStyle/>
+          <a:p>
+            <a:pPr algn="ctr" indent="0" marL="0">
+              <a:buNone/>
+            </a:pPr>
+            <a:r>
+              <a:rPr lang="en-US" sz="1250" dirty="0">
+                <a:solidFill>
+                  <a:srgbClr val="FFFFFF"/>
+                </a:solidFill>
+                <a:latin typeface="Calibri" pitchFamily="34" charset="0"/>
+                <a:ea typeface="Calibri" pitchFamily="34" charset="-122"/>
+                <a:cs typeface="Calibri" pitchFamily="34" charset="-120"/>
+              </a:rPr>
+              <a:t>15,0% do painel</a:t>
+            </a:r>
+            <a:endParaRPr lang="en-US" sz="1250" dirty="0"/>
+          </a:p>
+        </p:txBody>
+      </p:sp>
+      <p:sp>
+        <p:nvSpPr>
+          <p:cNvPr id="29" name="Shape 27"/>
+          <p:cNvSpPr/>
+          <p:nvPr/>
+        </p:nvSpPr>
+        <p:spPr>
+          <a:xfrm>
+            <a:off x="7322515" y="3246120"/>
+            <a:ext cx="2181758" cy="2880360"/>
+          </a:xfrm>
+          <a:prstGeom prst="roundRect">
+            <a:avLst>
+              <a:gd name="adj" fmla="val 3353"/>
+            </a:avLst>
+          </a:prstGeom>
+          <a:solidFill>
+            <a:srgbClr val="6A4C93"/>
+          </a:solidFill>
+          <a:ln/>
+          <a:effectLst>
+            <a:outerShdw sx="100000" sy="100000" kx="0" ky="0" algn="bl" rotWithShape="0" blurRad="76200" dist="25400" dir="5400000">
+              <a:srgbClr val="000000">
+                <a:alpha val="18000"/>
+              </a:srgbClr>
+            </a:outerShdw>
+          </a:effectLst>
+        </p:spPr>
+      </p:sp>
+      <p:sp>
+        <p:nvSpPr>
+          <p:cNvPr id="30" name="Text 28"/>
+          <p:cNvSpPr txBox="1"/>
+          <p:nvPr/>
+        </p:nvSpPr>
+        <p:spPr>
+          <a:xfrm>
+            <a:off x="7432243" y="3429000"/>
+            <a:ext cx="1962302" cy="365760"/>
+          </a:xfrm>
+          <a:prstGeom prst="rect">
+            <a:avLst/>
+          </a:prstGeom>
+          <a:noFill/>
+          <a:ln/>
+        </p:spPr>
+        <p:txBody>
+          <a:bodyPr wrap="square" lIns="0" tIns="0" rIns="0" bIns="0" rtlCol="0" anchor="ctr"/>
+          <a:lstStyle/>
+          <a:p>
+            <a:pPr algn="l" indent="0" marL="0">
+              <a:buNone/>
+            </a:pPr>
+            <a:r>
+              <a:rPr lang="en-US" sz="1600" b="1" dirty="0">
+                <a:solidFill>
+                  <a:srgbClr val="FFFFFF"/>
+                </a:solidFill>
+                <a:latin typeface="Calibri" pitchFamily="34" charset="0"/>
+                <a:ea typeface="Calibri" pitchFamily="34" charset="-122"/>
+                <a:cs typeface="Calibri" pitchFamily="34" charset="-120"/>
+              </a:rPr>
+              <a:t>CAT 4</a:t>
+            </a:r>
+            <a:endParaRPr lang="en-US" sz="1600" dirty="0"/>
+          </a:p>
+        </p:txBody>
+      </p:sp>
+      <p:sp>
+        <p:nvSpPr>
+          <p:cNvPr id="31" name="Text 29"/>
+          <p:cNvSpPr txBox="1"/>
+          <p:nvPr/>
+        </p:nvSpPr>
+        <p:spPr>
+          <a:xfrm>
+            <a:off x="7413955" y="4114800"/>
+            <a:ext cx="1998878" cy="1051560"/>
+          </a:xfrm>
+          <a:prstGeom prst="rect">
+            <a:avLst/>
+          </a:prstGeom>
+          <a:noFill/>
+          <a:ln/>
+        </p:spPr>
+        <p:txBody>
+          <a:bodyPr wrap="square" lIns="0" tIns="0" rIns="0" bIns="0" rtlCol="0" anchor="ctr"/>
+          <a:lstStyle/>
+          <a:p>
+            <a:pPr algn="ctr" indent="0" marL="0">
+              <a:buNone/>
+            </a:pPr>
+            <a:r>
+              <a:rPr lang="en-US" sz="4000" b="1" dirty="0">
+                <a:solidFill>
+                  <a:srgbClr val="FFFFFF"/>
+                </a:solidFill>
+                <a:latin typeface="Calibri" pitchFamily="34" charset="0"/>
+                <a:ea typeface="Calibri" pitchFamily="34" charset="-122"/>
+                <a:cs typeface="Calibri" pitchFamily="34" charset="-120"/>
+              </a:rPr>
+              <a:t>617</a:t>
+            </a:r>
+            <a:endParaRPr lang="en-US" sz="4000" dirty="0"/>
+          </a:p>
+        </p:txBody>
+      </p:sp>
+      <p:sp>
+        <p:nvSpPr>
+          <p:cNvPr id="32" name="Text 30"/>
+          <p:cNvSpPr txBox="1"/>
+          <p:nvPr/>
+        </p:nvSpPr>
+        <p:spPr>
+          <a:xfrm>
+            <a:off x="7413955" y="5623560"/>
+            <a:ext cx="1998878" cy="320040"/>
+          </a:xfrm>
+          <a:prstGeom prst="rect">
+            <a:avLst/>
+          </a:prstGeom>
+          <a:noFill/>
+          <a:ln/>
+        </p:spPr>
+        <p:txBody>
+          <a:bodyPr wrap="square" lIns="0" tIns="0" rIns="0" bIns="0" rtlCol="0" anchor="ctr"/>
+          <a:lstStyle/>
+          <a:p>
+            <a:pPr algn="ctr" indent="0" marL="0">
+              <a:buNone/>
+            </a:pPr>
+            <a:r>
+              <a:rPr lang="en-US" sz="1250" dirty="0">
+                <a:solidFill>
+                  <a:srgbClr val="FFFFFF"/>
+                </a:solidFill>
+                <a:latin typeface="Calibri" pitchFamily="34" charset="0"/>
+                <a:ea typeface="Calibri" pitchFamily="34" charset="-122"/>
+                <a:cs typeface="Calibri" pitchFamily="34" charset="-120"/>
+              </a:rPr>
+              <a:t>26,3% do painel</a:t>
+            </a:r>
+            <a:endParaRPr lang="en-US" sz="1250" dirty="0"/>
+          </a:p>
+        </p:txBody>
+      </p:sp>
+      <p:sp>
+        <p:nvSpPr>
+          <p:cNvPr id="33" name="Shape 31"/>
+          <p:cNvSpPr/>
+          <p:nvPr/>
+        </p:nvSpPr>
+        <p:spPr>
+          <a:xfrm>
+            <a:off x="9641434" y="3246120"/>
+            <a:ext cx="2181758" cy="2880360"/>
+          </a:xfrm>
+          <a:prstGeom prst="roundRect">
+            <a:avLst>
+              <a:gd name="adj" fmla="val 3353"/>
+            </a:avLst>
+          </a:prstGeom>
+          <a:solidFill>
+            <a:srgbClr val="52B788"/>
+          </a:solidFill>
+          <a:ln/>
+          <a:effectLst>
+            <a:outerShdw sx="100000" sy="100000" kx="0" ky="0" algn="bl" rotWithShape="0" blurRad="76200" dist="25400" dir="5400000">
+              <a:srgbClr val="000000">
+                <a:alpha val="18000"/>
+              </a:srgbClr>
+            </a:outerShdw>
+          </a:effectLst>
+        </p:spPr>
+      </p:sp>
+      <p:sp>
+        <p:nvSpPr>
+          <p:cNvPr id="34" name="Text 32"/>
+          <p:cNvSpPr txBox="1"/>
+          <p:nvPr/>
+        </p:nvSpPr>
+        <p:spPr>
+          <a:xfrm>
+            <a:off x="9751162" y="3429000"/>
+            <a:ext cx="1962302" cy="365760"/>
+          </a:xfrm>
+          <a:prstGeom prst="rect">
+            <a:avLst/>
+          </a:prstGeom>
+          <a:noFill/>
+          <a:ln/>
+        </p:spPr>
+        <p:txBody>
+          <a:bodyPr wrap="square" lIns="0" tIns="0" rIns="0" bIns="0" rtlCol="0" anchor="ctr"/>
+          <a:lstStyle/>
+          <a:p>
+            <a:pPr algn="l" indent="0" marL="0">
+              <a:buNone/>
+            </a:pPr>
+            <a:r>
+              <a:rPr lang="en-US" sz="1600" b="1" dirty="0">
+                <a:solidFill>
+                  <a:srgbClr val="FFFFFF"/>
+                </a:solidFill>
+                <a:latin typeface="Calibri" pitchFamily="34" charset="0"/>
+                <a:ea typeface="Calibri" pitchFamily="34" charset="-122"/>
+                <a:cs typeface="Calibri" pitchFamily="34" charset="-120"/>
+              </a:rPr>
+              <a:t>CAT 5</a:t>
+            </a:r>
+            <a:endParaRPr lang="en-US" sz="1600" dirty="0"/>
+          </a:p>
+        </p:txBody>
+      </p:sp>
+      <p:sp>
+        <p:nvSpPr>
+          <p:cNvPr id="35" name="Text 33"/>
+          <p:cNvSpPr txBox="1"/>
+          <p:nvPr/>
+        </p:nvSpPr>
+        <p:spPr>
+          <a:xfrm>
+            <a:off x="9732874" y="4114800"/>
+            <a:ext cx="1998878" cy="1051560"/>
+          </a:xfrm>
+          <a:prstGeom prst="rect">
+            <a:avLst/>
+          </a:prstGeom>
+          <a:noFill/>
+          <a:ln/>
+        </p:spPr>
+        <p:txBody>
+          <a:bodyPr wrap="square" lIns="0" tIns="0" rIns="0" bIns="0" rtlCol="0" anchor="ctr"/>
+          <a:lstStyle/>
+          <a:p>
+            <a:pPr algn="ctr" indent="0" marL="0">
+              <a:buNone/>
+            </a:pPr>
+            <a:r>
+              <a:rPr lang="en-US" sz="4000" b="1" dirty="0">
+                <a:solidFill>
+                  <a:srgbClr val="FFFFFF"/>
+                </a:solidFill>
+                <a:latin typeface="Calibri" pitchFamily="34" charset="0"/>
+                <a:ea typeface="Calibri" pitchFamily="34" charset="-122"/>
+                <a:cs typeface="Calibri" pitchFamily="34" charset="-120"/>
+              </a:rPr>
+              <a:t>1.046</a:t>
+            </a:r>
+            <a:endParaRPr lang="en-US" sz="4000" dirty="0"/>
+          </a:p>
+        </p:txBody>
+      </p:sp>
+      <p:sp>
+        <p:nvSpPr>
+          <p:cNvPr id="36" name="Text 34"/>
+          <p:cNvSpPr txBox="1"/>
+          <p:nvPr/>
+        </p:nvSpPr>
+        <p:spPr>
+          <a:xfrm>
+            <a:off x="9732874" y="5623560"/>
+            <a:ext cx="1998878" cy="320040"/>
+          </a:xfrm>
+          <a:prstGeom prst="rect">
+            <a:avLst/>
+          </a:prstGeom>
+          <a:noFill/>
+          <a:ln/>
+        </p:spPr>
+        <p:txBody>
+          <a:bodyPr wrap="square" lIns="0" tIns="0" rIns="0" bIns="0" rtlCol="0" anchor="ctr"/>
+          <a:lstStyle/>
+          <a:p>
+            <a:pPr algn="ctr" indent="0" marL="0">
+              <a:buNone/>
+            </a:pPr>
+            <a:r>
+              <a:rPr lang="en-US" sz="1250" dirty="0">
+                <a:solidFill>
+                  <a:srgbClr val="FFFFFF"/>
+                </a:solidFill>
+                <a:latin typeface="Calibri" pitchFamily="34" charset="0"/>
+                <a:ea typeface="Calibri" pitchFamily="34" charset="-122"/>
+                <a:cs typeface="Calibri" pitchFamily="34" charset="-120"/>
+              </a:rPr>
+              <a:t>44,6% do painel</a:t>
+            </a:r>
+            <a:endParaRPr lang="en-US" sz="1250" dirty="0"/>
+          </a:p>
+        </p:txBody>
+      </p:sp>
+      <p:sp>
+        <p:nvSpPr>
+          <p:cNvPr id="37" name="Text 35"/>
+          <p:cNvSpPr txBox="1"/>
+          <p:nvPr/>
+        </p:nvSpPr>
+        <p:spPr>
+          <a:xfrm>
+            <a:off x="365760" y="6537960"/>
+            <a:ext cx="11457432" cy="182880"/>
+          </a:xfrm>
+          <a:prstGeom prst="rect">
+            <a:avLst/>
+          </a:prstGeom>
+          <a:noFill/>
+          <a:ln/>
+        </p:spPr>
+        <p:txBody>
+          <a:bodyPr wrap="square" lIns="0" tIns="0" rIns="0" bIns="0" rtlCol="0" anchor="ctr"/>
+          <a:lstStyle/>
+          <a:p>
+            <a:pPr algn="l" indent="0" marL="0">
+              <a:buNone/>
+            </a:pPr>
+            <a:r>
+              <a:rPr lang="en-US" sz="850" i="1" dirty="0">
+                <a:solidFill>
+                  <a:srgbClr val="9AA0A6"/>
+                </a:solidFill>
+                <a:latin typeface="Calibri" pitchFamily="34" charset="0"/>
+                <a:ea typeface="Calibri" pitchFamily="34" charset="-122"/>
+                <a:cs typeface="Calibri" pitchFamily="34" charset="-120"/>
+              </a:rPr>
+              <a:t>Base: 2.551 profissionais cadastrados na planilha, sendo 208 sem CAT classificada (não incluídos no compilado por CAT).</a:t>
             </a:r>
             <a:endParaRPr lang="en-US" sz="850" dirty="0"/>
           </a:p>

</xml_diff>

<commit_message>
Refaz slide 2 com análise de representatividade CAT 1+2+3
Remove os cartões de setores mapeados e cidades atendidas; adiciona
faixa de destaque com a representatividade dos prescritores das
CAT 1, 2 e 3 frente ao total de médicos e de prescritores da distrital.

Co-Authored-By: Claude Sonnet 5 <noreply@anthropic.com>
Claude-Session: https://claude.ai/code/session_01KqmuB8xxfxpvceuypurV9G
</commit_message>
<xml_diff>
--- a/output/painel_medico_distrital_1880.pptx
+++ b/output/painel_medico_distrital_1880.pptx
@@ -11403,12 +11403,12 @@
         </p:nvSpPr>
         <p:spPr>
           <a:xfrm>
-            <a:off x="365760" y="1143000"/>
-            <a:ext cx="2692908" cy="1600200"/>
-          </a:xfrm>
-          <a:prstGeom prst="roundRect">
-            <a:avLst>
-              <a:gd name="adj" fmla="val 4571"/>
+            <a:off x="365760" y="1051560"/>
+            <a:ext cx="3666744" cy="1188720"/>
+          </a:xfrm>
+          <a:prstGeom prst="roundRect">
+            <a:avLst>
+              <a:gd name="adj" fmla="val 6154"/>
             </a:avLst>
           </a:prstGeom>
           <a:solidFill>
@@ -11432,8 +11432,8 @@
         </p:nvSpPr>
         <p:spPr>
           <a:xfrm>
-            <a:off x="365760" y="1344168"/>
-            <a:ext cx="2692908" cy="868680"/>
+            <a:off x="365760" y="1188720"/>
+            <a:ext cx="3666744" cy="594360"/>
           </a:xfrm>
           <a:prstGeom prst="rect">
             <a:avLst/>
@@ -11449,7 +11449,7 @@
               <a:buNone/>
             </a:pPr>
             <a:r>
-              <a:rPr lang="en-US" sz="4600" b="1" dirty="0">
+              <a:rPr lang="en-US" sz="4000" b="1" dirty="0">
                 <a:solidFill>
                   <a:srgbClr val="1D3557"/>
                 </a:solidFill>
@@ -11459,7 +11459,7 @@
               </a:rPr>
               <a:t>2.343</a:t>
             </a:r>
-            <a:endParaRPr lang="en-US" sz="4600" dirty="0"/>
+            <a:endParaRPr lang="en-US" sz="4000" dirty="0"/>
           </a:p>
         </p:txBody>
       </p:sp>
@@ -11471,8 +11471,8 @@
         </p:nvSpPr>
         <p:spPr>
           <a:xfrm>
-            <a:off x="502920" y="2286000"/>
-            <a:ext cx="2418588" cy="365760"/>
+            <a:off x="502920" y="1783080"/>
+            <a:ext cx="3392424" cy="411480"/>
           </a:xfrm>
           <a:prstGeom prst="rect">
             <a:avLst/>
@@ -11488,7 +11488,7 @@
               <a:buNone/>
             </a:pPr>
             <a:r>
-              <a:rPr lang="en-US" sz="1250" dirty="0">
+              <a:rPr lang="en-US" sz="1150" dirty="0">
                 <a:solidFill>
                   <a:srgbClr val="6B7280"/>
                 </a:solidFill>
@@ -11498,7 +11498,7 @@
               </a:rPr>
               <a:t>médicos classificados no painel</a:t>
             </a:r>
-            <a:endParaRPr lang="en-US" sz="1250" dirty="0"/>
+            <a:endParaRPr lang="en-US" sz="1150" dirty="0"/>
           </a:p>
         </p:txBody>
       </p:sp>
@@ -11510,12 +11510,12 @@
         </p:nvSpPr>
         <p:spPr>
           <a:xfrm>
-            <a:off x="3287268" y="1143000"/>
-            <a:ext cx="2692908" cy="1600200"/>
-          </a:xfrm>
-          <a:prstGeom prst="roundRect">
-            <a:avLst>
-              <a:gd name="adj" fmla="val 4571"/>
+            <a:off x="4261104" y="1051560"/>
+            <a:ext cx="3666744" cy="1188720"/>
+          </a:xfrm>
+          <a:prstGeom prst="roundRect">
+            <a:avLst>
+              <a:gd name="adj" fmla="val 6154"/>
             </a:avLst>
           </a:prstGeom>
           <a:solidFill>
@@ -11539,8 +11539,8 @@
         </p:nvSpPr>
         <p:spPr>
           <a:xfrm>
-            <a:off x="3287268" y="1344168"/>
-            <a:ext cx="2692908" cy="868680"/>
+            <a:off x="4261104" y="1188720"/>
+            <a:ext cx="3666744" cy="594360"/>
           </a:xfrm>
           <a:prstGeom prst="rect">
             <a:avLst/>
@@ -11556,7 +11556,7 @@
               <a:buNone/>
             </a:pPr>
             <a:r>
-              <a:rPr lang="en-US" sz="4600" b="1" dirty="0">
+              <a:rPr lang="en-US" sz="4000" b="1" dirty="0">
                 <a:solidFill>
                   <a:srgbClr val="1D3557"/>
                 </a:solidFill>
@@ -11564,9 +11564,9 @@
                 <a:ea typeface="Calibri" pitchFamily="34" charset="-122"/>
                 <a:cs typeface="Calibri" pitchFamily="34" charset="-120"/>
               </a:rPr>
-              <a:t>8</a:t>
-            </a:r>
-            <a:endParaRPr lang="en-US" sz="4600" dirty="0"/>
+              <a:t>79,5%</a:t>
+            </a:r>
+            <a:endParaRPr lang="en-US" sz="4000" dirty="0"/>
           </a:p>
         </p:txBody>
       </p:sp>
@@ -11578,8 +11578,8 @@
         </p:nvSpPr>
         <p:spPr>
           <a:xfrm>
-            <a:off x="3424428" y="2286000"/>
-            <a:ext cx="2418588" cy="365760"/>
+            <a:off x="4398264" y="1783080"/>
+            <a:ext cx="3392424" cy="411480"/>
           </a:xfrm>
           <a:prstGeom prst="rect">
             <a:avLst/>
@@ -11595,7 +11595,7 @@
               <a:buNone/>
             </a:pPr>
             <a:r>
-              <a:rPr lang="en-US" sz="1250" dirty="0">
+              <a:rPr lang="en-US" sz="1150" dirty="0">
                 <a:solidFill>
                   <a:srgbClr val="6B7280"/>
                 </a:solidFill>
@@ -11603,9 +11603,9 @@
                 <a:ea typeface="Calibri" pitchFamily="34" charset="-122"/>
                 <a:cs typeface="Calibri" pitchFamily="34" charset="-120"/>
               </a:rPr>
-              <a:t>setores mapeados</a:t>
-            </a:r>
-            <a:endParaRPr lang="en-US" sz="1250" dirty="0"/>
+              <a:t>do painel já prescrevem EUF (MAT)</a:t>
+            </a:r>
+            <a:endParaRPr lang="en-US" sz="1150" dirty="0"/>
           </a:p>
         </p:txBody>
       </p:sp>
@@ -11617,12 +11617,12 @@
         </p:nvSpPr>
         <p:spPr>
           <a:xfrm>
-            <a:off x="6208776" y="1143000"/>
-            <a:ext cx="2692908" cy="1600200"/>
-          </a:xfrm>
-          <a:prstGeom prst="roundRect">
-            <a:avLst>
-              <a:gd name="adj" fmla="val 4571"/>
+            <a:off x="8156448" y="1051560"/>
+            <a:ext cx="3666744" cy="1188720"/>
+          </a:xfrm>
+          <a:prstGeom prst="roundRect">
+            <a:avLst>
+              <a:gd name="adj" fmla="val 6154"/>
             </a:avLst>
           </a:prstGeom>
           <a:solidFill>
@@ -11646,8 +11646,8 @@
         </p:nvSpPr>
         <p:spPr>
           <a:xfrm>
-            <a:off x="6208776" y="1344168"/>
-            <a:ext cx="2692908" cy="868680"/>
+            <a:off x="8156448" y="1188720"/>
+            <a:ext cx="3666744" cy="594360"/>
           </a:xfrm>
           <a:prstGeom prst="rect">
             <a:avLst/>
@@ -11663,7 +11663,7 @@
               <a:buNone/>
             </a:pPr>
             <a:r>
-              <a:rPr lang="en-US" sz="4600" b="1" dirty="0">
+              <a:rPr lang="en-US" sz="4000" b="1" dirty="0">
                 <a:solidFill>
                   <a:srgbClr val="1D3557"/>
                 </a:solidFill>
@@ -11671,9 +11671,9 @@
                 <a:ea typeface="Calibri" pitchFamily="34" charset="-122"/>
                 <a:cs typeface="Calibri" pitchFamily="34" charset="-120"/>
               </a:rPr>
-              <a:t>64</a:t>
-            </a:r>
-            <a:endParaRPr lang="en-US" sz="4600" dirty="0"/>
+              <a:t>29,0%</a:t>
+            </a:r>
+            <a:endParaRPr lang="en-US" sz="4000" dirty="0"/>
           </a:p>
         </p:txBody>
       </p:sp>
@@ -11685,8 +11685,8 @@
         </p:nvSpPr>
         <p:spPr>
           <a:xfrm>
-            <a:off x="6345936" y="2286000"/>
-            <a:ext cx="2418588" cy="365760"/>
+            <a:off x="8293608" y="1783080"/>
+            <a:ext cx="3392424" cy="411480"/>
           </a:xfrm>
           <a:prstGeom prst="rect">
             <a:avLst/>
@@ -11702,7 +11702,7 @@
               <a:buNone/>
             </a:pPr>
             <a:r>
-              <a:rPr lang="en-US" sz="1250" dirty="0">
+              <a:rPr lang="en-US" sz="1150" dirty="0">
                 <a:solidFill>
                   <a:srgbClr val="6B7280"/>
                 </a:solidFill>
@@ -11710,67 +11710,38 @@
                 <a:ea typeface="Calibri" pitchFamily="34" charset="-122"/>
                 <a:cs typeface="Calibri" pitchFamily="34" charset="-120"/>
               </a:rPr>
-              <a:t>cidades atendidas</a:t>
-            </a:r>
-            <a:endParaRPr lang="en-US" sz="1250" dirty="0"/>
-          </a:p>
-        </p:txBody>
-      </p:sp>
-      <p:sp>
-        <p:nvSpPr>
-          <p:cNvPr id="13" name="Shape 11"/>
-          <p:cNvSpPr/>
-          <p:nvPr/>
-        </p:nvSpPr>
-        <p:spPr>
-          <a:xfrm>
-            <a:off x="9130284" y="1143000"/>
-            <a:ext cx="2692908" cy="1600200"/>
-          </a:xfrm>
-          <a:prstGeom prst="roundRect">
-            <a:avLst>
-              <a:gd name="adj" fmla="val 4571"/>
-            </a:avLst>
-          </a:prstGeom>
-          <a:solidFill>
-            <a:srgbClr val="F5F6F8"/>
-          </a:solidFill>
-          <a:ln/>
-          <a:effectLst>
-            <a:outerShdw sx="100000" sy="100000" kx="0" ky="0" algn="bl" rotWithShape="0" blurRad="76200" dist="25400" dir="5400000">
-              <a:srgbClr val="000000">
-                <a:alpha val="12000"/>
-              </a:srgbClr>
-            </a:outerShdw>
-          </a:effectLst>
-        </p:spPr>
-      </p:sp>
-      <p:sp>
-        <p:nvSpPr>
-          <p:cNvPr id="14" name="Text 12"/>
-          <p:cNvSpPr txBox="1"/>
-          <p:nvPr/>
-        </p:nvSpPr>
-        <p:spPr>
-          <a:xfrm>
-            <a:off x="9130284" y="1344168"/>
-            <a:ext cx="2692908" cy="868680"/>
-          </a:xfrm>
-          <a:prstGeom prst="rect">
-            <a:avLst/>
-          </a:prstGeom>
-          <a:noFill/>
-          <a:ln/>
-        </p:spPr>
-        <p:txBody>
-          <a:bodyPr wrap="square" lIns="0" tIns="0" rIns="0" bIns="0" rtlCol="0" anchor="ctr"/>
-          <a:lstStyle/>
-          <a:p>
-            <a:pPr algn="ctr" indent="0" marL="0">
-              <a:buNone/>
-            </a:pPr>
-            <a:r>
-              <a:rPr lang="en-US" sz="4600" b="1" dirty="0">
+              <a:t>do painel são CAT 1, 2 ou 3 (680 médicos)</a:t>
+            </a:r>
+            <a:endParaRPr lang="en-US" sz="1150" dirty="0"/>
+          </a:p>
+        </p:txBody>
+      </p:sp>
+      <p:sp>
+        <p:nvSpPr>
+          <p:cNvPr id="13" name="Text 11"/>
+          <p:cNvSpPr txBox="1"/>
+          <p:nvPr/>
+        </p:nvSpPr>
+        <p:spPr>
+          <a:xfrm>
+            <a:off x="365760" y="2350008"/>
+            <a:ext cx="11457432" cy="274320"/>
+          </a:xfrm>
+          <a:prstGeom prst="rect">
+            <a:avLst/>
+          </a:prstGeom>
+          <a:noFill/>
+          <a:ln/>
+        </p:spPr>
+        <p:txBody>
+          <a:bodyPr wrap="square" lIns="0" tIns="0" rIns="0" bIns="0" rtlCol="0" anchor="ctr"/>
+          <a:lstStyle/>
+          <a:p>
+            <a:pPr algn="l" indent="0" marL="0">
+              <a:buNone/>
+            </a:pPr>
+            <a:r>
+              <a:rPr lang="en-US" sz="1500" b="1" dirty="0">
                 <a:solidFill>
                   <a:srgbClr val="1D3557"/>
                 </a:solidFill>
@@ -11778,84 +11749,6 @@
                 <a:ea typeface="Calibri" pitchFamily="34" charset="-122"/>
                 <a:cs typeface="Calibri" pitchFamily="34" charset="-120"/>
               </a:rPr>
-              <a:t>79,5%</a:t>
-            </a:r>
-            <a:endParaRPr lang="en-US" sz="4600" dirty="0"/>
-          </a:p>
-        </p:txBody>
-      </p:sp>
-      <p:sp>
-        <p:nvSpPr>
-          <p:cNvPr id="15" name="Text 13"/>
-          <p:cNvSpPr txBox="1"/>
-          <p:nvPr/>
-        </p:nvSpPr>
-        <p:spPr>
-          <a:xfrm>
-            <a:off x="9267444" y="2286000"/>
-            <a:ext cx="2418588" cy="365760"/>
-          </a:xfrm>
-          <a:prstGeom prst="rect">
-            <a:avLst/>
-          </a:prstGeom>
-          <a:noFill/>
-          <a:ln/>
-        </p:spPr>
-        <p:txBody>
-          <a:bodyPr wrap="square" lIns="0" tIns="0" rIns="0" bIns="0" rtlCol="0" anchor="t"/>
-          <a:lstStyle/>
-          <a:p>
-            <a:pPr algn="ctr" indent="0" marL="0">
-              <a:buNone/>
-            </a:pPr>
-            <a:r>
-              <a:rPr lang="en-US" sz="1250" dirty="0">
-                <a:solidFill>
-                  <a:srgbClr val="6B7280"/>
-                </a:solidFill>
-                <a:latin typeface="Calibri" pitchFamily="34" charset="0"/>
-                <a:ea typeface="Calibri" pitchFamily="34" charset="-122"/>
-                <a:cs typeface="Calibri" pitchFamily="34" charset="-120"/>
-              </a:rPr>
-              <a:t>prescrevem EUF (MAT)</a:t>
-            </a:r>
-            <a:endParaRPr lang="en-US" sz="1250" dirty="0"/>
-          </a:p>
-        </p:txBody>
-      </p:sp>
-      <p:sp>
-        <p:nvSpPr>
-          <p:cNvPr id="16" name="Text 14"/>
-          <p:cNvSpPr txBox="1"/>
-          <p:nvPr/>
-        </p:nvSpPr>
-        <p:spPr>
-          <a:xfrm>
-            <a:off x="365760" y="2880360"/>
-            <a:ext cx="11457432" cy="274320"/>
-          </a:xfrm>
-          <a:prstGeom prst="rect">
-            <a:avLst/>
-          </a:prstGeom>
-          <a:noFill/>
-          <a:ln/>
-        </p:spPr>
-        <p:txBody>
-          <a:bodyPr wrap="square" lIns="0" tIns="0" rIns="0" bIns="0" rtlCol="0" anchor="ctr"/>
-          <a:lstStyle/>
-          <a:p>
-            <a:pPr algn="l" indent="0" marL="0">
-              <a:buNone/>
-            </a:pPr>
-            <a:r>
-              <a:rPr lang="en-US" sz="1500" b="1" dirty="0">
-                <a:solidFill>
-                  <a:srgbClr val="1D3557"/>
-                </a:solidFill>
-                <a:latin typeface="Calibri" pitchFamily="34" charset="0"/>
-                <a:ea typeface="Calibri" pitchFamily="34" charset="-122"/>
-                <a:cs typeface="Calibri" pitchFamily="34" charset="-120"/>
-              </a:rPr>
               <a:t>Distribuição por CAT</a:t>
             </a:r>
             <a:endParaRPr lang="en-US" sz="1500" dirty="0"/>
@@ -11864,14 +11757,14 @@
       </p:sp>
       <p:sp>
         <p:nvSpPr>
-          <p:cNvPr id="17" name="Shape 15"/>
-          <p:cNvSpPr/>
-          <p:nvPr/>
-        </p:nvSpPr>
-        <p:spPr>
-          <a:xfrm>
-            <a:off x="365760" y="3246120"/>
-            <a:ext cx="2181758" cy="2880360"/>
+          <p:cNvPr id="14" name="Shape 12"/>
+          <p:cNvSpPr/>
+          <p:nvPr/>
+        </p:nvSpPr>
+        <p:spPr>
+          <a:xfrm>
+            <a:off x="365760" y="2697480"/>
+            <a:ext cx="2181758" cy="2286000"/>
           </a:xfrm>
           <a:prstGeom prst="roundRect">
             <a:avLst>
@@ -11893,14 +11786,14 @@
       </p:sp>
       <p:sp>
         <p:nvSpPr>
-          <p:cNvPr id="18" name="Text 16"/>
-          <p:cNvSpPr txBox="1"/>
-          <p:nvPr/>
-        </p:nvSpPr>
-        <p:spPr>
-          <a:xfrm>
-            <a:off x="475488" y="3429000"/>
-            <a:ext cx="1962302" cy="365760"/>
+          <p:cNvPr id="15" name="Text 13"/>
+          <p:cNvSpPr txBox="1"/>
+          <p:nvPr/>
+        </p:nvSpPr>
+        <p:spPr>
+          <a:xfrm>
+            <a:off x="475488" y="2843784"/>
+            <a:ext cx="1962302" cy="320040"/>
           </a:xfrm>
           <a:prstGeom prst="rect">
             <a:avLst/>
@@ -11916,7 +11809,7 @@
               <a:buNone/>
             </a:pPr>
             <a:r>
-              <a:rPr lang="en-US" sz="1600" b="1" dirty="0">
+              <a:rPr lang="en-US" sz="1500" b="1" dirty="0">
                 <a:solidFill>
                   <a:srgbClr val="FFFFFF"/>
                 </a:solidFill>
@@ -11926,20 +11819,20 @@
               </a:rPr>
               <a:t>CAT 1</a:t>
             </a:r>
-            <a:endParaRPr lang="en-US" sz="1600" dirty="0"/>
-          </a:p>
-        </p:txBody>
-      </p:sp>
-      <p:sp>
-        <p:nvSpPr>
-          <p:cNvPr id="19" name="Text 17"/>
-          <p:cNvSpPr txBox="1"/>
-          <p:nvPr/>
-        </p:nvSpPr>
-        <p:spPr>
-          <a:xfrm>
-            <a:off x="457200" y="4114800"/>
-            <a:ext cx="1998878" cy="1051560"/>
+            <a:endParaRPr lang="en-US" sz="1500" dirty="0"/>
+          </a:p>
+        </p:txBody>
+      </p:sp>
+      <p:sp>
+        <p:nvSpPr>
+          <p:cNvPr id="16" name="Text 14"/>
+          <p:cNvSpPr txBox="1"/>
+          <p:nvPr/>
+        </p:nvSpPr>
+        <p:spPr>
+          <a:xfrm>
+            <a:off x="457200" y="3319272"/>
+            <a:ext cx="1998878" cy="822960"/>
           </a:xfrm>
           <a:prstGeom prst="rect">
             <a:avLst/>
@@ -11955,7 +11848,7 @@
               <a:buNone/>
             </a:pPr>
             <a:r>
-              <a:rPr lang="en-US" sz="4000" b="1" dirty="0">
+              <a:rPr lang="en-US" sz="3200" b="1" dirty="0">
                 <a:solidFill>
                   <a:srgbClr val="FFFFFF"/>
                 </a:solidFill>
@@ -11965,20 +11858,20 @@
               </a:rPr>
               <a:t>105</a:t>
             </a:r>
-            <a:endParaRPr lang="en-US" sz="4000" dirty="0"/>
-          </a:p>
-        </p:txBody>
-      </p:sp>
-      <p:sp>
-        <p:nvSpPr>
-          <p:cNvPr id="20" name="Text 18"/>
-          <p:cNvSpPr txBox="1"/>
-          <p:nvPr/>
-        </p:nvSpPr>
-        <p:spPr>
-          <a:xfrm>
-            <a:off x="457200" y="5623560"/>
-            <a:ext cx="1998878" cy="320040"/>
+            <a:endParaRPr lang="en-US" sz="3200" dirty="0"/>
+          </a:p>
+        </p:txBody>
+      </p:sp>
+      <p:sp>
+        <p:nvSpPr>
+          <p:cNvPr id="17" name="Text 15"/>
+          <p:cNvSpPr txBox="1"/>
+          <p:nvPr/>
+        </p:nvSpPr>
+        <p:spPr>
+          <a:xfrm>
+            <a:off x="457200" y="4572000"/>
+            <a:ext cx="1998878" cy="274320"/>
           </a:xfrm>
           <a:prstGeom prst="rect">
             <a:avLst/>
@@ -11994,7 +11887,7 @@
               <a:buNone/>
             </a:pPr>
             <a:r>
-              <a:rPr lang="en-US" sz="1250" dirty="0">
+              <a:rPr lang="en-US" sz="1100" dirty="0">
                 <a:solidFill>
                   <a:srgbClr val="FFFFFF"/>
                 </a:solidFill>
@@ -12004,20 +11897,20 @@
               </a:rPr>
               <a:t>4,5% do painel</a:t>
             </a:r>
-            <a:endParaRPr lang="en-US" sz="1250" dirty="0"/>
-          </a:p>
-        </p:txBody>
-      </p:sp>
-      <p:sp>
-        <p:nvSpPr>
-          <p:cNvPr id="21" name="Shape 19"/>
-          <p:cNvSpPr/>
-          <p:nvPr/>
-        </p:nvSpPr>
-        <p:spPr>
-          <a:xfrm>
-            <a:off x="2684678" y="3246120"/>
-            <a:ext cx="2181758" cy="2880360"/>
+            <a:endParaRPr lang="en-US" sz="1100" dirty="0"/>
+          </a:p>
+        </p:txBody>
+      </p:sp>
+      <p:sp>
+        <p:nvSpPr>
+          <p:cNvPr id="18" name="Shape 16"/>
+          <p:cNvSpPr/>
+          <p:nvPr/>
+        </p:nvSpPr>
+        <p:spPr>
+          <a:xfrm>
+            <a:off x="2684678" y="2697480"/>
+            <a:ext cx="2181758" cy="2286000"/>
           </a:xfrm>
           <a:prstGeom prst="roundRect">
             <a:avLst>
@@ -12039,14 +11932,14 @@
       </p:sp>
       <p:sp>
         <p:nvSpPr>
-          <p:cNvPr id="22" name="Text 20"/>
-          <p:cNvSpPr txBox="1"/>
-          <p:nvPr/>
-        </p:nvSpPr>
-        <p:spPr>
-          <a:xfrm>
-            <a:off x="2794406" y="3429000"/>
-            <a:ext cx="1962302" cy="365760"/>
+          <p:cNvPr id="19" name="Text 17"/>
+          <p:cNvSpPr txBox="1"/>
+          <p:nvPr/>
+        </p:nvSpPr>
+        <p:spPr>
+          <a:xfrm>
+            <a:off x="2794406" y="2843784"/>
+            <a:ext cx="1962302" cy="320040"/>
           </a:xfrm>
           <a:prstGeom prst="rect">
             <a:avLst/>
@@ -12062,7 +11955,7 @@
               <a:buNone/>
             </a:pPr>
             <a:r>
-              <a:rPr lang="en-US" sz="1600" b="1" dirty="0">
+              <a:rPr lang="en-US" sz="1500" b="1" dirty="0">
                 <a:solidFill>
                   <a:srgbClr val="FFFFFF"/>
                 </a:solidFill>
@@ -12072,20 +11965,20 @@
               </a:rPr>
               <a:t>CAT 2</a:t>
             </a:r>
-            <a:endParaRPr lang="en-US" sz="1600" dirty="0"/>
-          </a:p>
-        </p:txBody>
-      </p:sp>
-      <p:sp>
-        <p:nvSpPr>
-          <p:cNvPr id="23" name="Text 21"/>
-          <p:cNvSpPr txBox="1"/>
-          <p:nvPr/>
-        </p:nvSpPr>
-        <p:spPr>
-          <a:xfrm>
-            <a:off x="2776118" y="4114800"/>
-            <a:ext cx="1998878" cy="1051560"/>
+            <a:endParaRPr lang="en-US" sz="1500" dirty="0"/>
+          </a:p>
+        </p:txBody>
+      </p:sp>
+      <p:sp>
+        <p:nvSpPr>
+          <p:cNvPr id="20" name="Text 18"/>
+          <p:cNvSpPr txBox="1"/>
+          <p:nvPr/>
+        </p:nvSpPr>
+        <p:spPr>
+          <a:xfrm>
+            <a:off x="2776118" y="3319272"/>
+            <a:ext cx="1998878" cy="822960"/>
           </a:xfrm>
           <a:prstGeom prst="rect">
             <a:avLst/>
@@ -12101,7 +11994,7 @@
               <a:buNone/>
             </a:pPr>
             <a:r>
-              <a:rPr lang="en-US" sz="4000" b="1" dirty="0">
+              <a:rPr lang="en-US" sz="3200" b="1" dirty="0">
                 <a:solidFill>
                   <a:srgbClr val="FFFFFF"/>
                 </a:solidFill>
@@ -12111,20 +12004,20 @@
               </a:rPr>
               <a:t>224</a:t>
             </a:r>
-            <a:endParaRPr lang="en-US" sz="4000" dirty="0"/>
-          </a:p>
-        </p:txBody>
-      </p:sp>
-      <p:sp>
-        <p:nvSpPr>
-          <p:cNvPr id="24" name="Text 22"/>
-          <p:cNvSpPr txBox="1"/>
-          <p:nvPr/>
-        </p:nvSpPr>
-        <p:spPr>
-          <a:xfrm>
-            <a:off x="2776118" y="5623560"/>
-            <a:ext cx="1998878" cy="320040"/>
+            <a:endParaRPr lang="en-US" sz="3200" dirty="0"/>
+          </a:p>
+        </p:txBody>
+      </p:sp>
+      <p:sp>
+        <p:nvSpPr>
+          <p:cNvPr id="21" name="Text 19"/>
+          <p:cNvSpPr txBox="1"/>
+          <p:nvPr/>
+        </p:nvSpPr>
+        <p:spPr>
+          <a:xfrm>
+            <a:off x="2776118" y="4572000"/>
+            <a:ext cx="1998878" cy="274320"/>
           </a:xfrm>
           <a:prstGeom prst="rect">
             <a:avLst/>
@@ -12140,7 +12033,7 @@
               <a:buNone/>
             </a:pPr>
             <a:r>
-              <a:rPr lang="en-US" sz="1250" dirty="0">
+              <a:rPr lang="en-US" sz="1100" dirty="0">
                 <a:solidFill>
                   <a:srgbClr val="FFFFFF"/>
                 </a:solidFill>
@@ -12150,20 +12043,20 @@
               </a:rPr>
               <a:t>9,6% do painel</a:t>
             </a:r>
-            <a:endParaRPr lang="en-US" sz="1250" dirty="0"/>
-          </a:p>
-        </p:txBody>
-      </p:sp>
-      <p:sp>
-        <p:nvSpPr>
-          <p:cNvPr id="25" name="Shape 23"/>
-          <p:cNvSpPr/>
-          <p:nvPr/>
-        </p:nvSpPr>
-        <p:spPr>
-          <a:xfrm>
-            <a:off x="5003597" y="3246120"/>
-            <a:ext cx="2181758" cy="2880360"/>
+            <a:endParaRPr lang="en-US" sz="1100" dirty="0"/>
+          </a:p>
+        </p:txBody>
+      </p:sp>
+      <p:sp>
+        <p:nvSpPr>
+          <p:cNvPr id="22" name="Shape 20"/>
+          <p:cNvSpPr/>
+          <p:nvPr/>
+        </p:nvSpPr>
+        <p:spPr>
+          <a:xfrm>
+            <a:off x="5003597" y="2697480"/>
+            <a:ext cx="2181758" cy="2286000"/>
           </a:xfrm>
           <a:prstGeom prst="roundRect">
             <a:avLst>
@@ -12185,14 +12078,14 @@
       </p:sp>
       <p:sp>
         <p:nvSpPr>
-          <p:cNvPr id="26" name="Text 24"/>
-          <p:cNvSpPr txBox="1"/>
-          <p:nvPr/>
-        </p:nvSpPr>
-        <p:spPr>
-          <a:xfrm>
-            <a:off x="5113325" y="3429000"/>
-            <a:ext cx="1962302" cy="365760"/>
+          <p:cNvPr id="23" name="Text 21"/>
+          <p:cNvSpPr txBox="1"/>
+          <p:nvPr/>
+        </p:nvSpPr>
+        <p:spPr>
+          <a:xfrm>
+            <a:off x="5113325" y="2843784"/>
+            <a:ext cx="1962302" cy="320040"/>
           </a:xfrm>
           <a:prstGeom prst="rect">
             <a:avLst/>
@@ -12208,7 +12101,7 @@
               <a:buNone/>
             </a:pPr>
             <a:r>
-              <a:rPr lang="en-US" sz="1600" b="1" dirty="0">
+              <a:rPr lang="en-US" sz="1500" b="1" dirty="0">
                 <a:solidFill>
                   <a:srgbClr val="FFFFFF"/>
                 </a:solidFill>
@@ -12218,20 +12111,20 @@
               </a:rPr>
               <a:t>CAT 3</a:t>
             </a:r>
-            <a:endParaRPr lang="en-US" sz="1600" dirty="0"/>
-          </a:p>
-        </p:txBody>
-      </p:sp>
-      <p:sp>
-        <p:nvSpPr>
-          <p:cNvPr id="27" name="Text 25"/>
-          <p:cNvSpPr txBox="1"/>
-          <p:nvPr/>
-        </p:nvSpPr>
-        <p:spPr>
-          <a:xfrm>
-            <a:off x="5095037" y="4114800"/>
-            <a:ext cx="1998878" cy="1051560"/>
+            <a:endParaRPr lang="en-US" sz="1500" dirty="0"/>
+          </a:p>
+        </p:txBody>
+      </p:sp>
+      <p:sp>
+        <p:nvSpPr>
+          <p:cNvPr id="24" name="Text 22"/>
+          <p:cNvSpPr txBox="1"/>
+          <p:nvPr/>
+        </p:nvSpPr>
+        <p:spPr>
+          <a:xfrm>
+            <a:off x="5095037" y="3319272"/>
+            <a:ext cx="1998878" cy="822960"/>
           </a:xfrm>
           <a:prstGeom prst="rect">
             <a:avLst/>
@@ -12247,7 +12140,7 @@
               <a:buNone/>
             </a:pPr>
             <a:r>
-              <a:rPr lang="en-US" sz="4000" b="1" dirty="0">
+              <a:rPr lang="en-US" sz="3200" b="1" dirty="0">
                 <a:solidFill>
                   <a:srgbClr val="FFFFFF"/>
                 </a:solidFill>
@@ -12257,20 +12150,20 @@
               </a:rPr>
               <a:t>351</a:t>
             </a:r>
-            <a:endParaRPr lang="en-US" sz="4000" dirty="0"/>
-          </a:p>
-        </p:txBody>
-      </p:sp>
-      <p:sp>
-        <p:nvSpPr>
-          <p:cNvPr id="28" name="Text 26"/>
-          <p:cNvSpPr txBox="1"/>
-          <p:nvPr/>
-        </p:nvSpPr>
-        <p:spPr>
-          <a:xfrm>
-            <a:off x="5095037" y="5623560"/>
-            <a:ext cx="1998878" cy="320040"/>
+            <a:endParaRPr lang="en-US" sz="3200" dirty="0"/>
+          </a:p>
+        </p:txBody>
+      </p:sp>
+      <p:sp>
+        <p:nvSpPr>
+          <p:cNvPr id="25" name="Text 23"/>
+          <p:cNvSpPr txBox="1"/>
+          <p:nvPr/>
+        </p:nvSpPr>
+        <p:spPr>
+          <a:xfrm>
+            <a:off x="5095037" y="4572000"/>
+            <a:ext cx="1998878" cy="274320"/>
           </a:xfrm>
           <a:prstGeom prst="rect">
             <a:avLst/>
@@ -12286,7 +12179,7 @@
               <a:buNone/>
             </a:pPr>
             <a:r>
-              <a:rPr lang="en-US" sz="1250" dirty="0">
+              <a:rPr lang="en-US" sz="1100" dirty="0">
                 <a:solidFill>
                   <a:srgbClr val="FFFFFF"/>
                 </a:solidFill>
@@ -12296,20 +12189,20 @@
               </a:rPr>
               <a:t>15,0% do painel</a:t>
             </a:r>
-            <a:endParaRPr lang="en-US" sz="1250" dirty="0"/>
-          </a:p>
-        </p:txBody>
-      </p:sp>
-      <p:sp>
-        <p:nvSpPr>
-          <p:cNvPr id="29" name="Shape 27"/>
-          <p:cNvSpPr/>
-          <p:nvPr/>
-        </p:nvSpPr>
-        <p:spPr>
-          <a:xfrm>
-            <a:off x="7322515" y="3246120"/>
-            <a:ext cx="2181758" cy="2880360"/>
+            <a:endParaRPr lang="en-US" sz="1100" dirty="0"/>
+          </a:p>
+        </p:txBody>
+      </p:sp>
+      <p:sp>
+        <p:nvSpPr>
+          <p:cNvPr id="26" name="Shape 24"/>
+          <p:cNvSpPr/>
+          <p:nvPr/>
+        </p:nvSpPr>
+        <p:spPr>
+          <a:xfrm>
+            <a:off x="7322515" y="2697480"/>
+            <a:ext cx="2181758" cy="2286000"/>
           </a:xfrm>
           <a:prstGeom prst="roundRect">
             <a:avLst>
@@ -12331,14 +12224,14 @@
       </p:sp>
       <p:sp>
         <p:nvSpPr>
-          <p:cNvPr id="30" name="Text 28"/>
-          <p:cNvSpPr txBox="1"/>
-          <p:nvPr/>
-        </p:nvSpPr>
-        <p:spPr>
-          <a:xfrm>
-            <a:off x="7432243" y="3429000"/>
-            <a:ext cx="1962302" cy="365760"/>
+          <p:cNvPr id="27" name="Text 25"/>
+          <p:cNvSpPr txBox="1"/>
+          <p:nvPr/>
+        </p:nvSpPr>
+        <p:spPr>
+          <a:xfrm>
+            <a:off x="7432243" y="2843784"/>
+            <a:ext cx="1962302" cy="320040"/>
           </a:xfrm>
           <a:prstGeom prst="rect">
             <a:avLst/>
@@ -12354,7 +12247,7 @@
               <a:buNone/>
             </a:pPr>
             <a:r>
-              <a:rPr lang="en-US" sz="1600" b="1" dirty="0">
+              <a:rPr lang="en-US" sz="1500" b="1" dirty="0">
                 <a:solidFill>
                   <a:srgbClr val="FFFFFF"/>
                 </a:solidFill>
@@ -12364,20 +12257,20 @@
               </a:rPr>
               <a:t>CAT 4</a:t>
             </a:r>
-            <a:endParaRPr lang="en-US" sz="1600" dirty="0"/>
-          </a:p>
-        </p:txBody>
-      </p:sp>
-      <p:sp>
-        <p:nvSpPr>
-          <p:cNvPr id="31" name="Text 29"/>
-          <p:cNvSpPr txBox="1"/>
-          <p:nvPr/>
-        </p:nvSpPr>
-        <p:spPr>
-          <a:xfrm>
-            <a:off x="7413955" y="4114800"/>
-            <a:ext cx="1998878" cy="1051560"/>
+            <a:endParaRPr lang="en-US" sz="1500" dirty="0"/>
+          </a:p>
+        </p:txBody>
+      </p:sp>
+      <p:sp>
+        <p:nvSpPr>
+          <p:cNvPr id="28" name="Text 26"/>
+          <p:cNvSpPr txBox="1"/>
+          <p:nvPr/>
+        </p:nvSpPr>
+        <p:spPr>
+          <a:xfrm>
+            <a:off x="7413955" y="3319272"/>
+            <a:ext cx="1998878" cy="822960"/>
           </a:xfrm>
           <a:prstGeom prst="rect">
             <a:avLst/>
@@ -12393,7 +12286,7 @@
               <a:buNone/>
             </a:pPr>
             <a:r>
-              <a:rPr lang="en-US" sz="4000" b="1" dirty="0">
+              <a:rPr lang="en-US" sz="3200" b="1" dirty="0">
                 <a:solidFill>
                   <a:srgbClr val="FFFFFF"/>
                 </a:solidFill>
@@ -12403,20 +12296,20 @@
               </a:rPr>
               <a:t>617</a:t>
             </a:r>
-            <a:endParaRPr lang="en-US" sz="4000" dirty="0"/>
-          </a:p>
-        </p:txBody>
-      </p:sp>
-      <p:sp>
-        <p:nvSpPr>
-          <p:cNvPr id="32" name="Text 30"/>
-          <p:cNvSpPr txBox="1"/>
-          <p:nvPr/>
-        </p:nvSpPr>
-        <p:spPr>
-          <a:xfrm>
-            <a:off x="7413955" y="5623560"/>
-            <a:ext cx="1998878" cy="320040"/>
+            <a:endParaRPr lang="en-US" sz="3200" dirty="0"/>
+          </a:p>
+        </p:txBody>
+      </p:sp>
+      <p:sp>
+        <p:nvSpPr>
+          <p:cNvPr id="29" name="Text 27"/>
+          <p:cNvSpPr txBox="1"/>
+          <p:nvPr/>
+        </p:nvSpPr>
+        <p:spPr>
+          <a:xfrm>
+            <a:off x="7413955" y="4572000"/>
+            <a:ext cx="1998878" cy="274320"/>
           </a:xfrm>
           <a:prstGeom prst="rect">
             <a:avLst/>
@@ -12432,7 +12325,7 @@
               <a:buNone/>
             </a:pPr>
             <a:r>
-              <a:rPr lang="en-US" sz="1250" dirty="0">
+              <a:rPr lang="en-US" sz="1100" dirty="0">
                 <a:solidFill>
                   <a:srgbClr val="FFFFFF"/>
                 </a:solidFill>
@@ -12442,20 +12335,20 @@
               </a:rPr>
               <a:t>26,3% do painel</a:t>
             </a:r>
-            <a:endParaRPr lang="en-US" sz="1250" dirty="0"/>
-          </a:p>
-        </p:txBody>
-      </p:sp>
-      <p:sp>
-        <p:nvSpPr>
-          <p:cNvPr id="33" name="Shape 31"/>
-          <p:cNvSpPr/>
-          <p:nvPr/>
-        </p:nvSpPr>
-        <p:spPr>
-          <a:xfrm>
-            <a:off x="9641434" y="3246120"/>
-            <a:ext cx="2181758" cy="2880360"/>
+            <a:endParaRPr lang="en-US" sz="1100" dirty="0"/>
+          </a:p>
+        </p:txBody>
+      </p:sp>
+      <p:sp>
+        <p:nvSpPr>
+          <p:cNvPr id="30" name="Shape 28"/>
+          <p:cNvSpPr/>
+          <p:nvPr/>
+        </p:nvSpPr>
+        <p:spPr>
+          <a:xfrm>
+            <a:off x="9641434" y="2697480"/>
+            <a:ext cx="2181758" cy="2286000"/>
           </a:xfrm>
           <a:prstGeom prst="roundRect">
             <a:avLst>
@@ -12477,14 +12370,14 @@
       </p:sp>
       <p:sp>
         <p:nvSpPr>
-          <p:cNvPr id="34" name="Text 32"/>
-          <p:cNvSpPr txBox="1"/>
-          <p:nvPr/>
-        </p:nvSpPr>
-        <p:spPr>
-          <a:xfrm>
-            <a:off x="9751162" y="3429000"/>
-            <a:ext cx="1962302" cy="365760"/>
+          <p:cNvPr id="31" name="Text 29"/>
+          <p:cNvSpPr txBox="1"/>
+          <p:nvPr/>
+        </p:nvSpPr>
+        <p:spPr>
+          <a:xfrm>
+            <a:off x="9751162" y="2843784"/>
+            <a:ext cx="1962302" cy="320040"/>
           </a:xfrm>
           <a:prstGeom prst="rect">
             <a:avLst/>
@@ -12500,7 +12393,7 @@
               <a:buNone/>
             </a:pPr>
             <a:r>
-              <a:rPr lang="en-US" sz="1600" b="1" dirty="0">
+              <a:rPr lang="en-US" sz="1500" b="1" dirty="0">
                 <a:solidFill>
                   <a:srgbClr val="FFFFFF"/>
                 </a:solidFill>
@@ -12510,9 +12403,116 @@
               </a:rPr>
               <a:t>CAT 5</a:t>
             </a:r>
-            <a:endParaRPr lang="en-US" sz="1600" dirty="0"/>
-          </a:p>
-        </p:txBody>
+            <a:endParaRPr lang="en-US" sz="1500" dirty="0"/>
+          </a:p>
+        </p:txBody>
+      </p:sp>
+      <p:sp>
+        <p:nvSpPr>
+          <p:cNvPr id="32" name="Text 30"/>
+          <p:cNvSpPr txBox="1"/>
+          <p:nvPr/>
+        </p:nvSpPr>
+        <p:spPr>
+          <a:xfrm>
+            <a:off x="9732874" y="3319272"/>
+            <a:ext cx="1998878" cy="822960"/>
+          </a:xfrm>
+          <a:prstGeom prst="rect">
+            <a:avLst/>
+          </a:prstGeom>
+          <a:noFill/>
+          <a:ln/>
+        </p:spPr>
+        <p:txBody>
+          <a:bodyPr wrap="square" lIns="0" tIns="0" rIns="0" bIns="0" rtlCol="0" anchor="ctr"/>
+          <a:lstStyle/>
+          <a:p>
+            <a:pPr algn="ctr" indent="0" marL="0">
+              <a:buNone/>
+            </a:pPr>
+            <a:r>
+              <a:rPr lang="en-US" sz="3200" b="1" dirty="0">
+                <a:solidFill>
+                  <a:srgbClr val="FFFFFF"/>
+                </a:solidFill>
+                <a:latin typeface="Calibri" pitchFamily="34" charset="0"/>
+                <a:ea typeface="Calibri" pitchFamily="34" charset="-122"/>
+                <a:cs typeface="Calibri" pitchFamily="34" charset="-120"/>
+              </a:rPr>
+              <a:t>1.046</a:t>
+            </a:r>
+            <a:endParaRPr lang="en-US" sz="3200" dirty="0"/>
+          </a:p>
+        </p:txBody>
+      </p:sp>
+      <p:sp>
+        <p:nvSpPr>
+          <p:cNvPr id="33" name="Text 31"/>
+          <p:cNvSpPr txBox="1"/>
+          <p:nvPr/>
+        </p:nvSpPr>
+        <p:spPr>
+          <a:xfrm>
+            <a:off x="9732874" y="4572000"/>
+            <a:ext cx="1998878" cy="274320"/>
+          </a:xfrm>
+          <a:prstGeom prst="rect">
+            <a:avLst/>
+          </a:prstGeom>
+          <a:noFill/>
+          <a:ln/>
+        </p:spPr>
+        <p:txBody>
+          <a:bodyPr wrap="square" lIns="0" tIns="0" rIns="0" bIns="0" rtlCol="0" anchor="ctr"/>
+          <a:lstStyle/>
+          <a:p>
+            <a:pPr algn="ctr" indent="0" marL="0">
+              <a:buNone/>
+            </a:pPr>
+            <a:r>
+              <a:rPr lang="en-US" sz="1100" dirty="0">
+                <a:solidFill>
+                  <a:srgbClr val="FFFFFF"/>
+                </a:solidFill>
+                <a:latin typeface="Calibri" pitchFamily="34" charset="0"/>
+                <a:ea typeface="Calibri" pitchFamily="34" charset="-122"/>
+                <a:cs typeface="Calibri" pitchFamily="34" charset="-120"/>
+              </a:rPr>
+              <a:t>44,6% do painel</a:t>
+            </a:r>
+            <a:endParaRPr lang="en-US" sz="1100" dirty="0"/>
+          </a:p>
+        </p:txBody>
+      </p:sp>
+      <p:sp>
+        <p:nvSpPr>
+          <p:cNvPr id="34" name="Shape 32"/>
+          <p:cNvSpPr/>
+          <p:nvPr/>
+        </p:nvSpPr>
+        <p:spPr>
+          <a:xfrm>
+            <a:off x="365760" y="5257800"/>
+            <a:ext cx="11457432" cy="1234440"/>
+          </a:xfrm>
+          <a:prstGeom prst="roundRect">
+            <a:avLst>
+              <a:gd name="adj" fmla="val 5926"/>
+            </a:avLst>
+          </a:prstGeom>
+          <a:solidFill>
+            <a:srgbClr val="1D3557"/>
+          </a:solidFill>
+          <a:ln/>
+          <a:effectLst>
+            <a:outerShdw sx="100000" sy="100000" kx="0" ky="0" algn="bl" rotWithShape="0" blurRad="101600" dist="38100" dir="5400000">
+              <a:srgbClr val="000000">
+                <a:alpha val="20000"/>
+              </a:srgbClr>
+            </a:outerShdw>
+          </a:effectLst>
+        </p:spPr>
       </p:sp>
       <p:sp>
         <p:nvSpPr>
@@ -12522,24 +12522,63 @@
         </p:nvSpPr>
         <p:spPr>
           <a:xfrm>
-            <a:off x="9732874" y="4114800"/>
-            <a:ext cx="1998878" cy="1051560"/>
-          </a:xfrm>
-          <a:prstGeom prst="rect">
-            <a:avLst/>
-          </a:prstGeom>
-          <a:noFill/>
-          <a:ln/>
-        </p:spPr>
-        <p:txBody>
-          <a:bodyPr wrap="square" lIns="0" tIns="0" rIns="0" bIns="0" rtlCol="0" anchor="ctr"/>
-          <a:lstStyle/>
-          <a:p>
-            <a:pPr algn="ctr" indent="0" marL="0">
-              <a:buNone/>
-            </a:pPr>
-            <a:r>
-              <a:rPr lang="en-US" sz="4000" b="1" dirty="0">
+            <a:off x="640080" y="5394960"/>
+            <a:ext cx="10908792" cy="274320"/>
+          </a:xfrm>
+          <a:prstGeom prst="rect">
+            <a:avLst/>
+          </a:prstGeom>
+          <a:noFill/>
+          <a:ln/>
+        </p:spPr>
+        <p:txBody>
+          <a:bodyPr wrap="square" lIns="0" tIns="0" rIns="0" bIns="0" rtlCol="0" anchor="ctr"/>
+          <a:lstStyle/>
+          <a:p>
+            <a:pPr algn="l" indent="0" marL="0">
+              <a:buNone/>
+            </a:pPr>
+            <a:r>
+              <a:rPr lang="en-US" sz="1200" b="1" spc="100" kern="0" dirty="0">
+                <a:solidFill>
+                  <a:srgbClr val="CADCFC"/>
+                </a:solidFill>
+                <a:latin typeface="Calibri" pitchFamily="34" charset="0"/>
+                <a:ea typeface="Calibri" pitchFamily="34" charset="-122"/>
+                <a:cs typeface="Calibri" pitchFamily="34" charset="-120"/>
+              </a:rPr>
+              <a:t>REPRESENTATIVIDADE DOS PRESCRITORES · CAT 1 + 2 + 3</a:t>
+            </a:r>
+            <a:endParaRPr lang="en-US" sz="1200" dirty="0"/>
+          </a:p>
+        </p:txBody>
+      </p:sp>
+      <p:sp>
+        <p:nvSpPr>
+          <p:cNvPr id="36" name="Text 34"/>
+          <p:cNvSpPr txBox="1"/>
+          <p:nvPr/>
+        </p:nvSpPr>
+        <p:spPr>
+          <a:xfrm>
+            <a:off x="640080" y="5623560"/>
+            <a:ext cx="3407664" cy="457200"/>
+          </a:xfrm>
+          <a:prstGeom prst="rect">
+            <a:avLst/>
+          </a:prstGeom>
+          <a:noFill/>
+          <a:ln/>
+        </p:spPr>
+        <p:txBody>
+          <a:bodyPr wrap="square" lIns="0" tIns="0" rIns="0" bIns="0" rtlCol="0" anchor="ctr"/>
+          <a:lstStyle/>
+          <a:p>
+            <a:pPr algn="l" indent="0" marL="0">
+              <a:buNone/>
+            </a:pPr>
+            <a:r>
+              <a:rPr lang="en-US" sz="3200" b="1" dirty="0">
                 <a:solidFill>
                   <a:srgbClr val="FFFFFF"/>
                 </a:solidFill>
@@ -12547,38 +12586,77 @@
                 <a:ea typeface="Calibri" pitchFamily="34" charset="-122"/>
                 <a:cs typeface="Calibri" pitchFamily="34" charset="-120"/>
               </a:rPr>
-              <a:t>1.046</a:t>
-            </a:r>
-            <a:endParaRPr lang="en-US" sz="4000" dirty="0"/>
-          </a:p>
-        </p:txBody>
-      </p:sp>
-      <p:sp>
-        <p:nvSpPr>
-          <p:cNvPr id="36" name="Text 34"/>
-          <p:cNvSpPr txBox="1"/>
-          <p:nvPr/>
-        </p:nvSpPr>
-        <p:spPr>
-          <a:xfrm>
-            <a:off x="9732874" y="5623560"/>
-            <a:ext cx="1998878" cy="320040"/>
-          </a:xfrm>
-          <a:prstGeom prst="rect">
-            <a:avLst/>
-          </a:prstGeom>
-          <a:noFill/>
-          <a:ln/>
-        </p:spPr>
-        <p:txBody>
-          <a:bodyPr wrap="square" lIns="0" tIns="0" rIns="0" bIns="0" rtlCol="0" anchor="ctr"/>
-          <a:lstStyle/>
-          <a:p>
-            <a:pPr algn="ctr" indent="0" marL="0">
-              <a:buNone/>
-            </a:pPr>
-            <a:r>
-              <a:rPr lang="en-US" sz="1250" dirty="0">
+              <a:t>680</a:t>
+            </a:r>
+            <a:endParaRPr lang="en-US" sz="3200" dirty="0"/>
+          </a:p>
+        </p:txBody>
+      </p:sp>
+      <p:sp>
+        <p:nvSpPr>
+          <p:cNvPr id="37" name="Text 35"/>
+          <p:cNvSpPr txBox="1"/>
+          <p:nvPr/>
+        </p:nvSpPr>
+        <p:spPr>
+          <a:xfrm>
+            <a:off x="640080" y="6099048"/>
+            <a:ext cx="3407664" cy="365760"/>
+          </a:xfrm>
+          <a:prstGeom prst="rect">
+            <a:avLst/>
+          </a:prstGeom>
+          <a:noFill/>
+          <a:ln/>
+        </p:spPr>
+        <p:txBody>
+          <a:bodyPr wrap="square" lIns="0" tIns="0" rIns="0" bIns="0" rtlCol="0" anchor="t"/>
+          <a:lstStyle/>
+          <a:p>
+            <a:pPr algn="l" indent="0" marL="0">
+              <a:buNone/>
+            </a:pPr>
+            <a:r>
+              <a:rPr lang="en-US" sz="1050" dirty="0">
+                <a:solidFill>
+                  <a:srgbClr val="CADCFC"/>
+                </a:solidFill>
+                <a:latin typeface="Calibri" pitchFamily="34" charset="0"/>
+                <a:ea typeface="Calibri" pitchFamily="34" charset="-122"/>
+                <a:cs typeface="Calibri" pitchFamily="34" charset="-120"/>
+              </a:rPr>
+              <a:t>médicos nas CAT 1, 2 e 3</a:t>
+            </a:r>
+            <a:endParaRPr lang="en-US" sz="1050" dirty="0"/>
+          </a:p>
+        </p:txBody>
+      </p:sp>
+      <p:sp>
+        <p:nvSpPr>
+          <p:cNvPr id="38" name="Text 36"/>
+          <p:cNvSpPr txBox="1"/>
+          <p:nvPr/>
+        </p:nvSpPr>
+        <p:spPr>
+          <a:xfrm>
+            <a:off x="4276344" y="5623560"/>
+            <a:ext cx="3407664" cy="457200"/>
+          </a:xfrm>
+          <a:prstGeom prst="rect">
+            <a:avLst/>
+          </a:prstGeom>
+          <a:noFill/>
+          <a:ln/>
+        </p:spPr>
+        <p:txBody>
+          <a:bodyPr wrap="square" lIns="0" tIns="0" rIns="0" bIns="0" rtlCol="0" anchor="ctr"/>
+          <a:lstStyle/>
+          <a:p>
+            <a:pPr algn="l" indent="0" marL="0">
+              <a:buNone/>
+            </a:pPr>
+            <a:r>
+              <a:rPr lang="en-US" sz="3200" b="1" dirty="0">
                 <a:solidFill>
                   <a:srgbClr val="FFFFFF"/>
                 </a:solidFill>
@@ -12586,21 +12664,138 @@
                 <a:ea typeface="Calibri" pitchFamily="34" charset="-122"/>
                 <a:cs typeface="Calibri" pitchFamily="34" charset="-120"/>
               </a:rPr>
-              <a:t>44,6% do painel</a:t>
-            </a:r>
-            <a:endParaRPr lang="en-US" sz="1250" dirty="0"/>
-          </a:p>
-        </p:txBody>
-      </p:sp>
-      <p:sp>
-        <p:nvSpPr>
-          <p:cNvPr id="37" name="Text 35"/>
-          <p:cNvSpPr txBox="1"/>
-          <p:nvPr/>
-        </p:nvSpPr>
-        <p:spPr>
-          <a:xfrm>
-            <a:off x="365760" y="6537960"/>
+              <a:t>99,7%</a:t>
+            </a:r>
+            <a:endParaRPr lang="en-US" sz="3200" dirty="0"/>
+          </a:p>
+        </p:txBody>
+      </p:sp>
+      <p:sp>
+        <p:nvSpPr>
+          <p:cNvPr id="39" name="Text 37"/>
+          <p:cNvSpPr txBox="1"/>
+          <p:nvPr/>
+        </p:nvSpPr>
+        <p:spPr>
+          <a:xfrm>
+            <a:off x="4276344" y="6099048"/>
+            <a:ext cx="3407664" cy="365760"/>
+          </a:xfrm>
+          <a:prstGeom prst="rect">
+            <a:avLst/>
+          </a:prstGeom>
+          <a:noFill/>
+          <a:ln/>
+        </p:spPr>
+        <p:txBody>
+          <a:bodyPr wrap="square" lIns="0" tIns="0" rIns="0" bIns="0" rtlCol="0" anchor="t"/>
+          <a:lstStyle/>
+          <a:p>
+            <a:pPr algn="l" indent="0" marL="0">
+              <a:buNone/>
+            </a:pPr>
+            <a:r>
+              <a:rPr lang="en-US" sz="1050" dirty="0">
+                <a:solidFill>
+                  <a:srgbClr val="CADCFC"/>
+                </a:solidFill>
+                <a:latin typeface="Calibri" pitchFamily="34" charset="0"/>
+                <a:ea typeface="Calibri" pitchFamily="34" charset="-122"/>
+                <a:cs typeface="Calibri" pitchFamily="34" charset="-120"/>
+              </a:rPr>
+              <a:t>prescrevem EUF dentro do grupo (678 médicos)</a:t>
+            </a:r>
+            <a:endParaRPr lang="en-US" sz="1050" dirty="0"/>
+          </a:p>
+        </p:txBody>
+      </p:sp>
+      <p:sp>
+        <p:nvSpPr>
+          <p:cNvPr id="40" name="Text 38"/>
+          <p:cNvSpPr txBox="1"/>
+          <p:nvPr/>
+        </p:nvSpPr>
+        <p:spPr>
+          <a:xfrm>
+            <a:off x="7912608" y="5623560"/>
+            <a:ext cx="3407664" cy="457200"/>
+          </a:xfrm>
+          <a:prstGeom prst="rect">
+            <a:avLst/>
+          </a:prstGeom>
+          <a:noFill/>
+          <a:ln/>
+        </p:spPr>
+        <p:txBody>
+          <a:bodyPr wrap="square" lIns="0" tIns="0" rIns="0" bIns="0" rtlCol="0" anchor="ctr"/>
+          <a:lstStyle/>
+          <a:p>
+            <a:pPr algn="l" indent="0" marL="0">
+              <a:buNone/>
+            </a:pPr>
+            <a:r>
+              <a:rPr lang="en-US" sz="3200" b="1" dirty="0">
+                <a:solidFill>
+                  <a:srgbClr val="FFFFFF"/>
+                </a:solidFill>
+                <a:latin typeface="Calibri" pitchFamily="34" charset="0"/>
+                <a:ea typeface="Calibri" pitchFamily="34" charset="-122"/>
+                <a:cs typeface="Calibri" pitchFamily="34" charset="-120"/>
+              </a:rPr>
+              <a:t>36,4%</a:t>
+            </a:r>
+            <a:endParaRPr lang="en-US" sz="3200" dirty="0"/>
+          </a:p>
+        </p:txBody>
+      </p:sp>
+      <p:sp>
+        <p:nvSpPr>
+          <p:cNvPr id="41" name="Text 39"/>
+          <p:cNvSpPr txBox="1"/>
+          <p:nvPr/>
+        </p:nvSpPr>
+        <p:spPr>
+          <a:xfrm>
+            <a:off x="7912608" y="6099048"/>
+            <a:ext cx="3407664" cy="365760"/>
+          </a:xfrm>
+          <a:prstGeom prst="rect">
+            <a:avLst/>
+          </a:prstGeom>
+          <a:noFill/>
+          <a:ln/>
+        </p:spPr>
+        <p:txBody>
+          <a:bodyPr wrap="square" lIns="0" tIns="0" rIns="0" bIns="0" rtlCol="0" anchor="t"/>
+          <a:lstStyle/>
+          <a:p>
+            <a:pPr algn="l" indent="0" marL="0">
+              <a:buNone/>
+            </a:pPr>
+            <a:r>
+              <a:rPr lang="en-US" sz="1050" dirty="0">
+                <a:solidFill>
+                  <a:srgbClr val="CADCFC"/>
+                </a:solidFill>
+                <a:latin typeface="Calibri" pitchFamily="34" charset="0"/>
+                <a:ea typeface="Calibri" pitchFamily="34" charset="-122"/>
+                <a:cs typeface="Calibri" pitchFamily="34" charset="-120"/>
+              </a:rPr>
+              <a:t>de todos os prescritores da distrital estão nesse grupo</a:t>
+            </a:r>
+            <a:endParaRPr lang="en-US" sz="1050" dirty="0"/>
+          </a:p>
+        </p:txBody>
+      </p:sp>
+      <p:sp>
+        <p:nvSpPr>
+          <p:cNvPr id="42" name="Text 40"/>
+          <p:cNvSpPr txBox="1"/>
+          <p:nvPr/>
+        </p:nvSpPr>
+        <p:spPr>
+          <a:xfrm>
+            <a:off x="365760" y="6583680"/>
             <a:ext cx="11457432" cy="182880"/>
           </a:xfrm>
           <a:prstGeom prst="rect">
@@ -12625,7 +12820,7 @@
                 <a:ea typeface="Calibri" pitchFamily="34" charset="-122"/>
                 <a:cs typeface="Calibri" pitchFamily="34" charset="-120"/>
               </a:rPr>
-              <a:t>Base: 2.551 profissionais cadastrados na planilha, sendo 208 sem CAT classificada (não incluídos no compilado por CAT).</a:t>
+              <a:t>Base: 2.551 profissionais cadastrados na planilha, sendo 208 sem CAT classificada (não incluídos neste compilado).</a:t>
             </a:r>
             <a:endParaRPr lang="en-US" sz="850" dirty="0"/>
           </a:p>

</xml_diff>

<commit_message>
Aumenta o tamanho das fontes do slide 1
Eleva o tamanho de todos os textos (título, cabeçalhos de CAT, setor,
contagem, % e rodapé) até o máximo que cabe em cada caixa existente,
sem alterar posições, larguras ou o layout de 5 colunas x 8 linhas.

Co-Authored-By: Claude Sonnet 5 <noreply@anthropic.com>
Claude-Session: https://claude.ai/code/session_01KqmuB8xxfxpvceuypurV9G
</commit_message>
<xml_diff>
--- a/output/painel_medico_distrital_1880.pptx
+++ b/output/painel_medico_distrital_1880.pptx
@@ -989,7 +989,7 @@
               <a:buNone/>
             </a:pPr>
             <a:r>
-              <a:rPr lang="en-US" sz="3000" b="1" dirty="0">
+              <a:rPr lang="en-US" sz="3300" b="1" dirty="0">
                 <a:solidFill>
                   <a:srgbClr val="1D3557"/>
                 </a:solidFill>
@@ -1003,7 +1003,7 @@
               <a:buNone/>
             </a:pPr>
             <a:r>
-              <a:rPr lang="en-US" sz="3000" b="1" dirty="0">
+              <a:rPr lang="en-US" sz="3300" b="1" dirty="0">
                 <a:solidFill>
                   <a:srgbClr val="6A4C93"/>
                 </a:solidFill>
@@ -1013,7 +1013,7 @@
               </a:rPr>
               <a:t>  —  DISTRITAL 1880</a:t>
             </a:r>
-            <a:endParaRPr lang="en-US" sz="3000" dirty="0"/>
+            <a:endParaRPr lang="en-US" sz="3300" dirty="0"/>
           </a:p>
         </p:txBody>
       </p:sp>
@@ -1071,7 +1071,7 @@
               <a:buNone/>
             </a:pPr>
             <a:r>
-              <a:rPr lang="en-US" sz="1800" b="1" dirty="0">
+              <a:rPr lang="en-US" sz="2300" b="1" dirty="0">
                 <a:solidFill>
                   <a:srgbClr val="FFFFFF"/>
                 </a:solidFill>
@@ -1081,7 +1081,7 @@
               </a:rPr>
               <a:t>CAT 1</a:t>
             </a:r>
-            <a:endParaRPr lang="en-US" sz="1800" dirty="0"/>
+            <a:endParaRPr lang="en-US" sz="2300" dirty="0"/>
           </a:p>
         </p:txBody>
       </p:sp>
@@ -1110,7 +1110,7 @@
               <a:buNone/>
             </a:pPr>
             <a:r>
-              <a:rPr lang="en-US" sz="1050" dirty="0">
+              <a:rPr lang="en-US" sz="1250" dirty="0">
                 <a:solidFill>
                   <a:srgbClr val="FFFFFF"/>
                 </a:solidFill>
@@ -1120,7 +1120,7 @@
               </a:rPr>
               <a:t>105 médicos no painel</a:t>
             </a:r>
-            <a:endParaRPr lang="en-US" sz="1050" dirty="0"/>
+            <a:endParaRPr lang="en-US" sz="1250" dirty="0"/>
           </a:p>
         </p:txBody>
       </p:sp>
@@ -1191,7 +1191,7 @@
               <a:buNone/>
             </a:pPr>
             <a:r>
-              <a:rPr lang="en-US" sz="1100" b="1" dirty="0">
+              <a:rPr lang="en-US" sz="1300" b="1" dirty="0">
                 <a:solidFill>
                   <a:srgbClr val="FFFFFF"/>
                 </a:solidFill>
@@ -1201,7 +1201,7 @@
               </a:rPr>
               <a:t>1</a:t>
             </a:r>
-            <a:endParaRPr lang="en-US" sz="1100" dirty="0"/>
+            <a:endParaRPr lang="en-US" sz="1300" dirty="0"/>
           </a:p>
         </p:txBody>
       </p:sp>
@@ -1230,7 +1230,7 @@
               <a:buNone/>
             </a:pPr>
             <a:r>
-              <a:rPr lang="en-US" sz="1150" b="1" dirty="0">
+              <a:rPr lang="en-US" sz="1500" b="1" dirty="0">
                 <a:solidFill>
                   <a:srgbClr val="1D3557"/>
                 </a:solidFill>
@@ -1240,7 +1240,7 @@
               </a:rPr>
               <a:t>Setor 5153</a:t>
             </a:r>
-            <a:endParaRPr lang="en-US" sz="1150" dirty="0"/>
+            <a:endParaRPr lang="en-US" sz="1500" dirty="0"/>
           </a:p>
         </p:txBody>
       </p:sp>
@@ -1269,7 +1269,7 @@
               <a:buNone/>
             </a:pPr>
             <a:r>
-              <a:rPr lang="en-US" sz="1400" b="1" dirty="0">
+              <a:rPr lang="en-US" sz="1700" b="1" dirty="0">
                 <a:solidFill>
                   <a:srgbClr val="D62839"/>
                 </a:solidFill>
@@ -1279,7 +1279,7 @@
               </a:rPr>
               <a:t>25</a:t>
             </a:r>
-            <a:endParaRPr lang="en-US" sz="1400" dirty="0"/>
+            <a:endParaRPr lang="en-US" sz="1700" dirty="0"/>
           </a:p>
         </p:txBody>
       </p:sp>
@@ -1352,7 +1352,7 @@
               <a:buNone/>
             </a:pPr>
             <a:r>
-              <a:rPr lang="en-US" sz="750" dirty="0">
+              <a:rPr lang="en-US" sz="800" dirty="0">
                 <a:solidFill>
                   <a:srgbClr val="6B7280"/>
                 </a:solidFill>
@@ -1362,7 +1362,7 @@
               </a:rPr>
               <a:t>8,7% do setor</a:t>
             </a:r>
-            <a:endParaRPr lang="en-US" sz="750" dirty="0"/>
+            <a:endParaRPr lang="en-US" sz="800" dirty="0"/>
           </a:p>
         </p:txBody>
       </p:sp>
@@ -1433,7 +1433,7 @@
               <a:buNone/>
             </a:pPr>
             <a:r>
-              <a:rPr lang="en-US" sz="1100" b="1" dirty="0">
+              <a:rPr lang="en-US" sz="1300" b="1" dirty="0">
                 <a:solidFill>
                   <a:srgbClr val="FFFFFF"/>
                 </a:solidFill>
@@ -1443,7 +1443,7 @@
               </a:rPr>
               <a:t>2</a:t>
             </a:r>
-            <a:endParaRPr lang="en-US" sz="1100" dirty="0"/>
+            <a:endParaRPr lang="en-US" sz="1300" dirty="0"/>
           </a:p>
         </p:txBody>
       </p:sp>
@@ -1472,7 +1472,7 @@
               <a:buNone/>
             </a:pPr>
             <a:r>
-              <a:rPr lang="en-US" sz="1150" b="1" dirty="0">
+              <a:rPr lang="en-US" sz="1500" b="1" dirty="0">
                 <a:solidFill>
                   <a:srgbClr val="1D3557"/>
                 </a:solidFill>
@@ -1482,7 +1482,7 @@
               </a:rPr>
               <a:t>Setor 5149</a:t>
             </a:r>
-            <a:endParaRPr lang="en-US" sz="1150" dirty="0"/>
+            <a:endParaRPr lang="en-US" sz="1500" dirty="0"/>
           </a:p>
         </p:txBody>
       </p:sp>
@@ -1511,7 +1511,7 @@
               <a:buNone/>
             </a:pPr>
             <a:r>
-              <a:rPr lang="en-US" sz="1400" b="1" dirty="0">
+              <a:rPr lang="en-US" sz="1700" b="1" dirty="0">
                 <a:solidFill>
                   <a:srgbClr val="D62839"/>
                 </a:solidFill>
@@ -1521,7 +1521,7 @@
               </a:rPr>
               <a:t>20</a:t>
             </a:r>
-            <a:endParaRPr lang="en-US" sz="1400" dirty="0"/>
+            <a:endParaRPr lang="en-US" sz="1700" dirty="0"/>
           </a:p>
         </p:txBody>
       </p:sp>
@@ -1594,7 +1594,7 @@
               <a:buNone/>
             </a:pPr>
             <a:r>
-              <a:rPr lang="en-US" sz="750" dirty="0">
+              <a:rPr lang="en-US" sz="800" dirty="0">
                 <a:solidFill>
                   <a:srgbClr val="6B7280"/>
                 </a:solidFill>
@@ -1604,7 +1604,7 @@
               </a:rPr>
               <a:t>6,5% do setor</a:t>
             </a:r>
-            <a:endParaRPr lang="en-US" sz="750" dirty="0"/>
+            <a:endParaRPr lang="en-US" sz="800" dirty="0"/>
           </a:p>
         </p:txBody>
       </p:sp>
@@ -1675,7 +1675,7 @@
               <a:buNone/>
             </a:pPr>
             <a:r>
-              <a:rPr lang="en-US" sz="1100" b="1" dirty="0">
+              <a:rPr lang="en-US" sz="1300" b="1" dirty="0">
                 <a:solidFill>
                   <a:srgbClr val="FFFFFF"/>
                 </a:solidFill>
@@ -1685,7 +1685,7 @@
               </a:rPr>
               <a:t>3</a:t>
             </a:r>
-            <a:endParaRPr lang="en-US" sz="1100" dirty="0"/>
+            <a:endParaRPr lang="en-US" sz="1300" dirty="0"/>
           </a:p>
         </p:txBody>
       </p:sp>
@@ -1714,7 +1714,7 @@
               <a:buNone/>
             </a:pPr>
             <a:r>
-              <a:rPr lang="en-US" sz="1150" b="1" dirty="0">
+              <a:rPr lang="en-US" sz="1500" b="1" dirty="0">
                 <a:solidFill>
                   <a:srgbClr val="1D3557"/>
                 </a:solidFill>
@@ -1724,7 +1724,7 @@
               </a:rPr>
               <a:t>Setor 7745</a:t>
             </a:r>
-            <a:endParaRPr lang="en-US" sz="1150" dirty="0"/>
+            <a:endParaRPr lang="en-US" sz="1500" dirty="0"/>
           </a:p>
         </p:txBody>
       </p:sp>
@@ -1753,7 +1753,7 @@
               <a:buNone/>
             </a:pPr>
             <a:r>
-              <a:rPr lang="en-US" sz="1400" b="1" dirty="0">
+              <a:rPr lang="en-US" sz="1700" b="1" dirty="0">
                 <a:solidFill>
                   <a:srgbClr val="D62839"/>
                 </a:solidFill>
@@ -1763,7 +1763,7 @@
               </a:rPr>
               <a:t>18</a:t>
             </a:r>
-            <a:endParaRPr lang="en-US" sz="1400" dirty="0"/>
+            <a:endParaRPr lang="en-US" sz="1700" dirty="0"/>
           </a:p>
         </p:txBody>
       </p:sp>
@@ -1836,7 +1836,7 @@
               <a:buNone/>
             </a:pPr>
             <a:r>
-              <a:rPr lang="en-US" sz="750" dirty="0">
+              <a:rPr lang="en-US" sz="800" dirty="0">
                 <a:solidFill>
                   <a:srgbClr val="6B7280"/>
                 </a:solidFill>
@@ -1846,7 +1846,7 @@
               </a:rPr>
               <a:t>6,3% do setor</a:t>
             </a:r>
-            <a:endParaRPr lang="en-US" sz="750" dirty="0"/>
+            <a:endParaRPr lang="en-US" sz="800" dirty="0"/>
           </a:p>
         </p:txBody>
       </p:sp>
@@ -1917,7 +1917,7 @@
               <a:buNone/>
             </a:pPr>
             <a:r>
-              <a:rPr lang="en-US" sz="1100" b="1" dirty="0">
+              <a:rPr lang="en-US" sz="1300" b="1" dirty="0">
                 <a:solidFill>
                   <a:srgbClr val="FFFFFF"/>
                 </a:solidFill>
@@ -1927,7 +1927,7 @@
               </a:rPr>
               <a:t>4</a:t>
             </a:r>
-            <a:endParaRPr lang="en-US" sz="1100" dirty="0"/>
+            <a:endParaRPr lang="en-US" sz="1300" dirty="0"/>
           </a:p>
         </p:txBody>
       </p:sp>
@@ -1956,7 +1956,7 @@
               <a:buNone/>
             </a:pPr>
             <a:r>
-              <a:rPr lang="en-US" sz="1150" b="1" dirty="0">
+              <a:rPr lang="en-US" sz="1500" b="1" dirty="0">
                 <a:solidFill>
                   <a:srgbClr val="1D3557"/>
                 </a:solidFill>
@@ -1966,7 +1966,7 @@
               </a:rPr>
               <a:t>Setor 5152</a:t>
             </a:r>
-            <a:endParaRPr lang="en-US" sz="1150" dirty="0"/>
+            <a:endParaRPr lang="en-US" sz="1500" dirty="0"/>
           </a:p>
         </p:txBody>
       </p:sp>
@@ -1995,7 +1995,7 @@
               <a:buNone/>
             </a:pPr>
             <a:r>
-              <a:rPr lang="en-US" sz="1400" b="1" dirty="0">
+              <a:rPr lang="en-US" sz="1700" b="1" dirty="0">
                 <a:solidFill>
                   <a:srgbClr val="D62839"/>
                 </a:solidFill>
@@ -2005,7 +2005,7 @@
               </a:rPr>
               <a:t>12</a:t>
             </a:r>
-            <a:endParaRPr lang="en-US" sz="1400" dirty="0"/>
+            <a:endParaRPr lang="en-US" sz="1700" dirty="0"/>
           </a:p>
         </p:txBody>
       </p:sp>
@@ -2078,7 +2078,7 @@
               <a:buNone/>
             </a:pPr>
             <a:r>
-              <a:rPr lang="en-US" sz="750" dirty="0">
+              <a:rPr lang="en-US" sz="800" dirty="0">
                 <a:solidFill>
                   <a:srgbClr val="6B7280"/>
                 </a:solidFill>
@@ -2088,7 +2088,7 @@
               </a:rPr>
               <a:t>4,0% do setor</a:t>
             </a:r>
-            <a:endParaRPr lang="en-US" sz="750" dirty="0"/>
+            <a:endParaRPr lang="en-US" sz="800" dirty="0"/>
           </a:p>
         </p:txBody>
       </p:sp>
@@ -2159,7 +2159,7 @@
               <a:buNone/>
             </a:pPr>
             <a:r>
-              <a:rPr lang="en-US" sz="1100" b="1" dirty="0">
+              <a:rPr lang="en-US" sz="1300" b="1" dirty="0">
                 <a:solidFill>
                   <a:srgbClr val="FFFFFF"/>
                 </a:solidFill>
@@ -2169,7 +2169,7 @@
               </a:rPr>
               <a:t>5</a:t>
             </a:r>
-            <a:endParaRPr lang="en-US" sz="1100" dirty="0"/>
+            <a:endParaRPr lang="en-US" sz="1300" dirty="0"/>
           </a:p>
         </p:txBody>
       </p:sp>
@@ -2198,7 +2198,7 @@
               <a:buNone/>
             </a:pPr>
             <a:r>
-              <a:rPr lang="en-US" sz="1150" b="1" dirty="0">
+              <a:rPr lang="en-US" sz="1500" b="1" dirty="0">
                 <a:solidFill>
                   <a:srgbClr val="1D3557"/>
                 </a:solidFill>
@@ -2208,7 +2208,7 @@
               </a:rPr>
               <a:t>Setor 7741</a:t>
             </a:r>
-            <a:endParaRPr lang="en-US" sz="1150" dirty="0"/>
+            <a:endParaRPr lang="en-US" sz="1500" dirty="0"/>
           </a:p>
         </p:txBody>
       </p:sp>
@@ -2237,7 +2237,7 @@
               <a:buNone/>
             </a:pPr>
             <a:r>
-              <a:rPr lang="en-US" sz="1400" b="1" dirty="0">
+              <a:rPr lang="en-US" sz="1700" b="1" dirty="0">
                 <a:solidFill>
                   <a:srgbClr val="D62839"/>
                 </a:solidFill>
@@ -2247,7 +2247,7 @@
               </a:rPr>
               <a:t>12</a:t>
             </a:r>
-            <a:endParaRPr lang="en-US" sz="1400" dirty="0"/>
+            <a:endParaRPr lang="en-US" sz="1700" dirty="0"/>
           </a:p>
         </p:txBody>
       </p:sp>
@@ -2320,7 +2320,7 @@
               <a:buNone/>
             </a:pPr>
             <a:r>
-              <a:rPr lang="en-US" sz="750" dirty="0">
+              <a:rPr lang="en-US" sz="800" dirty="0">
                 <a:solidFill>
                   <a:srgbClr val="6B7280"/>
                 </a:solidFill>
@@ -2330,7 +2330,7 @@
               </a:rPr>
               <a:t>4,2% do setor</a:t>
             </a:r>
-            <a:endParaRPr lang="en-US" sz="750" dirty="0"/>
+            <a:endParaRPr lang="en-US" sz="800" dirty="0"/>
           </a:p>
         </p:txBody>
       </p:sp>
@@ -2401,7 +2401,7 @@
               <a:buNone/>
             </a:pPr>
             <a:r>
-              <a:rPr lang="en-US" sz="1100" b="1" dirty="0">
+              <a:rPr lang="en-US" sz="1300" b="1" dirty="0">
                 <a:solidFill>
                   <a:srgbClr val="FFFFFF"/>
                 </a:solidFill>
@@ -2411,7 +2411,7 @@
               </a:rPr>
               <a:t>6</a:t>
             </a:r>
-            <a:endParaRPr lang="en-US" sz="1100" dirty="0"/>
+            <a:endParaRPr lang="en-US" sz="1300" dirty="0"/>
           </a:p>
         </p:txBody>
       </p:sp>
@@ -2440,7 +2440,7 @@
               <a:buNone/>
             </a:pPr>
             <a:r>
-              <a:rPr lang="en-US" sz="1150" b="1" dirty="0">
+              <a:rPr lang="en-US" sz="1500" b="1" dirty="0">
                 <a:solidFill>
                   <a:srgbClr val="1D3557"/>
                 </a:solidFill>
@@ -2450,7 +2450,7 @@
               </a:rPr>
               <a:t>Setor 7742</a:t>
             </a:r>
-            <a:endParaRPr lang="en-US" sz="1150" dirty="0"/>
+            <a:endParaRPr lang="en-US" sz="1500" dirty="0"/>
           </a:p>
         </p:txBody>
       </p:sp>
@@ -2479,7 +2479,7 @@
               <a:buNone/>
             </a:pPr>
             <a:r>
-              <a:rPr lang="en-US" sz="1400" b="1" dirty="0">
+              <a:rPr lang="en-US" sz="1700" b="1" dirty="0">
                 <a:solidFill>
                   <a:srgbClr val="D62839"/>
                 </a:solidFill>
@@ -2489,7 +2489,7 @@
               </a:rPr>
               <a:t>7</a:t>
             </a:r>
-            <a:endParaRPr lang="en-US" sz="1400" dirty="0"/>
+            <a:endParaRPr lang="en-US" sz="1700" dirty="0"/>
           </a:p>
         </p:txBody>
       </p:sp>
@@ -2562,7 +2562,7 @@
               <a:buNone/>
             </a:pPr>
             <a:r>
-              <a:rPr lang="en-US" sz="750" dirty="0">
+              <a:rPr lang="en-US" sz="800" dirty="0">
                 <a:solidFill>
                   <a:srgbClr val="6B7280"/>
                 </a:solidFill>
@@ -2572,7 +2572,7 @@
               </a:rPr>
               <a:t>2,3% do setor</a:t>
             </a:r>
-            <a:endParaRPr lang="en-US" sz="750" dirty="0"/>
+            <a:endParaRPr lang="en-US" sz="800" dirty="0"/>
           </a:p>
         </p:txBody>
       </p:sp>
@@ -2643,7 +2643,7 @@
               <a:buNone/>
             </a:pPr>
             <a:r>
-              <a:rPr lang="en-US" sz="1100" b="1" dirty="0">
+              <a:rPr lang="en-US" sz="1300" b="1" dirty="0">
                 <a:solidFill>
                   <a:srgbClr val="FFFFFF"/>
                 </a:solidFill>
@@ -2653,7 +2653,7 @@
               </a:rPr>
               <a:t>7</a:t>
             </a:r>
-            <a:endParaRPr lang="en-US" sz="1100" dirty="0"/>
+            <a:endParaRPr lang="en-US" sz="1300" dirty="0"/>
           </a:p>
         </p:txBody>
       </p:sp>
@@ -2682,7 +2682,7 @@
               <a:buNone/>
             </a:pPr>
             <a:r>
-              <a:rPr lang="en-US" sz="1150" b="1" dirty="0">
+              <a:rPr lang="en-US" sz="1500" b="1" dirty="0">
                 <a:solidFill>
                   <a:srgbClr val="1D3557"/>
                 </a:solidFill>
@@ -2692,7 +2692,7 @@
               </a:rPr>
               <a:t>Setor 5613</a:t>
             </a:r>
-            <a:endParaRPr lang="en-US" sz="1150" dirty="0"/>
+            <a:endParaRPr lang="en-US" sz="1500" dirty="0"/>
           </a:p>
         </p:txBody>
       </p:sp>
@@ -2721,7 +2721,7 @@
               <a:buNone/>
             </a:pPr>
             <a:r>
-              <a:rPr lang="en-US" sz="1400" b="1" dirty="0">
+              <a:rPr lang="en-US" sz="1700" b="1" dirty="0">
                 <a:solidFill>
                   <a:srgbClr val="D62839"/>
                 </a:solidFill>
@@ -2731,7 +2731,7 @@
               </a:rPr>
               <a:t>6</a:t>
             </a:r>
-            <a:endParaRPr lang="en-US" sz="1400" dirty="0"/>
+            <a:endParaRPr lang="en-US" sz="1700" dirty="0"/>
           </a:p>
         </p:txBody>
       </p:sp>
@@ -2804,7 +2804,7 @@
               <a:buNone/>
             </a:pPr>
             <a:r>
-              <a:rPr lang="en-US" sz="750" dirty="0">
+              <a:rPr lang="en-US" sz="800" dirty="0">
                 <a:solidFill>
                   <a:srgbClr val="6B7280"/>
                 </a:solidFill>
@@ -2814,7 +2814,7 @@
               </a:rPr>
               <a:t>2,1% do setor</a:t>
             </a:r>
-            <a:endParaRPr lang="en-US" sz="750" dirty="0"/>
+            <a:endParaRPr lang="en-US" sz="800" dirty="0"/>
           </a:p>
         </p:txBody>
       </p:sp>
@@ -2885,7 +2885,7 @@
               <a:buNone/>
             </a:pPr>
             <a:r>
-              <a:rPr lang="en-US" sz="1100" b="1" dirty="0">
+              <a:rPr lang="en-US" sz="1300" b="1" dirty="0">
                 <a:solidFill>
                   <a:srgbClr val="FFFFFF"/>
                 </a:solidFill>
@@ -2895,7 +2895,7 @@
               </a:rPr>
               <a:t>8</a:t>
             </a:r>
-            <a:endParaRPr lang="en-US" sz="1100" dirty="0"/>
+            <a:endParaRPr lang="en-US" sz="1300" dirty="0"/>
           </a:p>
         </p:txBody>
       </p:sp>
@@ -2924,7 +2924,7 @@
               <a:buNone/>
             </a:pPr>
             <a:r>
-              <a:rPr lang="en-US" sz="1150" b="1" dirty="0">
+              <a:rPr lang="en-US" sz="1500" b="1" dirty="0">
                 <a:solidFill>
                   <a:srgbClr val="1D3557"/>
                 </a:solidFill>
@@ -2934,7 +2934,7 @@
               </a:rPr>
               <a:t>Setor 7748</a:t>
             </a:r>
-            <a:endParaRPr lang="en-US" sz="1150" dirty="0"/>
+            <a:endParaRPr lang="en-US" sz="1500" dirty="0"/>
           </a:p>
         </p:txBody>
       </p:sp>
@@ -2963,7 +2963,7 @@
               <a:buNone/>
             </a:pPr>
             <a:r>
-              <a:rPr lang="en-US" sz="1400" b="1" dirty="0">
+              <a:rPr lang="en-US" sz="1700" b="1" dirty="0">
                 <a:solidFill>
                   <a:srgbClr val="D62839"/>
                 </a:solidFill>
@@ -2973,7 +2973,7 @@
               </a:rPr>
               <a:t>5</a:t>
             </a:r>
-            <a:endParaRPr lang="en-US" sz="1400" dirty="0"/>
+            <a:endParaRPr lang="en-US" sz="1700" dirty="0"/>
           </a:p>
         </p:txBody>
       </p:sp>
@@ -3046,7 +3046,7 @@
               <a:buNone/>
             </a:pPr>
             <a:r>
-              <a:rPr lang="en-US" sz="750" dirty="0">
+              <a:rPr lang="en-US" sz="800" dirty="0">
                 <a:solidFill>
                   <a:srgbClr val="6B7280"/>
                 </a:solidFill>
@@ -3056,7 +3056,7 @@
               </a:rPr>
               <a:t>1,7% do setor</a:t>
             </a:r>
-            <a:endParaRPr lang="en-US" sz="750" dirty="0"/>
+            <a:endParaRPr lang="en-US" sz="800" dirty="0"/>
           </a:p>
         </p:txBody>
       </p:sp>
@@ -3114,7 +3114,7 @@
               <a:buNone/>
             </a:pPr>
             <a:r>
-              <a:rPr lang="en-US" sz="1800" b="1" dirty="0">
+              <a:rPr lang="en-US" sz="2300" b="1" dirty="0">
                 <a:solidFill>
                   <a:srgbClr val="FFFFFF"/>
                 </a:solidFill>
@@ -3124,7 +3124,7 @@
               </a:rPr>
               <a:t>CAT 2</a:t>
             </a:r>
-            <a:endParaRPr lang="en-US" sz="1800" dirty="0"/>
+            <a:endParaRPr lang="en-US" sz="2300" dirty="0"/>
           </a:p>
         </p:txBody>
       </p:sp>
@@ -3153,7 +3153,7 @@
               <a:buNone/>
             </a:pPr>
             <a:r>
-              <a:rPr lang="en-US" sz="1050" dirty="0">
+              <a:rPr lang="en-US" sz="1250" dirty="0">
                 <a:solidFill>
                   <a:srgbClr val="FFFFFF"/>
                 </a:solidFill>
@@ -3163,7 +3163,7 @@
               </a:rPr>
               <a:t>224 médicos no painel</a:t>
             </a:r>
-            <a:endParaRPr lang="en-US" sz="1050" dirty="0"/>
+            <a:endParaRPr lang="en-US" sz="1250" dirty="0"/>
           </a:p>
         </p:txBody>
       </p:sp>
@@ -3234,7 +3234,7 @@
               <a:buNone/>
             </a:pPr>
             <a:r>
-              <a:rPr lang="en-US" sz="1100" b="1" dirty="0">
+              <a:rPr lang="en-US" sz="1300" b="1" dirty="0">
                 <a:solidFill>
                   <a:srgbClr val="FFFFFF"/>
                 </a:solidFill>
@@ -3244,7 +3244,7 @@
               </a:rPr>
               <a:t>1</a:t>
             </a:r>
-            <a:endParaRPr lang="en-US" sz="1100" dirty="0"/>
+            <a:endParaRPr lang="en-US" sz="1300" dirty="0"/>
           </a:p>
         </p:txBody>
       </p:sp>
@@ -3273,7 +3273,7 @@
               <a:buNone/>
             </a:pPr>
             <a:r>
-              <a:rPr lang="en-US" sz="1150" b="1" dirty="0">
+              <a:rPr lang="en-US" sz="1500" b="1" dirty="0">
                 <a:solidFill>
                   <a:srgbClr val="1D3557"/>
                 </a:solidFill>
@@ -3283,7 +3283,7 @@
               </a:rPr>
               <a:t>Setor 7745</a:t>
             </a:r>
-            <a:endParaRPr lang="en-US" sz="1150" dirty="0"/>
+            <a:endParaRPr lang="en-US" sz="1500" dirty="0"/>
           </a:p>
         </p:txBody>
       </p:sp>
@@ -3312,7 +3312,7 @@
               <a:buNone/>
             </a:pPr>
             <a:r>
-              <a:rPr lang="en-US" sz="1400" b="1" dirty="0">
+              <a:rPr lang="en-US" sz="1700" b="1" dirty="0">
                 <a:solidFill>
                   <a:srgbClr val="F3A712"/>
                 </a:solidFill>
@@ -3322,7 +3322,7 @@
               </a:rPr>
               <a:t>51</a:t>
             </a:r>
-            <a:endParaRPr lang="en-US" sz="1400" dirty="0"/>
+            <a:endParaRPr lang="en-US" sz="1700" dirty="0"/>
           </a:p>
         </p:txBody>
       </p:sp>
@@ -3395,7 +3395,7 @@
               <a:buNone/>
             </a:pPr>
             <a:r>
-              <a:rPr lang="en-US" sz="750" dirty="0">
+              <a:rPr lang="en-US" sz="800" dirty="0">
                 <a:solidFill>
                   <a:srgbClr val="6B7280"/>
                 </a:solidFill>
@@ -3405,7 +3405,7 @@
               </a:rPr>
               <a:t>17,8% do setor</a:t>
             </a:r>
-            <a:endParaRPr lang="en-US" sz="750" dirty="0"/>
+            <a:endParaRPr lang="en-US" sz="800" dirty="0"/>
           </a:p>
         </p:txBody>
       </p:sp>
@@ -3476,7 +3476,7 @@
               <a:buNone/>
             </a:pPr>
             <a:r>
-              <a:rPr lang="en-US" sz="1100" b="1" dirty="0">
+              <a:rPr lang="en-US" sz="1300" b="1" dirty="0">
                 <a:solidFill>
                   <a:srgbClr val="FFFFFF"/>
                 </a:solidFill>
@@ -3486,7 +3486,7 @@
               </a:rPr>
               <a:t>2</a:t>
             </a:r>
-            <a:endParaRPr lang="en-US" sz="1100" dirty="0"/>
+            <a:endParaRPr lang="en-US" sz="1300" dirty="0"/>
           </a:p>
         </p:txBody>
       </p:sp>
@@ -3515,7 +3515,7 @@
               <a:buNone/>
             </a:pPr>
             <a:r>
-              <a:rPr lang="en-US" sz="1150" b="1" dirty="0">
+              <a:rPr lang="en-US" sz="1500" b="1" dirty="0">
                 <a:solidFill>
                   <a:srgbClr val="1D3557"/>
                 </a:solidFill>
@@ -3525,7 +3525,7 @@
               </a:rPr>
               <a:t>Setor 5153</a:t>
             </a:r>
-            <a:endParaRPr lang="en-US" sz="1150" dirty="0"/>
+            <a:endParaRPr lang="en-US" sz="1500" dirty="0"/>
           </a:p>
         </p:txBody>
       </p:sp>
@@ -3554,7 +3554,7 @@
               <a:buNone/>
             </a:pPr>
             <a:r>
-              <a:rPr lang="en-US" sz="1400" b="1" dirty="0">
+              <a:rPr lang="en-US" sz="1700" b="1" dirty="0">
                 <a:solidFill>
                   <a:srgbClr val="F3A712"/>
                 </a:solidFill>
@@ -3564,7 +3564,7 @@
               </a:rPr>
               <a:t>45</a:t>
             </a:r>
-            <a:endParaRPr lang="en-US" sz="1400" dirty="0"/>
+            <a:endParaRPr lang="en-US" sz="1700" dirty="0"/>
           </a:p>
         </p:txBody>
       </p:sp>
@@ -3637,7 +3637,7 @@
               <a:buNone/>
             </a:pPr>
             <a:r>
-              <a:rPr lang="en-US" sz="750" dirty="0">
+              <a:rPr lang="en-US" sz="800" dirty="0">
                 <a:solidFill>
                   <a:srgbClr val="6B7280"/>
                 </a:solidFill>
@@ -3647,7 +3647,7 @@
               </a:rPr>
               <a:t>15,7% do setor</a:t>
             </a:r>
-            <a:endParaRPr lang="en-US" sz="750" dirty="0"/>
+            <a:endParaRPr lang="en-US" sz="800" dirty="0"/>
           </a:p>
         </p:txBody>
       </p:sp>
@@ -3718,7 +3718,7 @@
               <a:buNone/>
             </a:pPr>
             <a:r>
-              <a:rPr lang="en-US" sz="1100" b="1" dirty="0">
+              <a:rPr lang="en-US" sz="1300" b="1" dirty="0">
                 <a:solidFill>
                   <a:srgbClr val="FFFFFF"/>
                 </a:solidFill>
@@ -3728,7 +3728,7 @@
               </a:rPr>
               <a:t>3</a:t>
             </a:r>
-            <a:endParaRPr lang="en-US" sz="1100" dirty="0"/>
+            <a:endParaRPr lang="en-US" sz="1300" dirty="0"/>
           </a:p>
         </p:txBody>
       </p:sp>
@@ -3757,7 +3757,7 @@
               <a:buNone/>
             </a:pPr>
             <a:r>
-              <a:rPr lang="en-US" sz="1150" b="1" dirty="0">
+              <a:rPr lang="en-US" sz="1500" b="1" dirty="0">
                 <a:solidFill>
                   <a:srgbClr val="1D3557"/>
                 </a:solidFill>
@@ -3767,7 +3767,7 @@
               </a:rPr>
               <a:t>Setor 5149</a:t>
             </a:r>
-            <a:endParaRPr lang="en-US" sz="1150" dirty="0"/>
+            <a:endParaRPr lang="en-US" sz="1500" dirty="0"/>
           </a:p>
         </p:txBody>
       </p:sp>
@@ -3796,7 +3796,7 @@
               <a:buNone/>
             </a:pPr>
             <a:r>
-              <a:rPr lang="en-US" sz="1400" b="1" dirty="0">
+              <a:rPr lang="en-US" sz="1700" b="1" dirty="0">
                 <a:solidFill>
                   <a:srgbClr val="F3A712"/>
                 </a:solidFill>
@@ -3806,7 +3806,7 @@
               </a:rPr>
               <a:t>28</a:t>
             </a:r>
-            <a:endParaRPr lang="en-US" sz="1400" dirty="0"/>
+            <a:endParaRPr lang="en-US" sz="1700" dirty="0"/>
           </a:p>
         </p:txBody>
       </p:sp>
@@ -3879,7 +3879,7 @@
               <a:buNone/>
             </a:pPr>
             <a:r>
-              <a:rPr lang="en-US" sz="750" dirty="0">
+              <a:rPr lang="en-US" sz="800" dirty="0">
                 <a:solidFill>
                   <a:srgbClr val="6B7280"/>
                 </a:solidFill>
@@ -3889,7 +3889,7 @@
               </a:rPr>
               <a:t>9,0% do setor</a:t>
             </a:r>
-            <a:endParaRPr lang="en-US" sz="750" dirty="0"/>
+            <a:endParaRPr lang="en-US" sz="800" dirty="0"/>
           </a:p>
         </p:txBody>
       </p:sp>
@@ -3960,7 +3960,7 @@
               <a:buNone/>
             </a:pPr>
             <a:r>
-              <a:rPr lang="en-US" sz="1100" b="1" dirty="0">
+              <a:rPr lang="en-US" sz="1300" b="1" dirty="0">
                 <a:solidFill>
                   <a:srgbClr val="FFFFFF"/>
                 </a:solidFill>
@@ -3970,7 +3970,7 @@
               </a:rPr>
               <a:t>4</a:t>
             </a:r>
-            <a:endParaRPr lang="en-US" sz="1100" dirty="0"/>
+            <a:endParaRPr lang="en-US" sz="1300" dirty="0"/>
           </a:p>
         </p:txBody>
       </p:sp>
@@ -3999,7 +3999,7 @@
               <a:buNone/>
             </a:pPr>
             <a:r>
-              <a:rPr lang="en-US" sz="1150" b="1" dirty="0">
+              <a:rPr lang="en-US" sz="1500" b="1" dirty="0">
                 <a:solidFill>
                   <a:srgbClr val="1D3557"/>
                 </a:solidFill>
@@ -4009,7 +4009,7 @@
               </a:rPr>
               <a:t>Setor 7748</a:t>
             </a:r>
-            <a:endParaRPr lang="en-US" sz="1150" dirty="0"/>
+            <a:endParaRPr lang="en-US" sz="1500" dirty="0"/>
           </a:p>
         </p:txBody>
       </p:sp>
@@ -4038,7 +4038,7 @@
               <a:buNone/>
             </a:pPr>
             <a:r>
-              <a:rPr lang="en-US" sz="1400" b="1" dirty="0">
+              <a:rPr lang="en-US" sz="1700" b="1" dirty="0">
                 <a:solidFill>
                   <a:srgbClr val="F3A712"/>
                 </a:solidFill>
@@ -4048,7 +4048,7 @@
               </a:rPr>
               <a:t>24</a:t>
             </a:r>
-            <a:endParaRPr lang="en-US" sz="1400" dirty="0"/>
+            <a:endParaRPr lang="en-US" sz="1700" dirty="0"/>
           </a:p>
         </p:txBody>
       </p:sp>
@@ -4121,7 +4121,7 @@
               <a:buNone/>
             </a:pPr>
             <a:r>
-              <a:rPr lang="en-US" sz="750" dirty="0">
+              <a:rPr lang="en-US" sz="800" dirty="0">
                 <a:solidFill>
                   <a:srgbClr val="6B7280"/>
                 </a:solidFill>
@@ -4131,7 +4131,7 @@
               </a:rPr>
               <a:t>8,3% do setor</a:t>
             </a:r>
-            <a:endParaRPr lang="en-US" sz="750" dirty="0"/>
+            <a:endParaRPr lang="en-US" sz="800" dirty="0"/>
           </a:p>
         </p:txBody>
       </p:sp>
@@ -4202,7 +4202,7 @@
               <a:buNone/>
             </a:pPr>
             <a:r>
-              <a:rPr lang="en-US" sz="1100" b="1" dirty="0">
+              <a:rPr lang="en-US" sz="1300" b="1" dirty="0">
                 <a:solidFill>
                   <a:srgbClr val="FFFFFF"/>
                 </a:solidFill>
@@ -4212,7 +4212,7 @@
               </a:rPr>
               <a:t>5</a:t>
             </a:r>
-            <a:endParaRPr lang="en-US" sz="1100" dirty="0"/>
+            <a:endParaRPr lang="en-US" sz="1300" dirty="0"/>
           </a:p>
         </p:txBody>
       </p:sp>
@@ -4241,7 +4241,7 @@
               <a:buNone/>
             </a:pPr>
             <a:r>
-              <a:rPr lang="en-US" sz="1150" b="1" dirty="0">
+              <a:rPr lang="en-US" sz="1500" b="1" dirty="0">
                 <a:solidFill>
                   <a:srgbClr val="1D3557"/>
                 </a:solidFill>
@@ -4251,7 +4251,7 @@
               </a:rPr>
               <a:t>Setor 5613</a:t>
             </a:r>
-            <a:endParaRPr lang="en-US" sz="1150" dirty="0"/>
+            <a:endParaRPr lang="en-US" sz="1500" dirty="0"/>
           </a:p>
         </p:txBody>
       </p:sp>
@@ -4280,7 +4280,7 @@
               <a:buNone/>
             </a:pPr>
             <a:r>
-              <a:rPr lang="en-US" sz="1400" b="1" dirty="0">
+              <a:rPr lang="en-US" sz="1700" b="1" dirty="0">
                 <a:solidFill>
                   <a:srgbClr val="F3A712"/>
                 </a:solidFill>
@@ -4290,7 +4290,7 @@
               </a:rPr>
               <a:t>23</a:t>
             </a:r>
-            <a:endParaRPr lang="en-US" sz="1400" dirty="0"/>
+            <a:endParaRPr lang="en-US" sz="1700" dirty="0"/>
           </a:p>
         </p:txBody>
       </p:sp>
@@ -4363,7 +4363,7 @@
               <a:buNone/>
             </a:pPr>
             <a:r>
-              <a:rPr lang="en-US" sz="750" dirty="0">
+              <a:rPr lang="en-US" sz="800" dirty="0">
                 <a:solidFill>
                   <a:srgbClr val="6B7280"/>
                 </a:solidFill>
@@ -4373,7 +4373,7 @@
               </a:rPr>
               <a:t>8,2% do setor</a:t>
             </a:r>
-            <a:endParaRPr lang="en-US" sz="750" dirty="0"/>
+            <a:endParaRPr lang="en-US" sz="800" dirty="0"/>
           </a:p>
         </p:txBody>
       </p:sp>
@@ -4444,7 +4444,7 @@
               <a:buNone/>
             </a:pPr>
             <a:r>
-              <a:rPr lang="en-US" sz="1100" b="1" dirty="0">
+              <a:rPr lang="en-US" sz="1300" b="1" dirty="0">
                 <a:solidFill>
                   <a:srgbClr val="FFFFFF"/>
                 </a:solidFill>
@@ -4454,7 +4454,7 @@
               </a:rPr>
               <a:t>6</a:t>
             </a:r>
-            <a:endParaRPr lang="en-US" sz="1100" dirty="0"/>
+            <a:endParaRPr lang="en-US" sz="1300" dirty="0"/>
           </a:p>
         </p:txBody>
       </p:sp>
@@ -4483,7 +4483,7 @@
               <a:buNone/>
             </a:pPr>
             <a:r>
-              <a:rPr lang="en-US" sz="1150" b="1" dirty="0">
+              <a:rPr lang="en-US" sz="1500" b="1" dirty="0">
                 <a:solidFill>
                   <a:srgbClr val="1D3557"/>
                 </a:solidFill>
@@ -4493,7 +4493,7 @@
               </a:rPr>
               <a:t>Setor 7741</a:t>
             </a:r>
-            <a:endParaRPr lang="en-US" sz="1150" dirty="0"/>
+            <a:endParaRPr lang="en-US" sz="1500" dirty="0"/>
           </a:p>
         </p:txBody>
       </p:sp>
@@ -4522,7 +4522,7 @@
               <a:buNone/>
             </a:pPr>
             <a:r>
-              <a:rPr lang="en-US" sz="1400" b="1" dirty="0">
+              <a:rPr lang="en-US" sz="1700" b="1" dirty="0">
                 <a:solidFill>
                   <a:srgbClr val="F3A712"/>
                 </a:solidFill>
@@ -4532,7 +4532,7 @@
               </a:rPr>
               <a:t>22</a:t>
             </a:r>
-            <a:endParaRPr lang="en-US" sz="1400" dirty="0"/>
+            <a:endParaRPr lang="en-US" sz="1700" dirty="0"/>
           </a:p>
         </p:txBody>
       </p:sp>
@@ -4605,7 +4605,7 @@
               <a:buNone/>
             </a:pPr>
             <a:r>
-              <a:rPr lang="en-US" sz="750" dirty="0">
+              <a:rPr lang="en-US" sz="800" dirty="0">
                 <a:solidFill>
                   <a:srgbClr val="6B7280"/>
                 </a:solidFill>
@@ -4615,7 +4615,7 @@
               </a:rPr>
               <a:t>7,7% do setor</a:t>
             </a:r>
-            <a:endParaRPr lang="en-US" sz="750" dirty="0"/>
+            <a:endParaRPr lang="en-US" sz="800" dirty="0"/>
           </a:p>
         </p:txBody>
       </p:sp>
@@ -4686,7 +4686,7 @@
               <a:buNone/>
             </a:pPr>
             <a:r>
-              <a:rPr lang="en-US" sz="1100" b="1" dirty="0">
+              <a:rPr lang="en-US" sz="1300" b="1" dirty="0">
                 <a:solidFill>
                   <a:srgbClr val="FFFFFF"/>
                 </a:solidFill>
@@ -4696,7 +4696,7 @@
               </a:rPr>
               <a:t>7</a:t>
             </a:r>
-            <a:endParaRPr lang="en-US" sz="1100" dirty="0"/>
+            <a:endParaRPr lang="en-US" sz="1300" dirty="0"/>
           </a:p>
         </p:txBody>
       </p:sp>
@@ -4725,7 +4725,7 @@
               <a:buNone/>
             </a:pPr>
             <a:r>
-              <a:rPr lang="en-US" sz="1150" b="1" dirty="0">
+              <a:rPr lang="en-US" sz="1500" b="1" dirty="0">
                 <a:solidFill>
                   <a:srgbClr val="1D3557"/>
                 </a:solidFill>
@@ -4735,7 +4735,7 @@
               </a:rPr>
               <a:t>Setor 5152</a:t>
             </a:r>
-            <a:endParaRPr lang="en-US" sz="1150" dirty="0"/>
+            <a:endParaRPr lang="en-US" sz="1500" dirty="0"/>
           </a:p>
         </p:txBody>
       </p:sp>
@@ -4764,7 +4764,7 @@
               <a:buNone/>
             </a:pPr>
             <a:r>
-              <a:rPr lang="en-US" sz="1400" b="1" dirty="0">
+              <a:rPr lang="en-US" sz="1700" b="1" dirty="0">
                 <a:solidFill>
                   <a:srgbClr val="F3A712"/>
                 </a:solidFill>
@@ -4774,7 +4774,7 @@
               </a:rPr>
               <a:t>18</a:t>
             </a:r>
-            <a:endParaRPr lang="en-US" sz="1400" dirty="0"/>
+            <a:endParaRPr lang="en-US" sz="1700" dirty="0"/>
           </a:p>
         </p:txBody>
       </p:sp>
@@ -4847,7 +4847,7 @@
               <a:buNone/>
             </a:pPr>
             <a:r>
-              <a:rPr lang="en-US" sz="750" dirty="0">
+              <a:rPr lang="en-US" sz="800" dirty="0">
                 <a:solidFill>
                   <a:srgbClr val="6B7280"/>
                 </a:solidFill>
@@ -4857,7 +4857,7 @@
               </a:rPr>
               <a:t>6,1% do setor</a:t>
             </a:r>
-            <a:endParaRPr lang="en-US" sz="750" dirty="0"/>
+            <a:endParaRPr lang="en-US" sz="800" dirty="0"/>
           </a:p>
         </p:txBody>
       </p:sp>
@@ -4928,7 +4928,7 @@
               <a:buNone/>
             </a:pPr>
             <a:r>
-              <a:rPr lang="en-US" sz="1100" b="1" dirty="0">
+              <a:rPr lang="en-US" sz="1300" b="1" dirty="0">
                 <a:solidFill>
                   <a:srgbClr val="FFFFFF"/>
                 </a:solidFill>
@@ -4938,7 +4938,7 @@
               </a:rPr>
               <a:t>8</a:t>
             </a:r>
-            <a:endParaRPr lang="en-US" sz="1100" dirty="0"/>
+            <a:endParaRPr lang="en-US" sz="1300" dirty="0"/>
           </a:p>
         </p:txBody>
       </p:sp>
@@ -4967,7 +4967,7 @@
               <a:buNone/>
             </a:pPr>
             <a:r>
-              <a:rPr lang="en-US" sz="1150" b="1" dirty="0">
+              <a:rPr lang="en-US" sz="1500" b="1" dirty="0">
                 <a:solidFill>
                   <a:srgbClr val="1D3557"/>
                 </a:solidFill>
@@ -4977,7 +4977,7 @@
               </a:rPr>
               <a:t>Setor 7742</a:t>
             </a:r>
-            <a:endParaRPr lang="en-US" sz="1150" dirty="0"/>
+            <a:endParaRPr lang="en-US" sz="1500" dirty="0"/>
           </a:p>
         </p:txBody>
       </p:sp>
@@ -5006,7 +5006,7 @@
               <a:buNone/>
             </a:pPr>
             <a:r>
-              <a:rPr lang="en-US" sz="1400" b="1" dirty="0">
+              <a:rPr lang="en-US" sz="1700" b="1" dirty="0">
                 <a:solidFill>
                   <a:srgbClr val="F3A712"/>
                 </a:solidFill>
@@ -5016,7 +5016,7 @@
               </a:rPr>
               <a:t>13</a:t>
             </a:r>
-            <a:endParaRPr lang="en-US" sz="1400" dirty="0"/>
+            <a:endParaRPr lang="en-US" sz="1700" dirty="0"/>
           </a:p>
         </p:txBody>
       </p:sp>
@@ -5089,7 +5089,7 @@
               <a:buNone/>
             </a:pPr>
             <a:r>
-              <a:rPr lang="en-US" sz="750" dirty="0">
+              <a:rPr lang="en-US" sz="800" dirty="0">
                 <a:solidFill>
                   <a:srgbClr val="6B7280"/>
                 </a:solidFill>
@@ -5099,7 +5099,7 @@
               </a:rPr>
               <a:t>4,2% do setor</a:t>
             </a:r>
-            <a:endParaRPr lang="en-US" sz="750" dirty="0"/>
+            <a:endParaRPr lang="en-US" sz="800" dirty="0"/>
           </a:p>
         </p:txBody>
       </p:sp>
@@ -5157,7 +5157,7 @@
               <a:buNone/>
             </a:pPr>
             <a:r>
-              <a:rPr lang="en-US" sz="1800" b="1" dirty="0">
+              <a:rPr lang="en-US" sz="2300" b="1" dirty="0">
                 <a:solidFill>
                   <a:srgbClr val="FFFFFF"/>
                 </a:solidFill>
@@ -5167,7 +5167,7 @@
               </a:rPr>
               <a:t>CAT 3</a:t>
             </a:r>
-            <a:endParaRPr lang="en-US" sz="1800" dirty="0"/>
+            <a:endParaRPr lang="en-US" sz="2300" dirty="0"/>
           </a:p>
         </p:txBody>
       </p:sp>
@@ -5196,7 +5196,7 @@
               <a:buNone/>
             </a:pPr>
             <a:r>
-              <a:rPr lang="en-US" sz="1050" dirty="0">
+              <a:rPr lang="en-US" sz="1250" dirty="0">
                 <a:solidFill>
                   <a:srgbClr val="FFFFFF"/>
                 </a:solidFill>
@@ -5206,7 +5206,7 @@
               </a:rPr>
               <a:t>351 médicos no painel</a:t>
             </a:r>
-            <a:endParaRPr lang="en-US" sz="1050" dirty="0"/>
+            <a:endParaRPr lang="en-US" sz="1250" dirty="0"/>
           </a:p>
         </p:txBody>
       </p:sp>
@@ -5277,7 +5277,7 @@
               <a:buNone/>
             </a:pPr>
             <a:r>
-              <a:rPr lang="en-US" sz="1100" b="1" dirty="0">
+              <a:rPr lang="en-US" sz="1300" b="1" dirty="0">
                 <a:solidFill>
                   <a:srgbClr val="FFFFFF"/>
                 </a:solidFill>
@@ -5287,7 +5287,7 @@
               </a:rPr>
               <a:t>1</a:t>
             </a:r>
-            <a:endParaRPr lang="en-US" sz="1100" dirty="0"/>
+            <a:endParaRPr lang="en-US" sz="1300" dirty="0"/>
           </a:p>
         </p:txBody>
       </p:sp>
@@ -5316,7 +5316,7 @@
               <a:buNone/>
             </a:pPr>
             <a:r>
-              <a:rPr lang="en-US" sz="1150" b="1" dirty="0">
+              <a:rPr lang="en-US" sz="1500" b="1" dirty="0">
                 <a:solidFill>
                   <a:srgbClr val="1D3557"/>
                 </a:solidFill>
@@ -5326,7 +5326,7 @@
               </a:rPr>
               <a:t>Setor 7745</a:t>
             </a:r>
-            <a:endParaRPr lang="en-US" sz="1150" dirty="0"/>
+            <a:endParaRPr lang="en-US" sz="1500" dirty="0"/>
           </a:p>
         </p:txBody>
       </p:sp>
@@ -5355,7 +5355,7 @@
               <a:buNone/>
             </a:pPr>
             <a:r>
-              <a:rPr lang="en-US" sz="1400" b="1" dirty="0">
+              <a:rPr lang="en-US" sz="1700" b="1" dirty="0">
                 <a:solidFill>
                   <a:srgbClr val="2A9D8F"/>
                 </a:solidFill>
@@ -5365,7 +5365,7 @@
               </a:rPr>
               <a:t>72</a:t>
             </a:r>
-            <a:endParaRPr lang="en-US" sz="1400" dirty="0"/>
+            <a:endParaRPr lang="en-US" sz="1700" dirty="0"/>
           </a:p>
         </p:txBody>
       </p:sp>
@@ -5438,7 +5438,7 @@
               <a:buNone/>
             </a:pPr>
             <a:r>
-              <a:rPr lang="en-US" sz="750" dirty="0">
+              <a:rPr lang="en-US" sz="800" dirty="0">
                 <a:solidFill>
                   <a:srgbClr val="6B7280"/>
                 </a:solidFill>
@@ -5448,7 +5448,7 @@
               </a:rPr>
               <a:t>25,2% do setor</a:t>
             </a:r>
-            <a:endParaRPr lang="en-US" sz="750" dirty="0"/>
+            <a:endParaRPr lang="en-US" sz="800" dirty="0"/>
           </a:p>
         </p:txBody>
       </p:sp>
@@ -5519,7 +5519,7 @@
               <a:buNone/>
             </a:pPr>
             <a:r>
-              <a:rPr lang="en-US" sz="1100" b="1" dirty="0">
+              <a:rPr lang="en-US" sz="1300" b="1" dirty="0">
                 <a:solidFill>
                   <a:srgbClr val="FFFFFF"/>
                 </a:solidFill>
@@ -5529,7 +5529,7 @@
               </a:rPr>
               <a:t>2</a:t>
             </a:r>
-            <a:endParaRPr lang="en-US" sz="1100" dirty="0"/>
+            <a:endParaRPr lang="en-US" sz="1300" dirty="0"/>
           </a:p>
         </p:txBody>
       </p:sp>
@@ -5558,7 +5558,7 @@
               <a:buNone/>
             </a:pPr>
             <a:r>
-              <a:rPr lang="en-US" sz="1150" b="1" dirty="0">
+              <a:rPr lang="en-US" sz="1500" b="1" dirty="0">
                 <a:solidFill>
                   <a:srgbClr val="1D3557"/>
                 </a:solidFill>
@@ -5568,7 +5568,7 @@
               </a:rPr>
               <a:t>Setor 5153</a:t>
             </a:r>
-            <a:endParaRPr lang="en-US" sz="1150" dirty="0"/>
+            <a:endParaRPr lang="en-US" sz="1500" dirty="0"/>
           </a:p>
         </p:txBody>
       </p:sp>
@@ -5597,7 +5597,7 @@
               <a:buNone/>
             </a:pPr>
             <a:r>
-              <a:rPr lang="en-US" sz="1400" b="1" dirty="0">
+              <a:rPr lang="en-US" sz="1700" b="1" dirty="0">
                 <a:solidFill>
                   <a:srgbClr val="2A9D8F"/>
                 </a:solidFill>
@@ -5607,7 +5607,7 @@
               </a:rPr>
               <a:t>57</a:t>
             </a:r>
-            <a:endParaRPr lang="en-US" sz="1400" dirty="0"/>
+            <a:endParaRPr lang="en-US" sz="1700" dirty="0"/>
           </a:p>
         </p:txBody>
       </p:sp>
@@ -5680,7 +5680,7 @@
               <a:buNone/>
             </a:pPr>
             <a:r>
-              <a:rPr lang="en-US" sz="750" dirty="0">
+              <a:rPr lang="en-US" sz="800" dirty="0">
                 <a:solidFill>
                   <a:srgbClr val="6B7280"/>
                 </a:solidFill>
@@ -5690,7 +5690,7 @@
               </a:rPr>
               <a:t>19,9% do setor</a:t>
             </a:r>
-            <a:endParaRPr lang="en-US" sz="750" dirty="0"/>
+            <a:endParaRPr lang="en-US" sz="800" dirty="0"/>
           </a:p>
         </p:txBody>
       </p:sp>
@@ -5761,7 +5761,7 @@
               <a:buNone/>
             </a:pPr>
             <a:r>
-              <a:rPr lang="en-US" sz="1100" b="1" dirty="0">
+              <a:rPr lang="en-US" sz="1300" b="1" dirty="0">
                 <a:solidFill>
                   <a:srgbClr val="FFFFFF"/>
                 </a:solidFill>
@@ -5771,7 +5771,7 @@
               </a:rPr>
               <a:t>3</a:t>
             </a:r>
-            <a:endParaRPr lang="en-US" sz="1100" dirty="0"/>
+            <a:endParaRPr lang="en-US" sz="1300" dirty="0"/>
           </a:p>
         </p:txBody>
       </p:sp>
@@ -5800,7 +5800,7 @@
               <a:buNone/>
             </a:pPr>
             <a:r>
-              <a:rPr lang="en-US" sz="1150" b="1" dirty="0">
+              <a:rPr lang="en-US" sz="1500" b="1" dirty="0">
                 <a:solidFill>
                   <a:srgbClr val="1D3557"/>
                 </a:solidFill>
@@ -5810,7 +5810,7 @@
               </a:rPr>
               <a:t>Setor 5149</a:t>
             </a:r>
-            <a:endParaRPr lang="en-US" sz="1150" dirty="0"/>
+            <a:endParaRPr lang="en-US" sz="1500" dirty="0"/>
           </a:p>
         </p:txBody>
       </p:sp>
@@ -5839,7 +5839,7 @@
               <a:buNone/>
             </a:pPr>
             <a:r>
-              <a:rPr lang="en-US" sz="1400" b="1" dirty="0">
+              <a:rPr lang="en-US" sz="1700" b="1" dirty="0">
                 <a:solidFill>
                   <a:srgbClr val="2A9D8F"/>
                 </a:solidFill>
@@ -5849,7 +5849,7 @@
               </a:rPr>
               <a:t>45</a:t>
             </a:r>
-            <a:endParaRPr lang="en-US" sz="1400" dirty="0"/>
+            <a:endParaRPr lang="en-US" sz="1700" dirty="0"/>
           </a:p>
         </p:txBody>
       </p:sp>
@@ -5922,7 +5922,7 @@
               <a:buNone/>
             </a:pPr>
             <a:r>
-              <a:rPr lang="en-US" sz="750" dirty="0">
+              <a:rPr lang="en-US" sz="800" dirty="0">
                 <a:solidFill>
                   <a:srgbClr val="6B7280"/>
                 </a:solidFill>
@@ -5932,7 +5932,7 @@
               </a:rPr>
               <a:t>14,5% do setor</a:t>
             </a:r>
-            <a:endParaRPr lang="en-US" sz="750" dirty="0"/>
+            <a:endParaRPr lang="en-US" sz="800" dirty="0"/>
           </a:p>
         </p:txBody>
       </p:sp>
@@ -6003,7 +6003,7 @@
               <a:buNone/>
             </a:pPr>
             <a:r>
-              <a:rPr lang="en-US" sz="1100" b="1" dirty="0">
+              <a:rPr lang="en-US" sz="1300" b="1" dirty="0">
                 <a:solidFill>
                   <a:srgbClr val="FFFFFF"/>
                 </a:solidFill>
@@ -6013,7 +6013,7 @@
               </a:rPr>
               <a:t>4</a:t>
             </a:r>
-            <a:endParaRPr lang="en-US" sz="1100" dirty="0"/>
+            <a:endParaRPr lang="en-US" sz="1300" dirty="0"/>
           </a:p>
         </p:txBody>
       </p:sp>
@@ -6042,7 +6042,7 @@
               <a:buNone/>
             </a:pPr>
             <a:r>
-              <a:rPr lang="en-US" sz="1150" b="1" dirty="0">
+              <a:rPr lang="en-US" sz="1500" b="1" dirty="0">
                 <a:solidFill>
                   <a:srgbClr val="1D3557"/>
                 </a:solidFill>
@@ -6052,7 +6052,7 @@
               </a:rPr>
               <a:t>Setor 7742</a:t>
             </a:r>
-            <a:endParaRPr lang="en-US" sz="1150" dirty="0"/>
+            <a:endParaRPr lang="en-US" sz="1500" dirty="0"/>
           </a:p>
         </p:txBody>
       </p:sp>
@@ -6081,7 +6081,7 @@
               <a:buNone/>
             </a:pPr>
             <a:r>
-              <a:rPr lang="en-US" sz="1400" b="1" dirty="0">
+              <a:rPr lang="en-US" sz="1700" b="1" dirty="0">
                 <a:solidFill>
                   <a:srgbClr val="2A9D8F"/>
                 </a:solidFill>
@@ -6091,7 +6091,7 @@
               </a:rPr>
               <a:t>45</a:t>
             </a:r>
-            <a:endParaRPr lang="en-US" sz="1400" dirty="0"/>
+            <a:endParaRPr lang="en-US" sz="1700" dirty="0"/>
           </a:p>
         </p:txBody>
       </p:sp>
@@ -6164,7 +6164,7 @@
               <a:buNone/>
             </a:pPr>
             <a:r>
-              <a:rPr lang="en-US" sz="750" dirty="0">
+              <a:rPr lang="en-US" sz="800" dirty="0">
                 <a:solidFill>
                   <a:srgbClr val="6B7280"/>
                 </a:solidFill>
@@ -6174,7 +6174,7 @@
               </a:rPr>
               <a:t>14,6% do setor</a:t>
             </a:r>
-            <a:endParaRPr lang="en-US" sz="750" dirty="0"/>
+            <a:endParaRPr lang="en-US" sz="800" dirty="0"/>
           </a:p>
         </p:txBody>
       </p:sp>
@@ -6245,7 +6245,7 @@
               <a:buNone/>
             </a:pPr>
             <a:r>
-              <a:rPr lang="en-US" sz="1100" b="1" dirty="0">
+              <a:rPr lang="en-US" sz="1300" b="1" dirty="0">
                 <a:solidFill>
                   <a:srgbClr val="FFFFFF"/>
                 </a:solidFill>
@@ -6255,7 +6255,7 @@
               </a:rPr>
               <a:t>5</a:t>
             </a:r>
-            <a:endParaRPr lang="en-US" sz="1100" dirty="0"/>
+            <a:endParaRPr lang="en-US" sz="1300" dirty="0"/>
           </a:p>
         </p:txBody>
       </p:sp>
@@ -6284,7 +6284,7 @@
               <a:buNone/>
             </a:pPr>
             <a:r>
-              <a:rPr lang="en-US" sz="1150" b="1" dirty="0">
+              <a:rPr lang="en-US" sz="1500" b="1" dirty="0">
                 <a:solidFill>
                   <a:srgbClr val="1D3557"/>
                 </a:solidFill>
@@ -6294,7 +6294,7 @@
               </a:rPr>
               <a:t>Setor 7741</a:t>
             </a:r>
-            <a:endParaRPr lang="en-US" sz="1150" dirty="0"/>
+            <a:endParaRPr lang="en-US" sz="1500" dirty="0"/>
           </a:p>
         </p:txBody>
       </p:sp>
@@ -6323,7 +6323,7 @@
               <a:buNone/>
             </a:pPr>
             <a:r>
-              <a:rPr lang="en-US" sz="1400" b="1" dirty="0">
+              <a:rPr lang="en-US" sz="1700" b="1" dirty="0">
                 <a:solidFill>
                   <a:srgbClr val="2A9D8F"/>
                 </a:solidFill>
@@ -6333,7 +6333,7 @@
               </a:rPr>
               <a:t>43</a:t>
             </a:r>
-            <a:endParaRPr lang="en-US" sz="1400" dirty="0"/>
+            <a:endParaRPr lang="en-US" sz="1700" dirty="0"/>
           </a:p>
         </p:txBody>
       </p:sp>
@@ -6406,7 +6406,7 @@
               <a:buNone/>
             </a:pPr>
             <a:r>
-              <a:rPr lang="en-US" sz="750" dirty="0">
+              <a:rPr lang="en-US" sz="800" dirty="0">
                 <a:solidFill>
                   <a:srgbClr val="6B7280"/>
                 </a:solidFill>
@@ -6416,7 +6416,7 @@
               </a:rPr>
               <a:t>15,1% do setor</a:t>
             </a:r>
-            <a:endParaRPr lang="en-US" sz="750" dirty="0"/>
+            <a:endParaRPr lang="en-US" sz="800" dirty="0"/>
           </a:p>
         </p:txBody>
       </p:sp>
@@ -6487,7 +6487,7 @@
               <a:buNone/>
             </a:pPr>
             <a:r>
-              <a:rPr lang="en-US" sz="1100" b="1" dirty="0">
+              <a:rPr lang="en-US" sz="1300" b="1" dirty="0">
                 <a:solidFill>
                   <a:srgbClr val="FFFFFF"/>
                 </a:solidFill>
@@ -6497,7 +6497,7 @@
               </a:rPr>
               <a:t>6</a:t>
             </a:r>
-            <a:endParaRPr lang="en-US" sz="1100" dirty="0"/>
+            <a:endParaRPr lang="en-US" sz="1300" dirty="0"/>
           </a:p>
         </p:txBody>
       </p:sp>
@@ -6526,7 +6526,7 @@
               <a:buNone/>
             </a:pPr>
             <a:r>
-              <a:rPr lang="en-US" sz="1150" b="1" dirty="0">
+              <a:rPr lang="en-US" sz="1500" b="1" dirty="0">
                 <a:solidFill>
                   <a:srgbClr val="1D3557"/>
                 </a:solidFill>
@@ -6536,7 +6536,7 @@
               </a:rPr>
               <a:t>Setor 5152</a:t>
             </a:r>
-            <a:endParaRPr lang="en-US" sz="1150" dirty="0"/>
+            <a:endParaRPr lang="en-US" sz="1500" dirty="0"/>
           </a:p>
         </p:txBody>
       </p:sp>
@@ -6565,7 +6565,7 @@
               <a:buNone/>
             </a:pPr>
             <a:r>
-              <a:rPr lang="en-US" sz="1400" b="1" dirty="0">
+              <a:rPr lang="en-US" sz="1700" b="1" dirty="0">
                 <a:solidFill>
                   <a:srgbClr val="2A9D8F"/>
                 </a:solidFill>
@@ -6575,7 +6575,7 @@
               </a:rPr>
               <a:t>34</a:t>
             </a:r>
-            <a:endParaRPr lang="en-US" sz="1400" dirty="0"/>
+            <a:endParaRPr lang="en-US" sz="1700" dirty="0"/>
           </a:p>
         </p:txBody>
       </p:sp>
@@ -6648,7 +6648,7 @@
               <a:buNone/>
             </a:pPr>
             <a:r>
-              <a:rPr lang="en-US" sz="750" dirty="0">
+              <a:rPr lang="en-US" sz="800" dirty="0">
                 <a:solidFill>
                   <a:srgbClr val="6B7280"/>
                 </a:solidFill>
@@ -6658,7 +6658,7 @@
               </a:rPr>
               <a:t>11,4% do setor</a:t>
             </a:r>
-            <a:endParaRPr lang="en-US" sz="750" dirty="0"/>
+            <a:endParaRPr lang="en-US" sz="800" dirty="0"/>
           </a:p>
         </p:txBody>
       </p:sp>
@@ -6729,7 +6729,7 @@
               <a:buNone/>
             </a:pPr>
             <a:r>
-              <a:rPr lang="en-US" sz="1100" b="1" dirty="0">
+              <a:rPr lang="en-US" sz="1300" b="1" dirty="0">
                 <a:solidFill>
                   <a:srgbClr val="FFFFFF"/>
                 </a:solidFill>
@@ -6739,7 +6739,7 @@
               </a:rPr>
               <a:t>7</a:t>
             </a:r>
-            <a:endParaRPr lang="en-US" sz="1100" dirty="0"/>
+            <a:endParaRPr lang="en-US" sz="1300" dirty="0"/>
           </a:p>
         </p:txBody>
       </p:sp>
@@ -6768,7 +6768,7 @@
               <a:buNone/>
             </a:pPr>
             <a:r>
-              <a:rPr lang="en-US" sz="1150" b="1" dirty="0">
+              <a:rPr lang="en-US" sz="1500" b="1" dirty="0">
                 <a:solidFill>
                   <a:srgbClr val="1D3557"/>
                 </a:solidFill>
@@ -6778,7 +6778,7 @@
               </a:rPr>
               <a:t>Setor 5613</a:t>
             </a:r>
-            <a:endParaRPr lang="en-US" sz="1150" dirty="0"/>
+            <a:endParaRPr lang="en-US" sz="1500" dirty="0"/>
           </a:p>
         </p:txBody>
       </p:sp>
@@ -6807,7 +6807,7 @@
               <a:buNone/>
             </a:pPr>
             <a:r>
-              <a:rPr lang="en-US" sz="1400" b="1" dirty="0">
+              <a:rPr lang="en-US" sz="1700" b="1" dirty="0">
                 <a:solidFill>
                   <a:srgbClr val="2A9D8F"/>
                 </a:solidFill>
@@ -6817,7 +6817,7 @@
               </a:rPr>
               <a:t>32</a:t>
             </a:r>
-            <a:endParaRPr lang="en-US" sz="1400" dirty="0"/>
+            <a:endParaRPr lang="en-US" sz="1700" dirty="0"/>
           </a:p>
         </p:txBody>
       </p:sp>
@@ -6890,7 +6890,7 @@
               <a:buNone/>
             </a:pPr>
             <a:r>
-              <a:rPr lang="en-US" sz="750" dirty="0">
+              <a:rPr lang="en-US" sz="800" dirty="0">
                 <a:solidFill>
                   <a:srgbClr val="6B7280"/>
                 </a:solidFill>
@@ -6900,7 +6900,7 @@
               </a:rPr>
               <a:t>11,4% do setor</a:t>
             </a:r>
-            <a:endParaRPr lang="en-US" sz="750" dirty="0"/>
+            <a:endParaRPr lang="en-US" sz="800" dirty="0"/>
           </a:p>
         </p:txBody>
       </p:sp>
@@ -6971,7 +6971,7 @@
               <a:buNone/>
             </a:pPr>
             <a:r>
-              <a:rPr lang="en-US" sz="1100" b="1" dirty="0">
+              <a:rPr lang="en-US" sz="1300" b="1" dirty="0">
                 <a:solidFill>
                   <a:srgbClr val="FFFFFF"/>
                 </a:solidFill>
@@ -6981,7 +6981,7 @@
               </a:rPr>
               <a:t>8</a:t>
             </a:r>
-            <a:endParaRPr lang="en-US" sz="1100" dirty="0"/>
+            <a:endParaRPr lang="en-US" sz="1300" dirty="0"/>
           </a:p>
         </p:txBody>
       </p:sp>
@@ -7010,7 +7010,7 @@
               <a:buNone/>
             </a:pPr>
             <a:r>
-              <a:rPr lang="en-US" sz="1150" b="1" dirty="0">
+              <a:rPr lang="en-US" sz="1500" b="1" dirty="0">
                 <a:solidFill>
                   <a:srgbClr val="1D3557"/>
                 </a:solidFill>
@@ -7020,7 +7020,7 @@
               </a:rPr>
               <a:t>Setor 7748</a:t>
             </a:r>
-            <a:endParaRPr lang="en-US" sz="1150" dirty="0"/>
+            <a:endParaRPr lang="en-US" sz="1500" dirty="0"/>
           </a:p>
         </p:txBody>
       </p:sp>
@@ -7049,7 +7049,7 @@
               <a:buNone/>
             </a:pPr>
             <a:r>
-              <a:rPr lang="en-US" sz="1400" b="1" dirty="0">
+              <a:rPr lang="en-US" sz="1700" b="1" dirty="0">
                 <a:solidFill>
                   <a:srgbClr val="2A9D8F"/>
                 </a:solidFill>
@@ -7059,7 +7059,7 @@
               </a:rPr>
               <a:t>23</a:t>
             </a:r>
-            <a:endParaRPr lang="en-US" sz="1400" dirty="0"/>
+            <a:endParaRPr lang="en-US" sz="1700" dirty="0"/>
           </a:p>
         </p:txBody>
       </p:sp>
@@ -7132,7 +7132,7 @@
               <a:buNone/>
             </a:pPr>
             <a:r>
-              <a:rPr lang="en-US" sz="750" dirty="0">
+              <a:rPr lang="en-US" sz="800" dirty="0">
                 <a:solidFill>
                   <a:srgbClr val="6B7280"/>
                 </a:solidFill>
@@ -7142,7 +7142,7 @@
               </a:rPr>
               <a:t>8,0% do setor</a:t>
             </a:r>
-            <a:endParaRPr lang="en-US" sz="750" dirty="0"/>
+            <a:endParaRPr lang="en-US" sz="800" dirty="0"/>
           </a:p>
         </p:txBody>
       </p:sp>
@@ -7200,7 +7200,7 @@
               <a:buNone/>
             </a:pPr>
             <a:r>
-              <a:rPr lang="en-US" sz="1800" b="1" dirty="0">
+              <a:rPr lang="en-US" sz="2300" b="1" dirty="0">
                 <a:solidFill>
                   <a:srgbClr val="FFFFFF"/>
                 </a:solidFill>
@@ -7210,7 +7210,7 @@
               </a:rPr>
               <a:t>CAT 4</a:t>
             </a:r>
-            <a:endParaRPr lang="en-US" sz="1800" dirty="0"/>
+            <a:endParaRPr lang="en-US" sz="2300" dirty="0"/>
           </a:p>
         </p:txBody>
       </p:sp>
@@ -7239,7 +7239,7 @@
               <a:buNone/>
             </a:pPr>
             <a:r>
-              <a:rPr lang="en-US" sz="1050" dirty="0">
+              <a:rPr lang="en-US" sz="1250" dirty="0">
                 <a:solidFill>
                   <a:srgbClr val="FFFFFF"/>
                 </a:solidFill>
@@ -7249,7 +7249,7 @@
               </a:rPr>
               <a:t>617 médicos no painel</a:t>
             </a:r>
-            <a:endParaRPr lang="en-US" sz="1050" dirty="0"/>
+            <a:endParaRPr lang="en-US" sz="1250" dirty="0"/>
           </a:p>
         </p:txBody>
       </p:sp>
@@ -7320,7 +7320,7 @@
               <a:buNone/>
             </a:pPr>
             <a:r>
-              <a:rPr lang="en-US" sz="1100" b="1" dirty="0">
+              <a:rPr lang="en-US" sz="1300" b="1" dirty="0">
                 <a:solidFill>
                   <a:srgbClr val="FFFFFF"/>
                 </a:solidFill>
@@ -7330,7 +7330,7 @@
               </a:rPr>
               <a:t>1</a:t>
             </a:r>
-            <a:endParaRPr lang="en-US" sz="1100" dirty="0"/>
+            <a:endParaRPr lang="en-US" sz="1300" dirty="0"/>
           </a:p>
         </p:txBody>
       </p:sp>
@@ -7359,7 +7359,7 @@
               <a:buNone/>
             </a:pPr>
             <a:r>
-              <a:rPr lang="en-US" sz="1150" b="1" dirty="0">
+              <a:rPr lang="en-US" sz="1500" b="1" dirty="0">
                 <a:solidFill>
                   <a:srgbClr val="1D3557"/>
                 </a:solidFill>
@@ -7369,7 +7369,7 @@
               </a:rPr>
               <a:t>Setor 7742</a:t>
             </a:r>
-            <a:endParaRPr lang="en-US" sz="1150" dirty="0"/>
+            <a:endParaRPr lang="en-US" sz="1500" dirty="0"/>
           </a:p>
         </p:txBody>
       </p:sp>
@@ -7398,7 +7398,7 @@
               <a:buNone/>
             </a:pPr>
             <a:r>
-              <a:rPr lang="en-US" sz="1400" b="1" dirty="0">
+              <a:rPr lang="en-US" sz="1700" b="1" dirty="0">
                 <a:solidFill>
                   <a:srgbClr val="6A4C93"/>
                 </a:solidFill>
@@ -7408,7 +7408,7 @@
               </a:rPr>
               <a:t>92</a:t>
             </a:r>
-            <a:endParaRPr lang="en-US" sz="1400" dirty="0"/>
+            <a:endParaRPr lang="en-US" sz="1700" dirty="0"/>
           </a:p>
         </p:txBody>
       </p:sp>
@@ -7481,7 +7481,7 @@
               <a:buNone/>
             </a:pPr>
             <a:r>
-              <a:rPr lang="en-US" sz="750" dirty="0">
+              <a:rPr lang="en-US" sz="800" dirty="0">
                 <a:solidFill>
                   <a:srgbClr val="6B7280"/>
                 </a:solidFill>
@@ -7491,7 +7491,7 @@
               </a:rPr>
               <a:t>29,8% do setor</a:t>
             </a:r>
-            <a:endParaRPr lang="en-US" sz="750" dirty="0"/>
+            <a:endParaRPr lang="en-US" sz="800" dirty="0"/>
           </a:p>
         </p:txBody>
       </p:sp>
@@ -7562,7 +7562,7 @@
               <a:buNone/>
             </a:pPr>
             <a:r>
-              <a:rPr lang="en-US" sz="1100" b="1" dirty="0">
+              <a:rPr lang="en-US" sz="1300" b="1" dirty="0">
                 <a:solidFill>
                   <a:srgbClr val="FFFFFF"/>
                 </a:solidFill>
@@ -7572,7 +7572,7 @@
               </a:rPr>
               <a:t>2</a:t>
             </a:r>
-            <a:endParaRPr lang="en-US" sz="1100" dirty="0"/>
+            <a:endParaRPr lang="en-US" sz="1300" dirty="0"/>
           </a:p>
         </p:txBody>
       </p:sp>
@@ -7601,7 +7601,7 @@
               <a:buNone/>
             </a:pPr>
             <a:r>
-              <a:rPr lang="en-US" sz="1150" b="1" dirty="0">
+              <a:rPr lang="en-US" sz="1500" b="1" dirty="0">
                 <a:solidFill>
                   <a:srgbClr val="1D3557"/>
                 </a:solidFill>
@@ -7611,7 +7611,7 @@
               </a:rPr>
               <a:t>Setor 5153</a:t>
             </a:r>
-            <a:endParaRPr lang="en-US" sz="1150" dirty="0"/>
+            <a:endParaRPr lang="en-US" sz="1500" dirty="0"/>
           </a:p>
         </p:txBody>
       </p:sp>
@@ -7640,7 +7640,7 @@
               <a:buNone/>
             </a:pPr>
             <a:r>
-              <a:rPr lang="en-US" sz="1400" b="1" dirty="0">
+              <a:rPr lang="en-US" sz="1700" b="1" dirty="0">
                 <a:solidFill>
                   <a:srgbClr val="6A4C93"/>
                 </a:solidFill>
@@ -7650,7 +7650,7 @@
               </a:rPr>
               <a:t>85</a:t>
             </a:r>
-            <a:endParaRPr lang="en-US" sz="1400" dirty="0"/>
+            <a:endParaRPr lang="en-US" sz="1700" dirty="0"/>
           </a:p>
         </p:txBody>
       </p:sp>
@@ -7723,7 +7723,7 @@
               <a:buNone/>
             </a:pPr>
             <a:r>
-              <a:rPr lang="en-US" sz="750" dirty="0">
+              <a:rPr lang="en-US" sz="800" dirty="0">
                 <a:solidFill>
                   <a:srgbClr val="6B7280"/>
                 </a:solidFill>
@@ -7733,7 +7733,7 @@
               </a:rPr>
               <a:t>29,6% do setor</a:t>
             </a:r>
-            <a:endParaRPr lang="en-US" sz="750" dirty="0"/>
+            <a:endParaRPr lang="en-US" sz="800" dirty="0"/>
           </a:p>
         </p:txBody>
       </p:sp>
@@ -7804,7 +7804,7 @@
               <a:buNone/>
             </a:pPr>
             <a:r>
-              <a:rPr lang="en-US" sz="1100" b="1" dirty="0">
+              <a:rPr lang="en-US" sz="1300" b="1" dirty="0">
                 <a:solidFill>
                   <a:srgbClr val="FFFFFF"/>
                 </a:solidFill>
@@ -7814,7 +7814,7 @@
               </a:rPr>
               <a:t>3</a:t>
             </a:r>
-            <a:endParaRPr lang="en-US" sz="1100" dirty="0"/>
+            <a:endParaRPr lang="en-US" sz="1300" dirty="0"/>
           </a:p>
         </p:txBody>
       </p:sp>
@@ -7843,7 +7843,7 @@
               <a:buNone/>
             </a:pPr>
             <a:r>
-              <a:rPr lang="en-US" sz="1150" b="1" dirty="0">
+              <a:rPr lang="en-US" sz="1500" b="1" dirty="0">
                 <a:solidFill>
                   <a:srgbClr val="1D3557"/>
                 </a:solidFill>
@@ -7853,7 +7853,7 @@
               </a:rPr>
               <a:t>Setor 7741</a:t>
             </a:r>
-            <a:endParaRPr lang="en-US" sz="1150" dirty="0"/>
+            <a:endParaRPr lang="en-US" sz="1500" dirty="0"/>
           </a:p>
         </p:txBody>
       </p:sp>
@@ -7882,7 +7882,7 @@
               <a:buNone/>
             </a:pPr>
             <a:r>
-              <a:rPr lang="en-US" sz="1400" b="1" dirty="0">
+              <a:rPr lang="en-US" sz="1700" b="1" dirty="0">
                 <a:solidFill>
                   <a:srgbClr val="6A4C93"/>
                 </a:solidFill>
@@ -7892,7 +7892,7 @@
               </a:rPr>
               <a:t>85</a:t>
             </a:r>
-            <a:endParaRPr lang="en-US" sz="1400" dirty="0"/>
+            <a:endParaRPr lang="en-US" sz="1700" dirty="0"/>
           </a:p>
         </p:txBody>
       </p:sp>
@@ -7965,7 +7965,7 @@
               <a:buNone/>
             </a:pPr>
             <a:r>
-              <a:rPr lang="en-US" sz="750" dirty="0">
+              <a:rPr lang="en-US" sz="800" dirty="0">
                 <a:solidFill>
                   <a:srgbClr val="6B7280"/>
                 </a:solidFill>
@@ -7975,7 +7975,7 @@
               </a:rPr>
               <a:t>29,9% do setor</a:t>
             </a:r>
-            <a:endParaRPr lang="en-US" sz="750" dirty="0"/>
+            <a:endParaRPr lang="en-US" sz="800" dirty="0"/>
           </a:p>
         </p:txBody>
       </p:sp>
@@ -8046,7 +8046,7 @@
               <a:buNone/>
             </a:pPr>
             <a:r>
-              <a:rPr lang="en-US" sz="1100" b="1" dirty="0">
+              <a:rPr lang="en-US" sz="1300" b="1" dirty="0">
                 <a:solidFill>
                   <a:srgbClr val="FFFFFF"/>
                 </a:solidFill>
@@ -8056,7 +8056,7 @@
               </a:rPr>
               <a:t>4</a:t>
             </a:r>
-            <a:endParaRPr lang="en-US" sz="1100" dirty="0"/>
+            <a:endParaRPr lang="en-US" sz="1300" dirty="0"/>
           </a:p>
         </p:txBody>
       </p:sp>
@@ -8085,7 +8085,7 @@
               <a:buNone/>
             </a:pPr>
             <a:r>
-              <a:rPr lang="en-US" sz="1150" b="1" dirty="0">
+              <a:rPr lang="en-US" sz="1500" b="1" dirty="0">
                 <a:solidFill>
                   <a:srgbClr val="1D3557"/>
                 </a:solidFill>
@@ -8095,7 +8095,7 @@
               </a:rPr>
               <a:t>Setor 5152</a:t>
             </a:r>
-            <a:endParaRPr lang="en-US" sz="1150" dirty="0"/>
+            <a:endParaRPr lang="en-US" sz="1500" dirty="0"/>
           </a:p>
         </p:txBody>
       </p:sp>
@@ -8124,7 +8124,7 @@
               <a:buNone/>
             </a:pPr>
             <a:r>
-              <a:rPr lang="en-US" sz="1400" b="1" dirty="0">
+              <a:rPr lang="en-US" sz="1700" b="1" dirty="0">
                 <a:solidFill>
                   <a:srgbClr val="6A4C93"/>
                 </a:solidFill>
@@ -8134,7 +8134,7 @@
               </a:rPr>
               <a:t>84</a:t>
             </a:r>
-            <a:endParaRPr lang="en-US" sz="1400" dirty="0"/>
+            <a:endParaRPr lang="en-US" sz="1700" dirty="0"/>
           </a:p>
         </p:txBody>
       </p:sp>
@@ -8207,7 +8207,7 @@
               <a:buNone/>
             </a:pPr>
             <a:r>
-              <a:rPr lang="en-US" sz="750" dirty="0">
+              <a:rPr lang="en-US" sz="800" dirty="0">
                 <a:solidFill>
                   <a:srgbClr val="6B7280"/>
                 </a:solidFill>
@@ -8217,7 +8217,7 @@
               </a:rPr>
               <a:t>28,3% do setor</a:t>
             </a:r>
-            <a:endParaRPr lang="en-US" sz="750" dirty="0"/>
+            <a:endParaRPr lang="en-US" sz="800" dirty="0"/>
           </a:p>
         </p:txBody>
       </p:sp>
@@ -8288,7 +8288,7 @@
               <a:buNone/>
             </a:pPr>
             <a:r>
-              <a:rPr lang="en-US" sz="1100" b="1" dirty="0">
+              <a:rPr lang="en-US" sz="1300" b="1" dirty="0">
                 <a:solidFill>
                   <a:srgbClr val="FFFFFF"/>
                 </a:solidFill>
@@ -8298,7 +8298,7 @@
               </a:rPr>
               <a:t>5</a:t>
             </a:r>
-            <a:endParaRPr lang="en-US" sz="1100" dirty="0"/>
+            <a:endParaRPr lang="en-US" sz="1300" dirty="0"/>
           </a:p>
         </p:txBody>
       </p:sp>
@@ -8327,7 +8327,7 @@
               <a:buNone/>
             </a:pPr>
             <a:r>
-              <a:rPr lang="en-US" sz="1150" b="1" dirty="0">
+              <a:rPr lang="en-US" sz="1500" b="1" dirty="0">
                 <a:solidFill>
                   <a:srgbClr val="1D3557"/>
                 </a:solidFill>
@@ -8337,7 +8337,7 @@
               </a:rPr>
               <a:t>Setor 7745</a:t>
             </a:r>
-            <a:endParaRPr lang="en-US" sz="1150" dirty="0"/>
+            <a:endParaRPr lang="en-US" sz="1500" dirty="0"/>
           </a:p>
         </p:txBody>
       </p:sp>
@@ -8366,7 +8366,7 @@
               <a:buNone/>
             </a:pPr>
             <a:r>
-              <a:rPr lang="en-US" sz="1400" b="1" dirty="0">
+              <a:rPr lang="en-US" sz="1700" b="1" dirty="0">
                 <a:solidFill>
                   <a:srgbClr val="6A4C93"/>
                 </a:solidFill>
@@ -8376,7 +8376,7 @@
               </a:rPr>
               <a:t>72</a:t>
             </a:r>
-            <a:endParaRPr lang="en-US" sz="1400" dirty="0"/>
+            <a:endParaRPr lang="en-US" sz="1700" dirty="0"/>
           </a:p>
         </p:txBody>
       </p:sp>
@@ -8449,7 +8449,7 @@
               <a:buNone/>
             </a:pPr>
             <a:r>
-              <a:rPr lang="en-US" sz="750" dirty="0">
+              <a:rPr lang="en-US" sz="800" dirty="0">
                 <a:solidFill>
                   <a:srgbClr val="6B7280"/>
                 </a:solidFill>
@@ -8459,7 +8459,7 @@
               </a:rPr>
               <a:t>25,2% do setor</a:t>
             </a:r>
-            <a:endParaRPr lang="en-US" sz="750" dirty="0"/>
+            <a:endParaRPr lang="en-US" sz="800" dirty="0"/>
           </a:p>
         </p:txBody>
       </p:sp>
@@ -8530,7 +8530,7 @@
               <a:buNone/>
             </a:pPr>
             <a:r>
-              <a:rPr lang="en-US" sz="1100" b="1" dirty="0">
+              <a:rPr lang="en-US" sz="1300" b="1" dirty="0">
                 <a:solidFill>
                   <a:srgbClr val="FFFFFF"/>
                 </a:solidFill>
@@ -8540,7 +8540,7 @@
               </a:rPr>
               <a:t>6</a:t>
             </a:r>
-            <a:endParaRPr lang="en-US" sz="1100" dirty="0"/>
+            <a:endParaRPr lang="en-US" sz="1300" dirty="0"/>
           </a:p>
         </p:txBody>
       </p:sp>
@@ -8569,7 +8569,7 @@
               <a:buNone/>
             </a:pPr>
             <a:r>
-              <a:rPr lang="en-US" sz="1150" b="1" dirty="0">
+              <a:rPr lang="en-US" sz="1500" b="1" dirty="0">
                 <a:solidFill>
                   <a:srgbClr val="1D3557"/>
                 </a:solidFill>
@@ -8579,7 +8579,7 @@
               </a:rPr>
               <a:t>Setor 5149</a:t>
             </a:r>
-            <a:endParaRPr lang="en-US" sz="1150" dirty="0"/>
+            <a:endParaRPr lang="en-US" sz="1500" dirty="0"/>
           </a:p>
         </p:txBody>
       </p:sp>
@@ -8608,7 +8608,7 @@
               <a:buNone/>
             </a:pPr>
             <a:r>
-              <a:rPr lang="en-US" sz="1400" b="1" dirty="0">
+              <a:rPr lang="en-US" sz="1700" b="1" dirty="0">
                 <a:solidFill>
                   <a:srgbClr val="6A4C93"/>
                 </a:solidFill>
@@ -8618,7 +8618,7 @@
               </a:rPr>
               <a:t>71</a:t>
             </a:r>
-            <a:endParaRPr lang="en-US" sz="1400" dirty="0"/>
+            <a:endParaRPr lang="en-US" sz="1700" dirty="0"/>
           </a:p>
         </p:txBody>
       </p:sp>
@@ -8691,7 +8691,7 @@
               <a:buNone/>
             </a:pPr>
             <a:r>
-              <a:rPr lang="en-US" sz="750" dirty="0">
+              <a:rPr lang="en-US" sz="800" dirty="0">
                 <a:solidFill>
                   <a:srgbClr val="6B7280"/>
                 </a:solidFill>
@@ -8701,7 +8701,7 @@
               </a:rPr>
               <a:t>22,9% do setor</a:t>
             </a:r>
-            <a:endParaRPr lang="en-US" sz="750" dirty="0"/>
+            <a:endParaRPr lang="en-US" sz="800" dirty="0"/>
           </a:p>
         </p:txBody>
       </p:sp>
@@ -8772,7 +8772,7 @@
               <a:buNone/>
             </a:pPr>
             <a:r>
-              <a:rPr lang="en-US" sz="1100" b="1" dirty="0">
+              <a:rPr lang="en-US" sz="1300" b="1" dirty="0">
                 <a:solidFill>
                   <a:srgbClr val="FFFFFF"/>
                 </a:solidFill>
@@ -8782,7 +8782,7 @@
               </a:rPr>
               <a:t>7</a:t>
             </a:r>
-            <a:endParaRPr lang="en-US" sz="1100" dirty="0"/>
+            <a:endParaRPr lang="en-US" sz="1300" dirty="0"/>
           </a:p>
         </p:txBody>
       </p:sp>
@@ -8811,7 +8811,7 @@
               <a:buNone/>
             </a:pPr>
             <a:r>
-              <a:rPr lang="en-US" sz="1150" b="1" dirty="0">
+              <a:rPr lang="en-US" sz="1500" b="1" dirty="0">
                 <a:solidFill>
                   <a:srgbClr val="1D3557"/>
                 </a:solidFill>
@@ -8821,7 +8821,7 @@
               </a:rPr>
               <a:t>Setor 5613</a:t>
             </a:r>
-            <a:endParaRPr lang="en-US" sz="1150" dirty="0"/>
+            <a:endParaRPr lang="en-US" sz="1500" dirty="0"/>
           </a:p>
         </p:txBody>
       </p:sp>
@@ -8850,7 +8850,7 @@
               <a:buNone/>
             </a:pPr>
             <a:r>
-              <a:rPr lang="en-US" sz="1400" b="1" dirty="0">
+              <a:rPr lang="en-US" sz="1700" b="1" dirty="0">
                 <a:solidFill>
                   <a:srgbClr val="6A4C93"/>
                 </a:solidFill>
@@ -8860,7 +8860,7 @@
               </a:rPr>
               <a:t>64</a:t>
             </a:r>
-            <a:endParaRPr lang="en-US" sz="1400" dirty="0"/>
+            <a:endParaRPr lang="en-US" sz="1700" dirty="0"/>
           </a:p>
         </p:txBody>
       </p:sp>
@@ -8933,7 +8933,7 @@
               <a:buNone/>
             </a:pPr>
             <a:r>
-              <a:rPr lang="en-US" sz="750" dirty="0">
+              <a:rPr lang="en-US" sz="800" dirty="0">
                 <a:solidFill>
                   <a:srgbClr val="6B7280"/>
                 </a:solidFill>
@@ -8943,7 +8943,7 @@
               </a:rPr>
               <a:t>22,8% do setor</a:t>
             </a:r>
-            <a:endParaRPr lang="en-US" sz="750" dirty="0"/>
+            <a:endParaRPr lang="en-US" sz="800" dirty="0"/>
           </a:p>
         </p:txBody>
       </p:sp>
@@ -9014,7 +9014,7 @@
               <a:buNone/>
             </a:pPr>
             <a:r>
-              <a:rPr lang="en-US" sz="1100" b="1" dirty="0">
+              <a:rPr lang="en-US" sz="1300" b="1" dirty="0">
                 <a:solidFill>
                   <a:srgbClr val="FFFFFF"/>
                 </a:solidFill>
@@ -9024,7 +9024,7 @@
               </a:rPr>
               <a:t>8</a:t>
             </a:r>
-            <a:endParaRPr lang="en-US" sz="1100" dirty="0"/>
+            <a:endParaRPr lang="en-US" sz="1300" dirty="0"/>
           </a:p>
         </p:txBody>
       </p:sp>
@@ -9053,7 +9053,7 @@
               <a:buNone/>
             </a:pPr>
             <a:r>
-              <a:rPr lang="en-US" sz="1150" b="1" dirty="0">
+              <a:rPr lang="en-US" sz="1500" b="1" dirty="0">
                 <a:solidFill>
                   <a:srgbClr val="1D3557"/>
                 </a:solidFill>
@@ -9063,7 +9063,7 @@
               </a:rPr>
               <a:t>Setor 7748</a:t>
             </a:r>
-            <a:endParaRPr lang="en-US" sz="1150" dirty="0"/>
+            <a:endParaRPr lang="en-US" sz="1500" dirty="0"/>
           </a:p>
         </p:txBody>
       </p:sp>
@@ -9092,7 +9092,7 @@
               <a:buNone/>
             </a:pPr>
             <a:r>
-              <a:rPr lang="en-US" sz="1400" b="1" dirty="0">
+              <a:rPr lang="en-US" sz="1700" b="1" dirty="0">
                 <a:solidFill>
                   <a:srgbClr val="6A4C93"/>
                 </a:solidFill>
@@ -9102,7 +9102,7 @@
               </a:rPr>
               <a:t>64</a:t>
             </a:r>
-            <a:endParaRPr lang="en-US" sz="1400" dirty="0"/>
+            <a:endParaRPr lang="en-US" sz="1700" dirty="0"/>
           </a:p>
         </p:txBody>
       </p:sp>
@@ -9175,7 +9175,7 @@
               <a:buNone/>
             </a:pPr>
             <a:r>
-              <a:rPr lang="en-US" sz="750" dirty="0">
+              <a:rPr lang="en-US" sz="800" dirty="0">
                 <a:solidFill>
                   <a:srgbClr val="6B7280"/>
                 </a:solidFill>
@@ -9185,7 +9185,7 @@
               </a:rPr>
               <a:t>22,1% do setor</a:t>
             </a:r>
-            <a:endParaRPr lang="en-US" sz="750" dirty="0"/>
+            <a:endParaRPr lang="en-US" sz="800" dirty="0"/>
           </a:p>
         </p:txBody>
       </p:sp>
@@ -9243,7 +9243,7 @@
               <a:buNone/>
             </a:pPr>
             <a:r>
-              <a:rPr lang="en-US" sz="1800" b="1" dirty="0">
+              <a:rPr lang="en-US" sz="2300" b="1" dirty="0">
                 <a:solidFill>
                   <a:srgbClr val="FFFFFF"/>
                 </a:solidFill>
@@ -9253,7 +9253,7 @@
               </a:rPr>
               <a:t>CAT 5</a:t>
             </a:r>
-            <a:endParaRPr lang="en-US" sz="1800" dirty="0"/>
+            <a:endParaRPr lang="en-US" sz="2300" dirty="0"/>
           </a:p>
         </p:txBody>
       </p:sp>
@@ -9282,7 +9282,7 @@
               <a:buNone/>
             </a:pPr>
             <a:r>
-              <a:rPr lang="en-US" sz="1050" dirty="0">
+              <a:rPr lang="en-US" sz="1250" dirty="0">
                 <a:solidFill>
                   <a:srgbClr val="FFFFFF"/>
                 </a:solidFill>
@@ -9292,7 +9292,7 @@
               </a:rPr>
               <a:t>1046 médicos no painel</a:t>
             </a:r>
-            <a:endParaRPr lang="en-US" sz="1050" dirty="0"/>
+            <a:endParaRPr lang="en-US" sz="1250" dirty="0"/>
           </a:p>
         </p:txBody>
       </p:sp>
@@ -9363,7 +9363,7 @@
               <a:buNone/>
             </a:pPr>
             <a:r>
-              <a:rPr lang="en-US" sz="1100" b="1" dirty="0">
+              <a:rPr lang="en-US" sz="1300" b="1" dirty="0">
                 <a:solidFill>
                   <a:srgbClr val="FFFFFF"/>
                 </a:solidFill>
@@ -9373,7 +9373,7 @@
               </a:rPr>
               <a:t>1</a:t>
             </a:r>
-            <a:endParaRPr lang="en-US" sz="1100" dirty="0"/>
+            <a:endParaRPr lang="en-US" sz="1300" dirty="0"/>
           </a:p>
         </p:txBody>
       </p:sp>
@@ -9402,7 +9402,7 @@
               <a:buNone/>
             </a:pPr>
             <a:r>
-              <a:rPr lang="en-US" sz="1150" b="1" dirty="0">
+              <a:rPr lang="en-US" sz="1500" b="1" dirty="0">
                 <a:solidFill>
                   <a:srgbClr val="1D3557"/>
                 </a:solidFill>
@@ -9412,7 +9412,7 @@
               </a:rPr>
               <a:t>Setor 7748</a:t>
             </a:r>
-            <a:endParaRPr lang="en-US" sz="1150" dirty="0"/>
+            <a:endParaRPr lang="en-US" sz="1500" dirty="0"/>
           </a:p>
         </p:txBody>
       </p:sp>
@@ -9441,7 +9441,7 @@
               <a:buNone/>
             </a:pPr>
             <a:r>
-              <a:rPr lang="en-US" sz="1400" b="1" dirty="0">
+              <a:rPr lang="en-US" sz="1700" b="1" dirty="0">
                 <a:solidFill>
                   <a:srgbClr val="52B788"/>
                 </a:solidFill>
@@ -9451,7 +9451,7 @@
               </a:rPr>
               <a:t>173</a:t>
             </a:r>
-            <a:endParaRPr lang="en-US" sz="1400" dirty="0"/>
+            <a:endParaRPr lang="en-US" sz="1700" dirty="0"/>
           </a:p>
         </p:txBody>
       </p:sp>
@@ -9524,7 +9524,7 @@
               <a:buNone/>
             </a:pPr>
             <a:r>
-              <a:rPr lang="en-US" sz="750" dirty="0">
+              <a:rPr lang="en-US" sz="800" dirty="0">
                 <a:solidFill>
                   <a:srgbClr val="6B7280"/>
                 </a:solidFill>
@@ -9534,7 +9534,7 @@
               </a:rPr>
               <a:t>59,9% do setor</a:t>
             </a:r>
-            <a:endParaRPr lang="en-US" sz="750" dirty="0"/>
+            <a:endParaRPr lang="en-US" sz="800" dirty="0"/>
           </a:p>
         </p:txBody>
       </p:sp>
@@ -9605,7 +9605,7 @@
               <a:buNone/>
             </a:pPr>
             <a:r>
-              <a:rPr lang="en-US" sz="1100" b="1" dirty="0">
+              <a:rPr lang="en-US" sz="1300" b="1" dirty="0">
                 <a:solidFill>
                   <a:srgbClr val="FFFFFF"/>
                 </a:solidFill>
@@ -9615,7 +9615,7 @@
               </a:rPr>
               <a:t>2</a:t>
             </a:r>
-            <a:endParaRPr lang="en-US" sz="1100" dirty="0"/>
+            <a:endParaRPr lang="en-US" sz="1300" dirty="0"/>
           </a:p>
         </p:txBody>
       </p:sp>
@@ -9644,7 +9644,7 @@
               <a:buNone/>
             </a:pPr>
             <a:r>
-              <a:rPr lang="en-US" sz="1150" b="1" dirty="0">
+              <a:rPr lang="en-US" sz="1500" b="1" dirty="0">
                 <a:solidFill>
                   <a:srgbClr val="1D3557"/>
                 </a:solidFill>
@@ -9654,7 +9654,7 @@
               </a:rPr>
               <a:t>Setor 5613</a:t>
             </a:r>
-            <a:endParaRPr lang="en-US" sz="1150" dirty="0"/>
+            <a:endParaRPr lang="en-US" sz="1500" dirty="0"/>
           </a:p>
         </p:txBody>
       </p:sp>
@@ -9683,7 +9683,7 @@
               <a:buNone/>
             </a:pPr>
             <a:r>
-              <a:rPr lang="en-US" sz="1400" b="1" dirty="0">
+              <a:rPr lang="en-US" sz="1700" b="1" dirty="0">
                 <a:solidFill>
                   <a:srgbClr val="52B788"/>
                 </a:solidFill>
@@ -9693,7 +9693,7 @@
               </a:rPr>
               <a:t>156</a:t>
             </a:r>
-            <a:endParaRPr lang="en-US" sz="1400" dirty="0"/>
+            <a:endParaRPr lang="en-US" sz="1700" dirty="0"/>
           </a:p>
         </p:txBody>
       </p:sp>
@@ -9766,7 +9766,7 @@
               <a:buNone/>
             </a:pPr>
             <a:r>
-              <a:rPr lang="en-US" sz="750" dirty="0">
+              <a:rPr lang="en-US" sz="800" dirty="0">
                 <a:solidFill>
                   <a:srgbClr val="6B7280"/>
                 </a:solidFill>
@@ -9776,7 +9776,7 @@
               </a:rPr>
               <a:t>55,5% do setor</a:t>
             </a:r>
-            <a:endParaRPr lang="en-US" sz="750" dirty="0"/>
+            <a:endParaRPr lang="en-US" sz="800" dirty="0"/>
           </a:p>
         </p:txBody>
       </p:sp>
@@ -9847,7 +9847,7 @@
               <a:buNone/>
             </a:pPr>
             <a:r>
-              <a:rPr lang="en-US" sz="1100" b="1" dirty="0">
+              <a:rPr lang="en-US" sz="1300" b="1" dirty="0">
                 <a:solidFill>
                   <a:srgbClr val="FFFFFF"/>
                 </a:solidFill>
@@ -9857,7 +9857,7 @@
               </a:rPr>
               <a:t>3</a:t>
             </a:r>
-            <a:endParaRPr lang="en-US" sz="1100" dirty="0"/>
+            <a:endParaRPr lang="en-US" sz="1300" dirty="0"/>
           </a:p>
         </p:txBody>
       </p:sp>
@@ -9886,7 +9886,7 @@
               <a:buNone/>
             </a:pPr>
             <a:r>
-              <a:rPr lang="en-US" sz="1150" b="1" dirty="0">
+              <a:rPr lang="en-US" sz="1500" b="1" dirty="0">
                 <a:solidFill>
                   <a:srgbClr val="1D3557"/>
                 </a:solidFill>
@@ -9896,7 +9896,7 @@
               </a:rPr>
               <a:t>Setor 7742</a:t>
             </a:r>
-            <a:endParaRPr lang="en-US" sz="1150" dirty="0"/>
+            <a:endParaRPr lang="en-US" sz="1500" dirty="0"/>
           </a:p>
         </p:txBody>
       </p:sp>
@@ -9925,7 +9925,7 @@
               <a:buNone/>
             </a:pPr>
             <a:r>
-              <a:rPr lang="en-US" sz="1400" b="1" dirty="0">
+              <a:rPr lang="en-US" sz="1700" b="1" dirty="0">
                 <a:solidFill>
                   <a:srgbClr val="52B788"/>
                 </a:solidFill>
@@ -9935,7 +9935,7 @@
               </a:rPr>
               <a:t>152</a:t>
             </a:r>
-            <a:endParaRPr lang="en-US" sz="1400" dirty="0"/>
+            <a:endParaRPr lang="en-US" sz="1700" dirty="0"/>
           </a:p>
         </p:txBody>
       </p:sp>
@@ -10008,7 +10008,7 @@
               <a:buNone/>
             </a:pPr>
             <a:r>
-              <a:rPr lang="en-US" sz="750" dirty="0">
+              <a:rPr lang="en-US" sz="800" dirty="0">
                 <a:solidFill>
                   <a:srgbClr val="6B7280"/>
                 </a:solidFill>
@@ -10018,7 +10018,7 @@
               </a:rPr>
               <a:t>49,2% do setor</a:t>
             </a:r>
-            <a:endParaRPr lang="en-US" sz="750" dirty="0"/>
+            <a:endParaRPr lang="en-US" sz="800" dirty="0"/>
           </a:p>
         </p:txBody>
       </p:sp>
@@ -10089,7 +10089,7 @@
               <a:buNone/>
             </a:pPr>
             <a:r>
-              <a:rPr lang="en-US" sz="1100" b="1" dirty="0">
+              <a:rPr lang="en-US" sz="1300" b="1" dirty="0">
                 <a:solidFill>
                   <a:srgbClr val="FFFFFF"/>
                 </a:solidFill>
@@ -10099,7 +10099,7 @@
               </a:rPr>
               <a:t>4</a:t>
             </a:r>
-            <a:endParaRPr lang="en-US" sz="1100" dirty="0"/>
+            <a:endParaRPr lang="en-US" sz="1300" dirty="0"/>
           </a:p>
         </p:txBody>
       </p:sp>
@@ -10128,7 +10128,7 @@
               <a:buNone/>
             </a:pPr>
             <a:r>
-              <a:rPr lang="en-US" sz="1150" b="1" dirty="0">
+              <a:rPr lang="en-US" sz="1500" b="1" dirty="0">
                 <a:solidFill>
                   <a:srgbClr val="1D3557"/>
                 </a:solidFill>
@@ -10138,7 +10138,7 @@
               </a:rPr>
               <a:t>Setor 5152</a:t>
             </a:r>
-            <a:endParaRPr lang="en-US" sz="1150" dirty="0"/>
+            <a:endParaRPr lang="en-US" sz="1500" dirty="0"/>
           </a:p>
         </p:txBody>
       </p:sp>
@@ -10167,7 +10167,7 @@
               <a:buNone/>
             </a:pPr>
             <a:r>
-              <a:rPr lang="en-US" sz="1400" b="1" dirty="0">
+              <a:rPr lang="en-US" sz="1700" b="1" dirty="0">
                 <a:solidFill>
                   <a:srgbClr val="52B788"/>
                 </a:solidFill>
@@ -10177,7 +10177,7 @@
               </a:rPr>
               <a:t>149</a:t>
             </a:r>
-            <a:endParaRPr lang="en-US" sz="1400" dirty="0"/>
+            <a:endParaRPr lang="en-US" sz="1700" dirty="0"/>
           </a:p>
         </p:txBody>
       </p:sp>
@@ -10250,7 +10250,7 @@
               <a:buNone/>
             </a:pPr>
             <a:r>
-              <a:rPr lang="en-US" sz="750" dirty="0">
+              <a:rPr lang="en-US" sz="800" dirty="0">
                 <a:solidFill>
                   <a:srgbClr val="6B7280"/>
                 </a:solidFill>
@@ -10260,7 +10260,7 @@
               </a:rPr>
               <a:t>50,2% do setor</a:t>
             </a:r>
-            <a:endParaRPr lang="en-US" sz="750" dirty="0"/>
+            <a:endParaRPr lang="en-US" sz="800" dirty="0"/>
           </a:p>
         </p:txBody>
       </p:sp>
@@ -10331,7 +10331,7 @@
               <a:buNone/>
             </a:pPr>
             <a:r>
-              <a:rPr lang="en-US" sz="1100" b="1" dirty="0">
+              <a:rPr lang="en-US" sz="1300" b="1" dirty="0">
                 <a:solidFill>
                   <a:srgbClr val="FFFFFF"/>
                 </a:solidFill>
@@ -10341,7 +10341,7 @@
               </a:rPr>
               <a:t>5</a:t>
             </a:r>
-            <a:endParaRPr lang="en-US" sz="1100" dirty="0"/>
+            <a:endParaRPr lang="en-US" sz="1300" dirty="0"/>
           </a:p>
         </p:txBody>
       </p:sp>
@@ -10370,7 +10370,7 @@
               <a:buNone/>
             </a:pPr>
             <a:r>
-              <a:rPr lang="en-US" sz="1150" b="1" dirty="0">
+              <a:rPr lang="en-US" sz="1500" b="1" dirty="0">
                 <a:solidFill>
                   <a:srgbClr val="1D3557"/>
                 </a:solidFill>
@@ -10380,7 +10380,7 @@
               </a:rPr>
               <a:t>Setor 5149</a:t>
             </a:r>
-            <a:endParaRPr lang="en-US" sz="1150" dirty="0"/>
+            <a:endParaRPr lang="en-US" sz="1500" dirty="0"/>
           </a:p>
         </p:txBody>
       </p:sp>
@@ -10409,7 +10409,7 @@
               <a:buNone/>
             </a:pPr>
             <a:r>
-              <a:rPr lang="en-US" sz="1400" b="1" dirty="0">
+              <a:rPr lang="en-US" sz="1700" b="1" dirty="0">
                 <a:solidFill>
                   <a:srgbClr val="52B788"/>
                 </a:solidFill>
@@ -10419,7 +10419,7 @@
               </a:rPr>
               <a:t>146</a:t>
             </a:r>
-            <a:endParaRPr lang="en-US" sz="1400" dirty="0"/>
+            <a:endParaRPr lang="en-US" sz="1700" dirty="0"/>
           </a:p>
         </p:txBody>
       </p:sp>
@@ -10492,7 +10492,7 @@
               <a:buNone/>
             </a:pPr>
             <a:r>
-              <a:rPr lang="en-US" sz="750" dirty="0">
+              <a:rPr lang="en-US" sz="800" dirty="0">
                 <a:solidFill>
                   <a:srgbClr val="6B7280"/>
                 </a:solidFill>
@@ -10502,7 +10502,7 @@
               </a:rPr>
               <a:t>47,1% do setor</a:t>
             </a:r>
-            <a:endParaRPr lang="en-US" sz="750" dirty="0"/>
+            <a:endParaRPr lang="en-US" sz="800" dirty="0"/>
           </a:p>
         </p:txBody>
       </p:sp>
@@ -10573,7 +10573,7 @@
               <a:buNone/>
             </a:pPr>
             <a:r>
-              <a:rPr lang="en-US" sz="1100" b="1" dirty="0">
+              <a:rPr lang="en-US" sz="1300" b="1" dirty="0">
                 <a:solidFill>
                   <a:srgbClr val="FFFFFF"/>
                 </a:solidFill>
@@ -10583,7 +10583,7 @@
               </a:rPr>
               <a:t>6</a:t>
             </a:r>
-            <a:endParaRPr lang="en-US" sz="1100" dirty="0"/>
+            <a:endParaRPr lang="en-US" sz="1300" dirty="0"/>
           </a:p>
         </p:txBody>
       </p:sp>
@@ -10612,7 +10612,7 @@
               <a:buNone/>
             </a:pPr>
             <a:r>
-              <a:rPr lang="en-US" sz="1150" b="1" dirty="0">
+              <a:rPr lang="en-US" sz="1500" b="1" dirty="0">
                 <a:solidFill>
                   <a:srgbClr val="1D3557"/>
                 </a:solidFill>
@@ -10622,7 +10622,7 @@
               </a:rPr>
               <a:t>Setor 7741</a:t>
             </a:r>
-            <a:endParaRPr lang="en-US" sz="1150" dirty="0"/>
+            <a:endParaRPr lang="en-US" sz="1500" dirty="0"/>
           </a:p>
         </p:txBody>
       </p:sp>
@@ -10651,7 +10651,7 @@
               <a:buNone/>
             </a:pPr>
             <a:r>
-              <a:rPr lang="en-US" sz="1400" b="1" dirty="0">
+              <a:rPr lang="en-US" sz="1700" b="1" dirty="0">
                 <a:solidFill>
                   <a:srgbClr val="52B788"/>
                 </a:solidFill>
@@ -10661,7 +10661,7 @@
               </a:rPr>
               <a:t>122</a:t>
             </a:r>
-            <a:endParaRPr lang="en-US" sz="1400" dirty="0"/>
+            <a:endParaRPr lang="en-US" sz="1700" dirty="0"/>
           </a:p>
         </p:txBody>
       </p:sp>
@@ -10734,7 +10734,7 @@
               <a:buNone/>
             </a:pPr>
             <a:r>
-              <a:rPr lang="en-US" sz="750" dirty="0">
+              <a:rPr lang="en-US" sz="800" dirty="0">
                 <a:solidFill>
                   <a:srgbClr val="6B7280"/>
                 </a:solidFill>
@@ -10744,7 +10744,7 @@
               </a:rPr>
               <a:t>43,0% do setor</a:t>
             </a:r>
-            <a:endParaRPr lang="en-US" sz="750" dirty="0"/>
+            <a:endParaRPr lang="en-US" sz="800" dirty="0"/>
           </a:p>
         </p:txBody>
       </p:sp>
@@ -10815,7 +10815,7 @@
               <a:buNone/>
             </a:pPr>
             <a:r>
-              <a:rPr lang="en-US" sz="1100" b="1" dirty="0">
+              <a:rPr lang="en-US" sz="1300" b="1" dirty="0">
                 <a:solidFill>
                   <a:srgbClr val="FFFFFF"/>
                 </a:solidFill>
@@ -10825,7 +10825,7 @@
               </a:rPr>
               <a:t>7</a:t>
             </a:r>
-            <a:endParaRPr lang="en-US" sz="1100" dirty="0"/>
+            <a:endParaRPr lang="en-US" sz="1300" dirty="0"/>
           </a:p>
         </p:txBody>
       </p:sp>
@@ -10854,7 +10854,7 @@
               <a:buNone/>
             </a:pPr>
             <a:r>
-              <a:rPr lang="en-US" sz="1150" b="1" dirty="0">
+              <a:rPr lang="en-US" sz="1500" b="1" dirty="0">
                 <a:solidFill>
                   <a:srgbClr val="1D3557"/>
                 </a:solidFill>
@@ -10864,7 +10864,7 @@
               </a:rPr>
               <a:t>Setor 5153</a:t>
             </a:r>
-            <a:endParaRPr lang="en-US" sz="1150" dirty="0"/>
+            <a:endParaRPr lang="en-US" sz="1500" dirty="0"/>
           </a:p>
         </p:txBody>
       </p:sp>
@@ -10893,7 +10893,7 @@
               <a:buNone/>
             </a:pPr>
             <a:r>
-              <a:rPr lang="en-US" sz="1400" b="1" dirty="0">
+              <a:rPr lang="en-US" sz="1700" b="1" dirty="0">
                 <a:solidFill>
                   <a:srgbClr val="52B788"/>
                 </a:solidFill>
@@ -10903,7 +10903,7 @@
               </a:rPr>
               <a:t>75</a:t>
             </a:r>
-            <a:endParaRPr lang="en-US" sz="1400" dirty="0"/>
+            <a:endParaRPr lang="en-US" sz="1700" dirty="0"/>
           </a:p>
         </p:txBody>
       </p:sp>
@@ -10976,7 +10976,7 @@
               <a:buNone/>
             </a:pPr>
             <a:r>
-              <a:rPr lang="en-US" sz="750" dirty="0">
+              <a:rPr lang="en-US" sz="800" dirty="0">
                 <a:solidFill>
                   <a:srgbClr val="6B7280"/>
                 </a:solidFill>
@@ -10986,7 +10986,7 @@
               </a:rPr>
               <a:t>26,1% do setor</a:t>
             </a:r>
-            <a:endParaRPr lang="en-US" sz="750" dirty="0"/>
+            <a:endParaRPr lang="en-US" sz="800" dirty="0"/>
           </a:p>
         </p:txBody>
       </p:sp>
@@ -11057,7 +11057,7 @@
               <a:buNone/>
             </a:pPr>
             <a:r>
-              <a:rPr lang="en-US" sz="1100" b="1" dirty="0">
+              <a:rPr lang="en-US" sz="1300" b="1" dirty="0">
                 <a:solidFill>
                   <a:srgbClr val="FFFFFF"/>
                 </a:solidFill>
@@ -11067,7 +11067,7 @@
               </a:rPr>
               <a:t>8</a:t>
             </a:r>
-            <a:endParaRPr lang="en-US" sz="1100" dirty="0"/>
+            <a:endParaRPr lang="en-US" sz="1300" dirty="0"/>
           </a:p>
         </p:txBody>
       </p:sp>
@@ -11096,7 +11096,7 @@
               <a:buNone/>
             </a:pPr>
             <a:r>
-              <a:rPr lang="en-US" sz="1150" b="1" dirty="0">
+              <a:rPr lang="en-US" sz="1500" b="1" dirty="0">
                 <a:solidFill>
                   <a:srgbClr val="1D3557"/>
                 </a:solidFill>
@@ -11106,7 +11106,7 @@
               </a:rPr>
               <a:t>Setor 7745</a:t>
             </a:r>
-            <a:endParaRPr lang="en-US" sz="1150" dirty="0"/>
+            <a:endParaRPr lang="en-US" sz="1500" dirty="0"/>
           </a:p>
         </p:txBody>
       </p:sp>
@@ -11135,7 +11135,7 @@
               <a:buNone/>
             </a:pPr>
             <a:r>
-              <a:rPr lang="en-US" sz="1400" b="1" dirty="0">
+              <a:rPr lang="en-US" sz="1700" b="1" dirty="0">
                 <a:solidFill>
                   <a:srgbClr val="52B788"/>
                 </a:solidFill>
@@ -11145,7 +11145,7 @@
               </a:rPr>
               <a:t>73</a:t>
             </a:r>
-            <a:endParaRPr lang="en-US" sz="1400" dirty="0"/>
+            <a:endParaRPr lang="en-US" sz="1700" dirty="0"/>
           </a:p>
         </p:txBody>
       </p:sp>
@@ -11218,7 +11218,7 @@
               <a:buNone/>
             </a:pPr>
             <a:r>
-              <a:rPr lang="en-US" sz="750" dirty="0">
+              <a:rPr lang="en-US" sz="800" dirty="0">
                 <a:solidFill>
                   <a:srgbClr val="6B7280"/>
                 </a:solidFill>
@@ -11228,7 +11228,7 @@
               </a:rPr>
               <a:t>25,5% do setor</a:t>
             </a:r>
-            <a:endParaRPr lang="en-US" sz="750" dirty="0"/>
+            <a:endParaRPr lang="en-US" sz="800" dirty="0"/>
           </a:p>
         </p:txBody>
       </p:sp>
@@ -11257,7 +11257,7 @@
               <a:buNone/>
             </a:pPr>
             <a:r>
-              <a:rPr lang="en-US" sz="850" i="1" dirty="0">
+              <a:rPr lang="en-US" sz="1100" i="1" dirty="0">
                 <a:solidFill>
                   <a:srgbClr val="9AA0A6"/>
                 </a:solidFill>
@@ -11267,7 +11267,7 @@
               </a:rPr>
               <a:t>"% do setor" = participação da CAT no total de médicos classificados (CAT 1 a 5) daquele setor.</a:t>
             </a:r>
-            <a:endParaRPr lang="en-US" sz="850" dirty="0"/>
+            <a:endParaRPr lang="en-US" sz="1100" dirty="0"/>
           </a:p>
         </p:txBody>
       </p:sp>

</xml_diff>

<commit_message>
Remove DOZI do plano de ação e combina SINOT CLAV (CPR+SUSP)
DOZI foi excluído por estar em falta de estoque. SINOT CLAV CPR e
SUSP passam a ser somados como um único mercado (mesma franquia,
mesmo líder concorrente), que assume a maior representatividade
entre os 5 mercados-foco. Também corrige um cálculo que considerava
apenas um SKU Eurofarma em mercados com mais de uma apresentação
(MELOCOX), subestimando o share real da marca.

Co-Authored-By: Claude Sonnet 5 <noreply@anthropic.com>
Claude-Session: https://claude.ai/code/session_01KqmuB8xxfxpvceuypurV9G
</commit_message>
<xml_diff>
--- a/output/painel_medico_distrital_1880.pptx
+++ b/output/painel_medico_distrital_1880.pptx
@@ -13386,7 +13386,7 @@
                 <a:ea typeface="Calibri" pitchFamily="34" charset="-122"/>
                 <a:cs typeface="Calibri" pitchFamily="34" charset="-120"/>
               </a:rPr>
-              <a:t>44,4%</a:t>
+              <a:t>33,0%</a:t>
             </a:r>
             <a:endParaRPr lang="en-US" sz="3000" dirty="0"/>
           </a:p>
@@ -13493,7 +13493,7 @@
                 <a:ea typeface="Calibri" pitchFamily="34" charset="-122"/>
                 <a:cs typeface="Calibri" pitchFamily="34" charset="-120"/>
               </a:rPr>
-              <a:t>R$ 13,1M</a:t>
+              <a:t>R$ 10,4M</a:t>
             </a:r>
             <a:endParaRPr lang="en-US" sz="3000" dirty="0"/>
           </a:p>
@@ -14260,7 +14260,7 @@
                           <a:ea typeface="Calibri" pitchFamily="34" charset="-122"/>
                           <a:cs typeface="Calibri" pitchFamily="34" charset="-120"/>
                         </a:rPr>
-                        <a:t>DOZI</a:t>
+                        <a:t>SINOT CLAV</a:t>
                       </a:r>
                       <a:endParaRPr lang="en-US" sz="1150" dirty="0">
                         <a:latin typeface="Calibri" charset="0"/>
@@ -14328,7 +14328,7 @@
                           <a:ea typeface="Calibri" pitchFamily="34" charset="-122"/>
                           <a:cs typeface="Calibri" pitchFamily="34" charset="-120"/>
                         </a:rPr>
-                        <a:t>R$ 7.799.473</a:t>
+                        <a:t>R$ 4.368.417</a:t>
                       </a:r>
                       <a:endParaRPr lang="en-US" sz="1100" dirty="0">
                         <a:latin typeface="Calibri" charset="0"/>
@@ -14396,7 +14396,7 @@
                           <a:ea typeface="Calibri" pitchFamily="34" charset="-122"/>
                           <a:cs typeface="Calibri" pitchFamily="34" charset="-120"/>
                         </a:rPr>
-                        <a:t>16,3%</a:t>
+                        <a:t>9,1%</a:t>
                       </a:r>
                       <a:endParaRPr lang="en-US" sz="1100" dirty="0">
                         <a:latin typeface="Calibri" charset="0"/>
@@ -14458,13 +14458,13 @@
                       <a:r>
                         <a:rPr lang="en-US" sz="1100" b="1" dirty="0">
                           <a:solidFill>
-                            <a:srgbClr val="1E8449"/>
+                            <a:srgbClr val="C0392B"/>
                           </a:solidFill>
                           <a:latin typeface="Calibri" pitchFamily="34" charset="0"/>
                           <a:ea typeface="Calibri" pitchFamily="34" charset="-122"/>
                           <a:cs typeface="Calibri" pitchFamily="34" charset="-120"/>
                         </a:rPr>
-                        <a:t>+26,4%</a:t>
+                        <a:t>-11,3%</a:t>
                       </a:r>
                       <a:endParaRPr lang="en-US" sz="1100" dirty="0">
                         <a:latin typeface="Calibri" charset="0"/>
@@ -14532,7 +14532,1099 @@
                           <a:ea typeface="Calibri" pitchFamily="34" charset="-122"/>
                           <a:cs typeface="Calibri" pitchFamily="34" charset="-120"/>
                         </a:rPr>
-                        <a:t>1,0%</a:t>
+                        <a:t>14,4%</a:t>
+                      </a:r>
+                      <a:endParaRPr lang="en-US" sz="1100" dirty="0">
+                        <a:latin typeface="Calibri" charset="0"/>
+                        <a:ea typeface="Calibri" charset="0"/>
+                        <a:cs typeface="Calibri" charset="0"/>
+                      </a:endParaRPr>
+                    </a:p>
+                  </a:txBody>
+                  <a:tcPr marL="91440" marR="91440" marT="45720" marB="45720" anchor="ctr">
+                    <a:lnL w="9525" cap="flat" cmpd="sng" algn="ctr">
+                      <a:solidFill>
+                        <a:srgbClr val="E1E4E8"/>
+                      </a:solidFill>
+                      <a:prstDash val="solid"/>
+                      <a:round/>
+                      <a:headEnd type="none" w="med" len="med"/>
+                      <a:tailEnd type="none" w="med" len="med"/>
+                    </a:lnL>
+                    <a:lnR w="9525" cap="flat" cmpd="sng" algn="ctr">
+                      <a:solidFill>
+                        <a:srgbClr val="E1E4E8"/>
+                      </a:solidFill>
+                      <a:prstDash val="solid"/>
+                      <a:round/>
+                      <a:headEnd type="none" w="med" len="med"/>
+                      <a:tailEnd type="none" w="med" len="med"/>
+                    </a:lnR>
+                    <a:lnT w="9525" cap="flat" cmpd="sng" algn="ctr">
+                      <a:solidFill>
+                        <a:srgbClr val="E1E4E8"/>
+                      </a:solidFill>
+                      <a:prstDash val="solid"/>
+                      <a:round/>
+                      <a:headEnd type="none" w="med" len="med"/>
+                      <a:tailEnd type="none" w="med" len="med"/>
+                    </a:lnT>
+                    <a:lnB w="9525" cap="flat" cmpd="sng" algn="ctr">
+                      <a:solidFill>
+                        <a:srgbClr val="E1E4E8"/>
+                      </a:solidFill>
+                      <a:prstDash val="solid"/>
+                      <a:round/>
+                      <a:headEnd type="none" w="med" len="med"/>
+                      <a:tailEnd type="none" w="med" len="med"/>
+                    </a:lnB>
+                    <a:solidFill>
+                      <a:srgbClr val="FFFFFF"/>
+                    </a:solidFill>
+                  </a:tcPr>
+                </a:tc>
+                <a:tc>
+                  <a:txBody>
+                    <a:bodyPr/>
+                    <a:lstStyle/>
+                    <a:p>
+                      <a:pPr algn="ctr" indent="0" marL="0">
+                        <a:buNone/>
+                      </a:pPr>
+                      <a:r>
+                        <a:rPr lang="en-US" sz="1100" dirty="0">
+                          <a:solidFill>
+                            <a:srgbClr val="333333"/>
+                          </a:solidFill>
+                          <a:latin typeface="Calibri" pitchFamily="34" charset="0"/>
+                          <a:ea typeface="Calibri" pitchFamily="34" charset="-122"/>
+                          <a:cs typeface="Calibri" pitchFamily="34" charset="-120"/>
+                        </a:rPr>
+                        <a:t>#2</a:t>
+                      </a:r>
+                      <a:endParaRPr lang="en-US" sz="1100" dirty="0">
+                        <a:latin typeface="Calibri" charset="0"/>
+                        <a:ea typeface="Calibri" charset="0"/>
+                        <a:cs typeface="Calibri" charset="0"/>
+                      </a:endParaRPr>
+                    </a:p>
+                  </a:txBody>
+                  <a:tcPr marL="91440" marR="91440" marT="45720" marB="45720" anchor="ctr">
+                    <a:lnL w="9525" cap="flat" cmpd="sng" algn="ctr">
+                      <a:solidFill>
+                        <a:srgbClr val="E1E4E8"/>
+                      </a:solidFill>
+                      <a:prstDash val="solid"/>
+                      <a:round/>
+                      <a:headEnd type="none" w="med" len="med"/>
+                      <a:tailEnd type="none" w="med" len="med"/>
+                    </a:lnL>
+                    <a:lnR w="9525" cap="flat" cmpd="sng" algn="ctr">
+                      <a:solidFill>
+                        <a:srgbClr val="E1E4E8"/>
+                      </a:solidFill>
+                      <a:prstDash val="solid"/>
+                      <a:round/>
+                      <a:headEnd type="none" w="med" len="med"/>
+                      <a:tailEnd type="none" w="med" len="med"/>
+                    </a:lnR>
+                    <a:lnT w="9525" cap="flat" cmpd="sng" algn="ctr">
+                      <a:solidFill>
+                        <a:srgbClr val="E1E4E8"/>
+                      </a:solidFill>
+                      <a:prstDash val="solid"/>
+                      <a:round/>
+                      <a:headEnd type="none" w="med" len="med"/>
+                      <a:tailEnd type="none" w="med" len="med"/>
+                    </a:lnT>
+                    <a:lnB w="9525" cap="flat" cmpd="sng" algn="ctr">
+                      <a:solidFill>
+                        <a:srgbClr val="E1E4E8"/>
+                      </a:solidFill>
+                      <a:prstDash val="solid"/>
+                      <a:round/>
+                      <a:headEnd type="none" w="med" len="med"/>
+                      <a:tailEnd type="none" w="med" len="med"/>
+                    </a:lnB>
+                    <a:solidFill>
+                      <a:srgbClr val="FFFFFF"/>
+                    </a:solidFill>
+                  </a:tcPr>
+                </a:tc>
+                <a:tc>
+                  <a:txBody>
+                    <a:bodyPr/>
+                    <a:lstStyle/>
+                    <a:p>
+                      <a:pPr algn="l" indent="0" marL="0">
+                        <a:buNone/>
+                      </a:pPr>
+                      <a:r>
+                        <a:rPr lang="en-US" sz="1100" dirty="0">
+                          <a:solidFill>
+                            <a:srgbClr val="333333"/>
+                          </a:solidFill>
+                          <a:latin typeface="Calibri" pitchFamily="34" charset="0"/>
+                          <a:ea typeface="Calibri" pitchFamily="34" charset="-122"/>
+                          <a:cs typeface="Calibri" pitchFamily="34" charset="-120"/>
+                        </a:rPr>
+                        <a:t>Clavulin Bd  (67,4%)</a:t>
+                      </a:r>
+                      <a:endParaRPr lang="en-US" sz="1100" dirty="0">
+                        <a:latin typeface="Calibri" charset="0"/>
+                        <a:ea typeface="Calibri" charset="0"/>
+                        <a:cs typeface="Calibri" charset="0"/>
+                      </a:endParaRPr>
+                    </a:p>
+                  </a:txBody>
+                  <a:tcPr marL="91440" marR="91440" marT="45720" marB="45720" anchor="ctr">
+                    <a:lnL w="9525" cap="flat" cmpd="sng" algn="ctr">
+                      <a:solidFill>
+                        <a:srgbClr val="E1E4E8"/>
+                      </a:solidFill>
+                      <a:prstDash val="solid"/>
+                      <a:round/>
+                      <a:headEnd type="none" w="med" len="med"/>
+                      <a:tailEnd type="none" w="med" len="med"/>
+                    </a:lnL>
+                    <a:lnR w="9525" cap="flat" cmpd="sng" algn="ctr">
+                      <a:solidFill>
+                        <a:srgbClr val="E1E4E8"/>
+                      </a:solidFill>
+                      <a:prstDash val="solid"/>
+                      <a:round/>
+                      <a:headEnd type="none" w="med" len="med"/>
+                      <a:tailEnd type="none" w="med" len="med"/>
+                    </a:lnR>
+                    <a:lnT w="9525" cap="flat" cmpd="sng" algn="ctr">
+                      <a:solidFill>
+                        <a:srgbClr val="E1E4E8"/>
+                      </a:solidFill>
+                      <a:prstDash val="solid"/>
+                      <a:round/>
+                      <a:headEnd type="none" w="med" len="med"/>
+                      <a:tailEnd type="none" w="med" len="med"/>
+                    </a:lnT>
+                    <a:lnB w="9525" cap="flat" cmpd="sng" algn="ctr">
+                      <a:solidFill>
+                        <a:srgbClr val="E1E4E8"/>
+                      </a:solidFill>
+                      <a:prstDash val="solid"/>
+                      <a:round/>
+                      <a:headEnd type="none" w="med" len="med"/>
+                      <a:tailEnd type="none" w="med" len="med"/>
+                    </a:lnB>
+                    <a:solidFill>
+                      <a:srgbClr val="FFFFFF"/>
+                    </a:solidFill>
+                  </a:tcPr>
+                </a:tc>
+                <a:tc>
+                  <a:txBody>
+                    <a:bodyPr/>
+                    <a:lstStyle/>
+                    <a:p>
+                      <a:pPr algn="r" indent="0" marL="0">
+                        <a:buNone/>
+                      </a:pPr>
+                      <a:r>
+                        <a:rPr lang="en-US" sz="1150" b="1" dirty="0">
+                          <a:solidFill>
+                            <a:srgbClr val="D62839"/>
+                          </a:solidFill>
+                          <a:latin typeface="Calibri" pitchFamily="34" charset="0"/>
+                          <a:ea typeface="Calibri" pitchFamily="34" charset="-122"/>
+                          <a:cs typeface="Calibri" pitchFamily="34" charset="-120"/>
+                        </a:rPr>
+                        <a:t>R$ 2.317.187</a:t>
+                      </a:r>
+                      <a:endParaRPr lang="en-US" sz="1150" dirty="0">
+                        <a:latin typeface="Calibri" charset="0"/>
+                        <a:ea typeface="Calibri" charset="0"/>
+                        <a:cs typeface="Calibri" charset="0"/>
+                      </a:endParaRPr>
+                    </a:p>
+                  </a:txBody>
+                  <a:tcPr marL="91440" marR="91440" marT="45720" marB="45720" anchor="ctr">
+                    <a:lnL w="9525" cap="flat" cmpd="sng" algn="ctr">
+                      <a:solidFill>
+                        <a:srgbClr val="E1E4E8"/>
+                      </a:solidFill>
+                      <a:prstDash val="solid"/>
+                      <a:round/>
+                      <a:headEnd type="none" w="med" len="med"/>
+                      <a:tailEnd type="none" w="med" len="med"/>
+                    </a:lnL>
+                    <a:lnR w="9525" cap="flat" cmpd="sng" algn="ctr">
+                      <a:solidFill>
+                        <a:srgbClr val="E1E4E8"/>
+                      </a:solidFill>
+                      <a:prstDash val="solid"/>
+                      <a:round/>
+                      <a:headEnd type="none" w="med" len="med"/>
+                      <a:tailEnd type="none" w="med" len="med"/>
+                    </a:lnR>
+                    <a:lnT w="9525" cap="flat" cmpd="sng" algn="ctr">
+                      <a:solidFill>
+                        <a:srgbClr val="E1E4E8"/>
+                      </a:solidFill>
+                      <a:prstDash val="solid"/>
+                      <a:round/>
+                      <a:headEnd type="none" w="med" len="med"/>
+                      <a:tailEnd type="none" w="med" len="med"/>
+                    </a:lnT>
+                    <a:lnB w="9525" cap="flat" cmpd="sng" algn="ctr">
+                      <a:solidFill>
+                        <a:srgbClr val="E1E4E8"/>
+                      </a:solidFill>
+                      <a:prstDash val="solid"/>
+                      <a:round/>
+                      <a:headEnd type="none" w="med" len="med"/>
+                      <a:tailEnd type="none" w="med" len="med"/>
+                    </a:lnB>
+                    <a:solidFill>
+                      <a:srgbClr val="FFFFFF"/>
+                    </a:solidFill>
+                  </a:tcPr>
+                </a:tc>
+              </a:tr>
+              <a:tr h="475488">
+                <a:tc>
+                  <a:txBody>
+                    <a:bodyPr/>
+                    <a:lstStyle/>
+                    <a:p>
+                      <a:pPr algn="l" indent="0" marL="0">
+                        <a:buNone/>
+                      </a:pPr>
+                      <a:r>
+                        <a:rPr lang="en-US" sz="1150" b="1" dirty="0">
+                          <a:solidFill>
+                            <a:srgbClr val="1D3557"/>
+                          </a:solidFill>
+                          <a:latin typeface="Calibri" pitchFamily="34" charset="0"/>
+                          <a:ea typeface="Calibri" pitchFamily="34" charset="-122"/>
+                          <a:cs typeface="Calibri" pitchFamily="34" charset="-120"/>
+                        </a:rPr>
+                        <a:t>MELOCOX</a:t>
+                      </a:r>
+                      <a:endParaRPr lang="en-US" sz="1150" dirty="0">
+                        <a:latin typeface="Calibri" charset="0"/>
+                        <a:ea typeface="Calibri" charset="0"/>
+                        <a:cs typeface="Calibri" charset="0"/>
+                      </a:endParaRPr>
+                    </a:p>
+                  </a:txBody>
+                  <a:tcPr marL="91440" marR="91440" marT="45720" marB="45720" anchor="ctr">
+                    <a:lnL w="9525" cap="flat" cmpd="sng" algn="ctr">
+                      <a:solidFill>
+                        <a:srgbClr val="E1E4E8"/>
+                      </a:solidFill>
+                      <a:prstDash val="solid"/>
+                      <a:round/>
+                      <a:headEnd type="none" w="med" len="med"/>
+                      <a:tailEnd type="none" w="med" len="med"/>
+                    </a:lnL>
+                    <a:lnR w="9525" cap="flat" cmpd="sng" algn="ctr">
+                      <a:solidFill>
+                        <a:srgbClr val="E1E4E8"/>
+                      </a:solidFill>
+                      <a:prstDash val="solid"/>
+                      <a:round/>
+                      <a:headEnd type="none" w="med" len="med"/>
+                      <a:tailEnd type="none" w="med" len="med"/>
+                    </a:lnR>
+                    <a:lnT w="9525" cap="flat" cmpd="sng" algn="ctr">
+                      <a:solidFill>
+                        <a:srgbClr val="E1E4E8"/>
+                      </a:solidFill>
+                      <a:prstDash val="solid"/>
+                      <a:round/>
+                      <a:headEnd type="none" w="med" len="med"/>
+                      <a:tailEnd type="none" w="med" len="med"/>
+                    </a:lnT>
+                    <a:lnB w="9525" cap="flat" cmpd="sng" algn="ctr">
+                      <a:solidFill>
+                        <a:srgbClr val="E1E4E8"/>
+                      </a:solidFill>
+                      <a:prstDash val="solid"/>
+                      <a:round/>
+                      <a:headEnd type="none" w="med" len="med"/>
+                      <a:tailEnd type="none" w="med" len="med"/>
+                    </a:lnB>
+                    <a:solidFill>
+                      <a:srgbClr val="F5F6F8"/>
+                    </a:solidFill>
+                  </a:tcPr>
+                </a:tc>
+                <a:tc>
+                  <a:txBody>
+                    <a:bodyPr/>
+                    <a:lstStyle/>
+                    <a:p>
+                      <a:pPr algn="r" indent="0" marL="0">
+                        <a:buNone/>
+                      </a:pPr>
+                      <a:r>
+                        <a:rPr lang="en-US" sz="1100" dirty="0">
+                          <a:solidFill>
+                            <a:srgbClr val="333333"/>
+                          </a:solidFill>
+                          <a:latin typeface="Calibri" pitchFamily="34" charset="0"/>
+                          <a:ea typeface="Calibri" pitchFamily="34" charset="-122"/>
+                          <a:cs typeface="Calibri" pitchFamily="34" charset="-120"/>
+                        </a:rPr>
+                        <a:t>R$ 3.501.884</a:t>
+                      </a:r>
+                      <a:endParaRPr lang="en-US" sz="1100" dirty="0">
+                        <a:latin typeface="Calibri" charset="0"/>
+                        <a:ea typeface="Calibri" charset="0"/>
+                        <a:cs typeface="Calibri" charset="0"/>
+                      </a:endParaRPr>
+                    </a:p>
+                  </a:txBody>
+                  <a:tcPr marL="91440" marR="91440" marT="45720" marB="45720" anchor="ctr">
+                    <a:lnL w="9525" cap="flat" cmpd="sng" algn="ctr">
+                      <a:solidFill>
+                        <a:srgbClr val="E1E4E8"/>
+                      </a:solidFill>
+                      <a:prstDash val="solid"/>
+                      <a:round/>
+                      <a:headEnd type="none" w="med" len="med"/>
+                      <a:tailEnd type="none" w="med" len="med"/>
+                    </a:lnL>
+                    <a:lnR w="9525" cap="flat" cmpd="sng" algn="ctr">
+                      <a:solidFill>
+                        <a:srgbClr val="E1E4E8"/>
+                      </a:solidFill>
+                      <a:prstDash val="solid"/>
+                      <a:round/>
+                      <a:headEnd type="none" w="med" len="med"/>
+                      <a:tailEnd type="none" w="med" len="med"/>
+                    </a:lnR>
+                    <a:lnT w="9525" cap="flat" cmpd="sng" algn="ctr">
+                      <a:solidFill>
+                        <a:srgbClr val="E1E4E8"/>
+                      </a:solidFill>
+                      <a:prstDash val="solid"/>
+                      <a:round/>
+                      <a:headEnd type="none" w="med" len="med"/>
+                      <a:tailEnd type="none" w="med" len="med"/>
+                    </a:lnT>
+                    <a:lnB w="9525" cap="flat" cmpd="sng" algn="ctr">
+                      <a:solidFill>
+                        <a:srgbClr val="E1E4E8"/>
+                      </a:solidFill>
+                      <a:prstDash val="solid"/>
+                      <a:round/>
+                      <a:headEnd type="none" w="med" len="med"/>
+                      <a:tailEnd type="none" w="med" len="med"/>
+                    </a:lnB>
+                    <a:solidFill>
+                      <a:srgbClr val="F5F6F8"/>
+                    </a:solidFill>
+                  </a:tcPr>
+                </a:tc>
+                <a:tc>
+                  <a:txBody>
+                    <a:bodyPr/>
+                    <a:lstStyle/>
+                    <a:p>
+                      <a:pPr algn="ctr" indent="0" marL="0">
+                        <a:buNone/>
+                      </a:pPr>
+                      <a:r>
+                        <a:rPr lang="en-US" sz="1100" dirty="0">
+                          <a:solidFill>
+                            <a:srgbClr val="333333"/>
+                          </a:solidFill>
+                          <a:latin typeface="Calibri" pitchFamily="34" charset="0"/>
+                          <a:ea typeface="Calibri" pitchFamily="34" charset="-122"/>
+                          <a:cs typeface="Calibri" pitchFamily="34" charset="-120"/>
+                        </a:rPr>
+                        <a:t>7,3%</a:t>
+                      </a:r>
+                      <a:endParaRPr lang="en-US" sz="1100" dirty="0">
+                        <a:latin typeface="Calibri" charset="0"/>
+                        <a:ea typeface="Calibri" charset="0"/>
+                        <a:cs typeface="Calibri" charset="0"/>
+                      </a:endParaRPr>
+                    </a:p>
+                  </a:txBody>
+                  <a:tcPr marL="91440" marR="91440" marT="45720" marB="45720" anchor="ctr">
+                    <a:lnL w="9525" cap="flat" cmpd="sng" algn="ctr">
+                      <a:solidFill>
+                        <a:srgbClr val="E1E4E8"/>
+                      </a:solidFill>
+                      <a:prstDash val="solid"/>
+                      <a:round/>
+                      <a:headEnd type="none" w="med" len="med"/>
+                      <a:tailEnd type="none" w="med" len="med"/>
+                    </a:lnL>
+                    <a:lnR w="9525" cap="flat" cmpd="sng" algn="ctr">
+                      <a:solidFill>
+                        <a:srgbClr val="E1E4E8"/>
+                      </a:solidFill>
+                      <a:prstDash val="solid"/>
+                      <a:round/>
+                      <a:headEnd type="none" w="med" len="med"/>
+                      <a:tailEnd type="none" w="med" len="med"/>
+                    </a:lnR>
+                    <a:lnT w="9525" cap="flat" cmpd="sng" algn="ctr">
+                      <a:solidFill>
+                        <a:srgbClr val="E1E4E8"/>
+                      </a:solidFill>
+                      <a:prstDash val="solid"/>
+                      <a:round/>
+                      <a:headEnd type="none" w="med" len="med"/>
+                      <a:tailEnd type="none" w="med" len="med"/>
+                    </a:lnT>
+                    <a:lnB w="9525" cap="flat" cmpd="sng" algn="ctr">
+                      <a:solidFill>
+                        <a:srgbClr val="E1E4E8"/>
+                      </a:solidFill>
+                      <a:prstDash val="solid"/>
+                      <a:round/>
+                      <a:headEnd type="none" w="med" len="med"/>
+                      <a:tailEnd type="none" w="med" len="med"/>
+                    </a:lnB>
+                    <a:solidFill>
+                      <a:srgbClr val="F5F6F8"/>
+                    </a:solidFill>
+                  </a:tcPr>
+                </a:tc>
+                <a:tc>
+                  <a:txBody>
+                    <a:bodyPr/>
+                    <a:lstStyle/>
+                    <a:p>
+                      <a:pPr algn="ctr" indent="0" marL="0">
+                        <a:buNone/>
+                      </a:pPr>
+                      <a:r>
+                        <a:rPr lang="en-US" sz="1100" b="1" dirty="0">
+                          <a:solidFill>
+                            <a:srgbClr val="1E8449"/>
+                          </a:solidFill>
+                          <a:latin typeface="Calibri" pitchFamily="34" charset="0"/>
+                          <a:ea typeface="Calibri" pitchFamily="34" charset="-122"/>
+                          <a:cs typeface="Calibri" pitchFamily="34" charset="-120"/>
+                        </a:rPr>
+                        <a:t>+7,4%</a:t>
+                      </a:r>
+                      <a:endParaRPr lang="en-US" sz="1100" dirty="0">
+                        <a:latin typeface="Calibri" charset="0"/>
+                        <a:ea typeface="Calibri" charset="0"/>
+                        <a:cs typeface="Calibri" charset="0"/>
+                      </a:endParaRPr>
+                    </a:p>
+                  </a:txBody>
+                  <a:tcPr marL="91440" marR="91440" marT="45720" marB="45720" anchor="ctr">
+                    <a:lnL w="9525" cap="flat" cmpd="sng" algn="ctr">
+                      <a:solidFill>
+                        <a:srgbClr val="E1E4E8"/>
+                      </a:solidFill>
+                      <a:prstDash val="solid"/>
+                      <a:round/>
+                      <a:headEnd type="none" w="med" len="med"/>
+                      <a:tailEnd type="none" w="med" len="med"/>
+                    </a:lnL>
+                    <a:lnR w="9525" cap="flat" cmpd="sng" algn="ctr">
+                      <a:solidFill>
+                        <a:srgbClr val="E1E4E8"/>
+                      </a:solidFill>
+                      <a:prstDash val="solid"/>
+                      <a:round/>
+                      <a:headEnd type="none" w="med" len="med"/>
+                      <a:tailEnd type="none" w="med" len="med"/>
+                    </a:lnR>
+                    <a:lnT w="9525" cap="flat" cmpd="sng" algn="ctr">
+                      <a:solidFill>
+                        <a:srgbClr val="E1E4E8"/>
+                      </a:solidFill>
+                      <a:prstDash val="solid"/>
+                      <a:round/>
+                      <a:headEnd type="none" w="med" len="med"/>
+                      <a:tailEnd type="none" w="med" len="med"/>
+                    </a:lnT>
+                    <a:lnB w="9525" cap="flat" cmpd="sng" algn="ctr">
+                      <a:solidFill>
+                        <a:srgbClr val="E1E4E8"/>
+                      </a:solidFill>
+                      <a:prstDash val="solid"/>
+                      <a:round/>
+                      <a:headEnd type="none" w="med" len="med"/>
+                      <a:tailEnd type="none" w="med" len="med"/>
+                    </a:lnB>
+                    <a:solidFill>
+                      <a:srgbClr val="F5F6F8"/>
+                    </a:solidFill>
+                  </a:tcPr>
+                </a:tc>
+                <a:tc>
+                  <a:txBody>
+                    <a:bodyPr/>
+                    <a:lstStyle/>
+                    <a:p>
+                      <a:pPr algn="ctr" indent="0" marL="0">
+                        <a:buNone/>
+                      </a:pPr>
+                      <a:r>
+                        <a:rPr lang="en-US" sz="1100" b="1" dirty="0">
+                          <a:solidFill>
+                            <a:srgbClr val="6A4C93"/>
+                          </a:solidFill>
+                          <a:latin typeface="Calibri" pitchFamily="34" charset="0"/>
+                          <a:ea typeface="Calibri" pitchFamily="34" charset="-122"/>
+                          <a:cs typeface="Calibri" pitchFamily="34" charset="-120"/>
+                        </a:rPr>
+                        <a:t>6,5%</a:t>
+                      </a:r>
+                      <a:endParaRPr lang="en-US" sz="1100" dirty="0">
+                        <a:latin typeface="Calibri" charset="0"/>
+                        <a:ea typeface="Calibri" charset="0"/>
+                        <a:cs typeface="Calibri" charset="0"/>
+                      </a:endParaRPr>
+                    </a:p>
+                  </a:txBody>
+                  <a:tcPr marL="91440" marR="91440" marT="45720" marB="45720" anchor="ctr">
+                    <a:lnL w="9525" cap="flat" cmpd="sng" algn="ctr">
+                      <a:solidFill>
+                        <a:srgbClr val="E1E4E8"/>
+                      </a:solidFill>
+                      <a:prstDash val="solid"/>
+                      <a:round/>
+                      <a:headEnd type="none" w="med" len="med"/>
+                      <a:tailEnd type="none" w="med" len="med"/>
+                    </a:lnL>
+                    <a:lnR w="9525" cap="flat" cmpd="sng" algn="ctr">
+                      <a:solidFill>
+                        <a:srgbClr val="E1E4E8"/>
+                      </a:solidFill>
+                      <a:prstDash val="solid"/>
+                      <a:round/>
+                      <a:headEnd type="none" w="med" len="med"/>
+                      <a:tailEnd type="none" w="med" len="med"/>
+                    </a:lnR>
+                    <a:lnT w="9525" cap="flat" cmpd="sng" algn="ctr">
+                      <a:solidFill>
+                        <a:srgbClr val="E1E4E8"/>
+                      </a:solidFill>
+                      <a:prstDash val="solid"/>
+                      <a:round/>
+                      <a:headEnd type="none" w="med" len="med"/>
+                      <a:tailEnd type="none" w="med" len="med"/>
+                    </a:lnT>
+                    <a:lnB w="9525" cap="flat" cmpd="sng" algn="ctr">
+                      <a:solidFill>
+                        <a:srgbClr val="E1E4E8"/>
+                      </a:solidFill>
+                      <a:prstDash val="solid"/>
+                      <a:round/>
+                      <a:headEnd type="none" w="med" len="med"/>
+                      <a:tailEnd type="none" w="med" len="med"/>
+                    </a:lnB>
+                    <a:solidFill>
+                      <a:srgbClr val="F5F6F8"/>
+                    </a:solidFill>
+                  </a:tcPr>
+                </a:tc>
+                <a:tc>
+                  <a:txBody>
+                    <a:bodyPr/>
+                    <a:lstStyle/>
+                    <a:p>
+                      <a:pPr algn="ctr" indent="0" marL="0">
+                        <a:buNone/>
+                      </a:pPr>
+                      <a:r>
+                        <a:rPr lang="en-US" sz="1100" dirty="0">
+                          <a:solidFill>
+                            <a:srgbClr val="333333"/>
+                          </a:solidFill>
+                          <a:latin typeface="Calibri" pitchFamily="34" charset="0"/>
+                          <a:ea typeface="Calibri" pitchFamily="34" charset="-122"/>
+                          <a:cs typeface="Calibri" pitchFamily="34" charset="-120"/>
+                        </a:rPr>
+                        <a:t>#3</a:t>
+                      </a:r>
+                      <a:endParaRPr lang="en-US" sz="1100" dirty="0">
+                        <a:latin typeface="Calibri" charset="0"/>
+                        <a:ea typeface="Calibri" charset="0"/>
+                        <a:cs typeface="Calibri" charset="0"/>
+                      </a:endParaRPr>
+                    </a:p>
+                  </a:txBody>
+                  <a:tcPr marL="91440" marR="91440" marT="45720" marB="45720" anchor="ctr">
+                    <a:lnL w="9525" cap="flat" cmpd="sng" algn="ctr">
+                      <a:solidFill>
+                        <a:srgbClr val="E1E4E8"/>
+                      </a:solidFill>
+                      <a:prstDash val="solid"/>
+                      <a:round/>
+                      <a:headEnd type="none" w="med" len="med"/>
+                      <a:tailEnd type="none" w="med" len="med"/>
+                    </a:lnL>
+                    <a:lnR w="9525" cap="flat" cmpd="sng" algn="ctr">
+                      <a:solidFill>
+                        <a:srgbClr val="E1E4E8"/>
+                      </a:solidFill>
+                      <a:prstDash val="solid"/>
+                      <a:round/>
+                      <a:headEnd type="none" w="med" len="med"/>
+                      <a:tailEnd type="none" w="med" len="med"/>
+                    </a:lnR>
+                    <a:lnT w="9525" cap="flat" cmpd="sng" algn="ctr">
+                      <a:solidFill>
+                        <a:srgbClr val="E1E4E8"/>
+                      </a:solidFill>
+                      <a:prstDash val="solid"/>
+                      <a:round/>
+                      <a:headEnd type="none" w="med" len="med"/>
+                      <a:tailEnd type="none" w="med" len="med"/>
+                    </a:lnT>
+                    <a:lnB w="9525" cap="flat" cmpd="sng" algn="ctr">
+                      <a:solidFill>
+                        <a:srgbClr val="E1E4E8"/>
+                      </a:solidFill>
+                      <a:prstDash val="solid"/>
+                      <a:round/>
+                      <a:headEnd type="none" w="med" len="med"/>
+                      <a:tailEnd type="none" w="med" len="med"/>
+                    </a:lnB>
+                    <a:solidFill>
+                      <a:srgbClr val="F5F6F8"/>
+                    </a:solidFill>
+                  </a:tcPr>
+                </a:tc>
+                <a:tc>
+                  <a:txBody>
+                    <a:bodyPr/>
+                    <a:lstStyle/>
+                    <a:p>
+                      <a:pPr algn="l" indent="0" marL="0">
+                        <a:buNone/>
+                      </a:pPr>
+                      <a:r>
+                        <a:rPr lang="en-US" sz="1100" dirty="0">
+                          <a:solidFill>
+                            <a:srgbClr val="333333"/>
+                          </a:solidFill>
+                          <a:latin typeface="Calibri" pitchFamily="34" charset="0"/>
+                          <a:ea typeface="Calibri" pitchFamily="34" charset="-122"/>
+                          <a:cs typeface="Calibri" pitchFamily="34" charset="-120"/>
+                        </a:rPr>
+                        <a:t>Flancox  (74,4%)</a:t>
+                      </a:r>
+                      <a:endParaRPr lang="en-US" sz="1100" dirty="0">
+                        <a:latin typeface="Calibri" charset="0"/>
+                        <a:ea typeface="Calibri" charset="0"/>
+                        <a:cs typeface="Calibri" charset="0"/>
+                      </a:endParaRPr>
+                    </a:p>
+                  </a:txBody>
+                  <a:tcPr marL="91440" marR="91440" marT="45720" marB="45720" anchor="ctr">
+                    <a:lnL w="9525" cap="flat" cmpd="sng" algn="ctr">
+                      <a:solidFill>
+                        <a:srgbClr val="E1E4E8"/>
+                      </a:solidFill>
+                      <a:prstDash val="solid"/>
+                      <a:round/>
+                      <a:headEnd type="none" w="med" len="med"/>
+                      <a:tailEnd type="none" w="med" len="med"/>
+                    </a:lnL>
+                    <a:lnR w="9525" cap="flat" cmpd="sng" algn="ctr">
+                      <a:solidFill>
+                        <a:srgbClr val="E1E4E8"/>
+                      </a:solidFill>
+                      <a:prstDash val="solid"/>
+                      <a:round/>
+                      <a:headEnd type="none" w="med" len="med"/>
+                      <a:tailEnd type="none" w="med" len="med"/>
+                    </a:lnR>
+                    <a:lnT w="9525" cap="flat" cmpd="sng" algn="ctr">
+                      <a:solidFill>
+                        <a:srgbClr val="E1E4E8"/>
+                      </a:solidFill>
+                      <a:prstDash val="solid"/>
+                      <a:round/>
+                      <a:headEnd type="none" w="med" len="med"/>
+                      <a:tailEnd type="none" w="med" len="med"/>
+                    </a:lnT>
+                    <a:lnB w="9525" cap="flat" cmpd="sng" algn="ctr">
+                      <a:solidFill>
+                        <a:srgbClr val="E1E4E8"/>
+                      </a:solidFill>
+                      <a:prstDash val="solid"/>
+                      <a:round/>
+                      <a:headEnd type="none" w="med" len="med"/>
+                      <a:tailEnd type="none" w="med" len="med"/>
+                    </a:lnB>
+                    <a:solidFill>
+                      <a:srgbClr val="F5F6F8"/>
+                    </a:solidFill>
+                  </a:tcPr>
+                </a:tc>
+                <a:tc>
+                  <a:txBody>
+                    <a:bodyPr/>
+                    <a:lstStyle/>
+                    <a:p>
+                      <a:pPr algn="r" indent="0" marL="0">
+                        <a:buNone/>
+                      </a:pPr>
+                      <a:r>
+                        <a:rPr lang="en-US" sz="1150" b="1" dirty="0">
+                          <a:solidFill>
+                            <a:srgbClr val="D62839"/>
+                          </a:solidFill>
+                          <a:latin typeface="Calibri" pitchFamily="34" charset="0"/>
+                          <a:ea typeface="Calibri" pitchFamily="34" charset="-122"/>
+                          <a:cs typeface="Calibri" pitchFamily="34" charset="-120"/>
+                        </a:rPr>
+                        <a:t>R$ 2.380.356</a:t>
+                      </a:r>
+                      <a:endParaRPr lang="en-US" sz="1150" dirty="0">
+                        <a:latin typeface="Calibri" charset="0"/>
+                        <a:ea typeface="Calibri" charset="0"/>
+                        <a:cs typeface="Calibri" charset="0"/>
+                      </a:endParaRPr>
+                    </a:p>
+                  </a:txBody>
+                  <a:tcPr marL="91440" marR="91440" marT="45720" marB="45720" anchor="ctr">
+                    <a:lnL w="9525" cap="flat" cmpd="sng" algn="ctr">
+                      <a:solidFill>
+                        <a:srgbClr val="E1E4E8"/>
+                      </a:solidFill>
+                      <a:prstDash val="solid"/>
+                      <a:round/>
+                      <a:headEnd type="none" w="med" len="med"/>
+                      <a:tailEnd type="none" w="med" len="med"/>
+                    </a:lnL>
+                    <a:lnR w="9525" cap="flat" cmpd="sng" algn="ctr">
+                      <a:solidFill>
+                        <a:srgbClr val="E1E4E8"/>
+                      </a:solidFill>
+                      <a:prstDash val="solid"/>
+                      <a:round/>
+                      <a:headEnd type="none" w="med" len="med"/>
+                      <a:tailEnd type="none" w="med" len="med"/>
+                    </a:lnR>
+                    <a:lnT w="9525" cap="flat" cmpd="sng" algn="ctr">
+                      <a:solidFill>
+                        <a:srgbClr val="E1E4E8"/>
+                      </a:solidFill>
+                      <a:prstDash val="solid"/>
+                      <a:round/>
+                      <a:headEnd type="none" w="med" len="med"/>
+                      <a:tailEnd type="none" w="med" len="med"/>
+                    </a:lnT>
+                    <a:lnB w="9525" cap="flat" cmpd="sng" algn="ctr">
+                      <a:solidFill>
+                        <a:srgbClr val="E1E4E8"/>
+                      </a:solidFill>
+                      <a:prstDash val="solid"/>
+                      <a:round/>
+                      <a:headEnd type="none" w="med" len="med"/>
+                      <a:tailEnd type="none" w="med" len="med"/>
+                    </a:lnB>
+                    <a:solidFill>
+                      <a:srgbClr val="F5F6F8"/>
+                    </a:solidFill>
+                  </a:tcPr>
+                </a:tc>
+              </a:tr>
+              <a:tr h="475488">
+                <a:tc>
+                  <a:txBody>
+                    <a:bodyPr/>
+                    <a:lstStyle/>
+                    <a:p>
+                      <a:pPr algn="l" indent="0" marL="0">
+                        <a:buNone/>
+                      </a:pPr>
+                      <a:r>
+                        <a:rPr lang="en-US" sz="1150" b="1" dirty="0">
+                          <a:solidFill>
+                            <a:srgbClr val="1D3557"/>
+                          </a:solidFill>
+                          <a:latin typeface="Calibri" pitchFamily="34" charset="0"/>
+                          <a:ea typeface="Calibri" pitchFamily="34" charset="-122"/>
+                          <a:cs typeface="Calibri" pitchFamily="34" charset="-120"/>
+                        </a:rPr>
+                        <a:t>EBASTEL XAROPE</a:t>
+                      </a:r>
+                      <a:endParaRPr lang="en-US" sz="1150" dirty="0">
+                        <a:latin typeface="Calibri" charset="0"/>
+                        <a:ea typeface="Calibri" charset="0"/>
+                        <a:cs typeface="Calibri" charset="0"/>
+                      </a:endParaRPr>
+                    </a:p>
+                  </a:txBody>
+                  <a:tcPr marL="91440" marR="91440" marT="45720" marB="45720" anchor="ctr">
+                    <a:lnL w="9525" cap="flat" cmpd="sng" algn="ctr">
+                      <a:solidFill>
+                        <a:srgbClr val="E1E4E8"/>
+                      </a:solidFill>
+                      <a:prstDash val="solid"/>
+                      <a:round/>
+                      <a:headEnd type="none" w="med" len="med"/>
+                      <a:tailEnd type="none" w="med" len="med"/>
+                    </a:lnL>
+                    <a:lnR w="9525" cap="flat" cmpd="sng" algn="ctr">
+                      <a:solidFill>
+                        <a:srgbClr val="E1E4E8"/>
+                      </a:solidFill>
+                      <a:prstDash val="solid"/>
+                      <a:round/>
+                      <a:headEnd type="none" w="med" len="med"/>
+                      <a:tailEnd type="none" w="med" len="med"/>
+                    </a:lnR>
+                    <a:lnT w="9525" cap="flat" cmpd="sng" algn="ctr">
+                      <a:solidFill>
+                        <a:srgbClr val="E1E4E8"/>
+                      </a:solidFill>
+                      <a:prstDash val="solid"/>
+                      <a:round/>
+                      <a:headEnd type="none" w="med" len="med"/>
+                      <a:tailEnd type="none" w="med" len="med"/>
+                    </a:lnT>
+                    <a:lnB w="9525" cap="flat" cmpd="sng" algn="ctr">
+                      <a:solidFill>
+                        <a:srgbClr val="E1E4E8"/>
+                      </a:solidFill>
+                      <a:prstDash val="solid"/>
+                      <a:round/>
+                      <a:headEnd type="none" w="med" len="med"/>
+                      <a:tailEnd type="none" w="med" len="med"/>
+                    </a:lnB>
+                    <a:solidFill>
+                      <a:srgbClr val="FFFFFF"/>
+                    </a:solidFill>
+                  </a:tcPr>
+                </a:tc>
+                <a:tc>
+                  <a:txBody>
+                    <a:bodyPr/>
+                    <a:lstStyle/>
+                    <a:p>
+                      <a:pPr algn="r" indent="0" marL="0">
+                        <a:buNone/>
+                      </a:pPr>
+                      <a:r>
+                        <a:rPr lang="en-US" sz="1100" dirty="0">
+                          <a:solidFill>
+                            <a:srgbClr val="333333"/>
+                          </a:solidFill>
+                          <a:latin typeface="Calibri" pitchFamily="34" charset="0"/>
+                          <a:ea typeface="Calibri" pitchFamily="34" charset="-122"/>
+                          <a:cs typeface="Calibri" pitchFamily="34" charset="-120"/>
+                        </a:rPr>
+                        <a:t>R$ 3.477.589</a:t>
+                      </a:r>
+                      <a:endParaRPr lang="en-US" sz="1100" dirty="0">
+                        <a:latin typeface="Calibri" charset="0"/>
+                        <a:ea typeface="Calibri" charset="0"/>
+                        <a:cs typeface="Calibri" charset="0"/>
+                      </a:endParaRPr>
+                    </a:p>
+                  </a:txBody>
+                  <a:tcPr marL="91440" marR="91440" marT="45720" marB="45720" anchor="ctr">
+                    <a:lnL w="9525" cap="flat" cmpd="sng" algn="ctr">
+                      <a:solidFill>
+                        <a:srgbClr val="E1E4E8"/>
+                      </a:solidFill>
+                      <a:prstDash val="solid"/>
+                      <a:round/>
+                      <a:headEnd type="none" w="med" len="med"/>
+                      <a:tailEnd type="none" w="med" len="med"/>
+                    </a:lnL>
+                    <a:lnR w="9525" cap="flat" cmpd="sng" algn="ctr">
+                      <a:solidFill>
+                        <a:srgbClr val="E1E4E8"/>
+                      </a:solidFill>
+                      <a:prstDash val="solid"/>
+                      <a:round/>
+                      <a:headEnd type="none" w="med" len="med"/>
+                      <a:tailEnd type="none" w="med" len="med"/>
+                    </a:lnR>
+                    <a:lnT w="9525" cap="flat" cmpd="sng" algn="ctr">
+                      <a:solidFill>
+                        <a:srgbClr val="E1E4E8"/>
+                      </a:solidFill>
+                      <a:prstDash val="solid"/>
+                      <a:round/>
+                      <a:headEnd type="none" w="med" len="med"/>
+                      <a:tailEnd type="none" w="med" len="med"/>
+                    </a:lnT>
+                    <a:lnB w="9525" cap="flat" cmpd="sng" algn="ctr">
+                      <a:solidFill>
+                        <a:srgbClr val="E1E4E8"/>
+                      </a:solidFill>
+                      <a:prstDash val="solid"/>
+                      <a:round/>
+                      <a:headEnd type="none" w="med" len="med"/>
+                      <a:tailEnd type="none" w="med" len="med"/>
+                    </a:lnB>
+                    <a:solidFill>
+                      <a:srgbClr val="FFFFFF"/>
+                    </a:solidFill>
+                  </a:tcPr>
+                </a:tc>
+                <a:tc>
+                  <a:txBody>
+                    <a:bodyPr/>
+                    <a:lstStyle/>
+                    <a:p>
+                      <a:pPr algn="ctr" indent="0" marL="0">
+                        <a:buNone/>
+                      </a:pPr>
+                      <a:r>
+                        <a:rPr lang="en-US" sz="1100" dirty="0">
+                          <a:solidFill>
+                            <a:srgbClr val="333333"/>
+                          </a:solidFill>
+                          <a:latin typeface="Calibri" pitchFamily="34" charset="0"/>
+                          <a:ea typeface="Calibri" pitchFamily="34" charset="-122"/>
+                          <a:cs typeface="Calibri" pitchFamily="34" charset="-120"/>
+                        </a:rPr>
+                        <a:t>7,3%</a:t>
+                      </a:r>
+                      <a:endParaRPr lang="en-US" sz="1100" dirty="0">
+                        <a:latin typeface="Calibri" charset="0"/>
+                        <a:ea typeface="Calibri" charset="0"/>
+                        <a:cs typeface="Calibri" charset="0"/>
+                      </a:endParaRPr>
+                    </a:p>
+                  </a:txBody>
+                  <a:tcPr marL="91440" marR="91440" marT="45720" marB="45720" anchor="ctr">
+                    <a:lnL w="9525" cap="flat" cmpd="sng" algn="ctr">
+                      <a:solidFill>
+                        <a:srgbClr val="E1E4E8"/>
+                      </a:solidFill>
+                      <a:prstDash val="solid"/>
+                      <a:round/>
+                      <a:headEnd type="none" w="med" len="med"/>
+                      <a:tailEnd type="none" w="med" len="med"/>
+                    </a:lnL>
+                    <a:lnR w="9525" cap="flat" cmpd="sng" algn="ctr">
+                      <a:solidFill>
+                        <a:srgbClr val="E1E4E8"/>
+                      </a:solidFill>
+                      <a:prstDash val="solid"/>
+                      <a:round/>
+                      <a:headEnd type="none" w="med" len="med"/>
+                      <a:tailEnd type="none" w="med" len="med"/>
+                    </a:lnR>
+                    <a:lnT w="9525" cap="flat" cmpd="sng" algn="ctr">
+                      <a:solidFill>
+                        <a:srgbClr val="E1E4E8"/>
+                      </a:solidFill>
+                      <a:prstDash val="solid"/>
+                      <a:round/>
+                      <a:headEnd type="none" w="med" len="med"/>
+                      <a:tailEnd type="none" w="med" len="med"/>
+                    </a:lnT>
+                    <a:lnB w="9525" cap="flat" cmpd="sng" algn="ctr">
+                      <a:solidFill>
+                        <a:srgbClr val="E1E4E8"/>
+                      </a:solidFill>
+                      <a:prstDash val="solid"/>
+                      <a:round/>
+                      <a:headEnd type="none" w="med" len="med"/>
+                      <a:tailEnd type="none" w="med" len="med"/>
+                    </a:lnB>
+                    <a:solidFill>
+                      <a:srgbClr val="FFFFFF"/>
+                    </a:solidFill>
+                  </a:tcPr>
+                </a:tc>
+                <a:tc>
+                  <a:txBody>
+                    <a:bodyPr/>
+                    <a:lstStyle/>
+                    <a:p>
+                      <a:pPr algn="ctr" indent="0" marL="0">
+                        <a:buNone/>
+                      </a:pPr>
+                      <a:r>
+                        <a:rPr lang="en-US" sz="1100" b="1" dirty="0">
+                          <a:solidFill>
+                            <a:srgbClr val="C0392B"/>
+                          </a:solidFill>
+                          <a:latin typeface="Calibri" pitchFamily="34" charset="0"/>
+                          <a:ea typeface="Calibri" pitchFamily="34" charset="-122"/>
+                          <a:cs typeface="Calibri" pitchFamily="34" charset="-120"/>
+                        </a:rPr>
+                        <a:t>-0,4%</a:t>
+                      </a:r>
+                      <a:endParaRPr lang="en-US" sz="1100" dirty="0">
+                        <a:latin typeface="Calibri" charset="0"/>
+                        <a:ea typeface="Calibri" charset="0"/>
+                        <a:cs typeface="Calibri" charset="0"/>
+                      </a:endParaRPr>
+                    </a:p>
+                  </a:txBody>
+                  <a:tcPr marL="91440" marR="91440" marT="45720" marB="45720" anchor="ctr">
+                    <a:lnL w="9525" cap="flat" cmpd="sng" algn="ctr">
+                      <a:solidFill>
+                        <a:srgbClr val="E1E4E8"/>
+                      </a:solidFill>
+                      <a:prstDash val="solid"/>
+                      <a:round/>
+                      <a:headEnd type="none" w="med" len="med"/>
+                      <a:tailEnd type="none" w="med" len="med"/>
+                    </a:lnL>
+                    <a:lnR w="9525" cap="flat" cmpd="sng" algn="ctr">
+                      <a:solidFill>
+                        <a:srgbClr val="E1E4E8"/>
+                      </a:solidFill>
+                      <a:prstDash val="solid"/>
+                      <a:round/>
+                      <a:headEnd type="none" w="med" len="med"/>
+                      <a:tailEnd type="none" w="med" len="med"/>
+                    </a:lnR>
+                    <a:lnT w="9525" cap="flat" cmpd="sng" algn="ctr">
+                      <a:solidFill>
+                        <a:srgbClr val="E1E4E8"/>
+                      </a:solidFill>
+                      <a:prstDash val="solid"/>
+                      <a:round/>
+                      <a:headEnd type="none" w="med" len="med"/>
+                      <a:tailEnd type="none" w="med" len="med"/>
+                    </a:lnT>
+                    <a:lnB w="9525" cap="flat" cmpd="sng" algn="ctr">
+                      <a:solidFill>
+                        <a:srgbClr val="E1E4E8"/>
+                      </a:solidFill>
+                      <a:prstDash val="solid"/>
+                      <a:round/>
+                      <a:headEnd type="none" w="med" len="med"/>
+                      <a:tailEnd type="none" w="med" len="med"/>
+                    </a:lnB>
+                    <a:solidFill>
+                      <a:srgbClr val="FFFFFF"/>
+                    </a:solidFill>
+                  </a:tcPr>
+                </a:tc>
+                <a:tc>
+                  <a:txBody>
+                    <a:bodyPr/>
+                    <a:lstStyle/>
+                    <a:p>
+                      <a:pPr algn="ctr" indent="0" marL="0">
+                        <a:buNone/>
+                      </a:pPr>
+                      <a:r>
+                        <a:rPr lang="en-US" sz="1100" b="1" dirty="0">
+                          <a:solidFill>
+                            <a:srgbClr val="6A4C93"/>
+                          </a:solidFill>
+                          <a:latin typeface="Calibri" pitchFamily="34" charset="0"/>
+                          <a:ea typeface="Calibri" pitchFamily="34" charset="-122"/>
+                          <a:cs typeface="Calibri" pitchFamily="34" charset="-120"/>
+                        </a:rPr>
+                        <a:t>7,8%</a:t>
                       </a:r>
                       <a:endParaRPr lang="en-US" sz="1100" dirty="0">
                         <a:latin typeface="Calibri" charset="0"/>
@@ -14668,7 +15760,7 @@
                           <a:ea typeface="Calibri" pitchFamily="34" charset="-122"/>
                           <a:cs typeface="Calibri" pitchFamily="34" charset="-120"/>
                         </a:rPr>
-                        <a:t>Mecobe  (51,5%)</a:t>
+                        <a:t>Allegra  (61,9%)</a:t>
                       </a:r>
                       <a:endParaRPr lang="en-US" sz="1100" dirty="0">
                         <a:latin typeface="Calibri" charset="0"/>
@@ -14736,7 +15828,7 @@
                           <a:ea typeface="Calibri" pitchFamily="34" charset="-122"/>
                           <a:cs typeface="Calibri" pitchFamily="34" charset="-120"/>
                         </a:rPr>
-                        <a:t>R$ 3.937.523</a:t>
+                        <a:t>R$ 1.883.228</a:t>
                       </a:r>
                       <a:endParaRPr lang="en-US" sz="1150" dirty="0">
                         <a:latin typeface="Calibri" charset="0"/>
@@ -15352,7 +16444,7 @@
                           <a:ea typeface="Calibri" pitchFamily="34" charset="-122"/>
                           <a:cs typeface="Calibri" pitchFamily="34" charset="-120"/>
                         </a:rPr>
-                        <a:t>MELOCOX</a:t>
+                        <a:t>AZOX CPR</a:t>
                       </a:r>
                       <a:endParaRPr lang="en-US" sz="1150" dirty="0">
                         <a:latin typeface="Calibri" charset="0"/>
@@ -15420,7 +16512,7 @@
                           <a:ea typeface="Calibri" pitchFamily="34" charset="-122"/>
                           <a:cs typeface="Calibri" pitchFamily="34" charset="-120"/>
                         </a:rPr>
-                        <a:t>R$ 3.501.884</a:t>
+                        <a:t>R$ 1.345.516</a:t>
                       </a:r>
                       <a:endParaRPr lang="en-US" sz="1100" dirty="0">
                         <a:latin typeface="Calibri" charset="0"/>
@@ -15488,7 +16580,7 @@
                           <a:ea typeface="Calibri" pitchFamily="34" charset="-122"/>
                           <a:cs typeface="Calibri" pitchFamily="34" charset="-120"/>
                         </a:rPr>
-                        <a:t>7,3%</a:t>
+                        <a:t>2,8%</a:t>
                       </a:r>
                       <a:endParaRPr lang="en-US" sz="1100" dirty="0">
                         <a:latin typeface="Calibri" charset="0"/>
@@ -15550,13 +16642,13 @@
                       <a:r>
                         <a:rPr lang="en-US" sz="1100" b="1" dirty="0">
                           <a:solidFill>
-                            <a:srgbClr val="1E8449"/>
+                            <a:srgbClr val="C0392B"/>
                           </a:solidFill>
                           <a:latin typeface="Calibri" pitchFamily="34" charset="0"/>
                           <a:ea typeface="Calibri" pitchFamily="34" charset="-122"/>
                           <a:cs typeface="Calibri" pitchFamily="34" charset="-120"/>
                         </a:rPr>
-                        <a:t>+7,4%</a:t>
+                        <a:t>-4,3%</a:t>
                       </a:r>
                       <a:endParaRPr lang="en-US" sz="1100" dirty="0">
                         <a:latin typeface="Calibri" charset="0"/>
@@ -15624,7 +16716,7 @@
                           <a:ea typeface="Calibri" pitchFamily="34" charset="-122"/>
                           <a:cs typeface="Calibri" pitchFamily="34" charset="-120"/>
                         </a:rPr>
-                        <a:t>4,1%</a:t>
+                        <a:t>6,3%</a:t>
                       </a:r>
                       <a:endParaRPr lang="en-US" sz="1100" dirty="0">
                         <a:latin typeface="Calibri" charset="0"/>
@@ -15672,552 +16764,6 @@
                     </a:lnB>
                     <a:solidFill>
                       <a:srgbClr val="FFFFFF"/>
-                    </a:solidFill>
-                  </a:tcPr>
-                </a:tc>
-                <a:tc>
-                  <a:txBody>
-                    <a:bodyPr/>
-                    <a:lstStyle/>
-                    <a:p>
-                      <a:pPr algn="ctr" indent="0" marL="0">
-                        <a:buNone/>
-                      </a:pPr>
-                      <a:r>
-                        <a:rPr lang="en-US" sz="1100" dirty="0">
-                          <a:solidFill>
-                            <a:srgbClr val="333333"/>
-                          </a:solidFill>
-                          <a:latin typeface="Calibri" pitchFamily="34" charset="0"/>
-                          <a:ea typeface="Calibri" pitchFamily="34" charset="-122"/>
-                          <a:cs typeface="Calibri" pitchFamily="34" charset="-120"/>
-                        </a:rPr>
-                        <a:t>#3</a:t>
-                      </a:r>
-                      <a:endParaRPr lang="en-US" sz="1100" dirty="0">
-                        <a:latin typeface="Calibri" charset="0"/>
-                        <a:ea typeface="Calibri" charset="0"/>
-                        <a:cs typeface="Calibri" charset="0"/>
-                      </a:endParaRPr>
-                    </a:p>
-                  </a:txBody>
-                  <a:tcPr marL="91440" marR="91440" marT="45720" marB="45720" anchor="ctr">
-                    <a:lnL w="9525" cap="flat" cmpd="sng" algn="ctr">
-                      <a:solidFill>
-                        <a:srgbClr val="E1E4E8"/>
-                      </a:solidFill>
-                      <a:prstDash val="solid"/>
-                      <a:round/>
-                      <a:headEnd type="none" w="med" len="med"/>
-                      <a:tailEnd type="none" w="med" len="med"/>
-                    </a:lnL>
-                    <a:lnR w="9525" cap="flat" cmpd="sng" algn="ctr">
-                      <a:solidFill>
-                        <a:srgbClr val="E1E4E8"/>
-                      </a:solidFill>
-                      <a:prstDash val="solid"/>
-                      <a:round/>
-                      <a:headEnd type="none" w="med" len="med"/>
-                      <a:tailEnd type="none" w="med" len="med"/>
-                    </a:lnR>
-                    <a:lnT w="9525" cap="flat" cmpd="sng" algn="ctr">
-                      <a:solidFill>
-                        <a:srgbClr val="E1E4E8"/>
-                      </a:solidFill>
-                      <a:prstDash val="solid"/>
-                      <a:round/>
-                      <a:headEnd type="none" w="med" len="med"/>
-                      <a:tailEnd type="none" w="med" len="med"/>
-                    </a:lnT>
-                    <a:lnB w="9525" cap="flat" cmpd="sng" algn="ctr">
-                      <a:solidFill>
-                        <a:srgbClr val="E1E4E8"/>
-                      </a:solidFill>
-                      <a:prstDash val="solid"/>
-                      <a:round/>
-                      <a:headEnd type="none" w="med" len="med"/>
-                      <a:tailEnd type="none" w="med" len="med"/>
-                    </a:lnB>
-                    <a:solidFill>
-                      <a:srgbClr val="FFFFFF"/>
-                    </a:solidFill>
-                  </a:tcPr>
-                </a:tc>
-                <a:tc>
-                  <a:txBody>
-                    <a:bodyPr/>
-                    <a:lstStyle/>
-                    <a:p>
-                      <a:pPr algn="l" indent="0" marL="0">
-                        <a:buNone/>
-                      </a:pPr>
-                      <a:r>
-                        <a:rPr lang="en-US" sz="1100" dirty="0">
-                          <a:solidFill>
-                            <a:srgbClr val="333333"/>
-                          </a:solidFill>
-                          <a:latin typeface="Calibri" pitchFamily="34" charset="0"/>
-                          <a:ea typeface="Calibri" pitchFamily="34" charset="-122"/>
-                          <a:cs typeface="Calibri" pitchFamily="34" charset="-120"/>
-                        </a:rPr>
-                        <a:t>Flancox  (74,4%)</a:t>
-                      </a:r>
-                      <a:endParaRPr lang="en-US" sz="1100" dirty="0">
-                        <a:latin typeface="Calibri" charset="0"/>
-                        <a:ea typeface="Calibri" charset="0"/>
-                        <a:cs typeface="Calibri" charset="0"/>
-                      </a:endParaRPr>
-                    </a:p>
-                  </a:txBody>
-                  <a:tcPr marL="91440" marR="91440" marT="45720" marB="45720" anchor="ctr">
-                    <a:lnL w="9525" cap="flat" cmpd="sng" algn="ctr">
-                      <a:solidFill>
-                        <a:srgbClr val="E1E4E8"/>
-                      </a:solidFill>
-                      <a:prstDash val="solid"/>
-                      <a:round/>
-                      <a:headEnd type="none" w="med" len="med"/>
-                      <a:tailEnd type="none" w="med" len="med"/>
-                    </a:lnL>
-                    <a:lnR w="9525" cap="flat" cmpd="sng" algn="ctr">
-                      <a:solidFill>
-                        <a:srgbClr val="E1E4E8"/>
-                      </a:solidFill>
-                      <a:prstDash val="solid"/>
-                      <a:round/>
-                      <a:headEnd type="none" w="med" len="med"/>
-                      <a:tailEnd type="none" w="med" len="med"/>
-                    </a:lnR>
-                    <a:lnT w="9525" cap="flat" cmpd="sng" algn="ctr">
-                      <a:solidFill>
-                        <a:srgbClr val="E1E4E8"/>
-                      </a:solidFill>
-                      <a:prstDash val="solid"/>
-                      <a:round/>
-                      <a:headEnd type="none" w="med" len="med"/>
-                      <a:tailEnd type="none" w="med" len="med"/>
-                    </a:lnT>
-                    <a:lnB w="9525" cap="flat" cmpd="sng" algn="ctr">
-                      <a:solidFill>
-                        <a:srgbClr val="E1E4E8"/>
-                      </a:solidFill>
-                      <a:prstDash val="solid"/>
-                      <a:round/>
-                      <a:headEnd type="none" w="med" len="med"/>
-                      <a:tailEnd type="none" w="med" len="med"/>
-                    </a:lnB>
-                    <a:solidFill>
-                      <a:srgbClr val="FFFFFF"/>
-                    </a:solidFill>
-                  </a:tcPr>
-                </a:tc>
-                <a:tc>
-                  <a:txBody>
-                    <a:bodyPr/>
-                    <a:lstStyle/>
-                    <a:p>
-                      <a:pPr algn="r" indent="0" marL="0">
-                        <a:buNone/>
-                      </a:pPr>
-                      <a:r>
-                        <a:rPr lang="en-US" sz="1150" b="1" dirty="0">
-                          <a:solidFill>
-                            <a:srgbClr val="D62839"/>
-                          </a:solidFill>
-                          <a:latin typeface="Calibri" pitchFamily="34" charset="0"/>
-                          <a:ea typeface="Calibri" pitchFamily="34" charset="-122"/>
-                          <a:cs typeface="Calibri" pitchFamily="34" charset="-120"/>
-                        </a:rPr>
-                        <a:t>R$ 2.464.684</a:t>
-                      </a:r>
-                      <a:endParaRPr lang="en-US" sz="1150" dirty="0">
-                        <a:latin typeface="Calibri" charset="0"/>
-                        <a:ea typeface="Calibri" charset="0"/>
-                        <a:cs typeface="Calibri" charset="0"/>
-                      </a:endParaRPr>
-                    </a:p>
-                  </a:txBody>
-                  <a:tcPr marL="91440" marR="91440" marT="45720" marB="45720" anchor="ctr">
-                    <a:lnL w="9525" cap="flat" cmpd="sng" algn="ctr">
-                      <a:solidFill>
-                        <a:srgbClr val="E1E4E8"/>
-                      </a:solidFill>
-                      <a:prstDash val="solid"/>
-                      <a:round/>
-                      <a:headEnd type="none" w="med" len="med"/>
-                      <a:tailEnd type="none" w="med" len="med"/>
-                    </a:lnL>
-                    <a:lnR w="9525" cap="flat" cmpd="sng" algn="ctr">
-                      <a:solidFill>
-                        <a:srgbClr val="E1E4E8"/>
-                      </a:solidFill>
-                      <a:prstDash val="solid"/>
-                      <a:round/>
-                      <a:headEnd type="none" w="med" len="med"/>
-                      <a:tailEnd type="none" w="med" len="med"/>
-                    </a:lnR>
-                    <a:lnT w="9525" cap="flat" cmpd="sng" algn="ctr">
-                      <a:solidFill>
-                        <a:srgbClr val="E1E4E8"/>
-                      </a:solidFill>
-                      <a:prstDash val="solid"/>
-                      <a:round/>
-                      <a:headEnd type="none" w="med" len="med"/>
-                      <a:tailEnd type="none" w="med" len="med"/>
-                    </a:lnT>
-                    <a:lnB w="9525" cap="flat" cmpd="sng" algn="ctr">
-                      <a:solidFill>
-                        <a:srgbClr val="E1E4E8"/>
-                      </a:solidFill>
-                      <a:prstDash val="solid"/>
-                      <a:round/>
-                      <a:headEnd type="none" w="med" len="med"/>
-                      <a:tailEnd type="none" w="med" len="med"/>
-                    </a:lnB>
-                    <a:solidFill>
-                      <a:srgbClr val="FFFFFF"/>
-                    </a:solidFill>
-                  </a:tcPr>
-                </a:tc>
-              </a:tr>
-              <a:tr h="475488">
-                <a:tc>
-                  <a:txBody>
-                    <a:bodyPr/>
-                    <a:lstStyle/>
-                    <a:p>
-                      <a:pPr algn="l" indent="0" marL="0">
-                        <a:buNone/>
-                      </a:pPr>
-                      <a:r>
-                        <a:rPr lang="en-US" sz="1150" b="1" dirty="0">
-                          <a:solidFill>
-                            <a:srgbClr val="1D3557"/>
-                          </a:solidFill>
-                          <a:latin typeface="Calibri" pitchFamily="34" charset="0"/>
-                          <a:ea typeface="Calibri" pitchFamily="34" charset="-122"/>
-                          <a:cs typeface="Calibri" pitchFamily="34" charset="-120"/>
-                        </a:rPr>
-                        <a:t>SINOT CLAV CPR</a:t>
-                      </a:r>
-                      <a:endParaRPr lang="en-US" sz="1150" dirty="0">
-                        <a:latin typeface="Calibri" charset="0"/>
-                        <a:ea typeface="Calibri" charset="0"/>
-                        <a:cs typeface="Calibri" charset="0"/>
-                      </a:endParaRPr>
-                    </a:p>
-                  </a:txBody>
-                  <a:tcPr marL="91440" marR="91440" marT="45720" marB="45720" anchor="ctr">
-                    <a:lnL w="9525" cap="flat" cmpd="sng" algn="ctr">
-                      <a:solidFill>
-                        <a:srgbClr val="E1E4E8"/>
-                      </a:solidFill>
-                      <a:prstDash val="solid"/>
-                      <a:round/>
-                      <a:headEnd type="none" w="med" len="med"/>
-                      <a:tailEnd type="none" w="med" len="med"/>
-                    </a:lnL>
-                    <a:lnR w="9525" cap="flat" cmpd="sng" algn="ctr">
-                      <a:solidFill>
-                        <a:srgbClr val="E1E4E8"/>
-                      </a:solidFill>
-                      <a:prstDash val="solid"/>
-                      <a:round/>
-                      <a:headEnd type="none" w="med" len="med"/>
-                      <a:tailEnd type="none" w="med" len="med"/>
-                    </a:lnR>
-                    <a:lnT w="9525" cap="flat" cmpd="sng" algn="ctr">
-                      <a:solidFill>
-                        <a:srgbClr val="E1E4E8"/>
-                      </a:solidFill>
-                      <a:prstDash val="solid"/>
-                      <a:round/>
-                      <a:headEnd type="none" w="med" len="med"/>
-                      <a:tailEnd type="none" w="med" len="med"/>
-                    </a:lnT>
-                    <a:lnB w="9525" cap="flat" cmpd="sng" algn="ctr">
-                      <a:solidFill>
-                        <a:srgbClr val="E1E4E8"/>
-                      </a:solidFill>
-                      <a:prstDash val="solid"/>
-                      <a:round/>
-                      <a:headEnd type="none" w="med" len="med"/>
-                      <a:tailEnd type="none" w="med" len="med"/>
-                    </a:lnB>
-                    <a:solidFill>
-                      <a:srgbClr val="F5F6F8"/>
-                    </a:solidFill>
-                  </a:tcPr>
-                </a:tc>
-                <a:tc>
-                  <a:txBody>
-                    <a:bodyPr/>
-                    <a:lstStyle/>
-                    <a:p>
-                      <a:pPr algn="r" indent="0" marL="0">
-                        <a:buNone/>
-                      </a:pPr>
-                      <a:r>
-                        <a:rPr lang="en-US" sz="1100" dirty="0">
-                          <a:solidFill>
-                            <a:srgbClr val="333333"/>
-                          </a:solidFill>
-                          <a:latin typeface="Calibri" pitchFamily="34" charset="0"/>
-                          <a:ea typeface="Calibri" pitchFamily="34" charset="-122"/>
-                          <a:cs typeface="Calibri" pitchFamily="34" charset="-120"/>
-                        </a:rPr>
-                        <a:t>R$ 3.346.310</a:t>
-                      </a:r>
-                      <a:endParaRPr lang="en-US" sz="1100" dirty="0">
-                        <a:latin typeface="Calibri" charset="0"/>
-                        <a:ea typeface="Calibri" charset="0"/>
-                        <a:cs typeface="Calibri" charset="0"/>
-                      </a:endParaRPr>
-                    </a:p>
-                  </a:txBody>
-                  <a:tcPr marL="91440" marR="91440" marT="45720" marB="45720" anchor="ctr">
-                    <a:lnL w="9525" cap="flat" cmpd="sng" algn="ctr">
-                      <a:solidFill>
-                        <a:srgbClr val="E1E4E8"/>
-                      </a:solidFill>
-                      <a:prstDash val="solid"/>
-                      <a:round/>
-                      <a:headEnd type="none" w="med" len="med"/>
-                      <a:tailEnd type="none" w="med" len="med"/>
-                    </a:lnL>
-                    <a:lnR w="9525" cap="flat" cmpd="sng" algn="ctr">
-                      <a:solidFill>
-                        <a:srgbClr val="E1E4E8"/>
-                      </a:solidFill>
-                      <a:prstDash val="solid"/>
-                      <a:round/>
-                      <a:headEnd type="none" w="med" len="med"/>
-                      <a:tailEnd type="none" w="med" len="med"/>
-                    </a:lnR>
-                    <a:lnT w="9525" cap="flat" cmpd="sng" algn="ctr">
-                      <a:solidFill>
-                        <a:srgbClr val="E1E4E8"/>
-                      </a:solidFill>
-                      <a:prstDash val="solid"/>
-                      <a:round/>
-                      <a:headEnd type="none" w="med" len="med"/>
-                      <a:tailEnd type="none" w="med" len="med"/>
-                    </a:lnT>
-                    <a:lnB w="9525" cap="flat" cmpd="sng" algn="ctr">
-                      <a:solidFill>
-                        <a:srgbClr val="E1E4E8"/>
-                      </a:solidFill>
-                      <a:prstDash val="solid"/>
-                      <a:round/>
-                      <a:headEnd type="none" w="med" len="med"/>
-                      <a:tailEnd type="none" w="med" len="med"/>
-                    </a:lnB>
-                    <a:solidFill>
-                      <a:srgbClr val="F5F6F8"/>
-                    </a:solidFill>
-                  </a:tcPr>
-                </a:tc>
-                <a:tc>
-                  <a:txBody>
-                    <a:bodyPr/>
-                    <a:lstStyle/>
-                    <a:p>
-                      <a:pPr algn="ctr" indent="0" marL="0">
-                        <a:buNone/>
-                      </a:pPr>
-                      <a:r>
-                        <a:rPr lang="en-US" sz="1100" dirty="0">
-                          <a:solidFill>
-                            <a:srgbClr val="333333"/>
-                          </a:solidFill>
-                          <a:latin typeface="Calibri" pitchFamily="34" charset="0"/>
-                          <a:ea typeface="Calibri" pitchFamily="34" charset="-122"/>
-                          <a:cs typeface="Calibri" pitchFamily="34" charset="-120"/>
-                        </a:rPr>
-                        <a:t>7,0%</a:t>
-                      </a:r>
-                      <a:endParaRPr lang="en-US" sz="1100" dirty="0">
-                        <a:latin typeface="Calibri" charset="0"/>
-                        <a:ea typeface="Calibri" charset="0"/>
-                        <a:cs typeface="Calibri" charset="0"/>
-                      </a:endParaRPr>
-                    </a:p>
-                  </a:txBody>
-                  <a:tcPr marL="91440" marR="91440" marT="45720" marB="45720" anchor="ctr">
-                    <a:lnL w="9525" cap="flat" cmpd="sng" algn="ctr">
-                      <a:solidFill>
-                        <a:srgbClr val="E1E4E8"/>
-                      </a:solidFill>
-                      <a:prstDash val="solid"/>
-                      <a:round/>
-                      <a:headEnd type="none" w="med" len="med"/>
-                      <a:tailEnd type="none" w="med" len="med"/>
-                    </a:lnL>
-                    <a:lnR w="9525" cap="flat" cmpd="sng" algn="ctr">
-                      <a:solidFill>
-                        <a:srgbClr val="E1E4E8"/>
-                      </a:solidFill>
-                      <a:prstDash val="solid"/>
-                      <a:round/>
-                      <a:headEnd type="none" w="med" len="med"/>
-                      <a:tailEnd type="none" w="med" len="med"/>
-                    </a:lnR>
-                    <a:lnT w="9525" cap="flat" cmpd="sng" algn="ctr">
-                      <a:solidFill>
-                        <a:srgbClr val="E1E4E8"/>
-                      </a:solidFill>
-                      <a:prstDash val="solid"/>
-                      <a:round/>
-                      <a:headEnd type="none" w="med" len="med"/>
-                      <a:tailEnd type="none" w="med" len="med"/>
-                    </a:lnT>
-                    <a:lnB w="9525" cap="flat" cmpd="sng" algn="ctr">
-                      <a:solidFill>
-                        <a:srgbClr val="E1E4E8"/>
-                      </a:solidFill>
-                      <a:prstDash val="solid"/>
-                      <a:round/>
-                      <a:headEnd type="none" w="med" len="med"/>
-                      <a:tailEnd type="none" w="med" len="med"/>
-                    </a:lnB>
-                    <a:solidFill>
-                      <a:srgbClr val="F5F6F8"/>
-                    </a:solidFill>
-                  </a:tcPr>
-                </a:tc>
-                <a:tc>
-                  <a:txBody>
-                    <a:bodyPr/>
-                    <a:lstStyle/>
-                    <a:p>
-                      <a:pPr algn="ctr" indent="0" marL="0">
-                        <a:buNone/>
-                      </a:pPr>
-                      <a:r>
-                        <a:rPr lang="en-US" sz="1100" b="1" dirty="0">
-                          <a:solidFill>
-                            <a:srgbClr val="C0392B"/>
-                          </a:solidFill>
-                          <a:latin typeface="Calibri" pitchFamily="34" charset="0"/>
-                          <a:ea typeface="Calibri" pitchFamily="34" charset="-122"/>
-                          <a:cs typeface="Calibri" pitchFamily="34" charset="-120"/>
-                        </a:rPr>
-                        <a:t>-12,8%</a:t>
-                      </a:r>
-                      <a:endParaRPr lang="en-US" sz="1100" dirty="0">
-                        <a:latin typeface="Calibri" charset="0"/>
-                        <a:ea typeface="Calibri" charset="0"/>
-                        <a:cs typeface="Calibri" charset="0"/>
-                      </a:endParaRPr>
-                    </a:p>
-                  </a:txBody>
-                  <a:tcPr marL="91440" marR="91440" marT="45720" marB="45720" anchor="ctr">
-                    <a:lnL w="9525" cap="flat" cmpd="sng" algn="ctr">
-                      <a:solidFill>
-                        <a:srgbClr val="E1E4E8"/>
-                      </a:solidFill>
-                      <a:prstDash val="solid"/>
-                      <a:round/>
-                      <a:headEnd type="none" w="med" len="med"/>
-                      <a:tailEnd type="none" w="med" len="med"/>
-                    </a:lnL>
-                    <a:lnR w="9525" cap="flat" cmpd="sng" algn="ctr">
-                      <a:solidFill>
-                        <a:srgbClr val="E1E4E8"/>
-                      </a:solidFill>
-                      <a:prstDash val="solid"/>
-                      <a:round/>
-                      <a:headEnd type="none" w="med" len="med"/>
-                      <a:tailEnd type="none" w="med" len="med"/>
-                    </a:lnR>
-                    <a:lnT w="9525" cap="flat" cmpd="sng" algn="ctr">
-                      <a:solidFill>
-                        <a:srgbClr val="E1E4E8"/>
-                      </a:solidFill>
-                      <a:prstDash val="solid"/>
-                      <a:round/>
-                      <a:headEnd type="none" w="med" len="med"/>
-                      <a:tailEnd type="none" w="med" len="med"/>
-                    </a:lnT>
-                    <a:lnB w="9525" cap="flat" cmpd="sng" algn="ctr">
-                      <a:solidFill>
-                        <a:srgbClr val="E1E4E8"/>
-                      </a:solidFill>
-                      <a:prstDash val="solid"/>
-                      <a:round/>
-                      <a:headEnd type="none" w="med" len="med"/>
-                      <a:tailEnd type="none" w="med" len="med"/>
-                    </a:lnB>
-                    <a:solidFill>
-                      <a:srgbClr val="F5F6F8"/>
-                    </a:solidFill>
-                  </a:tcPr>
-                </a:tc>
-                <a:tc>
-                  <a:txBody>
-                    <a:bodyPr/>
-                    <a:lstStyle/>
-                    <a:p>
-                      <a:pPr algn="ctr" indent="0" marL="0">
-                        <a:buNone/>
-                      </a:pPr>
-                      <a:r>
-                        <a:rPr lang="en-US" sz="1100" b="1" dirty="0">
-                          <a:solidFill>
-                            <a:srgbClr val="6A4C93"/>
-                          </a:solidFill>
-                          <a:latin typeface="Calibri" pitchFamily="34" charset="0"/>
-                          <a:ea typeface="Calibri" pitchFamily="34" charset="-122"/>
-                          <a:cs typeface="Calibri" pitchFamily="34" charset="-120"/>
-                        </a:rPr>
-                        <a:t>11,1%</a:t>
-                      </a:r>
-                      <a:endParaRPr lang="en-US" sz="1100" dirty="0">
-                        <a:latin typeface="Calibri" charset="0"/>
-                        <a:ea typeface="Calibri" charset="0"/>
-                        <a:cs typeface="Calibri" charset="0"/>
-                      </a:endParaRPr>
-                    </a:p>
-                  </a:txBody>
-                  <a:tcPr marL="91440" marR="91440" marT="45720" marB="45720" anchor="ctr">
-                    <a:lnL w="9525" cap="flat" cmpd="sng" algn="ctr">
-                      <a:solidFill>
-                        <a:srgbClr val="E1E4E8"/>
-                      </a:solidFill>
-                      <a:prstDash val="solid"/>
-                      <a:round/>
-                      <a:headEnd type="none" w="med" len="med"/>
-                      <a:tailEnd type="none" w="med" len="med"/>
-                    </a:lnL>
-                    <a:lnR w="9525" cap="flat" cmpd="sng" algn="ctr">
-                      <a:solidFill>
-                        <a:srgbClr val="E1E4E8"/>
-                      </a:solidFill>
-                      <a:prstDash val="solid"/>
-                      <a:round/>
-                      <a:headEnd type="none" w="med" len="med"/>
-                      <a:tailEnd type="none" w="med" len="med"/>
-                    </a:lnR>
-                    <a:lnT w="9525" cap="flat" cmpd="sng" algn="ctr">
-                      <a:solidFill>
-                        <a:srgbClr val="E1E4E8"/>
-                      </a:solidFill>
-                      <a:prstDash val="solid"/>
-                      <a:round/>
-                      <a:headEnd type="none" w="med" len="med"/>
-                      <a:tailEnd type="none" w="med" len="med"/>
-                    </a:lnT>
-                    <a:lnB w="9525" cap="flat" cmpd="sng" algn="ctr">
-                      <a:solidFill>
-                        <a:srgbClr val="E1E4E8"/>
-                      </a:solidFill>
-                      <a:prstDash val="solid"/>
-                      <a:round/>
-                      <a:headEnd type="none" w="med" len="med"/>
-                      <a:tailEnd type="none" w="med" len="med"/>
-                    </a:lnB>
-                    <a:solidFill>
-                      <a:srgbClr val="F5F6F8"/>
                     </a:solidFill>
                   </a:tcPr>
                 </a:tc>
@@ -16285,552 +16831,6 @@
                       <a:tailEnd type="none" w="med" len="med"/>
                     </a:lnB>
                     <a:solidFill>
-                      <a:srgbClr val="F5F6F8"/>
-                    </a:solidFill>
-                  </a:tcPr>
-                </a:tc>
-                <a:tc>
-                  <a:txBody>
-                    <a:bodyPr/>
-                    <a:lstStyle/>
-                    <a:p>
-                      <a:pPr algn="l" indent="0" marL="0">
-                        <a:buNone/>
-                      </a:pPr>
-                      <a:r>
-                        <a:rPr lang="en-US" sz="1100" dirty="0">
-                          <a:solidFill>
-                            <a:srgbClr val="333333"/>
-                          </a:solidFill>
-                          <a:latin typeface="Calibri" pitchFamily="34" charset="0"/>
-                          <a:ea typeface="Calibri" pitchFamily="34" charset="-122"/>
-                          <a:cs typeface="Calibri" pitchFamily="34" charset="-120"/>
-                        </a:rPr>
-                        <a:t>Clavulin Bd  (75,6%)</a:t>
-                      </a:r>
-                      <a:endParaRPr lang="en-US" sz="1100" dirty="0">
-                        <a:latin typeface="Calibri" charset="0"/>
-                        <a:ea typeface="Calibri" charset="0"/>
-                        <a:cs typeface="Calibri" charset="0"/>
-                      </a:endParaRPr>
-                    </a:p>
-                  </a:txBody>
-                  <a:tcPr marL="91440" marR="91440" marT="45720" marB="45720" anchor="ctr">
-                    <a:lnL w="9525" cap="flat" cmpd="sng" algn="ctr">
-                      <a:solidFill>
-                        <a:srgbClr val="E1E4E8"/>
-                      </a:solidFill>
-                      <a:prstDash val="solid"/>
-                      <a:round/>
-                      <a:headEnd type="none" w="med" len="med"/>
-                      <a:tailEnd type="none" w="med" len="med"/>
-                    </a:lnL>
-                    <a:lnR w="9525" cap="flat" cmpd="sng" algn="ctr">
-                      <a:solidFill>
-                        <a:srgbClr val="E1E4E8"/>
-                      </a:solidFill>
-                      <a:prstDash val="solid"/>
-                      <a:round/>
-                      <a:headEnd type="none" w="med" len="med"/>
-                      <a:tailEnd type="none" w="med" len="med"/>
-                    </a:lnR>
-                    <a:lnT w="9525" cap="flat" cmpd="sng" algn="ctr">
-                      <a:solidFill>
-                        <a:srgbClr val="E1E4E8"/>
-                      </a:solidFill>
-                      <a:prstDash val="solid"/>
-                      <a:round/>
-                      <a:headEnd type="none" w="med" len="med"/>
-                      <a:tailEnd type="none" w="med" len="med"/>
-                    </a:lnT>
-                    <a:lnB w="9525" cap="flat" cmpd="sng" algn="ctr">
-                      <a:solidFill>
-                        <a:srgbClr val="E1E4E8"/>
-                      </a:solidFill>
-                      <a:prstDash val="solid"/>
-                      <a:round/>
-                      <a:headEnd type="none" w="med" len="med"/>
-                      <a:tailEnd type="none" w="med" len="med"/>
-                    </a:lnB>
-                    <a:solidFill>
-                      <a:srgbClr val="F5F6F8"/>
-                    </a:solidFill>
-                  </a:tcPr>
-                </a:tc>
-                <a:tc>
-                  <a:txBody>
-                    <a:bodyPr/>
-                    <a:lstStyle/>
-                    <a:p>
-                      <a:pPr algn="r" indent="0" marL="0">
-                        <a:buNone/>
-                      </a:pPr>
-                      <a:r>
-                        <a:rPr lang="en-US" sz="1150" b="1" dirty="0">
-                          <a:solidFill>
-                            <a:srgbClr val="D62839"/>
-                          </a:solidFill>
-                          <a:latin typeface="Calibri" pitchFamily="34" charset="0"/>
-                          <a:ea typeface="Calibri" pitchFamily="34" charset="-122"/>
-                          <a:cs typeface="Calibri" pitchFamily="34" charset="-120"/>
-                        </a:rPr>
-                        <a:t>R$ 2.160.246</a:t>
-                      </a:r>
-                      <a:endParaRPr lang="en-US" sz="1150" dirty="0">
-                        <a:latin typeface="Calibri" charset="0"/>
-                        <a:ea typeface="Calibri" charset="0"/>
-                        <a:cs typeface="Calibri" charset="0"/>
-                      </a:endParaRPr>
-                    </a:p>
-                  </a:txBody>
-                  <a:tcPr marL="91440" marR="91440" marT="45720" marB="45720" anchor="ctr">
-                    <a:lnL w="9525" cap="flat" cmpd="sng" algn="ctr">
-                      <a:solidFill>
-                        <a:srgbClr val="E1E4E8"/>
-                      </a:solidFill>
-                      <a:prstDash val="solid"/>
-                      <a:round/>
-                      <a:headEnd type="none" w="med" len="med"/>
-                      <a:tailEnd type="none" w="med" len="med"/>
-                    </a:lnL>
-                    <a:lnR w="9525" cap="flat" cmpd="sng" algn="ctr">
-                      <a:solidFill>
-                        <a:srgbClr val="E1E4E8"/>
-                      </a:solidFill>
-                      <a:prstDash val="solid"/>
-                      <a:round/>
-                      <a:headEnd type="none" w="med" len="med"/>
-                      <a:tailEnd type="none" w="med" len="med"/>
-                    </a:lnR>
-                    <a:lnT w="9525" cap="flat" cmpd="sng" algn="ctr">
-                      <a:solidFill>
-                        <a:srgbClr val="E1E4E8"/>
-                      </a:solidFill>
-                      <a:prstDash val="solid"/>
-                      <a:round/>
-                      <a:headEnd type="none" w="med" len="med"/>
-                      <a:tailEnd type="none" w="med" len="med"/>
-                    </a:lnT>
-                    <a:lnB w="9525" cap="flat" cmpd="sng" algn="ctr">
-                      <a:solidFill>
-                        <a:srgbClr val="E1E4E8"/>
-                      </a:solidFill>
-                      <a:prstDash val="solid"/>
-                      <a:round/>
-                      <a:headEnd type="none" w="med" len="med"/>
-                      <a:tailEnd type="none" w="med" len="med"/>
-                    </a:lnB>
-                    <a:solidFill>
-                      <a:srgbClr val="F5F6F8"/>
-                    </a:solidFill>
-                  </a:tcPr>
-                </a:tc>
-              </a:tr>
-              <a:tr h="475488">
-                <a:tc>
-                  <a:txBody>
-                    <a:bodyPr/>
-                    <a:lstStyle/>
-                    <a:p>
-                      <a:pPr algn="l" indent="0" marL="0">
-                        <a:buNone/>
-                      </a:pPr>
-                      <a:r>
-                        <a:rPr lang="en-US" sz="1150" b="1" dirty="0">
-                          <a:solidFill>
-                            <a:srgbClr val="1D3557"/>
-                          </a:solidFill>
-                          <a:latin typeface="Calibri" pitchFamily="34" charset="0"/>
-                          <a:ea typeface="Calibri" pitchFamily="34" charset="-122"/>
-                          <a:cs typeface="Calibri" pitchFamily="34" charset="-120"/>
-                        </a:rPr>
-                        <a:t>EBASTEL XAROPE</a:t>
-                      </a:r>
-                      <a:endParaRPr lang="en-US" sz="1150" dirty="0">
-                        <a:latin typeface="Calibri" charset="0"/>
-                        <a:ea typeface="Calibri" charset="0"/>
-                        <a:cs typeface="Calibri" charset="0"/>
-                      </a:endParaRPr>
-                    </a:p>
-                  </a:txBody>
-                  <a:tcPr marL="91440" marR="91440" marT="45720" marB="45720" anchor="ctr">
-                    <a:lnL w="9525" cap="flat" cmpd="sng" algn="ctr">
-                      <a:solidFill>
-                        <a:srgbClr val="E1E4E8"/>
-                      </a:solidFill>
-                      <a:prstDash val="solid"/>
-                      <a:round/>
-                      <a:headEnd type="none" w="med" len="med"/>
-                      <a:tailEnd type="none" w="med" len="med"/>
-                    </a:lnL>
-                    <a:lnR w="9525" cap="flat" cmpd="sng" algn="ctr">
-                      <a:solidFill>
-                        <a:srgbClr val="E1E4E8"/>
-                      </a:solidFill>
-                      <a:prstDash val="solid"/>
-                      <a:round/>
-                      <a:headEnd type="none" w="med" len="med"/>
-                      <a:tailEnd type="none" w="med" len="med"/>
-                    </a:lnR>
-                    <a:lnT w="9525" cap="flat" cmpd="sng" algn="ctr">
-                      <a:solidFill>
-                        <a:srgbClr val="E1E4E8"/>
-                      </a:solidFill>
-                      <a:prstDash val="solid"/>
-                      <a:round/>
-                      <a:headEnd type="none" w="med" len="med"/>
-                      <a:tailEnd type="none" w="med" len="med"/>
-                    </a:lnT>
-                    <a:lnB w="9525" cap="flat" cmpd="sng" algn="ctr">
-                      <a:solidFill>
-                        <a:srgbClr val="E1E4E8"/>
-                      </a:solidFill>
-                      <a:prstDash val="solid"/>
-                      <a:round/>
-                      <a:headEnd type="none" w="med" len="med"/>
-                      <a:tailEnd type="none" w="med" len="med"/>
-                    </a:lnB>
-                    <a:solidFill>
-                      <a:srgbClr val="FFFFFF"/>
-                    </a:solidFill>
-                  </a:tcPr>
-                </a:tc>
-                <a:tc>
-                  <a:txBody>
-                    <a:bodyPr/>
-                    <a:lstStyle/>
-                    <a:p>
-                      <a:pPr algn="r" indent="0" marL="0">
-                        <a:buNone/>
-                      </a:pPr>
-                      <a:r>
-                        <a:rPr lang="en-US" sz="1100" dirty="0">
-                          <a:solidFill>
-                            <a:srgbClr val="333333"/>
-                          </a:solidFill>
-                          <a:latin typeface="Calibri" pitchFamily="34" charset="0"/>
-                          <a:ea typeface="Calibri" pitchFamily="34" charset="-122"/>
-                          <a:cs typeface="Calibri" pitchFamily="34" charset="-120"/>
-                        </a:rPr>
-                        <a:t>R$ 3.477.589</a:t>
-                      </a:r>
-                      <a:endParaRPr lang="en-US" sz="1100" dirty="0">
-                        <a:latin typeface="Calibri" charset="0"/>
-                        <a:ea typeface="Calibri" charset="0"/>
-                        <a:cs typeface="Calibri" charset="0"/>
-                      </a:endParaRPr>
-                    </a:p>
-                  </a:txBody>
-                  <a:tcPr marL="91440" marR="91440" marT="45720" marB="45720" anchor="ctr">
-                    <a:lnL w="9525" cap="flat" cmpd="sng" algn="ctr">
-                      <a:solidFill>
-                        <a:srgbClr val="E1E4E8"/>
-                      </a:solidFill>
-                      <a:prstDash val="solid"/>
-                      <a:round/>
-                      <a:headEnd type="none" w="med" len="med"/>
-                      <a:tailEnd type="none" w="med" len="med"/>
-                    </a:lnL>
-                    <a:lnR w="9525" cap="flat" cmpd="sng" algn="ctr">
-                      <a:solidFill>
-                        <a:srgbClr val="E1E4E8"/>
-                      </a:solidFill>
-                      <a:prstDash val="solid"/>
-                      <a:round/>
-                      <a:headEnd type="none" w="med" len="med"/>
-                      <a:tailEnd type="none" w="med" len="med"/>
-                    </a:lnR>
-                    <a:lnT w="9525" cap="flat" cmpd="sng" algn="ctr">
-                      <a:solidFill>
-                        <a:srgbClr val="E1E4E8"/>
-                      </a:solidFill>
-                      <a:prstDash val="solid"/>
-                      <a:round/>
-                      <a:headEnd type="none" w="med" len="med"/>
-                      <a:tailEnd type="none" w="med" len="med"/>
-                    </a:lnT>
-                    <a:lnB w="9525" cap="flat" cmpd="sng" algn="ctr">
-                      <a:solidFill>
-                        <a:srgbClr val="E1E4E8"/>
-                      </a:solidFill>
-                      <a:prstDash val="solid"/>
-                      <a:round/>
-                      <a:headEnd type="none" w="med" len="med"/>
-                      <a:tailEnd type="none" w="med" len="med"/>
-                    </a:lnB>
-                    <a:solidFill>
-                      <a:srgbClr val="FFFFFF"/>
-                    </a:solidFill>
-                  </a:tcPr>
-                </a:tc>
-                <a:tc>
-                  <a:txBody>
-                    <a:bodyPr/>
-                    <a:lstStyle/>
-                    <a:p>
-                      <a:pPr algn="ctr" indent="0" marL="0">
-                        <a:buNone/>
-                      </a:pPr>
-                      <a:r>
-                        <a:rPr lang="en-US" sz="1100" dirty="0">
-                          <a:solidFill>
-                            <a:srgbClr val="333333"/>
-                          </a:solidFill>
-                          <a:latin typeface="Calibri" pitchFamily="34" charset="0"/>
-                          <a:ea typeface="Calibri" pitchFamily="34" charset="-122"/>
-                          <a:cs typeface="Calibri" pitchFamily="34" charset="-120"/>
-                        </a:rPr>
-                        <a:t>7,3%</a:t>
-                      </a:r>
-                      <a:endParaRPr lang="en-US" sz="1100" dirty="0">
-                        <a:latin typeface="Calibri" charset="0"/>
-                        <a:ea typeface="Calibri" charset="0"/>
-                        <a:cs typeface="Calibri" charset="0"/>
-                      </a:endParaRPr>
-                    </a:p>
-                  </a:txBody>
-                  <a:tcPr marL="91440" marR="91440" marT="45720" marB="45720" anchor="ctr">
-                    <a:lnL w="9525" cap="flat" cmpd="sng" algn="ctr">
-                      <a:solidFill>
-                        <a:srgbClr val="E1E4E8"/>
-                      </a:solidFill>
-                      <a:prstDash val="solid"/>
-                      <a:round/>
-                      <a:headEnd type="none" w="med" len="med"/>
-                      <a:tailEnd type="none" w="med" len="med"/>
-                    </a:lnL>
-                    <a:lnR w="9525" cap="flat" cmpd="sng" algn="ctr">
-                      <a:solidFill>
-                        <a:srgbClr val="E1E4E8"/>
-                      </a:solidFill>
-                      <a:prstDash val="solid"/>
-                      <a:round/>
-                      <a:headEnd type="none" w="med" len="med"/>
-                      <a:tailEnd type="none" w="med" len="med"/>
-                    </a:lnR>
-                    <a:lnT w="9525" cap="flat" cmpd="sng" algn="ctr">
-                      <a:solidFill>
-                        <a:srgbClr val="E1E4E8"/>
-                      </a:solidFill>
-                      <a:prstDash val="solid"/>
-                      <a:round/>
-                      <a:headEnd type="none" w="med" len="med"/>
-                      <a:tailEnd type="none" w="med" len="med"/>
-                    </a:lnT>
-                    <a:lnB w="9525" cap="flat" cmpd="sng" algn="ctr">
-                      <a:solidFill>
-                        <a:srgbClr val="E1E4E8"/>
-                      </a:solidFill>
-                      <a:prstDash val="solid"/>
-                      <a:round/>
-                      <a:headEnd type="none" w="med" len="med"/>
-                      <a:tailEnd type="none" w="med" len="med"/>
-                    </a:lnB>
-                    <a:solidFill>
-                      <a:srgbClr val="FFFFFF"/>
-                    </a:solidFill>
-                  </a:tcPr>
-                </a:tc>
-                <a:tc>
-                  <a:txBody>
-                    <a:bodyPr/>
-                    <a:lstStyle/>
-                    <a:p>
-                      <a:pPr algn="ctr" indent="0" marL="0">
-                        <a:buNone/>
-                      </a:pPr>
-                      <a:r>
-                        <a:rPr lang="en-US" sz="1100" b="1" dirty="0">
-                          <a:solidFill>
-                            <a:srgbClr val="C0392B"/>
-                          </a:solidFill>
-                          <a:latin typeface="Calibri" pitchFamily="34" charset="0"/>
-                          <a:ea typeface="Calibri" pitchFamily="34" charset="-122"/>
-                          <a:cs typeface="Calibri" pitchFamily="34" charset="-120"/>
-                        </a:rPr>
-                        <a:t>-0,4%</a:t>
-                      </a:r>
-                      <a:endParaRPr lang="en-US" sz="1100" dirty="0">
-                        <a:latin typeface="Calibri" charset="0"/>
-                        <a:ea typeface="Calibri" charset="0"/>
-                        <a:cs typeface="Calibri" charset="0"/>
-                      </a:endParaRPr>
-                    </a:p>
-                  </a:txBody>
-                  <a:tcPr marL="91440" marR="91440" marT="45720" marB="45720" anchor="ctr">
-                    <a:lnL w="9525" cap="flat" cmpd="sng" algn="ctr">
-                      <a:solidFill>
-                        <a:srgbClr val="E1E4E8"/>
-                      </a:solidFill>
-                      <a:prstDash val="solid"/>
-                      <a:round/>
-                      <a:headEnd type="none" w="med" len="med"/>
-                      <a:tailEnd type="none" w="med" len="med"/>
-                    </a:lnL>
-                    <a:lnR w="9525" cap="flat" cmpd="sng" algn="ctr">
-                      <a:solidFill>
-                        <a:srgbClr val="E1E4E8"/>
-                      </a:solidFill>
-                      <a:prstDash val="solid"/>
-                      <a:round/>
-                      <a:headEnd type="none" w="med" len="med"/>
-                      <a:tailEnd type="none" w="med" len="med"/>
-                    </a:lnR>
-                    <a:lnT w="9525" cap="flat" cmpd="sng" algn="ctr">
-                      <a:solidFill>
-                        <a:srgbClr val="E1E4E8"/>
-                      </a:solidFill>
-                      <a:prstDash val="solid"/>
-                      <a:round/>
-                      <a:headEnd type="none" w="med" len="med"/>
-                      <a:tailEnd type="none" w="med" len="med"/>
-                    </a:lnT>
-                    <a:lnB w="9525" cap="flat" cmpd="sng" algn="ctr">
-                      <a:solidFill>
-                        <a:srgbClr val="E1E4E8"/>
-                      </a:solidFill>
-                      <a:prstDash val="solid"/>
-                      <a:round/>
-                      <a:headEnd type="none" w="med" len="med"/>
-                      <a:tailEnd type="none" w="med" len="med"/>
-                    </a:lnB>
-                    <a:solidFill>
-                      <a:srgbClr val="FFFFFF"/>
-                    </a:solidFill>
-                  </a:tcPr>
-                </a:tc>
-                <a:tc>
-                  <a:txBody>
-                    <a:bodyPr/>
-                    <a:lstStyle/>
-                    <a:p>
-                      <a:pPr algn="ctr" indent="0" marL="0">
-                        <a:buNone/>
-                      </a:pPr>
-                      <a:r>
-                        <a:rPr lang="en-US" sz="1100" b="1" dirty="0">
-                          <a:solidFill>
-                            <a:srgbClr val="6A4C93"/>
-                          </a:solidFill>
-                          <a:latin typeface="Calibri" pitchFamily="34" charset="0"/>
-                          <a:ea typeface="Calibri" pitchFamily="34" charset="-122"/>
-                          <a:cs typeface="Calibri" pitchFamily="34" charset="-120"/>
-                        </a:rPr>
-                        <a:t>7,8%</a:t>
-                      </a:r>
-                      <a:endParaRPr lang="en-US" sz="1100" dirty="0">
-                        <a:latin typeface="Calibri" charset="0"/>
-                        <a:ea typeface="Calibri" charset="0"/>
-                        <a:cs typeface="Calibri" charset="0"/>
-                      </a:endParaRPr>
-                    </a:p>
-                  </a:txBody>
-                  <a:tcPr marL="91440" marR="91440" marT="45720" marB="45720" anchor="ctr">
-                    <a:lnL w="9525" cap="flat" cmpd="sng" algn="ctr">
-                      <a:solidFill>
-                        <a:srgbClr val="E1E4E8"/>
-                      </a:solidFill>
-                      <a:prstDash val="solid"/>
-                      <a:round/>
-                      <a:headEnd type="none" w="med" len="med"/>
-                      <a:tailEnd type="none" w="med" len="med"/>
-                    </a:lnL>
-                    <a:lnR w="9525" cap="flat" cmpd="sng" algn="ctr">
-                      <a:solidFill>
-                        <a:srgbClr val="E1E4E8"/>
-                      </a:solidFill>
-                      <a:prstDash val="solid"/>
-                      <a:round/>
-                      <a:headEnd type="none" w="med" len="med"/>
-                      <a:tailEnd type="none" w="med" len="med"/>
-                    </a:lnR>
-                    <a:lnT w="9525" cap="flat" cmpd="sng" algn="ctr">
-                      <a:solidFill>
-                        <a:srgbClr val="E1E4E8"/>
-                      </a:solidFill>
-                      <a:prstDash val="solid"/>
-                      <a:round/>
-                      <a:headEnd type="none" w="med" len="med"/>
-                      <a:tailEnd type="none" w="med" len="med"/>
-                    </a:lnT>
-                    <a:lnB w="9525" cap="flat" cmpd="sng" algn="ctr">
-                      <a:solidFill>
-                        <a:srgbClr val="E1E4E8"/>
-                      </a:solidFill>
-                      <a:prstDash val="solid"/>
-                      <a:round/>
-                      <a:headEnd type="none" w="med" len="med"/>
-                      <a:tailEnd type="none" w="med" len="med"/>
-                    </a:lnB>
-                    <a:solidFill>
-                      <a:srgbClr val="FFFFFF"/>
-                    </a:solidFill>
-                  </a:tcPr>
-                </a:tc>
-                <a:tc>
-                  <a:txBody>
-                    <a:bodyPr/>
-                    <a:lstStyle/>
-                    <a:p>
-                      <a:pPr algn="ctr" indent="0" marL="0">
-                        <a:buNone/>
-                      </a:pPr>
-                      <a:r>
-                        <a:rPr lang="en-US" sz="1100" dirty="0">
-                          <a:solidFill>
-                            <a:srgbClr val="333333"/>
-                          </a:solidFill>
-                          <a:latin typeface="Calibri" pitchFamily="34" charset="0"/>
-                          <a:ea typeface="Calibri" pitchFamily="34" charset="-122"/>
-                          <a:cs typeface="Calibri" pitchFamily="34" charset="-120"/>
-                        </a:rPr>
-                        <a:t>#4</a:t>
-                      </a:r>
-                      <a:endParaRPr lang="en-US" sz="1100" dirty="0">
-                        <a:latin typeface="Calibri" charset="0"/>
-                        <a:ea typeface="Calibri" charset="0"/>
-                        <a:cs typeface="Calibri" charset="0"/>
-                      </a:endParaRPr>
-                    </a:p>
-                  </a:txBody>
-                  <a:tcPr marL="91440" marR="91440" marT="45720" marB="45720" anchor="ctr">
-                    <a:lnL w="9525" cap="flat" cmpd="sng" algn="ctr">
-                      <a:solidFill>
-                        <a:srgbClr val="E1E4E8"/>
-                      </a:solidFill>
-                      <a:prstDash val="solid"/>
-                      <a:round/>
-                      <a:headEnd type="none" w="med" len="med"/>
-                      <a:tailEnd type="none" w="med" len="med"/>
-                    </a:lnL>
-                    <a:lnR w="9525" cap="flat" cmpd="sng" algn="ctr">
-                      <a:solidFill>
-                        <a:srgbClr val="E1E4E8"/>
-                      </a:solidFill>
-                      <a:prstDash val="solid"/>
-                      <a:round/>
-                      <a:headEnd type="none" w="med" len="med"/>
-                      <a:tailEnd type="none" w="med" len="med"/>
-                    </a:lnR>
-                    <a:lnT w="9525" cap="flat" cmpd="sng" algn="ctr">
-                      <a:solidFill>
-                        <a:srgbClr val="E1E4E8"/>
-                      </a:solidFill>
-                      <a:prstDash val="solid"/>
-                      <a:round/>
-                      <a:headEnd type="none" w="med" len="med"/>
-                      <a:tailEnd type="none" w="med" len="med"/>
-                    </a:lnT>
-                    <a:lnB w="9525" cap="flat" cmpd="sng" algn="ctr">
-                      <a:solidFill>
-                        <a:srgbClr val="E1E4E8"/>
-                      </a:solidFill>
-                      <a:prstDash val="solid"/>
-                      <a:round/>
-                      <a:headEnd type="none" w="med" len="med"/>
-                      <a:tailEnd type="none" w="med" len="med"/>
-                    </a:lnB>
-                    <a:solidFill>
                       <a:srgbClr val="FFFFFF"/>
                     </a:solidFill>
                   </a:tcPr>
@@ -16852,7 +16852,7 @@
                           <a:ea typeface="Calibri" pitchFamily="34" charset="-122"/>
                           <a:cs typeface="Calibri" pitchFamily="34" charset="-120"/>
                         </a:rPr>
-                        <a:t>Allegra  (61,9%)</a:t>
+                        <a:t>Annita  (88,8%)</a:t>
                       </a:r>
                       <a:endParaRPr lang="en-US" sz="1100" dirty="0">
                         <a:latin typeface="Calibri" charset="0"/>
@@ -16920,7 +16920,7 @@
                           <a:ea typeface="Calibri" pitchFamily="34" charset="-122"/>
                           <a:cs typeface="Calibri" pitchFamily="34" charset="-120"/>
                         </a:rPr>
-                        <a:t>R$ 1.883.228</a:t>
+                        <a:t>R$ 1.109.604</a:t>
                       </a:r>
                       <a:endParaRPr lang="en-US" sz="1150" dirty="0">
                         <a:latin typeface="Calibri" charset="0"/>
@@ -17368,7 +17368,7 @@
                 <a:ea typeface="Calibri" pitchFamily="34" charset="-122"/>
                 <a:cs typeface="Calibri" pitchFamily="34" charset="-120"/>
               </a:rPr>
-              <a:t>Gap: R$ 3.255.523   ·   61 médicos CAT 1-3</a:t>
+              <a:t>Gap: R$ 2.373.337   ·   61 médicos CAT 1-3</a:t>
             </a:r>
             <a:endParaRPr lang="en-US" sz="1050" dirty="0"/>
           </a:p>
@@ -17453,7 +17453,7 @@
                 <a:ea typeface="Calibri" pitchFamily="34" charset="-122"/>
                 <a:cs typeface="Calibri" pitchFamily="34" charset="-120"/>
               </a:rPr>
-              <a:t>Maior gap de mercado da distrital nos 5 mercados-foco: R$ 3,26M não capturados</a:t>
+              <a:t>Maior gap de mercado da distrital nos 5 mercados-foco: R$ 2,37M não capturados</a:t>
             </a:r>
             <a:endParaRPr lang="en-US" sz="1150" dirty="0"/>
           </a:p>
@@ -17477,7 +17477,7 @@
                 <a:ea typeface="Calibri" pitchFamily="34" charset="-122"/>
                 <a:cs typeface="Calibri" pitchFamily="34" charset="-120"/>
               </a:rPr>
-              <a:t>Share EUF médio de apenas 3,3% nesses mercados</a:t>
+              <a:t>Share EUF médio de apenas 5,4% nesses mercados</a:t>
             </a:r>
             <a:endParaRPr lang="en-US" sz="1150" dirty="0"/>
           </a:p>
@@ -17633,7 +17633,7 @@
                 <a:ea typeface="Calibri" pitchFamily="34" charset="-122"/>
                 <a:cs typeface="Calibri" pitchFamily="34" charset="-120"/>
               </a:rPr>
-              <a:t>Priorizar DOZI, STIMA e EBASTEL XAROPE no ciclo de visitas</a:t>
+              <a:t>Priorizar SINOT CLAV, EBASTEL XAROPE e MELOCOX no ciclo de visitas</a:t>
             </a:r>
             <a:endParaRPr lang="en-US" sz="1150" dirty="0"/>
           </a:p>
@@ -17811,7 +17811,7 @@
                 <a:ea typeface="Calibri" pitchFamily="34" charset="-122"/>
                 <a:cs typeface="Calibri" pitchFamily="34" charset="-120"/>
               </a:rPr>
-              <a:t>Gap: R$ 3.070.172   ·   127 médicos CAT 1-3</a:t>
+              <a:t>Gap: R$ 2.243.364   ·   127 médicos CAT 1-3</a:t>
             </a:r>
             <a:endParaRPr lang="en-US" sz="1050" dirty="0"/>
           </a:p>
@@ -17896,7 +17896,7 @@
                 <a:ea typeface="Calibri" pitchFamily="34" charset="-122"/>
                 <a:cs typeface="Calibri" pitchFamily="34" charset="-120"/>
               </a:rPr>
-              <a:t>2º maior gap (R$ 3,07M) e 2º maior nº de médicos CAT 1-3 (127) — prioridade dupla</a:t>
+              <a:t>2º maior gap (R$ 2,24M) e 2º maior nº de médicos CAT 1-3 (127) — prioridade dupla</a:t>
             </a:r>
             <a:endParaRPr lang="en-US" sz="1150" dirty="0"/>
           </a:p>
@@ -17920,7 +17920,7 @@
                 <a:ea typeface="Calibri" pitchFamily="34" charset="-122"/>
                 <a:cs typeface="Calibri" pitchFamily="34" charset="-120"/>
               </a:rPr>
-              <a:t>Maior concentração de gap em DOZI e SINOT CLAV CPR</a:t>
+              <a:t>Maior concentração de gap em SINOT CLAV e STIMA</a:t>
             </a:r>
             <a:endParaRPr lang="en-US" sz="1150" dirty="0"/>
           </a:p>
@@ -18052,7 +18052,7 @@
                 <a:ea typeface="Calibri" pitchFamily="34" charset="-122"/>
                 <a:cs typeface="Calibri" pitchFamily="34" charset="-120"/>
               </a:rPr>
-              <a:t>Foco total em DOZI e SINOT CLAV CPR nas visitas aos 127 médicos CAT 1-3</a:t>
+              <a:t>Foco total em SINOT CLAV e STIMA nas visitas aos 127 médicos CAT 1-3</a:t>
             </a:r>
             <a:endParaRPr lang="en-US" sz="1150" dirty="0"/>
           </a:p>
@@ -18076,7 +18076,7 @@
                 <a:ea typeface="Calibri" pitchFamily="34" charset="-122"/>
                 <a:cs typeface="Calibri" pitchFamily="34" charset="-120"/>
               </a:rPr>
-              <a:t>Argumentário comparativo vs. líderes (Mecobe/Clavulin BD) para conversão de share</a:t>
+              <a:t>Argumentário comparativo vs. líderes (Clavulin BD/Ansitec) para conversão de share</a:t>
             </a:r>
             <a:endParaRPr lang="en-US" sz="1150" dirty="0"/>
           </a:p>
@@ -18254,7 +18254,7 @@
                 <a:ea typeface="Calibri" pitchFamily="34" charset="-122"/>
                 <a:cs typeface="Calibri" pitchFamily="34" charset="-120"/>
               </a:rPr>
-              <a:t>Gap: R$ 2.783.681   ·   65 médicos CAT 1-3</a:t>
+              <a:t>Gap: R$ 2.145.162   ·   65 médicos CAT 1-3</a:t>
             </a:r>
             <a:endParaRPr lang="en-US" sz="1050" dirty="0"/>
           </a:p>
@@ -18339,7 +18339,7 @@
                 <a:ea typeface="Calibri" pitchFamily="34" charset="-122"/>
                 <a:cs typeface="Calibri" pitchFamily="34" charset="-120"/>
               </a:rPr>
-              <a:t>3º maior gap (R$ 2,78M), concentrado em MELOCOX e STIMA</a:t>
+              <a:t>3º maior gap (R$ 2,15M), concentrado em MELOCOX e SINOT CLAV</a:t>
             </a:r>
             <a:endParaRPr lang="en-US" sz="1150" dirty="0"/>
           </a:p>
@@ -18363,7 +18363,7 @@
                 <a:ea typeface="Calibri" pitchFamily="34" charset="-122"/>
                 <a:cs typeface="Calibri" pitchFamily="34" charset="-120"/>
               </a:rPr>
-              <a:t>Share ainda baixo (3,2%) apesar do crescimento de MELOCOX (+89% no período)</a:t>
+              <a:t>Share ainda baixo (5,4%) apesar do crescimento de MELOCOX (+41% no período)</a:t>
             </a:r>
             <a:endParaRPr lang="en-US" sz="1150" dirty="0"/>
           </a:p>
@@ -18495,7 +18495,7 @@
                 <a:ea typeface="Calibri" pitchFamily="34" charset="-122"/>
                 <a:cs typeface="Calibri" pitchFamily="34" charset="-120"/>
               </a:rPr>
-              <a:t>Detalhamento dirigido de MELOCOX (maior momentum de crescimento) e STIMA</a:t>
+              <a:t>Detalhamento dirigido de MELOCOX (maior momentum de crescimento) e SINOT CLAV</a:t>
             </a:r>
             <a:endParaRPr lang="en-US" sz="1150" dirty="0"/>
           </a:p>
@@ -18543,7 +18543,7 @@
                 <a:ea typeface="Calibri" pitchFamily="34" charset="-122"/>
                 <a:cs typeface="Calibri" pitchFamily="34" charset="-120"/>
               </a:rPr>
-              <a:t>Monitorar concorrente líder ANSITEC (93% de share em STIMA) para argumentação diferenciada</a:t>
+              <a:t>Monitorar concorrente líder CLAVULIN BD (67% de share em SINOT CLAV) para argumentação diferenciada</a:t>
             </a:r>
             <a:endParaRPr lang="en-US" sz="1150" dirty="0"/>
           </a:p>
@@ -18899,7 +18899,7 @@
                 <a:ea typeface="Calibri" pitchFamily="34" charset="-122"/>
                 <a:cs typeface="Calibri" pitchFamily="34" charset="-120"/>
               </a:rPr>
-              <a:t>5 mercados = 44,4% do faturamento e R$ 13,1M de gap</a:t>
+              <a:t>5 mercados-foco = 33,0% do faturamento e R$ 10,4M de gap</a:t>
             </a:r>
             <a:endParaRPr lang="en-US" sz="1200" dirty="0"/>
           </a:p>
@@ -19038,7 +19038,7 @@
                 <a:ea typeface="Calibri" pitchFamily="34" charset="-122"/>
                 <a:cs typeface="Calibri" pitchFamily="34" charset="-120"/>
               </a:rPr>
-              <a:t>A penetração de 99,7% entre CAT 1-3 mostra que a barreira não é confiança na marca — é participação por SKU. Nos 5 mercados-foco a Eurofarma tem share de 1,0% a 11,1%. Os setores 5613, 5153 e 7742 concentram R$ 9,1M desse gap.</a:t>
+              <a:t>A penetração de 99,7% entre CAT 1-3 mostra que a barreira não é confiança na marca — é participação por SKU. Nos 5 mercados-foco a Eurofarma tem share de 6,3% a 14,4%. Os setores 5613, 5153 e 7742 concentram R$ 6,76M desse gap.</a:t>
             </a:r>
             <a:endParaRPr lang="en-US" sz="1150" dirty="0"/>
           </a:p>
@@ -19370,7 +19370,7 @@
                           <a:ea typeface="Calibri" pitchFamily="34" charset="-122"/>
                           <a:cs typeface="Calibri" pitchFamily="34" charset="-120"/>
                         </a:rPr>
-                        <a:t>Foco DOZI / SINOT CLAV / STIMA</a:t>
+                        <a:t>Foco SINOT CLAV / MELOCOX / STIMA</a:t>
                       </a:r>
                       <a:endParaRPr lang="en-US" sz="1030" dirty="0">
                         <a:latin typeface="Calibri" charset="0"/>
@@ -20310,7 +20310,7 @@
                 <a:ea typeface="Calibri" pitchFamily="34" charset="-122"/>
                 <a:cs typeface="Calibri" pitchFamily="34" charset="-120"/>
               </a:rPr>
-              <a:t>R$ 0,9M</a:t>
+              <a:t>R$ 0,7M</a:t>
             </a:r>
             <a:endParaRPr lang="en-US" sz="1800" dirty="0"/>
           </a:p>
@@ -20558,7 +20558,7 @@
                 <a:ea typeface="Calibri" pitchFamily="34" charset="-122"/>
                 <a:cs typeface="Calibri" pitchFamily="34" charset="-120"/>
               </a:rPr>
-              <a:t>mercados-foco (DOZI, STIMA, MELOCOX, SINOT CLAV CPR, EBASTEL XPE)</a:t>
+              <a:t>mercados-foco (SINOT CLAV, MELOCOX, EBASTEL XPE, STIMA, AZOX CPR)</a:t>
             </a:r>
             <a:endParaRPr lang="en-US" sz="780" dirty="0"/>
           </a:p>
@@ -20942,7 +20942,7 @@
                 <a:ea typeface="Calibri" pitchFamily="34" charset="-122"/>
                 <a:cs typeface="Calibri" pitchFamily="34" charset="-120"/>
               </a:rPr>
-              <a:t>Ciclo 1 — foco DOZI, SINOT CLAV e STIMA</a:t>
+              <a:t>Ciclo 1 — foco SINOT CLAV, MELOCOX e STIMA</a:t>
             </a:r>
             <a:endParaRPr lang="en-US" sz="850" dirty="0"/>
           </a:p>

</xml_diff>

<commit_message>
Aumenta fontes do slide 3 e adiciona per capita de médicos por setor
Fontes do gráfico, tabela de especialidades e cabeçalhos elevadas ao
máximo que cabe em cada elemento, sem alterar o layout de 2 colunas.
Adiciona indicador de per cápita (318,9 médicos por setor, em média).

Co-Authored-By: Claude Sonnet 5 <noreply@anthropic.com>
Claude-Session: https://claude.ai/code/session_01KqmuB8xxfxpvceuypurV9G
</commit_message>
<xml_diff>
--- a/output/painel_medico_distrital_1880.pptx
+++ b/output/painel_medico_distrital_1880.pptx
@@ -152,7 +152,7 @@
               <a:lstStyle/>
               <a:p>
                 <a:pPr>
-                  <a:defRPr b="1" i="0" strike="noStrike" sz="1100" u="none">
+                  <a:defRPr b="1" i="0" strike="noStrike" sz="1300" u="none">
                     <a:solidFill>
                       <a:srgbClr val="1D3557"/>
                     </a:solidFill>
@@ -244,7 +244,7 @@
             <a:lstStyle/>
             <a:p>
               <a:pPr>
-                <a:defRPr b="1" i="0" strike="noStrike" sz="1100" u="none">
+                <a:defRPr b="1" i="0" strike="noStrike" sz="1300" u="none">
                   <a:solidFill>
                     <a:srgbClr val="1D3557"/>
                   </a:solidFill>
@@ -292,7 +292,7 @@
           <a:lstStyle/>
           <a:p>
             <a:pPr>
-              <a:defRPr sz="1100" b="0" i="0" u="none" strike="noStrike">
+              <a:defRPr sz="1300" b="0" i="0" u="none" strike="noStrike">
                 <a:solidFill>
                   <a:srgbClr val="333333"/>
                 </a:solidFill>
@@ -13479,6 +13479,59 @@
               <a:buNone/>
             </a:pPr>
             <a:r>
+              <a:rPr lang="en-US" sz="1600" dirty="0">
+                <a:solidFill>
+                  <a:srgbClr val="6B7280"/>
+                </a:solidFill>
+                <a:latin typeface="Calibri" pitchFamily="34" charset="0"/>
+                <a:ea typeface="Calibri" pitchFamily="34" charset="-122"/>
+                <a:cs typeface="Calibri" pitchFamily="34" charset="-120"/>
+              </a:rPr>
+              <a:t>Distribuição por setor e por especialidade</a:t>
+            </a:r>
+            <a:endParaRPr lang="en-US" sz="1600" dirty="0"/>
+          </a:p>
+        </p:txBody>
+      </p:sp>
+      <p:sp>
+        <p:nvSpPr>
+          <p:cNvPr id="4" name="Text 2"/>
+          <p:cNvSpPr txBox="1"/>
+          <p:nvPr/>
+        </p:nvSpPr>
+        <p:spPr>
+          <a:xfrm>
+            <a:off x="365760" y="1051560"/>
+            <a:ext cx="5591556" cy="292608"/>
+          </a:xfrm>
+          <a:prstGeom prst="rect">
+            <a:avLst/>
+          </a:prstGeom>
+          <a:noFill/>
+          <a:ln/>
+        </p:spPr>
+        <p:txBody>
+          <a:bodyPr wrap="square" lIns="0" tIns="0" rIns="0" bIns="0" rtlCol="0" anchor="ctr"/>
+          <a:lstStyle/>
+          <a:p>
+            <a:pPr algn="l" indent="0" marL="0">
+              <a:buNone/>
+            </a:pPr>
+            <a:r>
+              <a:rPr lang="en-US" sz="1800" b="1" dirty="0">
+                <a:solidFill>
+                  <a:srgbClr val="1D3557"/>
+                </a:solidFill>
+                <a:latin typeface="Calibri" pitchFamily="34" charset="0"/>
+                <a:ea typeface="Calibri" pitchFamily="34" charset="-122"/>
+                <a:cs typeface="Calibri" pitchFamily="34" charset="-120"/>
+              </a:rPr>
+              <a:t>2.551 </a:t>
+            </a:r>
+            <a:pPr algn="l" indent="0" marL="0">
+              <a:buNone/>
+            </a:pPr>
+            <a:r>
               <a:rPr lang="en-US" sz="1400" dirty="0">
                 <a:solidFill>
                   <a:srgbClr val="6B7280"/>
@@ -13487,21 +13540,21 @@
                 <a:ea typeface="Calibri" pitchFamily="34" charset="-122"/>
                 <a:cs typeface="Calibri" pitchFamily="34" charset="-120"/>
               </a:rPr>
-              <a:t>Distribuição por setor e por especialidade</a:t>
-            </a:r>
-            <a:endParaRPr lang="en-US" sz="1400" dirty="0"/>
-          </a:p>
-        </p:txBody>
-      </p:sp>
-      <p:sp>
-        <p:nvSpPr>
-          <p:cNvPr id="4" name="Text 2"/>
-          <p:cNvSpPr txBox="1"/>
-          <p:nvPr/>
-        </p:nvSpPr>
-        <p:spPr>
-          <a:xfrm>
-            <a:off x="365760" y="1051560"/>
+              <a:t>médicos no painel (todas as CAT + sem CAT)</a:t>
+            </a:r>
+            <a:endParaRPr lang="en-US" sz="1800" dirty="0"/>
+          </a:p>
+        </p:txBody>
+      </p:sp>
+      <p:sp>
+        <p:nvSpPr>
+          <p:cNvPr id="5" name="Text 3"/>
+          <p:cNvSpPr txBox="1"/>
+          <p:nvPr/>
+        </p:nvSpPr>
+        <p:spPr>
+          <a:xfrm>
+            <a:off x="365760" y="1362456"/>
             <a:ext cx="5591556" cy="274320"/>
           </a:xfrm>
           <a:prstGeom prst="rect">
@@ -13518,7 +13571,60 @@
               <a:buNone/>
             </a:pPr>
             <a:r>
-              <a:rPr lang="en-US" sz="1500" b="1" dirty="0">
+              <a:rPr lang="en-US" sz="1600" b="1" dirty="0">
+                <a:solidFill>
+                  <a:srgbClr val="6A4C93"/>
+                </a:solidFill>
+                <a:latin typeface="Calibri" pitchFamily="34" charset="0"/>
+                <a:ea typeface="Calibri" pitchFamily="34" charset="-122"/>
+                <a:cs typeface="Calibri" pitchFamily="34" charset="-120"/>
+              </a:rPr>
+              <a:t>318,9 </a:t>
+            </a:r>
+            <a:pPr algn="l" indent="0" marL="0">
+              <a:buNone/>
+            </a:pPr>
+            <a:r>
+              <a:rPr lang="en-US" sz="1300" dirty="0">
+                <a:solidFill>
+                  <a:srgbClr val="6B7280"/>
+                </a:solidFill>
+                <a:latin typeface="Calibri" pitchFamily="34" charset="0"/>
+                <a:ea typeface="Calibri" pitchFamily="34" charset="-122"/>
+                <a:cs typeface="Calibri" pitchFamily="34" charset="-120"/>
+              </a:rPr>
+              <a:t>médicos por setor, em média (per cápita, 8 setores)</a:t>
+            </a:r>
+            <a:endParaRPr lang="en-US" sz="1600" dirty="0"/>
+          </a:p>
+        </p:txBody>
+      </p:sp>
+      <p:sp>
+        <p:nvSpPr>
+          <p:cNvPr id="6" name="Text 4"/>
+          <p:cNvSpPr txBox="1"/>
+          <p:nvPr/>
+        </p:nvSpPr>
+        <p:spPr>
+          <a:xfrm>
+            <a:off x="365760" y="1673352"/>
+            <a:ext cx="5591556" cy="274320"/>
+          </a:xfrm>
+          <a:prstGeom prst="rect">
+            <a:avLst/>
+          </a:prstGeom>
+          <a:noFill/>
+          <a:ln/>
+        </p:spPr>
+        <p:txBody>
+          <a:bodyPr wrap="square" lIns="0" tIns="0" rIns="0" bIns="0" rtlCol="0" anchor="ctr"/>
+          <a:lstStyle/>
+          <a:p>
+            <a:pPr algn="l" indent="0" marL="0">
+              <a:buNone/>
+            </a:pPr>
+            <a:r>
+              <a:rPr lang="en-US" sz="1600" b="1" dirty="0">
                 <a:solidFill>
                   <a:srgbClr val="1D3557"/>
                 </a:solidFill>
@@ -13526,74 +13632,21 @@
                 <a:ea typeface="Calibri" pitchFamily="34" charset="-122"/>
                 <a:cs typeface="Calibri" pitchFamily="34" charset="-120"/>
               </a:rPr>
-              <a:t>2.551 </a:t>
-            </a:r>
-            <a:pPr algn="l" indent="0" marL="0">
-              <a:buNone/>
-            </a:pPr>
-            <a:r>
-              <a:rPr lang="en-US" sz="1200" dirty="0">
-                <a:solidFill>
-                  <a:srgbClr val="6B7280"/>
-                </a:solidFill>
-                <a:latin typeface="Calibri" pitchFamily="34" charset="0"/>
-                <a:ea typeface="Calibri" pitchFamily="34" charset="-122"/>
-                <a:cs typeface="Calibri" pitchFamily="34" charset="-120"/>
-              </a:rPr>
-              <a:t>médicos no painel (todas as CAT + sem CAT)</a:t>
-            </a:r>
-            <a:endParaRPr lang="en-US" sz="1500" dirty="0"/>
-          </a:p>
-        </p:txBody>
-      </p:sp>
-      <p:sp>
-        <p:nvSpPr>
-          <p:cNvPr id="5" name="Text 3"/>
-          <p:cNvSpPr txBox="1"/>
-          <p:nvPr/>
-        </p:nvSpPr>
-        <p:spPr>
-          <a:xfrm>
-            <a:off x="365760" y="1371600"/>
-            <a:ext cx="5591556" cy="274320"/>
-          </a:xfrm>
-          <a:prstGeom prst="rect">
-            <a:avLst/>
-          </a:prstGeom>
-          <a:noFill/>
-          <a:ln/>
-        </p:spPr>
-        <p:txBody>
-          <a:bodyPr wrap="square" lIns="0" tIns="0" rIns="0" bIns="0" rtlCol="0" anchor="ctr"/>
-          <a:lstStyle/>
-          <a:p>
-            <a:pPr algn="l" indent="0" marL="0">
-              <a:buNone/>
-            </a:pPr>
-            <a:r>
-              <a:rPr lang="en-US" sz="1300" b="1" dirty="0">
-                <a:solidFill>
-                  <a:srgbClr val="1D3557"/>
-                </a:solidFill>
-                <a:latin typeface="Calibri" pitchFamily="34" charset="0"/>
-                <a:ea typeface="Calibri" pitchFamily="34" charset="-122"/>
-                <a:cs typeface="Calibri" pitchFamily="34" charset="-120"/>
-              </a:rPr>
               <a:t>MÉDICOS POR SETOR</a:t>
             </a:r>
-            <a:endParaRPr lang="en-US" sz="1300" dirty="0"/>
+            <a:endParaRPr lang="en-US" sz="1600" dirty="0"/>
           </a:p>
         </p:txBody>
       </p:sp>
       <p:graphicFrame>
         <p:nvGraphicFramePr>
-          <p:cNvPr id="6" name="Chart 0" descr=""/>
+          <p:cNvPr id="7" name="Chart 0" descr=""/>
           <p:cNvGraphicFramePr/>
           <p:nvPr/>
         </p:nvGraphicFramePr>
         <p:xfrm>
-          <a:off x="365760" y="1673352"/>
-          <a:ext cx="5591556" cy="5120640"/>
+          <a:off x="365760" y="1965960"/>
+          <a:ext cx="5591556" cy="4572000"/>
         </p:xfrm>
         <a:graphic xmlns:a="http://schemas.openxmlformats.org/drawingml/2006/main">
           <a:graphicData uri="http://schemas.openxmlformats.org/drawingml/2006/chart">
@@ -13603,7 +13656,7 @@
       </p:graphicFrame>
       <p:sp>
         <p:nvSpPr>
-          <p:cNvPr id="7" name="Text 4"/>
+          <p:cNvPr id="8" name="Text 5"/>
           <p:cNvSpPr txBox="1"/>
           <p:nvPr/>
         </p:nvSpPr>
@@ -13626,7 +13679,7 @@
               <a:buNone/>
             </a:pPr>
             <a:r>
-              <a:rPr lang="en-US" sz="1300" b="1" dirty="0">
+              <a:rPr lang="en-US" sz="1600" b="1" dirty="0">
                 <a:solidFill>
                   <a:srgbClr val="1D3557"/>
                 </a:solidFill>
@@ -13636,7 +13689,7 @@
               </a:rPr>
               <a:t>PAINEL POR ESPECIALIDADE EUROFARMA</a:t>
             </a:r>
-            <a:endParaRPr lang="en-US" sz="1300" dirty="0"/>
+            <a:endParaRPr lang="en-US" sz="1600" dirty="0"/>
           </a:p>
         </p:txBody>
       </p:sp>
@@ -13655,7 +13708,7 @@
           </p:nvPr>
         </p:nvGraphicFramePr>
         <p:xfrm>
-          <a:off x="6231636" y="1371600"/>
+          <a:off x="6231636" y="1947672"/>
           <a:ext cx="5591556" cy="914400"/>
         </p:xfrm>
         <a:graphic>
@@ -13677,7 +13730,7 @@
                         <a:buNone/>
                       </a:pPr>
                       <a:r>
-                        <a:rPr lang="en-US" sz="1050" b="1" dirty="0">
+                        <a:rPr lang="en-US" sz="1300" b="1" dirty="0">
                           <a:solidFill>
                             <a:srgbClr val="FFFFFF"/>
                           </a:solidFill>
@@ -13687,7 +13740,7 @@
                         </a:rPr>
                         <a:t>Especialidade</a:t>
                       </a:r>
-                      <a:endParaRPr lang="en-US" sz="1050" dirty="0">
+                      <a:endParaRPr lang="en-US" sz="1300" dirty="0">
                         <a:latin typeface="Calibri" charset="0"/>
                         <a:ea typeface="Calibri" charset="0"/>
                         <a:cs typeface="Calibri" charset="0"/>
@@ -13745,7 +13798,7 @@
                         <a:buNone/>
                       </a:pPr>
                       <a:r>
-                        <a:rPr lang="en-US" sz="1050" b="1" dirty="0">
+                        <a:rPr lang="en-US" sz="1300" b="1" dirty="0">
                           <a:solidFill>
                             <a:srgbClr val="FFFFFF"/>
                           </a:solidFill>
@@ -13753,9 +13806,9 @@
                           <a:ea typeface="Calibri" pitchFamily="34" charset="-122"/>
                           <a:cs typeface="Calibri" pitchFamily="34" charset="-120"/>
                         </a:rPr>
-                        <a:t>Médicos</a:t>
+                        <a:t>Méd.</a:t>
                       </a:r>
-                      <a:endParaRPr lang="en-US" sz="1050" dirty="0">
+                      <a:endParaRPr lang="en-US" sz="1300" dirty="0">
                         <a:latin typeface="Calibri" charset="0"/>
                         <a:ea typeface="Calibri" charset="0"/>
                         <a:cs typeface="Calibri" charset="0"/>
@@ -13813,7 +13866,7 @@
                         <a:buNone/>
                       </a:pPr>
                       <a:r>
-                        <a:rPr lang="en-US" sz="1050" b="1" dirty="0">
+                        <a:rPr lang="en-US" sz="1300" b="1" dirty="0">
                           <a:solidFill>
                             <a:srgbClr val="FFFFFF"/>
                           </a:solidFill>
@@ -13821,9 +13874,9 @@
                           <a:ea typeface="Calibri" pitchFamily="34" charset="-122"/>
                           <a:cs typeface="Calibri" pitchFamily="34" charset="-120"/>
                         </a:rPr>
-                        <a:t>% do painel</a:t>
+                        <a:t>% painel</a:t>
                       </a:r>
-                      <a:endParaRPr lang="en-US" sz="1050" dirty="0">
+                      <a:endParaRPr lang="en-US" sz="1300" dirty="0">
                         <a:latin typeface="Calibri" charset="0"/>
                         <a:ea typeface="Calibri" charset="0"/>
                         <a:cs typeface="Calibri" charset="0"/>
@@ -13883,7 +13936,7 @@
                         <a:buNone/>
                       </a:pPr>
                       <a:r>
-                        <a:rPr lang="en-US" sz="1000" b="1" dirty="0">
+                        <a:rPr lang="en-US" sz="1250" b="1" dirty="0">
                           <a:solidFill>
                             <a:srgbClr val="1D3557"/>
                           </a:solidFill>
@@ -13893,7 +13946,7 @@
                         </a:rPr>
                         <a:t>PED</a:t>
                       </a:r>
-                      <a:endParaRPr lang="en-US" sz="1000" dirty="0">
+                      <a:endParaRPr lang="en-US" sz="1250" dirty="0">
                         <a:latin typeface="Calibri" charset="0"/>
                         <a:ea typeface="Calibri" charset="0"/>
                         <a:cs typeface="Calibri" charset="0"/>
@@ -13951,7 +14004,7 @@
                         <a:buNone/>
                       </a:pPr>
                       <a:r>
-                        <a:rPr lang="en-US" sz="1000" dirty="0">
+                        <a:rPr lang="en-US" sz="1250" dirty="0">
                           <a:solidFill>
                             <a:srgbClr val="333333"/>
                           </a:solidFill>
@@ -13961,7 +14014,7 @@
                         </a:rPr>
                         <a:t>497</a:t>
                       </a:r>
-                      <a:endParaRPr lang="en-US" sz="1000" dirty="0">
+                      <a:endParaRPr lang="en-US" sz="1250" dirty="0">
                         <a:latin typeface="Calibri" charset="0"/>
                         <a:ea typeface="Calibri" charset="0"/>
                         <a:cs typeface="Calibri" charset="0"/>
@@ -14019,7 +14072,7 @@
                         <a:buNone/>
                       </a:pPr>
                       <a:r>
-                        <a:rPr lang="en-US" sz="1000" b="1" dirty="0">
+                        <a:rPr lang="en-US" sz="1250" b="1" dirty="0">
                           <a:solidFill>
                             <a:srgbClr val="6A4C93"/>
                           </a:solidFill>
@@ -14029,7 +14082,7 @@
                         </a:rPr>
                         <a:t>19,5%</a:t>
                       </a:r>
-                      <a:endParaRPr lang="en-US" sz="1000" dirty="0">
+                      <a:endParaRPr lang="en-US" sz="1250" dirty="0">
                         <a:latin typeface="Calibri" charset="0"/>
                         <a:ea typeface="Calibri" charset="0"/>
                         <a:cs typeface="Calibri" charset="0"/>
@@ -14089,7 +14142,7 @@
                         <a:buNone/>
                       </a:pPr>
                       <a:r>
-                        <a:rPr lang="en-US" sz="1000" b="1" dirty="0">
+                        <a:rPr lang="en-US" sz="1250" b="1" dirty="0">
                           <a:solidFill>
                             <a:srgbClr val="1D3557"/>
                           </a:solidFill>
@@ -14099,7 +14152,7 @@
                         </a:rPr>
                         <a:t>CLG / PA</a:t>
                       </a:r>
-                      <a:endParaRPr lang="en-US" sz="1000" dirty="0">
+                      <a:endParaRPr lang="en-US" sz="1250" dirty="0">
                         <a:latin typeface="Calibri" charset="0"/>
                         <a:ea typeface="Calibri" charset="0"/>
                         <a:cs typeface="Calibri" charset="0"/>
@@ -14157,7 +14210,7 @@
                         <a:buNone/>
                       </a:pPr>
                       <a:r>
-                        <a:rPr lang="en-US" sz="1000" dirty="0">
+                        <a:rPr lang="en-US" sz="1250" dirty="0">
                           <a:solidFill>
                             <a:srgbClr val="333333"/>
                           </a:solidFill>
@@ -14167,7 +14220,7 @@
                         </a:rPr>
                         <a:t>460</a:t>
                       </a:r>
-                      <a:endParaRPr lang="en-US" sz="1000" dirty="0">
+                      <a:endParaRPr lang="en-US" sz="1250" dirty="0">
                         <a:latin typeface="Calibri" charset="0"/>
                         <a:ea typeface="Calibri" charset="0"/>
                         <a:cs typeface="Calibri" charset="0"/>
@@ -14225,7 +14278,7 @@
                         <a:buNone/>
                       </a:pPr>
                       <a:r>
-                        <a:rPr lang="en-US" sz="1000" b="1" dirty="0">
+                        <a:rPr lang="en-US" sz="1250" b="1" dirty="0">
                           <a:solidFill>
                             <a:srgbClr val="6A4C93"/>
                           </a:solidFill>
@@ -14235,7 +14288,7 @@
                         </a:rPr>
                         <a:t>18,0%</a:t>
                       </a:r>
-                      <a:endParaRPr lang="en-US" sz="1000" dirty="0">
+                      <a:endParaRPr lang="en-US" sz="1250" dirty="0">
                         <a:latin typeface="Calibri" charset="0"/>
                         <a:ea typeface="Calibri" charset="0"/>
                         <a:cs typeface="Calibri" charset="0"/>
@@ -14295,7 +14348,7 @@
                         <a:buNone/>
                       </a:pPr>
                       <a:r>
-                        <a:rPr lang="en-US" sz="1000" b="1" dirty="0">
+                        <a:rPr lang="en-US" sz="1250" b="1" dirty="0">
                           <a:solidFill>
                             <a:srgbClr val="1D3557"/>
                           </a:solidFill>
@@ -14305,7 +14358,7 @@
                         </a:rPr>
                         <a:t>CLG</a:t>
                       </a:r>
-                      <a:endParaRPr lang="en-US" sz="1000" dirty="0">
+                      <a:endParaRPr lang="en-US" sz="1250" dirty="0">
                         <a:latin typeface="Calibri" charset="0"/>
                         <a:ea typeface="Calibri" charset="0"/>
                         <a:cs typeface="Calibri" charset="0"/>
@@ -14363,7 +14416,7 @@
                         <a:buNone/>
                       </a:pPr>
                       <a:r>
-                        <a:rPr lang="en-US" sz="1000" dirty="0">
+                        <a:rPr lang="en-US" sz="1250" dirty="0">
                           <a:solidFill>
                             <a:srgbClr val="333333"/>
                           </a:solidFill>
@@ -14373,7 +14426,7 @@
                         </a:rPr>
                         <a:t>257</a:t>
                       </a:r>
-                      <a:endParaRPr lang="en-US" sz="1000" dirty="0">
+                      <a:endParaRPr lang="en-US" sz="1250" dirty="0">
                         <a:latin typeface="Calibri" charset="0"/>
                         <a:ea typeface="Calibri" charset="0"/>
                         <a:cs typeface="Calibri" charset="0"/>
@@ -14431,7 +14484,7 @@
                         <a:buNone/>
                       </a:pPr>
                       <a:r>
-                        <a:rPr lang="en-US" sz="1000" b="1" dirty="0">
+                        <a:rPr lang="en-US" sz="1250" b="1" dirty="0">
                           <a:solidFill>
                             <a:srgbClr val="6A4C93"/>
                           </a:solidFill>
@@ -14441,7 +14494,7 @@
                         </a:rPr>
                         <a:t>10,1%</a:t>
                       </a:r>
-                      <a:endParaRPr lang="en-US" sz="1000" dirty="0">
+                      <a:endParaRPr lang="en-US" sz="1250" dirty="0">
                         <a:latin typeface="Calibri" charset="0"/>
                         <a:ea typeface="Calibri" charset="0"/>
                         <a:cs typeface="Calibri" charset="0"/>
@@ -14501,7 +14554,7 @@
                         <a:buNone/>
                       </a:pPr>
                       <a:r>
-                        <a:rPr lang="en-US" sz="1000" b="1" dirty="0">
+                        <a:rPr lang="en-US" sz="1250" b="1" dirty="0">
                           <a:solidFill>
                             <a:srgbClr val="1D3557"/>
                           </a:solidFill>
@@ -14511,7 +14564,7 @@
                         </a:rPr>
                         <a:t>ORT</a:t>
                       </a:r>
-                      <a:endParaRPr lang="en-US" sz="1000" dirty="0">
+                      <a:endParaRPr lang="en-US" sz="1250" dirty="0">
                         <a:latin typeface="Calibri" charset="0"/>
                         <a:ea typeface="Calibri" charset="0"/>
                         <a:cs typeface="Calibri" charset="0"/>
@@ -14569,7 +14622,7 @@
                         <a:buNone/>
                       </a:pPr>
                       <a:r>
-                        <a:rPr lang="en-US" sz="1000" dirty="0">
+                        <a:rPr lang="en-US" sz="1250" dirty="0">
                           <a:solidFill>
                             <a:srgbClr val="333333"/>
                           </a:solidFill>
@@ -14579,7 +14632,7 @@
                         </a:rPr>
                         <a:t>241</a:t>
                       </a:r>
-                      <a:endParaRPr lang="en-US" sz="1000" dirty="0">
+                      <a:endParaRPr lang="en-US" sz="1250" dirty="0">
                         <a:latin typeface="Calibri" charset="0"/>
                         <a:ea typeface="Calibri" charset="0"/>
                         <a:cs typeface="Calibri" charset="0"/>
@@ -14637,7 +14690,7 @@
                         <a:buNone/>
                       </a:pPr>
                       <a:r>
-                        <a:rPr lang="en-US" sz="1000" b="1" dirty="0">
+                        <a:rPr lang="en-US" sz="1250" b="1" dirty="0">
                           <a:solidFill>
                             <a:srgbClr val="6A4C93"/>
                           </a:solidFill>
@@ -14647,7 +14700,7 @@
                         </a:rPr>
                         <a:t>9,4%</a:t>
                       </a:r>
-                      <a:endParaRPr lang="en-US" sz="1000" dirty="0">
+                      <a:endParaRPr lang="en-US" sz="1250" dirty="0">
                         <a:latin typeface="Calibri" charset="0"/>
                         <a:ea typeface="Calibri" charset="0"/>
                         <a:cs typeface="Calibri" charset="0"/>
@@ -14707,7 +14760,7 @@
                         <a:buNone/>
                       </a:pPr>
                       <a:r>
-                        <a:rPr lang="en-US" sz="1000" b="1" dirty="0">
+                        <a:rPr lang="en-US" sz="1250" b="1" dirty="0">
                           <a:solidFill>
                             <a:srgbClr val="1D3557"/>
                           </a:solidFill>
@@ -14717,7 +14770,7 @@
                         </a:rPr>
                         <a:t>PSQ</a:t>
                       </a:r>
-                      <a:endParaRPr lang="en-US" sz="1000" dirty="0">
+                      <a:endParaRPr lang="en-US" sz="1250" dirty="0">
                         <a:latin typeface="Calibri" charset="0"/>
                         <a:ea typeface="Calibri" charset="0"/>
                         <a:cs typeface="Calibri" charset="0"/>
@@ -14775,7 +14828,7 @@
                         <a:buNone/>
                       </a:pPr>
                       <a:r>
-                        <a:rPr lang="en-US" sz="1000" dirty="0">
+                        <a:rPr lang="en-US" sz="1250" dirty="0">
                           <a:solidFill>
                             <a:srgbClr val="333333"/>
                           </a:solidFill>
@@ -14785,7 +14838,7 @@
                         </a:rPr>
                         <a:t>228</a:t>
                       </a:r>
-                      <a:endParaRPr lang="en-US" sz="1000" dirty="0">
+                      <a:endParaRPr lang="en-US" sz="1250" dirty="0">
                         <a:latin typeface="Calibri" charset="0"/>
                         <a:ea typeface="Calibri" charset="0"/>
                         <a:cs typeface="Calibri" charset="0"/>
@@ -14843,7 +14896,7 @@
                         <a:buNone/>
                       </a:pPr>
                       <a:r>
-                        <a:rPr lang="en-US" sz="1000" b="1" dirty="0">
+                        <a:rPr lang="en-US" sz="1250" b="1" dirty="0">
                           <a:solidFill>
                             <a:srgbClr val="6A4C93"/>
                           </a:solidFill>
@@ -14853,7 +14906,7 @@
                         </a:rPr>
                         <a:t>8,9%</a:t>
                       </a:r>
-                      <a:endParaRPr lang="en-US" sz="1000" dirty="0">
+                      <a:endParaRPr lang="en-US" sz="1250" dirty="0">
                         <a:latin typeface="Calibri" charset="0"/>
                         <a:ea typeface="Calibri" charset="0"/>
                         <a:cs typeface="Calibri" charset="0"/>
@@ -14913,7 +14966,7 @@
                         <a:buNone/>
                       </a:pPr>
                       <a:r>
-                        <a:rPr lang="en-US" sz="1000" b="1" dirty="0">
+                        <a:rPr lang="en-US" sz="1250" b="1" dirty="0">
                           <a:solidFill>
                             <a:srgbClr val="1D3557"/>
                           </a:solidFill>
@@ -14923,7 +14976,7 @@
                         </a:rPr>
                         <a:t>END</a:t>
                       </a:r>
-                      <a:endParaRPr lang="en-US" sz="1000" dirty="0">
+                      <a:endParaRPr lang="en-US" sz="1250" dirty="0">
                         <a:latin typeface="Calibri" charset="0"/>
                         <a:ea typeface="Calibri" charset="0"/>
                         <a:cs typeface="Calibri" charset="0"/>
@@ -14981,7 +15034,7 @@
                         <a:buNone/>
                       </a:pPr>
                       <a:r>
-                        <a:rPr lang="en-US" sz="1000" dirty="0">
+                        <a:rPr lang="en-US" sz="1250" dirty="0">
                           <a:solidFill>
                             <a:srgbClr val="333333"/>
                           </a:solidFill>
@@ -14991,7 +15044,7 @@
                         </a:rPr>
                         <a:t>145</a:t>
                       </a:r>
-                      <a:endParaRPr lang="en-US" sz="1000" dirty="0">
+                      <a:endParaRPr lang="en-US" sz="1250" dirty="0">
                         <a:latin typeface="Calibri" charset="0"/>
                         <a:ea typeface="Calibri" charset="0"/>
                         <a:cs typeface="Calibri" charset="0"/>
@@ -15049,7 +15102,7 @@
                         <a:buNone/>
                       </a:pPr>
                       <a:r>
-                        <a:rPr lang="en-US" sz="1000" b="1" dirty="0">
+                        <a:rPr lang="en-US" sz="1250" b="1" dirty="0">
                           <a:solidFill>
                             <a:srgbClr val="6A4C93"/>
                           </a:solidFill>
@@ -15059,7 +15112,7 @@
                         </a:rPr>
                         <a:t>5,7%</a:t>
                       </a:r>
-                      <a:endParaRPr lang="en-US" sz="1000" dirty="0">
+                      <a:endParaRPr lang="en-US" sz="1250" dirty="0">
                         <a:latin typeface="Calibri" charset="0"/>
                         <a:ea typeface="Calibri" charset="0"/>
                         <a:cs typeface="Calibri" charset="0"/>
@@ -15119,7 +15172,7 @@
                         <a:buNone/>
                       </a:pPr>
                       <a:r>
-                        <a:rPr lang="en-US" sz="1000" b="1" dirty="0">
+                        <a:rPr lang="en-US" sz="1250" b="1" dirty="0">
                           <a:solidFill>
                             <a:srgbClr val="1D3557"/>
                           </a:solidFill>
@@ -15129,7 +15182,7 @@
                         </a:rPr>
                         <a:t>CLG / END</a:t>
                       </a:r>
-                      <a:endParaRPr lang="en-US" sz="1000" dirty="0">
+                      <a:endParaRPr lang="en-US" sz="1250" dirty="0">
                         <a:latin typeface="Calibri" charset="0"/>
                         <a:ea typeface="Calibri" charset="0"/>
                         <a:cs typeface="Calibri" charset="0"/>
@@ -15187,7 +15240,7 @@
                         <a:buNone/>
                       </a:pPr>
                       <a:r>
-                        <a:rPr lang="en-US" sz="1000" dirty="0">
+                        <a:rPr lang="en-US" sz="1250" dirty="0">
                           <a:solidFill>
                             <a:srgbClr val="333333"/>
                           </a:solidFill>
@@ -15197,7 +15250,7 @@
                         </a:rPr>
                         <a:t>145</a:t>
                       </a:r>
-                      <a:endParaRPr lang="en-US" sz="1000" dirty="0">
+                      <a:endParaRPr lang="en-US" sz="1250" dirty="0">
                         <a:latin typeface="Calibri" charset="0"/>
                         <a:ea typeface="Calibri" charset="0"/>
                         <a:cs typeface="Calibri" charset="0"/>
@@ -15255,7 +15308,7 @@
                         <a:buNone/>
                       </a:pPr>
                       <a:r>
-                        <a:rPr lang="en-US" sz="1000" b="1" dirty="0">
+                        <a:rPr lang="en-US" sz="1250" b="1" dirty="0">
                           <a:solidFill>
                             <a:srgbClr val="6A4C93"/>
                           </a:solidFill>
@@ -15265,7 +15318,7 @@
                         </a:rPr>
                         <a:t>5,7%</a:t>
                       </a:r>
-                      <a:endParaRPr lang="en-US" sz="1000" dirty="0">
+                      <a:endParaRPr lang="en-US" sz="1250" dirty="0">
                         <a:latin typeface="Calibri" charset="0"/>
                         <a:ea typeface="Calibri" charset="0"/>
                         <a:cs typeface="Calibri" charset="0"/>
@@ -15325,7 +15378,7 @@
                         <a:buNone/>
                       </a:pPr>
                       <a:r>
-                        <a:rPr lang="en-US" sz="1000" b="1" dirty="0">
+                        <a:rPr lang="en-US" sz="1250" b="1" dirty="0">
                           <a:solidFill>
                             <a:srgbClr val="1D3557"/>
                           </a:solidFill>
@@ -15335,7 +15388,7 @@
                         </a:rPr>
                         <a:t>ORL</a:t>
                       </a:r>
-                      <a:endParaRPr lang="en-US" sz="1000" dirty="0">
+                      <a:endParaRPr lang="en-US" sz="1250" dirty="0">
                         <a:latin typeface="Calibri" charset="0"/>
                         <a:ea typeface="Calibri" charset="0"/>
                         <a:cs typeface="Calibri" charset="0"/>
@@ -15393,7 +15446,7 @@
                         <a:buNone/>
                       </a:pPr>
                       <a:r>
-                        <a:rPr lang="en-US" sz="1000" dirty="0">
+                        <a:rPr lang="en-US" sz="1250" dirty="0">
                           <a:solidFill>
                             <a:srgbClr val="333333"/>
                           </a:solidFill>
@@ -15403,7 +15456,7 @@
                         </a:rPr>
                         <a:t>133</a:t>
                       </a:r>
-                      <a:endParaRPr lang="en-US" sz="1000" dirty="0">
+                      <a:endParaRPr lang="en-US" sz="1250" dirty="0">
                         <a:latin typeface="Calibri" charset="0"/>
                         <a:ea typeface="Calibri" charset="0"/>
                         <a:cs typeface="Calibri" charset="0"/>
@@ -15461,7 +15514,7 @@
                         <a:buNone/>
                       </a:pPr>
                       <a:r>
-                        <a:rPr lang="en-US" sz="1000" b="1" dirty="0">
+                        <a:rPr lang="en-US" sz="1250" b="1" dirty="0">
                           <a:solidFill>
                             <a:srgbClr val="6A4C93"/>
                           </a:solidFill>
@@ -15471,7 +15524,7 @@
                         </a:rPr>
                         <a:t>5,2%</a:t>
                       </a:r>
-                      <a:endParaRPr lang="en-US" sz="1000" dirty="0">
+                      <a:endParaRPr lang="en-US" sz="1250" dirty="0">
                         <a:latin typeface="Calibri" charset="0"/>
                         <a:ea typeface="Calibri" charset="0"/>
                         <a:cs typeface="Calibri" charset="0"/>
@@ -15531,7 +15584,7 @@
                         <a:buNone/>
                       </a:pPr>
                       <a:r>
-                        <a:rPr lang="en-US" sz="1000" b="1" dirty="0">
+                        <a:rPr lang="en-US" sz="1250" b="1" dirty="0">
                           <a:solidFill>
                             <a:srgbClr val="1D3557"/>
                           </a:solidFill>
@@ -15541,7 +15594,7 @@
                         </a:rPr>
                         <a:t>NEU</a:t>
                       </a:r>
-                      <a:endParaRPr lang="en-US" sz="1000" dirty="0">
+                      <a:endParaRPr lang="en-US" sz="1250" dirty="0">
                         <a:latin typeface="Calibri" charset="0"/>
                         <a:ea typeface="Calibri" charset="0"/>
                         <a:cs typeface="Calibri" charset="0"/>
@@ -15599,7 +15652,7 @@
                         <a:buNone/>
                       </a:pPr>
                       <a:r>
-                        <a:rPr lang="en-US" sz="1000" dirty="0">
+                        <a:rPr lang="en-US" sz="1250" dirty="0">
                           <a:solidFill>
                             <a:srgbClr val="333333"/>
                           </a:solidFill>
@@ -15609,7 +15662,7 @@
                         </a:rPr>
                         <a:t>119</a:t>
                       </a:r>
-                      <a:endParaRPr lang="en-US" sz="1000" dirty="0">
+                      <a:endParaRPr lang="en-US" sz="1250" dirty="0">
                         <a:latin typeface="Calibri" charset="0"/>
                         <a:ea typeface="Calibri" charset="0"/>
                         <a:cs typeface="Calibri" charset="0"/>
@@ -15667,7 +15720,7 @@
                         <a:buNone/>
                       </a:pPr>
                       <a:r>
-                        <a:rPr lang="en-US" sz="1000" b="1" dirty="0">
+                        <a:rPr lang="en-US" sz="1250" b="1" dirty="0">
                           <a:solidFill>
                             <a:srgbClr val="6A4C93"/>
                           </a:solidFill>
@@ -15677,7 +15730,7 @@
                         </a:rPr>
                         <a:t>4,7%</a:t>
                       </a:r>
-                      <a:endParaRPr lang="en-US" sz="1000" dirty="0">
+                      <a:endParaRPr lang="en-US" sz="1250" dirty="0">
                         <a:latin typeface="Calibri" charset="0"/>
                         <a:ea typeface="Calibri" charset="0"/>
                         <a:cs typeface="Calibri" charset="0"/>
@@ -15737,7 +15790,7 @@
                         <a:buNone/>
                       </a:pPr>
                       <a:r>
-                        <a:rPr lang="en-US" sz="1000" b="1" dirty="0">
+                        <a:rPr lang="en-US" sz="1250" b="1" dirty="0">
                           <a:solidFill>
                             <a:srgbClr val="1D3557"/>
                           </a:solidFill>
@@ -15747,7 +15800,7 @@
                         </a:rPr>
                         <a:t>GAS</a:t>
                       </a:r>
-                      <a:endParaRPr lang="en-US" sz="1000" dirty="0">
+                      <a:endParaRPr lang="en-US" sz="1250" dirty="0">
                         <a:latin typeface="Calibri" charset="0"/>
                         <a:ea typeface="Calibri" charset="0"/>
                         <a:cs typeface="Calibri" charset="0"/>
@@ -15805,7 +15858,7 @@
                         <a:buNone/>
                       </a:pPr>
                       <a:r>
-                        <a:rPr lang="en-US" sz="1000" dirty="0">
+                        <a:rPr lang="en-US" sz="1250" dirty="0">
                           <a:solidFill>
                             <a:srgbClr val="333333"/>
                           </a:solidFill>
@@ -15815,7 +15868,7 @@
                         </a:rPr>
                         <a:t>107</a:t>
                       </a:r>
-                      <a:endParaRPr lang="en-US" sz="1000" dirty="0">
+                      <a:endParaRPr lang="en-US" sz="1250" dirty="0">
                         <a:latin typeface="Calibri" charset="0"/>
                         <a:ea typeface="Calibri" charset="0"/>
                         <a:cs typeface="Calibri" charset="0"/>
@@ -15873,7 +15926,7 @@
                         <a:buNone/>
                       </a:pPr>
                       <a:r>
-                        <a:rPr lang="en-US" sz="1000" b="1" dirty="0">
+                        <a:rPr lang="en-US" sz="1250" b="1" dirty="0">
                           <a:solidFill>
                             <a:srgbClr val="6A4C93"/>
                           </a:solidFill>
@@ -15883,7 +15936,7 @@
                         </a:rPr>
                         <a:t>4,2%</a:t>
                       </a:r>
-                      <a:endParaRPr lang="en-US" sz="1000" dirty="0">
+                      <a:endParaRPr lang="en-US" sz="1250" dirty="0">
                         <a:latin typeface="Calibri" charset="0"/>
                         <a:ea typeface="Calibri" charset="0"/>
                         <a:cs typeface="Calibri" charset="0"/>
@@ -15943,7 +15996,7 @@
                         <a:buNone/>
                       </a:pPr>
                       <a:r>
-                        <a:rPr lang="en-US" sz="1000" b="1" dirty="0">
+                        <a:rPr lang="en-US" sz="1250" b="1" dirty="0">
                           <a:solidFill>
                             <a:srgbClr val="1D3557"/>
                           </a:solidFill>
@@ -15953,7 +16006,7 @@
                         </a:rPr>
                         <a:t>URO</a:t>
                       </a:r>
-                      <a:endParaRPr lang="en-US" sz="1000" dirty="0">
+                      <a:endParaRPr lang="en-US" sz="1250" dirty="0">
                         <a:latin typeface="Calibri" charset="0"/>
                         <a:ea typeface="Calibri" charset="0"/>
                         <a:cs typeface="Calibri" charset="0"/>
@@ -16011,7 +16064,7 @@
                         <a:buNone/>
                       </a:pPr>
                       <a:r>
-                        <a:rPr lang="en-US" sz="1000" dirty="0">
+                        <a:rPr lang="en-US" sz="1250" dirty="0">
                           <a:solidFill>
                             <a:srgbClr val="333333"/>
                           </a:solidFill>
@@ -16021,7 +16074,7 @@
                         </a:rPr>
                         <a:t>81</a:t>
                       </a:r>
-                      <a:endParaRPr lang="en-US" sz="1000" dirty="0">
+                      <a:endParaRPr lang="en-US" sz="1250" dirty="0">
                         <a:latin typeface="Calibri" charset="0"/>
                         <a:ea typeface="Calibri" charset="0"/>
                         <a:cs typeface="Calibri" charset="0"/>
@@ -16079,7 +16132,7 @@
                         <a:buNone/>
                       </a:pPr>
                       <a:r>
-                        <a:rPr lang="en-US" sz="1000" b="1" dirty="0">
+                        <a:rPr lang="en-US" sz="1250" b="1" dirty="0">
                           <a:solidFill>
                             <a:srgbClr val="6A4C93"/>
                           </a:solidFill>
@@ -16089,7 +16142,7 @@
                         </a:rPr>
                         <a:t>3,2%</a:t>
                       </a:r>
-                      <a:endParaRPr lang="en-US" sz="1000" dirty="0">
+                      <a:endParaRPr lang="en-US" sz="1250" dirty="0">
                         <a:latin typeface="Calibri" charset="0"/>
                         <a:ea typeface="Calibri" charset="0"/>
                         <a:cs typeface="Calibri" charset="0"/>
@@ -16149,7 +16202,7 @@
                         <a:buNone/>
                       </a:pPr>
                       <a:r>
-                        <a:rPr lang="en-US" sz="1000" b="1" dirty="0">
+                        <a:rPr lang="en-US" sz="1250" b="1" dirty="0">
                           <a:solidFill>
                             <a:srgbClr val="1D3557"/>
                           </a:solidFill>
@@ -16159,7 +16212,7 @@
                         </a:rPr>
                         <a:t>CLG / SNC</a:t>
                       </a:r>
-                      <a:endParaRPr lang="en-US" sz="1000" dirty="0">
+                      <a:endParaRPr lang="en-US" sz="1250" dirty="0">
                         <a:latin typeface="Calibri" charset="0"/>
                         <a:ea typeface="Calibri" charset="0"/>
                         <a:cs typeface="Calibri" charset="0"/>
@@ -16217,7 +16270,7 @@
                         <a:buNone/>
                       </a:pPr>
                       <a:r>
-                        <a:rPr lang="en-US" sz="1000" dirty="0">
+                        <a:rPr lang="en-US" sz="1250" dirty="0">
                           <a:solidFill>
                             <a:srgbClr val="333333"/>
                           </a:solidFill>
@@ -16227,7 +16280,7 @@
                         </a:rPr>
                         <a:t>67</a:t>
                       </a:r>
-                      <a:endParaRPr lang="en-US" sz="1000" dirty="0">
+                      <a:endParaRPr lang="en-US" sz="1250" dirty="0">
                         <a:latin typeface="Calibri" charset="0"/>
                         <a:ea typeface="Calibri" charset="0"/>
                         <a:cs typeface="Calibri" charset="0"/>
@@ -16285,7 +16338,7 @@
                         <a:buNone/>
                       </a:pPr>
                       <a:r>
-                        <a:rPr lang="en-US" sz="1000" b="1" dirty="0">
+                        <a:rPr lang="en-US" sz="1250" b="1" dirty="0">
                           <a:solidFill>
                             <a:srgbClr val="6A4C93"/>
                           </a:solidFill>
@@ -16295,7 +16348,7 @@
                         </a:rPr>
                         <a:t>2,6%</a:t>
                       </a:r>
-                      <a:endParaRPr lang="en-US" sz="1000" dirty="0">
+                      <a:endParaRPr lang="en-US" sz="1250" dirty="0">
                         <a:latin typeface="Calibri" charset="0"/>
                         <a:ea typeface="Calibri" charset="0"/>
                         <a:cs typeface="Calibri" charset="0"/>
@@ -16355,7 +16408,7 @@
                         <a:buNone/>
                       </a:pPr>
                       <a:r>
-                        <a:rPr lang="en-US" sz="1000" b="1" dirty="0">
+                        <a:rPr lang="en-US" sz="1250" b="1" dirty="0">
                           <a:solidFill>
                             <a:srgbClr val="1D3557"/>
                           </a:solidFill>
@@ -16365,7 +16418,7 @@
                         </a:rPr>
                         <a:t>GER</a:t>
                       </a:r>
-                      <a:endParaRPr lang="en-US" sz="1000" dirty="0">
+                      <a:endParaRPr lang="en-US" sz="1250" dirty="0">
                         <a:latin typeface="Calibri" charset="0"/>
                         <a:ea typeface="Calibri" charset="0"/>
                         <a:cs typeface="Calibri" charset="0"/>
@@ -16423,7 +16476,7 @@
                         <a:buNone/>
                       </a:pPr>
                       <a:r>
-                        <a:rPr lang="en-US" sz="1000" dirty="0">
+                        <a:rPr lang="en-US" sz="1250" dirty="0">
                           <a:solidFill>
                             <a:srgbClr val="333333"/>
                           </a:solidFill>
@@ -16433,7 +16486,7 @@
                         </a:rPr>
                         <a:t>44</a:t>
                       </a:r>
-                      <a:endParaRPr lang="en-US" sz="1000" dirty="0">
+                      <a:endParaRPr lang="en-US" sz="1250" dirty="0">
                         <a:latin typeface="Calibri" charset="0"/>
                         <a:ea typeface="Calibri" charset="0"/>
                         <a:cs typeface="Calibri" charset="0"/>
@@ -16491,7 +16544,7 @@
                         <a:buNone/>
                       </a:pPr>
                       <a:r>
-                        <a:rPr lang="en-US" sz="1000" b="1" dirty="0">
+                        <a:rPr lang="en-US" sz="1250" b="1" dirty="0">
                           <a:solidFill>
                             <a:srgbClr val="6A4C93"/>
                           </a:solidFill>
@@ -16501,7 +16554,7 @@
                         </a:rPr>
                         <a:t>1,7%</a:t>
                       </a:r>
-                      <a:endParaRPr lang="en-US" sz="1000" dirty="0">
+                      <a:endParaRPr lang="en-US" sz="1250" dirty="0">
                         <a:latin typeface="Calibri" charset="0"/>
                         <a:ea typeface="Calibri" charset="0"/>
                         <a:cs typeface="Calibri" charset="0"/>
@@ -16561,7 +16614,7 @@
                         <a:buNone/>
                       </a:pPr>
                       <a:r>
-                        <a:rPr lang="en-US" sz="1000" b="1" dirty="0">
+                        <a:rPr lang="en-US" sz="1250" b="1" dirty="0">
                           <a:solidFill>
                             <a:srgbClr val="1D3557"/>
                           </a:solidFill>
@@ -16571,7 +16624,7 @@
                         </a:rPr>
                         <a:t>RMT</a:t>
                       </a:r>
-                      <a:endParaRPr lang="en-US" sz="1000" dirty="0">
+                      <a:endParaRPr lang="en-US" sz="1250" dirty="0">
                         <a:latin typeface="Calibri" charset="0"/>
                         <a:ea typeface="Calibri" charset="0"/>
                         <a:cs typeface="Calibri" charset="0"/>
@@ -16629,7 +16682,7 @@
                         <a:buNone/>
                       </a:pPr>
                       <a:r>
-                        <a:rPr lang="en-US" sz="1000" dirty="0">
+                        <a:rPr lang="en-US" sz="1250" dirty="0">
                           <a:solidFill>
                             <a:srgbClr val="333333"/>
                           </a:solidFill>
@@ -16639,7 +16692,7 @@
                         </a:rPr>
                         <a:t>12</a:t>
                       </a:r>
-                      <a:endParaRPr lang="en-US" sz="1000" dirty="0">
+                      <a:endParaRPr lang="en-US" sz="1250" dirty="0">
                         <a:latin typeface="Calibri" charset="0"/>
                         <a:ea typeface="Calibri" charset="0"/>
                         <a:cs typeface="Calibri" charset="0"/>
@@ -16697,7 +16750,7 @@
                         <a:buNone/>
                       </a:pPr>
                       <a:r>
-                        <a:rPr lang="en-US" sz="1000" b="1" dirty="0">
+                        <a:rPr lang="en-US" sz="1250" b="1" dirty="0">
                           <a:solidFill>
                             <a:srgbClr val="6A4C93"/>
                           </a:solidFill>
@@ -16707,7 +16760,7 @@
                         </a:rPr>
                         <a:t>0,5%</a:t>
                       </a:r>
-                      <a:endParaRPr lang="en-US" sz="1000" dirty="0">
+                      <a:endParaRPr lang="en-US" sz="1250" dirty="0">
                         <a:latin typeface="Calibri" charset="0"/>
                         <a:ea typeface="Calibri" charset="0"/>
                         <a:cs typeface="Calibri" charset="0"/>
@@ -16763,7 +16816,7 @@
       </p:graphicFrame>
       <p:sp>
         <p:nvSpPr>
-          <p:cNvPr id="9" name="Text 5"/>
+          <p:cNvPr id="10" name="Text 6"/>
           <p:cNvSpPr txBox="1"/>
           <p:nvPr/>
         </p:nvSpPr>
@@ -16786,7 +16839,7 @@
               <a:buNone/>
             </a:pPr>
             <a:r>
-              <a:rPr lang="en-US" sz="850" i="1" dirty="0">
+              <a:rPr lang="en-US" sz="1000" i="1" dirty="0">
                 <a:solidFill>
                   <a:srgbClr val="9AA0A6"/>
                 </a:solidFill>
@@ -16796,7 +16849,7 @@
               </a:rPr>
               <a:t>Especialidades agrupam variações (ex.: CLG = Clínica Geral, CLG / PA = Clínica Geral / Pronto Atendimento). Fonte: painel_distrital.</a:t>
             </a:r>
-            <a:endParaRPr lang="en-US" sz="850" dirty="0"/>
+            <a:endParaRPr lang="en-US" sz="1000" dirty="0"/>
           </a:p>
         </p:txBody>
       </p:sp>

</xml_diff>

<commit_message>
Substitui "Setor XXXX" pelo código + nome do representante (slides 1 e 3)
Ex.: "Setor 5153" vira "5153 - MARCELLE". Ajusta o tamanho da fonte
no slide 1 para caber o nome completo em uma linha sem sobrepor a
barra de progresso.

Co-Authored-By: Claude Sonnet 5 <noreply@anthropic.com>
Claude-Session: https://claude.ai/code/session_01KqmuB8xxfxpvceuypurV9G
</commit_message>
<xml_diff>
--- a/output/painel_medico_distrital_1880.pptx
+++ b/output/painel_medico_distrital_1880.pptx
@@ -176,28 +176,28 @@
                 <c:ptCount val="8"/>
                 <c:lvl>
                   <c:pt idx="0">
-                    <c:v>Setor 7745</c:v>
+                    <c:v>7745 - MATHEUS</c:v>
                   </c:pt>
                   <c:pt idx="1">
-                    <c:v>Setor 7741</c:v>
+                    <c:v>7741 - RAPHAEL</c:v>
                   </c:pt>
                   <c:pt idx="2">
-                    <c:v>Setor 5613</c:v>
+                    <c:v>5613 - MILLER</c:v>
                   </c:pt>
                   <c:pt idx="3">
-                    <c:v>Setor 7748</c:v>
+                    <c:v>7748 - CARLA</c:v>
                   </c:pt>
                   <c:pt idx="4">
-                    <c:v>Setor 5152</c:v>
+                    <c:v>5152 - FÁBIO</c:v>
                   </c:pt>
                   <c:pt idx="5">
-                    <c:v>Setor 5153</c:v>
+                    <c:v>5153 - MARCELLE</c:v>
                   </c:pt>
                   <c:pt idx="6">
-                    <c:v>Setor 5149</c:v>
+                    <c:v>5149 - LEONARDO</c:v>
                   </c:pt>
                   <c:pt idx="7">
-                    <c:v>Setor 7742</c:v>
+                    <c:v>7742 - EDUARDO</c:v>
                   </c:pt>
                 </c:lvl>
               </c:multiLvlStrCache>
@@ -1851,7 +1851,7 @@
               <a:buNone/>
             </a:pPr>
             <a:r>
-              <a:rPr lang="en-US" sz="1500" b="1" dirty="0">
+              <a:rPr lang="en-US" sz="900" b="1" dirty="0">
                 <a:solidFill>
                   <a:srgbClr val="1D3557"/>
                 </a:solidFill>
@@ -1859,9 +1859,9 @@
                 <a:ea typeface="Calibri" pitchFamily="34" charset="-122"/>
                 <a:cs typeface="Calibri" pitchFamily="34" charset="-120"/>
               </a:rPr>
-              <a:t>Setor 5153</a:t>
-            </a:r>
-            <a:endParaRPr lang="en-US" sz="1500" dirty="0"/>
+              <a:t>5153 - MARCELLE</a:t>
+            </a:r>
+            <a:endParaRPr lang="en-US" sz="900" dirty="0"/>
           </a:p>
         </p:txBody>
       </p:sp>
@@ -2093,7 +2093,7 @@
               <a:buNone/>
             </a:pPr>
             <a:r>
-              <a:rPr lang="en-US" sz="1500" b="1" dirty="0">
+              <a:rPr lang="en-US" sz="900" b="1" dirty="0">
                 <a:solidFill>
                   <a:srgbClr val="1D3557"/>
                 </a:solidFill>
@@ -2101,9 +2101,9 @@
                 <a:ea typeface="Calibri" pitchFamily="34" charset="-122"/>
                 <a:cs typeface="Calibri" pitchFamily="34" charset="-120"/>
               </a:rPr>
-              <a:t>Setor 5149</a:t>
-            </a:r>
-            <a:endParaRPr lang="en-US" sz="1500" dirty="0"/>
+              <a:t>5149 - LEONARDO</a:t>
+            </a:r>
+            <a:endParaRPr lang="en-US" sz="900" dirty="0"/>
           </a:p>
         </p:txBody>
       </p:sp>
@@ -2335,7 +2335,7 @@
               <a:buNone/>
             </a:pPr>
             <a:r>
-              <a:rPr lang="en-US" sz="1500" b="1" dirty="0">
+              <a:rPr lang="en-US" sz="900" b="1" dirty="0">
                 <a:solidFill>
                   <a:srgbClr val="1D3557"/>
                 </a:solidFill>
@@ -2343,9 +2343,9 @@
                 <a:ea typeface="Calibri" pitchFamily="34" charset="-122"/>
                 <a:cs typeface="Calibri" pitchFamily="34" charset="-120"/>
               </a:rPr>
-              <a:t>Setor 7745</a:t>
-            </a:r>
-            <a:endParaRPr lang="en-US" sz="1500" dirty="0"/>
+              <a:t>7745 - MATHEUS</a:t>
+            </a:r>
+            <a:endParaRPr lang="en-US" sz="900" dirty="0"/>
           </a:p>
         </p:txBody>
       </p:sp>
@@ -2577,7 +2577,7 @@
               <a:buNone/>
             </a:pPr>
             <a:r>
-              <a:rPr lang="en-US" sz="1500" b="1" dirty="0">
+              <a:rPr lang="en-US" sz="900" b="1" dirty="0">
                 <a:solidFill>
                   <a:srgbClr val="1D3557"/>
                 </a:solidFill>
@@ -2585,9 +2585,9 @@
                 <a:ea typeface="Calibri" pitchFamily="34" charset="-122"/>
                 <a:cs typeface="Calibri" pitchFamily="34" charset="-120"/>
               </a:rPr>
-              <a:t>Setor 5152</a:t>
-            </a:r>
-            <a:endParaRPr lang="en-US" sz="1500" dirty="0"/>
+              <a:t>5152 - FÁBIO</a:t>
+            </a:r>
+            <a:endParaRPr lang="en-US" sz="900" dirty="0"/>
           </a:p>
         </p:txBody>
       </p:sp>
@@ -2819,7 +2819,7 @@
               <a:buNone/>
             </a:pPr>
             <a:r>
-              <a:rPr lang="en-US" sz="1500" b="1" dirty="0">
+              <a:rPr lang="en-US" sz="900" b="1" dirty="0">
                 <a:solidFill>
                   <a:srgbClr val="1D3557"/>
                 </a:solidFill>
@@ -2827,9 +2827,9 @@
                 <a:ea typeface="Calibri" pitchFamily="34" charset="-122"/>
                 <a:cs typeface="Calibri" pitchFamily="34" charset="-120"/>
               </a:rPr>
-              <a:t>Setor 7741</a:t>
-            </a:r>
-            <a:endParaRPr lang="en-US" sz="1500" dirty="0"/>
+              <a:t>7741 - RAPHAEL</a:t>
+            </a:r>
+            <a:endParaRPr lang="en-US" sz="900" dirty="0"/>
           </a:p>
         </p:txBody>
       </p:sp>
@@ -3061,7 +3061,7 @@
               <a:buNone/>
             </a:pPr>
             <a:r>
-              <a:rPr lang="en-US" sz="1500" b="1" dirty="0">
+              <a:rPr lang="en-US" sz="900" b="1" dirty="0">
                 <a:solidFill>
                   <a:srgbClr val="1D3557"/>
                 </a:solidFill>
@@ -3069,9 +3069,9 @@
                 <a:ea typeface="Calibri" pitchFamily="34" charset="-122"/>
                 <a:cs typeface="Calibri" pitchFamily="34" charset="-120"/>
               </a:rPr>
-              <a:t>Setor 7742</a:t>
-            </a:r>
-            <a:endParaRPr lang="en-US" sz="1500" dirty="0"/>
+              <a:t>7742 - EDUARDO</a:t>
+            </a:r>
+            <a:endParaRPr lang="en-US" sz="900" dirty="0"/>
           </a:p>
         </p:txBody>
       </p:sp>
@@ -3303,7 +3303,7 @@
               <a:buNone/>
             </a:pPr>
             <a:r>
-              <a:rPr lang="en-US" sz="1500" b="1" dirty="0">
+              <a:rPr lang="en-US" sz="900" b="1" dirty="0">
                 <a:solidFill>
                   <a:srgbClr val="1D3557"/>
                 </a:solidFill>
@@ -3311,9 +3311,9 @@
                 <a:ea typeface="Calibri" pitchFamily="34" charset="-122"/>
                 <a:cs typeface="Calibri" pitchFamily="34" charset="-120"/>
               </a:rPr>
-              <a:t>Setor 5613</a:t>
-            </a:r>
-            <a:endParaRPr lang="en-US" sz="1500" dirty="0"/>
+              <a:t>5613 - MILLER</a:t>
+            </a:r>
+            <a:endParaRPr lang="en-US" sz="900" dirty="0"/>
           </a:p>
         </p:txBody>
       </p:sp>
@@ -3545,7 +3545,7 @@
               <a:buNone/>
             </a:pPr>
             <a:r>
-              <a:rPr lang="en-US" sz="1500" b="1" dirty="0">
+              <a:rPr lang="en-US" sz="900" b="1" dirty="0">
                 <a:solidFill>
                   <a:srgbClr val="1D3557"/>
                 </a:solidFill>
@@ -3553,9 +3553,9 @@
                 <a:ea typeface="Calibri" pitchFamily="34" charset="-122"/>
                 <a:cs typeface="Calibri" pitchFamily="34" charset="-120"/>
               </a:rPr>
-              <a:t>Setor 7748</a:t>
-            </a:r>
-            <a:endParaRPr lang="en-US" sz="1500" dirty="0"/>
+              <a:t>7748 - CARLA</a:t>
+            </a:r>
+            <a:endParaRPr lang="en-US" sz="900" dirty="0"/>
           </a:p>
         </p:txBody>
       </p:sp>
@@ -3894,7 +3894,7 @@
               <a:buNone/>
             </a:pPr>
             <a:r>
-              <a:rPr lang="en-US" sz="1500" b="1" dirty="0">
+              <a:rPr lang="en-US" sz="900" b="1" dirty="0">
                 <a:solidFill>
                   <a:srgbClr val="1D3557"/>
                 </a:solidFill>
@@ -3902,9 +3902,9 @@
                 <a:ea typeface="Calibri" pitchFamily="34" charset="-122"/>
                 <a:cs typeface="Calibri" pitchFamily="34" charset="-120"/>
               </a:rPr>
-              <a:t>Setor 7745</a:t>
-            </a:r>
-            <a:endParaRPr lang="en-US" sz="1500" dirty="0"/>
+              <a:t>7745 - MATHEUS</a:t>
+            </a:r>
+            <a:endParaRPr lang="en-US" sz="900" dirty="0"/>
           </a:p>
         </p:txBody>
       </p:sp>
@@ -4136,7 +4136,7 @@
               <a:buNone/>
             </a:pPr>
             <a:r>
-              <a:rPr lang="en-US" sz="1500" b="1" dirty="0">
+              <a:rPr lang="en-US" sz="900" b="1" dirty="0">
                 <a:solidFill>
                   <a:srgbClr val="1D3557"/>
                 </a:solidFill>
@@ -4144,9 +4144,9 @@
                 <a:ea typeface="Calibri" pitchFamily="34" charset="-122"/>
                 <a:cs typeface="Calibri" pitchFamily="34" charset="-120"/>
               </a:rPr>
-              <a:t>Setor 5153</a:t>
-            </a:r>
-            <a:endParaRPr lang="en-US" sz="1500" dirty="0"/>
+              <a:t>5153 - MARCELLE</a:t>
+            </a:r>
+            <a:endParaRPr lang="en-US" sz="900" dirty="0"/>
           </a:p>
         </p:txBody>
       </p:sp>
@@ -4378,7 +4378,7 @@
               <a:buNone/>
             </a:pPr>
             <a:r>
-              <a:rPr lang="en-US" sz="1500" b="1" dirty="0">
+              <a:rPr lang="en-US" sz="900" b="1" dirty="0">
                 <a:solidFill>
                   <a:srgbClr val="1D3557"/>
                 </a:solidFill>
@@ -4386,9 +4386,9 @@
                 <a:ea typeface="Calibri" pitchFamily="34" charset="-122"/>
                 <a:cs typeface="Calibri" pitchFamily="34" charset="-120"/>
               </a:rPr>
-              <a:t>Setor 5149</a:t>
-            </a:r>
-            <a:endParaRPr lang="en-US" sz="1500" dirty="0"/>
+              <a:t>5149 - LEONARDO</a:t>
+            </a:r>
+            <a:endParaRPr lang="en-US" sz="900" dirty="0"/>
           </a:p>
         </p:txBody>
       </p:sp>
@@ -4620,7 +4620,7 @@
               <a:buNone/>
             </a:pPr>
             <a:r>
-              <a:rPr lang="en-US" sz="1500" b="1" dirty="0">
+              <a:rPr lang="en-US" sz="900" b="1" dirty="0">
                 <a:solidFill>
                   <a:srgbClr val="1D3557"/>
                 </a:solidFill>
@@ -4628,9 +4628,9 @@
                 <a:ea typeface="Calibri" pitchFamily="34" charset="-122"/>
                 <a:cs typeface="Calibri" pitchFamily="34" charset="-120"/>
               </a:rPr>
-              <a:t>Setor 7748</a:t>
-            </a:r>
-            <a:endParaRPr lang="en-US" sz="1500" dirty="0"/>
+              <a:t>7748 - CARLA</a:t>
+            </a:r>
+            <a:endParaRPr lang="en-US" sz="900" dirty="0"/>
           </a:p>
         </p:txBody>
       </p:sp>
@@ -4862,7 +4862,7 @@
               <a:buNone/>
             </a:pPr>
             <a:r>
-              <a:rPr lang="en-US" sz="1500" b="1" dirty="0">
+              <a:rPr lang="en-US" sz="900" b="1" dirty="0">
                 <a:solidFill>
                   <a:srgbClr val="1D3557"/>
                 </a:solidFill>
@@ -4870,9 +4870,9 @@
                 <a:ea typeface="Calibri" pitchFamily="34" charset="-122"/>
                 <a:cs typeface="Calibri" pitchFamily="34" charset="-120"/>
               </a:rPr>
-              <a:t>Setor 5613</a:t>
-            </a:r>
-            <a:endParaRPr lang="en-US" sz="1500" dirty="0"/>
+              <a:t>5613 - MILLER</a:t>
+            </a:r>
+            <a:endParaRPr lang="en-US" sz="900" dirty="0"/>
           </a:p>
         </p:txBody>
       </p:sp>
@@ -5104,7 +5104,7 @@
               <a:buNone/>
             </a:pPr>
             <a:r>
-              <a:rPr lang="en-US" sz="1500" b="1" dirty="0">
+              <a:rPr lang="en-US" sz="900" b="1" dirty="0">
                 <a:solidFill>
                   <a:srgbClr val="1D3557"/>
                 </a:solidFill>
@@ -5112,9 +5112,9 @@
                 <a:ea typeface="Calibri" pitchFamily="34" charset="-122"/>
                 <a:cs typeface="Calibri" pitchFamily="34" charset="-120"/>
               </a:rPr>
-              <a:t>Setor 7741</a:t>
-            </a:r>
-            <a:endParaRPr lang="en-US" sz="1500" dirty="0"/>
+              <a:t>7741 - RAPHAEL</a:t>
+            </a:r>
+            <a:endParaRPr lang="en-US" sz="900" dirty="0"/>
           </a:p>
         </p:txBody>
       </p:sp>
@@ -5346,7 +5346,7 @@
               <a:buNone/>
             </a:pPr>
             <a:r>
-              <a:rPr lang="en-US" sz="1500" b="1" dirty="0">
+              <a:rPr lang="en-US" sz="900" b="1" dirty="0">
                 <a:solidFill>
                   <a:srgbClr val="1D3557"/>
                 </a:solidFill>
@@ -5354,9 +5354,9 @@
                 <a:ea typeface="Calibri" pitchFamily="34" charset="-122"/>
                 <a:cs typeface="Calibri" pitchFamily="34" charset="-120"/>
               </a:rPr>
-              <a:t>Setor 5152</a:t>
-            </a:r>
-            <a:endParaRPr lang="en-US" sz="1500" dirty="0"/>
+              <a:t>5152 - FÁBIO</a:t>
+            </a:r>
+            <a:endParaRPr lang="en-US" sz="900" dirty="0"/>
           </a:p>
         </p:txBody>
       </p:sp>
@@ -5588,7 +5588,7 @@
               <a:buNone/>
             </a:pPr>
             <a:r>
-              <a:rPr lang="en-US" sz="1500" b="1" dirty="0">
+              <a:rPr lang="en-US" sz="900" b="1" dirty="0">
                 <a:solidFill>
                   <a:srgbClr val="1D3557"/>
                 </a:solidFill>
@@ -5596,9 +5596,9 @@
                 <a:ea typeface="Calibri" pitchFamily="34" charset="-122"/>
                 <a:cs typeface="Calibri" pitchFamily="34" charset="-120"/>
               </a:rPr>
-              <a:t>Setor 7742</a:t>
-            </a:r>
-            <a:endParaRPr lang="en-US" sz="1500" dirty="0"/>
+              <a:t>7742 - EDUARDO</a:t>
+            </a:r>
+            <a:endParaRPr lang="en-US" sz="900" dirty="0"/>
           </a:p>
         </p:txBody>
       </p:sp>
@@ -5937,7 +5937,7 @@
               <a:buNone/>
             </a:pPr>
             <a:r>
-              <a:rPr lang="en-US" sz="1500" b="1" dirty="0">
+              <a:rPr lang="en-US" sz="900" b="1" dirty="0">
                 <a:solidFill>
                   <a:srgbClr val="1D3557"/>
                 </a:solidFill>
@@ -5945,9 +5945,9 @@
                 <a:ea typeface="Calibri" pitchFamily="34" charset="-122"/>
                 <a:cs typeface="Calibri" pitchFamily="34" charset="-120"/>
               </a:rPr>
-              <a:t>Setor 7745</a:t>
-            </a:r>
-            <a:endParaRPr lang="en-US" sz="1500" dirty="0"/>
+              <a:t>7745 - MATHEUS</a:t>
+            </a:r>
+            <a:endParaRPr lang="en-US" sz="900" dirty="0"/>
           </a:p>
         </p:txBody>
       </p:sp>
@@ -6179,7 +6179,7 @@
               <a:buNone/>
             </a:pPr>
             <a:r>
-              <a:rPr lang="en-US" sz="1500" b="1" dirty="0">
+              <a:rPr lang="en-US" sz="900" b="1" dirty="0">
                 <a:solidFill>
                   <a:srgbClr val="1D3557"/>
                 </a:solidFill>
@@ -6187,9 +6187,9 @@
                 <a:ea typeface="Calibri" pitchFamily="34" charset="-122"/>
                 <a:cs typeface="Calibri" pitchFamily="34" charset="-120"/>
               </a:rPr>
-              <a:t>Setor 5153</a:t>
-            </a:r>
-            <a:endParaRPr lang="en-US" sz="1500" dirty="0"/>
+              <a:t>5153 - MARCELLE</a:t>
+            </a:r>
+            <a:endParaRPr lang="en-US" sz="900" dirty="0"/>
           </a:p>
         </p:txBody>
       </p:sp>
@@ -6421,7 +6421,7 @@
               <a:buNone/>
             </a:pPr>
             <a:r>
-              <a:rPr lang="en-US" sz="1500" b="1" dirty="0">
+              <a:rPr lang="en-US" sz="900" b="1" dirty="0">
                 <a:solidFill>
                   <a:srgbClr val="1D3557"/>
                 </a:solidFill>
@@ -6429,9 +6429,9 @@
                 <a:ea typeface="Calibri" pitchFamily="34" charset="-122"/>
                 <a:cs typeface="Calibri" pitchFamily="34" charset="-120"/>
               </a:rPr>
-              <a:t>Setor 5149</a:t>
-            </a:r>
-            <a:endParaRPr lang="en-US" sz="1500" dirty="0"/>
+              <a:t>5149 - LEONARDO</a:t>
+            </a:r>
+            <a:endParaRPr lang="en-US" sz="900" dirty="0"/>
           </a:p>
         </p:txBody>
       </p:sp>
@@ -6663,7 +6663,7 @@
               <a:buNone/>
             </a:pPr>
             <a:r>
-              <a:rPr lang="en-US" sz="1500" b="1" dirty="0">
+              <a:rPr lang="en-US" sz="900" b="1" dirty="0">
                 <a:solidFill>
                   <a:srgbClr val="1D3557"/>
                 </a:solidFill>
@@ -6671,9 +6671,9 @@
                 <a:ea typeface="Calibri" pitchFamily="34" charset="-122"/>
                 <a:cs typeface="Calibri" pitchFamily="34" charset="-120"/>
               </a:rPr>
-              <a:t>Setor 7742</a:t>
-            </a:r>
-            <a:endParaRPr lang="en-US" sz="1500" dirty="0"/>
+              <a:t>7742 - EDUARDO</a:t>
+            </a:r>
+            <a:endParaRPr lang="en-US" sz="900" dirty="0"/>
           </a:p>
         </p:txBody>
       </p:sp>
@@ -6905,7 +6905,7 @@
               <a:buNone/>
             </a:pPr>
             <a:r>
-              <a:rPr lang="en-US" sz="1500" b="1" dirty="0">
+              <a:rPr lang="en-US" sz="900" b="1" dirty="0">
                 <a:solidFill>
                   <a:srgbClr val="1D3557"/>
                 </a:solidFill>
@@ -6913,9 +6913,9 @@
                 <a:ea typeface="Calibri" pitchFamily="34" charset="-122"/>
                 <a:cs typeface="Calibri" pitchFamily="34" charset="-120"/>
               </a:rPr>
-              <a:t>Setor 7741</a:t>
-            </a:r>
-            <a:endParaRPr lang="en-US" sz="1500" dirty="0"/>
+              <a:t>7741 - RAPHAEL</a:t>
+            </a:r>
+            <a:endParaRPr lang="en-US" sz="900" dirty="0"/>
           </a:p>
         </p:txBody>
       </p:sp>
@@ -7147,7 +7147,7 @@
               <a:buNone/>
             </a:pPr>
             <a:r>
-              <a:rPr lang="en-US" sz="1500" b="1" dirty="0">
+              <a:rPr lang="en-US" sz="900" b="1" dirty="0">
                 <a:solidFill>
                   <a:srgbClr val="1D3557"/>
                 </a:solidFill>
@@ -7155,9 +7155,9 @@
                 <a:ea typeface="Calibri" pitchFamily="34" charset="-122"/>
                 <a:cs typeface="Calibri" pitchFamily="34" charset="-120"/>
               </a:rPr>
-              <a:t>Setor 5152</a:t>
-            </a:r>
-            <a:endParaRPr lang="en-US" sz="1500" dirty="0"/>
+              <a:t>5152 - FÁBIO</a:t>
+            </a:r>
+            <a:endParaRPr lang="en-US" sz="900" dirty="0"/>
           </a:p>
         </p:txBody>
       </p:sp>
@@ -7389,7 +7389,7 @@
               <a:buNone/>
             </a:pPr>
             <a:r>
-              <a:rPr lang="en-US" sz="1500" b="1" dirty="0">
+              <a:rPr lang="en-US" sz="900" b="1" dirty="0">
                 <a:solidFill>
                   <a:srgbClr val="1D3557"/>
                 </a:solidFill>
@@ -7397,9 +7397,9 @@
                 <a:ea typeface="Calibri" pitchFamily="34" charset="-122"/>
                 <a:cs typeface="Calibri" pitchFamily="34" charset="-120"/>
               </a:rPr>
-              <a:t>Setor 5613</a:t>
-            </a:r>
-            <a:endParaRPr lang="en-US" sz="1500" dirty="0"/>
+              <a:t>5613 - MILLER</a:t>
+            </a:r>
+            <a:endParaRPr lang="en-US" sz="900" dirty="0"/>
           </a:p>
         </p:txBody>
       </p:sp>
@@ -7631,7 +7631,7 @@
               <a:buNone/>
             </a:pPr>
             <a:r>
-              <a:rPr lang="en-US" sz="1500" b="1" dirty="0">
+              <a:rPr lang="en-US" sz="900" b="1" dirty="0">
                 <a:solidFill>
                   <a:srgbClr val="1D3557"/>
                 </a:solidFill>
@@ -7639,9 +7639,9 @@
                 <a:ea typeface="Calibri" pitchFamily="34" charset="-122"/>
                 <a:cs typeface="Calibri" pitchFamily="34" charset="-120"/>
               </a:rPr>
-              <a:t>Setor 7748</a:t>
-            </a:r>
-            <a:endParaRPr lang="en-US" sz="1500" dirty="0"/>
+              <a:t>7748 - CARLA</a:t>
+            </a:r>
+            <a:endParaRPr lang="en-US" sz="900" dirty="0"/>
           </a:p>
         </p:txBody>
       </p:sp>
@@ -7980,7 +7980,7 @@
               <a:buNone/>
             </a:pPr>
             <a:r>
-              <a:rPr lang="en-US" sz="1500" b="1" dirty="0">
+              <a:rPr lang="en-US" sz="900" b="1" dirty="0">
                 <a:solidFill>
                   <a:srgbClr val="1D3557"/>
                 </a:solidFill>
@@ -7988,9 +7988,9 @@
                 <a:ea typeface="Calibri" pitchFamily="34" charset="-122"/>
                 <a:cs typeface="Calibri" pitchFamily="34" charset="-120"/>
               </a:rPr>
-              <a:t>Setor 7742</a:t>
-            </a:r>
-            <a:endParaRPr lang="en-US" sz="1500" dirty="0"/>
+              <a:t>7742 - EDUARDO</a:t>
+            </a:r>
+            <a:endParaRPr lang="en-US" sz="900" dirty="0"/>
           </a:p>
         </p:txBody>
       </p:sp>
@@ -8222,7 +8222,7 @@
               <a:buNone/>
             </a:pPr>
             <a:r>
-              <a:rPr lang="en-US" sz="1500" b="1" dirty="0">
+              <a:rPr lang="en-US" sz="900" b="1" dirty="0">
                 <a:solidFill>
                   <a:srgbClr val="1D3557"/>
                 </a:solidFill>
@@ -8230,9 +8230,9 @@
                 <a:ea typeface="Calibri" pitchFamily="34" charset="-122"/>
                 <a:cs typeface="Calibri" pitchFamily="34" charset="-120"/>
               </a:rPr>
-              <a:t>Setor 5153</a:t>
-            </a:r>
-            <a:endParaRPr lang="en-US" sz="1500" dirty="0"/>
+              <a:t>5153 - MARCELLE</a:t>
+            </a:r>
+            <a:endParaRPr lang="en-US" sz="900" dirty="0"/>
           </a:p>
         </p:txBody>
       </p:sp>
@@ -8464,7 +8464,7 @@
               <a:buNone/>
             </a:pPr>
             <a:r>
-              <a:rPr lang="en-US" sz="1500" b="1" dirty="0">
+              <a:rPr lang="en-US" sz="900" b="1" dirty="0">
                 <a:solidFill>
                   <a:srgbClr val="1D3557"/>
                 </a:solidFill>
@@ -8472,9 +8472,9 @@
                 <a:ea typeface="Calibri" pitchFamily="34" charset="-122"/>
                 <a:cs typeface="Calibri" pitchFamily="34" charset="-120"/>
               </a:rPr>
-              <a:t>Setor 7741</a:t>
-            </a:r>
-            <a:endParaRPr lang="en-US" sz="1500" dirty="0"/>
+              <a:t>7741 - RAPHAEL</a:t>
+            </a:r>
+            <a:endParaRPr lang="en-US" sz="900" dirty="0"/>
           </a:p>
         </p:txBody>
       </p:sp>
@@ -8706,7 +8706,7 @@
               <a:buNone/>
             </a:pPr>
             <a:r>
-              <a:rPr lang="en-US" sz="1500" b="1" dirty="0">
+              <a:rPr lang="en-US" sz="900" b="1" dirty="0">
                 <a:solidFill>
                   <a:srgbClr val="1D3557"/>
                 </a:solidFill>
@@ -8714,9 +8714,9 @@
                 <a:ea typeface="Calibri" pitchFamily="34" charset="-122"/>
                 <a:cs typeface="Calibri" pitchFamily="34" charset="-120"/>
               </a:rPr>
-              <a:t>Setor 5152</a:t>
-            </a:r>
-            <a:endParaRPr lang="en-US" sz="1500" dirty="0"/>
+              <a:t>5152 - FÁBIO</a:t>
+            </a:r>
+            <a:endParaRPr lang="en-US" sz="900" dirty="0"/>
           </a:p>
         </p:txBody>
       </p:sp>
@@ -8948,7 +8948,7 @@
               <a:buNone/>
             </a:pPr>
             <a:r>
-              <a:rPr lang="en-US" sz="1500" b="1" dirty="0">
+              <a:rPr lang="en-US" sz="900" b="1" dirty="0">
                 <a:solidFill>
                   <a:srgbClr val="1D3557"/>
                 </a:solidFill>
@@ -8956,9 +8956,9 @@
                 <a:ea typeface="Calibri" pitchFamily="34" charset="-122"/>
                 <a:cs typeface="Calibri" pitchFamily="34" charset="-120"/>
               </a:rPr>
-              <a:t>Setor 7745</a:t>
-            </a:r>
-            <a:endParaRPr lang="en-US" sz="1500" dirty="0"/>
+              <a:t>7745 - MATHEUS</a:t>
+            </a:r>
+            <a:endParaRPr lang="en-US" sz="900" dirty="0"/>
           </a:p>
         </p:txBody>
       </p:sp>
@@ -9190,7 +9190,7 @@
               <a:buNone/>
             </a:pPr>
             <a:r>
-              <a:rPr lang="en-US" sz="1500" b="1" dirty="0">
+              <a:rPr lang="en-US" sz="900" b="1" dirty="0">
                 <a:solidFill>
                   <a:srgbClr val="1D3557"/>
                 </a:solidFill>
@@ -9198,9 +9198,9 @@
                 <a:ea typeface="Calibri" pitchFamily="34" charset="-122"/>
                 <a:cs typeface="Calibri" pitchFamily="34" charset="-120"/>
               </a:rPr>
-              <a:t>Setor 5149</a:t>
-            </a:r>
-            <a:endParaRPr lang="en-US" sz="1500" dirty="0"/>
+              <a:t>5149 - LEONARDO</a:t>
+            </a:r>
+            <a:endParaRPr lang="en-US" sz="900" dirty="0"/>
           </a:p>
         </p:txBody>
       </p:sp>
@@ -9432,7 +9432,7 @@
               <a:buNone/>
             </a:pPr>
             <a:r>
-              <a:rPr lang="en-US" sz="1500" b="1" dirty="0">
+              <a:rPr lang="en-US" sz="900" b="1" dirty="0">
                 <a:solidFill>
                   <a:srgbClr val="1D3557"/>
                 </a:solidFill>
@@ -9440,9 +9440,9 @@
                 <a:ea typeface="Calibri" pitchFamily="34" charset="-122"/>
                 <a:cs typeface="Calibri" pitchFamily="34" charset="-120"/>
               </a:rPr>
-              <a:t>Setor 5613</a:t>
-            </a:r>
-            <a:endParaRPr lang="en-US" sz="1500" dirty="0"/>
+              <a:t>5613 - MILLER</a:t>
+            </a:r>
+            <a:endParaRPr lang="en-US" sz="900" dirty="0"/>
           </a:p>
         </p:txBody>
       </p:sp>
@@ -9674,7 +9674,7 @@
               <a:buNone/>
             </a:pPr>
             <a:r>
-              <a:rPr lang="en-US" sz="1500" b="1" dirty="0">
+              <a:rPr lang="en-US" sz="900" b="1" dirty="0">
                 <a:solidFill>
                   <a:srgbClr val="1D3557"/>
                 </a:solidFill>
@@ -9682,9 +9682,9 @@
                 <a:ea typeface="Calibri" pitchFamily="34" charset="-122"/>
                 <a:cs typeface="Calibri" pitchFamily="34" charset="-120"/>
               </a:rPr>
-              <a:t>Setor 7748</a:t>
-            </a:r>
-            <a:endParaRPr lang="en-US" sz="1500" dirty="0"/>
+              <a:t>7748 - CARLA</a:t>
+            </a:r>
+            <a:endParaRPr lang="en-US" sz="900" dirty="0"/>
           </a:p>
         </p:txBody>
       </p:sp>
@@ -10023,7 +10023,7 @@
               <a:buNone/>
             </a:pPr>
             <a:r>
-              <a:rPr lang="en-US" sz="1500" b="1" dirty="0">
+              <a:rPr lang="en-US" sz="900" b="1" dirty="0">
                 <a:solidFill>
                   <a:srgbClr val="1D3557"/>
                 </a:solidFill>
@@ -10031,9 +10031,9 @@
                 <a:ea typeface="Calibri" pitchFamily="34" charset="-122"/>
                 <a:cs typeface="Calibri" pitchFamily="34" charset="-120"/>
               </a:rPr>
-              <a:t>Setor 7748</a:t>
-            </a:r>
-            <a:endParaRPr lang="en-US" sz="1500" dirty="0"/>
+              <a:t>7748 - CARLA</a:t>
+            </a:r>
+            <a:endParaRPr lang="en-US" sz="900" dirty="0"/>
           </a:p>
         </p:txBody>
       </p:sp>
@@ -10265,7 +10265,7 @@
               <a:buNone/>
             </a:pPr>
             <a:r>
-              <a:rPr lang="en-US" sz="1500" b="1" dirty="0">
+              <a:rPr lang="en-US" sz="900" b="1" dirty="0">
                 <a:solidFill>
                   <a:srgbClr val="1D3557"/>
                 </a:solidFill>
@@ -10273,9 +10273,9 @@
                 <a:ea typeface="Calibri" pitchFamily="34" charset="-122"/>
                 <a:cs typeface="Calibri" pitchFamily="34" charset="-120"/>
               </a:rPr>
-              <a:t>Setor 5613</a:t>
-            </a:r>
-            <a:endParaRPr lang="en-US" sz="1500" dirty="0"/>
+              <a:t>5613 - MILLER</a:t>
+            </a:r>
+            <a:endParaRPr lang="en-US" sz="900" dirty="0"/>
           </a:p>
         </p:txBody>
       </p:sp>
@@ -10507,7 +10507,7 @@
               <a:buNone/>
             </a:pPr>
             <a:r>
-              <a:rPr lang="en-US" sz="1500" b="1" dirty="0">
+              <a:rPr lang="en-US" sz="900" b="1" dirty="0">
                 <a:solidFill>
                   <a:srgbClr val="1D3557"/>
                 </a:solidFill>
@@ -10515,9 +10515,9 @@
                 <a:ea typeface="Calibri" pitchFamily="34" charset="-122"/>
                 <a:cs typeface="Calibri" pitchFamily="34" charset="-120"/>
               </a:rPr>
-              <a:t>Setor 7742</a:t>
-            </a:r>
-            <a:endParaRPr lang="en-US" sz="1500" dirty="0"/>
+              <a:t>7742 - EDUARDO</a:t>
+            </a:r>
+            <a:endParaRPr lang="en-US" sz="900" dirty="0"/>
           </a:p>
         </p:txBody>
       </p:sp>
@@ -10749,7 +10749,7 @@
               <a:buNone/>
             </a:pPr>
             <a:r>
-              <a:rPr lang="en-US" sz="1500" b="1" dirty="0">
+              <a:rPr lang="en-US" sz="900" b="1" dirty="0">
                 <a:solidFill>
                   <a:srgbClr val="1D3557"/>
                 </a:solidFill>
@@ -10757,9 +10757,9 @@
                 <a:ea typeface="Calibri" pitchFamily="34" charset="-122"/>
                 <a:cs typeface="Calibri" pitchFamily="34" charset="-120"/>
               </a:rPr>
-              <a:t>Setor 5152</a:t>
-            </a:r>
-            <a:endParaRPr lang="en-US" sz="1500" dirty="0"/>
+              <a:t>5152 - FÁBIO</a:t>
+            </a:r>
+            <a:endParaRPr lang="en-US" sz="900" dirty="0"/>
           </a:p>
         </p:txBody>
       </p:sp>
@@ -10991,7 +10991,7 @@
               <a:buNone/>
             </a:pPr>
             <a:r>
-              <a:rPr lang="en-US" sz="1500" b="1" dirty="0">
+              <a:rPr lang="en-US" sz="900" b="1" dirty="0">
                 <a:solidFill>
                   <a:srgbClr val="1D3557"/>
                 </a:solidFill>
@@ -10999,9 +10999,9 @@
                 <a:ea typeface="Calibri" pitchFamily="34" charset="-122"/>
                 <a:cs typeface="Calibri" pitchFamily="34" charset="-120"/>
               </a:rPr>
-              <a:t>Setor 5149</a:t>
-            </a:r>
-            <a:endParaRPr lang="en-US" sz="1500" dirty="0"/>
+              <a:t>5149 - LEONARDO</a:t>
+            </a:r>
+            <a:endParaRPr lang="en-US" sz="900" dirty="0"/>
           </a:p>
         </p:txBody>
       </p:sp>
@@ -11233,7 +11233,7 @@
               <a:buNone/>
             </a:pPr>
             <a:r>
-              <a:rPr lang="en-US" sz="1500" b="1" dirty="0">
+              <a:rPr lang="en-US" sz="900" b="1" dirty="0">
                 <a:solidFill>
                   <a:srgbClr val="1D3557"/>
                 </a:solidFill>
@@ -11241,9 +11241,9 @@
                 <a:ea typeface="Calibri" pitchFamily="34" charset="-122"/>
                 <a:cs typeface="Calibri" pitchFamily="34" charset="-120"/>
               </a:rPr>
-              <a:t>Setor 7741</a:t>
-            </a:r>
-            <a:endParaRPr lang="en-US" sz="1500" dirty="0"/>
+              <a:t>7741 - RAPHAEL</a:t>
+            </a:r>
+            <a:endParaRPr lang="en-US" sz="900" dirty="0"/>
           </a:p>
         </p:txBody>
       </p:sp>
@@ -11475,7 +11475,7 @@
               <a:buNone/>
             </a:pPr>
             <a:r>
-              <a:rPr lang="en-US" sz="1500" b="1" dirty="0">
+              <a:rPr lang="en-US" sz="900" b="1" dirty="0">
                 <a:solidFill>
                   <a:srgbClr val="1D3557"/>
                 </a:solidFill>
@@ -11483,9 +11483,9 @@
                 <a:ea typeface="Calibri" pitchFamily="34" charset="-122"/>
                 <a:cs typeface="Calibri" pitchFamily="34" charset="-120"/>
               </a:rPr>
-              <a:t>Setor 5153</a:t>
-            </a:r>
-            <a:endParaRPr lang="en-US" sz="1500" dirty="0"/>
+              <a:t>5153 - MARCELLE</a:t>
+            </a:r>
+            <a:endParaRPr lang="en-US" sz="900" dirty="0"/>
           </a:p>
         </p:txBody>
       </p:sp>
@@ -11717,7 +11717,7 @@
               <a:buNone/>
             </a:pPr>
             <a:r>
-              <a:rPr lang="en-US" sz="1500" b="1" dirty="0">
+              <a:rPr lang="en-US" sz="900" b="1" dirty="0">
                 <a:solidFill>
                   <a:srgbClr val="1D3557"/>
                 </a:solidFill>
@@ -11725,9 +11725,9 @@
                 <a:ea typeface="Calibri" pitchFamily="34" charset="-122"/>
                 <a:cs typeface="Calibri" pitchFamily="34" charset="-120"/>
               </a:rPr>
-              <a:t>Setor 7745</a:t>
-            </a:r>
-            <a:endParaRPr lang="en-US" sz="1500" dirty="0"/>
+              <a:t>7745 - MATHEUS</a:t>
+            </a:r>
+            <a:endParaRPr lang="en-US" sz="900" dirty="0"/>
           </a:p>
         </p:txBody>
       </p:sp>

</xml_diff>